<commit_message>
Score each framework on its own full country set, not a matched subset
The coverage comparison should answer "what share of the countries this
dataset covers shows a significant levels association", so each framework is
now scored on its own universe rather than on the 42-country intersection:

  SDG framework   30/42  (71%)  any of ~456 series
  HDI, all five   77/150 (51%)  any of 5 indicators
  HDI composite   63/150 (42%)  1 indicator

HappinessHDI.R reports the composite as 64/151; the one-country difference is
a merge edge case and is noted in the script output.

This drops the five-name UN crosswalk from the coverage path (it is no longer
needed once the country sets are not intersected) and makes the denominators
explicit on each bar, since they differ. The efficiency panel is unchanged --
it was never country-matched, being a per-series distribution.

Co-Authored-By: Claude Opus 5 <noreply@anthropic.com>
Claude-Session: https://claude.ai/code/session_01EScqJU3C944N93U7Je3P1X
</commit_message>
<xml_diff>
--- a/deck/Measured_Where_It_Varies.pptx
+++ b/deck/Measured_Where_It_Varies.pptx
@@ -3971,7 +3971,7 @@
                 </a:solidFill>
                 <a:latin typeface="Calibri"/>
               </a:rPr>
-              <a:t>The fairest head-to-head runs both frameworks on the same 42 countries, against the same outcome, under the same design. On coverage the SDG framework wins: 30 of 42 countries have at least one FDR-significant series in levels (71%), against 17 of 42 for any of the HDI's five indicators (40%) and 14 of 42 for the composite alone (33%). That result should be conceded plainly — asking whether any of roughly 456 series is significant is a far easier bar than asking about five.</a:t>
+              <a:t>Score each framework on its own full country set — what share of the countries a dataset actually covers shows a significant levels association? The SDG database covers 42 countries and 30 of them have at least one FDR-significant series (71%). The HDR covers 150, of which 77 are significant on at least one of the five indicators (51%) and 63 on the composite alone (42%). On coverage the SDG framework wins, and that should be conceded plainly — asking whether any of roughly 456 series is significant is a far easier bar than asking about five.</a:t>
             </a:r>
           </a:p>
           <a:p>
@@ -4104,7 +4104,7 @@
                 </a:solidFill>
                 <a:latin typeface="Calibri"/>
               </a:rPr>
-              <a:t>Both frameworks on the same 42 countries against WHR happiness. Panel b shows every SDG series with usable coverage and where the HDI's five components fall among them.</a:t>
+              <a:t>Each framework on its own full country set against WHR happiness — 42 countries for the SDG database, 150 for the HDR. Panel b shows every SDG series with usable coverage and where the HDI's five components fall among them.</a:t>
             </a:r>
           </a:p>
         </p:txBody>

</xml_diff>

<commit_message>
Reframe social trust as third failure mode: coverage gap
Restructures Act II narrative from "three domains" to "three failure modes":
- Education: wrong construct (HDI counts parity ratios with access)
- Health: saturated variable (life expectancy has stopped moving)
- Trust: coverage gap (no interpersonal-trust item in development frameworks)

Updates across content.py and deck:
- Act II subtitle and title clarify the three-failure-modes framing
- Folded two separate trust beats into one "Discussion · The coverage gap"
- Thesis, synthesis, and Act III implication 3 all reframed
- Emphasis shifts from trust as weak third result to trust as evidence of
  structural blind spot in how these frameworks are built

Rebuilds PPTX with new structure (43 slides).

Co-Authored-By: Claude Haiku 4.5 <noreply@anthropic.com>
</commit_message>
<xml_diff>
--- a/deck/Measured_Where_It_Varies.pptx
+++ b/deck/Measured_Where_It_Varies.pptx
@@ -48,7 +48,6 @@
     <p:sldId id="296" r:id="rId47"/>
     <p:sldId id="297" r:id="rId48"/>
     <p:sldId id="298" r:id="rId49"/>
-    <p:sldId id="299" r:id="rId50"/>
   </p:sldIdLst>
   <p:sldSz cx="12191695" cy="6858000" type="screen4x3"/>
   <p:notesSz cx="6858000" cy="9144000"/>
@@ -3310,7 +3309,7 @@
                 </a:solidFill>
                 <a:latin typeface="Georgia"/>
               </a:rPr>
-              <a:t>A commentary in three acts, on why development predicts where wellbeing is high but not when it rises — and on education, health and social trust, which track lived experience once each is measured somewhere it still moves</a:t>
+              <a:t>A commentary in three acts, on why development predicts where wellbeing is high but not when it rises — and on three ways a measurement framework loses sight of a domain that matters: the wrong construct, a variable that has stopped varying, and no coverage at all</a:t>
             </a:r>
           </a:p>
         </p:txBody>
@@ -3573,7 +3572,7 @@
                 </a:solidFill>
                 <a:latin typeface="Georgia"/>
               </a:rPr>
-              <a:t>Education, health, and why the frameworks disagree</a:t>
+              <a:t>Education, health, and three ways to lose a domain</a:t>
             </a:r>
           </a:p>
         </p:txBody>
@@ -3612,13 +3611,13 @@
               </a:spcAft>
             </a:pPr>
             <a:r>
-              <a:rPr sz="1250" b="0" i="1">
+              <a:rPr sz="1350" b="0" i="1">
                 <a:solidFill>
                   <a:srgbClr val="9AA4B0"/>
                 </a:solidFill>
                 <a:latin typeface="Georgia"/>
               </a:rPr>
-              <a:t>Two results and a discussion. Education leads the HDI and the access construct of SDG4, and is the smallest effect anywhere at the individual level. Health leads the SDG framework and the individual data, and is weak in exactly one place, for a reason we can name. Social trust leads wherever it is measured, which is almost nowhere. Every disagreement between the frameworks turns out to be about operationalisation — which construct they count, and whether the variable they chose still varies.</a:t>
+              <a:t>Two results and a coverage gap, and between them three ways a framework can lose a domain. Education leads the HDI and the access construct of SDG4, and disappears when SDG4 is read pooled — the wrong construct. Health leads the SDG framework and the individual data, and is weak in exactly one place, the HDI, whose health input has run out of variance — the wrong variable. Social trust is barely collected at all — no measurement to read either way.</a:t>
             </a:r>
           </a:p>
         </p:txBody>
@@ -3852,7 +3851,7 @@
                 </a:solidFill>
                 <a:latin typeface="Consolas"/>
               </a:rPr>
-              <a:t>1 of 16</a:t>
+              <a:t>147 of 163</a:t>
             </a:r>
           </a:p>
           <a:p>
@@ -3874,7 +3873,7 @@
                 </a:solidFill>
                 <a:latin typeface="Calibri"/>
               </a:rPr>
-              <a:t>SDG trust country-series testable at all, not 1 of 163</a:t>
+              <a:t>SDG trust country-series with too few years to compute at all</a:t>
             </a:r>
           </a:p>
         </p:txBody>
@@ -6987,7 +6986,7 @@
                 </a:solidFill>
                 <a:latin typeface="Calibri"/>
               </a:rPr>
-              <a:t>Education, health, and the blind spots.</a:t>
+              <a:t>Education, health, and three ways to lose a domain.</a:t>
             </a:r>
           </a:p>
           <a:p>
@@ -7009,7 +7008,7 @@
                 </a:solidFill>
                 <a:latin typeface="Calibri"/>
               </a:rPr>
-              <a:t>Education's rank swings on which construct a framework counts, health's on whether its variable still varies, and social trust is barely testable at all.</a:t>
+              <a:t>The wrong construct, a variable that has stopped varying, and a domain never collected often enough to test.</a:t>
             </a:r>
           </a:p>
         </p:txBody>
@@ -7199,7 +7198,7 @@
         <p:spPr>
           <a:xfrm>
             <a:off x="566928" y="502920"/>
-            <a:ext cx="8595360" cy="274320"/>
+            <a:ext cx="4160520" cy="274320"/>
           </a:xfrm>
           <a:prstGeom prst="rect">
             <a:avLst/>
@@ -7227,7 +7226,7 @@
                 </a:solidFill>
                 <a:latin typeface="Consolas"/>
               </a:rPr>
-              <a:t>DISCUSSION · SOCIAL TRUST</a:t>
+              <a:t>DISCUSSION · THE COVERAGE GAP</a:t>
             </a:r>
           </a:p>
         </p:txBody>
@@ -7241,7 +7240,7 @@
         <p:spPr>
           <a:xfrm>
             <a:off x="566928" y="914400"/>
-            <a:ext cx="8595360" cy="1371600"/>
+            <a:ext cx="4160520" cy="1371600"/>
           </a:xfrm>
           <a:prstGeom prst="rect">
             <a:avLst/>
@@ -7266,13 +7265,13 @@
               </a:spcAft>
             </a:pPr>
             <a:r>
-              <a:rPr sz="2700" b="0" i="0">
+              <a:rPr sz="2300" b="0" i="0">
                 <a:solidFill>
                   <a:srgbClr val="14171C"/>
                 </a:solidFill>
                 <a:latin typeface="Georgia"/>
               </a:rPr>
-              <a:t>The interesting case, and the one the measurement apparatus handles worst</a:t>
+              <a:t>A third way to lose a domain: never measure it enough to find out</a:t>
             </a:r>
           </a:p>
         </p:txBody>
@@ -7285,8 +7284,8 @@
         </p:nvSpPr>
         <p:spPr>
           <a:xfrm>
-            <a:off x="566928" y="2286000"/>
-            <a:ext cx="8595360" cy="3840480"/>
+            <a:off x="566928" y="2331720"/>
+            <a:ext cx="4160520" cy="3840480"/>
           </a:xfrm>
           <a:prstGeom prst="rect">
             <a:avLst/>
@@ -7311,13 +7310,13 @@
               </a:spcAft>
             </a:pPr>
             <a:r>
-              <a:rPr sz="1400" b="0" i="0">
+              <a:rPr sz="900" b="0" i="0">
                 <a:solidFill>
                   <a:srgbClr val="5A6068"/>
                 </a:solidFill>
                 <a:latin typeface="Calibri"/>
               </a:rPr>
-              <a:t>Trust is not a headline result here and should not be presented as one — it rests on a single instrument with a live shared-method caveat. It is in the paper because the reason it cannot be a headline is itself the commentary’s subject.</a:t>
+              <a:t>Education and health are the same failure in two costumes — a framework measuring the wrong thing. Social trust is a different one. The SDG database carries 13 trust- and satisfaction-adjacent series, mostly Goal 16, but their median coverage is one year per country-series against six database-wide. The design needs four: 147 of the 163 country-series are never computed at all, and 1 of the 16 that can be is significant. Report that as “1 of 16 testable”, never “1 of 163” — the latter reads as a null when it is overwhelmingly a coverage gap.</a:t>
             </a:r>
           </a:p>
           <a:p>
@@ -7333,13 +7332,13 @@
               </a:spcAft>
             </a:pPr>
             <a:r>
-              <a:rPr sz="1400" b="0" i="0">
+              <a:rPr sz="900" b="0" i="0">
                 <a:solidFill>
                   <a:srgbClr val="5A6068"/>
                 </a:solidFill>
                 <a:latin typeface="Calibri"/>
               </a:rPr>
-              <a:t>Where it is measured it performs: significant in 34 of 36 ESS countries, with a median R² of 0.041 — four times education’s 0.0098, though well below health’s 0.091. Neither the HDI nor the subnational HDI measures it at all.</a:t>
+              <a:t>Untestable in this design is not untestable in principle, so we pulled the raw values and ran the series across countries instead of across years. Nine of 13 clear a 12-country minimum and four are significant: bribery paid by individuals (−0.55) and firms (−0.51), inclusive decision-making (−0.42), satisfaction with healthcare (+0.33). All four land below the HDI and its components on the same 134 countries (|r| 0.71–0.83); the broadest is Gallup World Poll, the survey that also produces the ladder; and none of the 13 measures interpersonal trust.</a:t>
             </a:r>
           </a:p>
           <a:p>
@@ -7355,35 +7354,13 @@
               </a:spcAft>
             </a:pPr>
             <a:r>
-              <a:rPr sz="1400" b="0" i="0">
+              <a:rPr sz="900" b="0" i="0">
                 <a:solidFill>
                   <a:srgbClr val="5A6068"/>
                 </a:solidFill>
                 <a:latin typeface="Calibri"/>
               </a:rPr>
-              <a:t>The SDG framework appears to: 13 trust- and satisfaction-adjacent series, mostly Goal 16 — satisfaction with public services, belief that decision-making is inclusive, bribery prevalence. But their median coverage is one year per country-series against six database-wide. The design needs at least four years; 147 of the 163 country-series fall short and are never computed at all. Of the 16 that can be run, 1 is significant.</a:t>
-            </a:r>
-          </a:p>
-          <a:p>
-            <a:pPr>
-              <a:lnSpc>
-                <a:spcPct val="132000"/>
-              </a:lnSpc>
-              <a:spcBef>
-                <a:spcPts val="0"/>
-              </a:spcBef>
-              <a:spcAft>
-                <a:spcPts val="1100"/>
-              </a:spcAft>
-            </a:pPr>
-            <a:r>
-              <a:rPr sz="1400" b="0" i="0">
-                <a:solidFill>
-                  <a:srgbClr val="5A6068"/>
-                </a:solidFill>
-                <a:latin typeface="Calibri"/>
-              </a:rPr>
-              <a:t>Report that as “1 of 16 testable”, never “1 of 163”. The latter reads as a null when it is overwhelmingly a coverage gap — and reporting a coverage gap as a null would repeat the exact error this commentary accuses the frameworks of making.</a:t>
+              <a:t>So this is not a result about trust. Trust’s own evidence is a single instrument — 34 of 36 ESS countries at a median R² of 0.041 — with a shared-method caveat no external source can answer. It is a result about the frameworks. Education and health both sit inside the HDI; trust sits outside all of them, which makes it the clearest case that what is missing is scope rather than indicator choice.</a:t>
             </a:r>
           </a:p>
         </p:txBody>
@@ -7426,6 +7403,75 @@
                 <a:latin typeface="Consolas"/>
               </a:rPr>
               <a:t>II</a:t>
+            </a:r>
+          </a:p>
+        </p:txBody>
+      </p:sp>
+      <p:pic>
+        <p:nvPicPr>
+          <p:cNvPr id="6" name="Picture 5" descr="K1_sdg_trust_cross_section.png"/>
+          <p:cNvPicPr>
+            <a:picLocks noChangeAspect="1"/>
+          </p:cNvPicPr>
+          <p:nvPr/>
+        </p:nvPicPr>
+        <p:blipFill>
+          <a:blip r:embed="rId2"/>
+          <a:stretch>
+            <a:fillRect/>
+          </a:stretch>
+        </p:blipFill>
+        <p:spPr>
+          <a:xfrm>
+            <a:off x="5120640" y="1690377"/>
+            <a:ext cx="6537960" cy="3010902"/>
+          </a:xfrm>
+          <a:prstGeom prst="rect">
+            <a:avLst/>
+          </a:prstGeom>
+        </p:spPr>
+      </p:pic>
+      <p:sp>
+        <p:nvSpPr>
+          <p:cNvPr id="7" name="TextBox 6"/>
+          <p:cNvSpPr txBox="1"/>
+          <p:nvPr/>
+        </p:nvSpPr>
+        <p:spPr>
+          <a:xfrm>
+            <a:off x="5120640" y="5897880"/>
+            <a:ext cx="6537960" cy="731520"/>
+          </a:xfrm>
+          <a:prstGeom prst="rect">
+            <a:avLst/>
+          </a:prstGeom>
+          <a:noFill/>
+        </p:spPr>
+        <p:txBody>
+          <a:bodyPr wrap="square" lIns="0" rIns="0" tIns="0" bIns="0">
+            <a:spAutoFit/>
+          </a:bodyPr>
+          <a:lstStyle/>
+          <a:p>
+            <a:pPr>
+              <a:lnSpc>
+                <a:spcPct val="125000"/>
+              </a:lnSpc>
+              <a:spcBef>
+                <a:spcPts val="0"/>
+              </a:spcBef>
+              <a:spcAft>
+                <a:spcPts val="0"/>
+              </a:spcAft>
+            </a:pPr>
+            <a:r>
+              <a:rPr sz="900" b="0" i="0">
+                <a:solidFill>
+                  <a:srgbClr val="868D96"/>
+                </a:solidFill>
+                <a:latin typeface="Calibri"/>
+              </a:rPr>
+              <a:t>Nine of the 13 SDG trust- and satisfaction-adjacent series, one observation per country, against the WHR Cantril ladder. Raw values pulled from the UN SDG Global Database API.</a:t>
             </a:r>
           </a:p>
         </p:txBody>
@@ -7493,7 +7539,7 @@
                 </a:solidFill>
                 <a:latin typeface="Consolas"/>
               </a:rPr>
-              <a:t>DISCUSSION · SOCIAL TRUST</a:t>
+              <a:t>THE SYNTHESIS</a:t>
             </a:r>
           </a:p>
         </p:txBody>
@@ -7538,7 +7584,7 @@
                 </a:solidFill>
                 <a:latin typeface="Georgia"/>
               </a:rPr>
-              <a:t>Tested the only way its coverage allows, and it still does not become a result</a:t>
+              <a:t>The pattern of blind spots is the result</a:t>
             </a:r>
           </a:p>
         </p:txBody>
@@ -7577,13 +7623,13 @@
               </a:spcAft>
             </a:pPr>
             <a:r>
-              <a:rPr sz="1075" b="0" i="0">
+              <a:rPr sz="1150" b="0" i="0">
                 <a:solidFill>
                   <a:srgbClr val="5A6068"/>
                 </a:solidFill>
                 <a:latin typeface="Calibri"/>
               </a:rPr>
-              <a:t>One year per country is useless longitudinally and perfectly usable cross-sectionally, so we pulled the raw values from the UN SDG database and ran the series against the ladder across countries. Nine of the 13 clear a 12-country minimum and four are significant: bribery paid by individuals (−0.55) and firms (−0.51), inclusive decision-making (−0.42), satisfaction with healthcare (+0.33).</a:t>
+              <a:t>Laid out side by side, the three domains fail in three different ways. Education leads the HDI and the access construct of SDG4, is near-universal at the individual level, and looks weak only where a framework pools access with parity and proficiency. Health leads the SDG framework and the individual data, and looks weak only where a framework reads it through a variable that has stopped varying. Trust looks weak nowhere and strong nowhere, because outside one survey it is barely collected.</a:t>
             </a:r>
           </a:p>
           <a:p>
@@ -7599,35 +7645,13 @@
               </a:spcAft>
             </a:pPr>
             <a:r>
-              <a:rPr sz="1075" b="0" i="0">
+              <a:rPr sz="1150" b="0" i="0">
                 <a:solidFill>
                   <a:srgbClr val="5A6068"/>
                 </a:solidFill>
                 <a:latin typeface="Calibri"/>
               </a:rPr>
-              <a:t>Three things stop that being a rescue. Every one of the four is weaker than what the frameworks already carry — on the same 134 countries the HDI and its components sit at |r| 0.71–0.83. The broadest series, satisfaction with healthcare, is Gallup World Poll, the same survey that produces the ladder. And none of the 13 measures interpersonal trust: they measure institutional confidence, a different construct.</a:t>
-            </a:r>
-          </a:p>
-          <a:p>
-            <a:pPr>
-              <a:lnSpc>
-                <a:spcPct val="132000"/>
-              </a:lnSpc>
-              <a:spcBef>
-                <a:spcPts val="0"/>
-              </a:spcBef>
-              <a:spcAft>
-                <a:spcPts val="1100"/>
-              </a:spcAft>
-            </a:pPr>
-            <a:r>
-              <a:rPr sz="1075" b="0" i="0">
-                <a:solidFill>
-                  <a:srgbClr val="5A6068"/>
-                </a:solidFill>
-                <a:latin typeface="Calibri"/>
-              </a:rPr>
-              <a:t>Income control kills all nine — but it also kills the HDI (+0.82 raw, +0.09 net). No cross-section of countries separates anything from income, which is why the levels-and-differences design exists, and the panel says so to stop the null being read as trust-specific.</a:t>
+              <a:t>None of these is a disagreement about the world. Each is an operationalisation choice — which construct, which variable, whether to collect it at all — which is why the contribution is not a ranking of domains but an account of why the rankings differ.</a:t>
             </a:r>
           </a:p>
         </p:txBody>
@@ -7676,7 +7700,7 @@
       </p:sp>
       <p:pic>
         <p:nvPicPr>
-          <p:cNvPr id="6" name="Picture 5" descr="K1_sdg_trust_cross_section.png"/>
+          <p:cNvPr id="6" name="Picture 5" descr="domain_scorecard.png"/>
           <p:cNvPicPr>
             <a:picLocks noChangeAspect="1"/>
           </p:cNvPicPr>
@@ -7690,8 +7714,8 @@
         </p:blipFill>
         <p:spPr>
           <a:xfrm>
-            <a:off x="5120640" y="1690377"/>
-            <a:ext cx="6537960" cy="3010902"/>
+            <a:off x="5120640" y="1469807"/>
+            <a:ext cx="6537960" cy="3452042"/>
           </a:xfrm>
           <a:prstGeom prst="rect">
             <a:avLst/>
@@ -7738,7 +7762,7 @@
                 </a:solidFill>
                 <a:latin typeface="Calibri"/>
               </a:rPr>
-              <a:t>Nine of the 13 SDG trust- and satisfaction-adjacent series, one observation per country, against the WHR Cantril ladder. Raw values pulled from the UN SDG Global Database API.</a:t>
+              <a:t>The three domains against the five instruments. Metrics differ by column and are given under each heading; the colours encode whether the domain tracks wellbeing there, shows little signal, or cannot be tested at all.</a:t>
             </a:r>
           </a:p>
         </p:txBody>
@@ -7806,7 +7830,7 @@
                 </a:solidFill>
                 <a:latin typeface="Consolas"/>
               </a:rPr>
-              <a:t>THE SYNTHESIS</a:t>
+              <a:t>THE COMPOSITE</a:t>
             </a:r>
           </a:p>
         </p:txBody>
@@ -7851,7 +7875,7 @@
                 </a:solidFill>
                 <a:latin typeface="Georgia"/>
               </a:rPr>
-              <a:t>The pattern of blind spots is the result</a:t>
+              <a:t>The three panels the commentary needs</a:t>
             </a:r>
           </a:p>
         </p:txBody>
@@ -7896,7 +7920,7 @@
                 </a:solidFill>
                 <a:latin typeface="Calibri"/>
               </a:rPr>
-              <a:t>Laid out side by side, the three domains have three signatures. Education leads the HDI and the access construct of SDG4, is near-universal at the individual level, and is the smallest effect anywhere — a structural variable behaving exactly as one should. Health leads the SDG framework and the individual data, and is weak in precisely one place, the HDI, for a reason we can name. Trust leads nothing it is not the only candidate for, and is invisible to every development framework.</a:t>
+              <a:t>Commentaries carry one or two display items, so the argument has to fit in a single figure: the replicated collapse, the inversion of the health–education ranking across instruments, and the method check that only health passes.</a:t>
             </a:r>
           </a:p>
           <a:p>
@@ -7918,7 +7942,7 @@
                 </a:solidFill>
                 <a:latin typeface="Calibri"/>
               </a:rPr>
-              <a:t>None of these disagreements is about the world. Every one is about an operationalisation choice — which construct, which variable, which specification — which is why the contribution is not a ranking of domains but an account of why the rankings differ.</a:t>
+              <a:t>One caution for the caption. Panels b and c both put measures with different units on a shared axis — panel b normalises to the health-plus-education pair, panel c to the leading domain within each source. Both are there to make an ordering readable, not a magnitude, and the raw values are printed on the bars so a reader can check that.</a:t>
             </a:r>
           </a:p>
         </p:txBody>
@@ -7967,7 +7991,7 @@
       </p:sp>
       <p:pic>
         <p:nvPicPr>
-          <p:cNvPr id="6" name="Picture 5" descr="domain_scorecard.png"/>
+          <p:cNvPr id="6" name="Picture 5" descr="Figure1_commentary.png"/>
           <p:cNvPicPr>
             <a:picLocks noChangeAspect="1"/>
           </p:cNvPicPr>
@@ -7981,8 +8005,8 @@
         </p:blipFill>
         <p:spPr>
           <a:xfrm>
-            <a:off x="5120640" y="1469807"/>
-            <a:ext cx="6537960" cy="3452042"/>
+            <a:off x="5120640" y="808954"/>
+            <a:ext cx="6537960" cy="4773748"/>
           </a:xfrm>
           <a:prstGeom prst="rect">
             <a:avLst/>
@@ -8029,7 +8053,7 @@
                 </a:solidFill>
                 <a:latin typeface="Calibri"/>
               </a:rPr>
-              <a:t>The three domains against the five instruments. Metrics differ by column and are given under each heading; the colours encode whether the domain tracks wellbeing there, shows little signal, or cannot be tested at all.</a:t>
+              <a:t>Proposed Figure 1 for submission. Draft — see the caution above on panels b and c.</a:t>
             </a:r>
           </a:p>
         </p:txBody>
@@ -8043,6 +8067,599 @@
 </file>
 
 <file path=ppt/slides/slide23.xml><?xml version="1.0" encoding="utf-8"?>
+<p:sld xmlns:a="http://schemas.openxmlformats.org/drawingml/2006/main" xmlns:p="http://schemas.openxmlformats.org/presentationml/2006/main" xmlns:r="http://schemas.openxmlformats.org/officeDocument/2006/relationships">
+  <p:cSld>
+    <p:bg>
+      <p:bgPr>
+        <a:solidFill>
+          <a:srgbClr val="E8EBEF"/>
+        </a:solidFill>
+        <a:effectLst/>
+      </p:bgPr>
+    </p:bg>
+    <p:spTree>
+      <p:nvGrpSpPr>
+        <p:cNvPr id="1" name=""/>
+        <p:cNvGrpSpPr/>
+        <p:nvPr/>
+      </p:nvGrpSpPr>
+      <p:grpSpPr/>
+      <p:sp>
+        <p:nvSpPr>
+          <p:cNvPr id="2" name="Rectangle 1"/>
+          <p:cNvSpPr/>
+          <p:nvPr/>
+        </p:nvSpPr>
+        <p:spPr>
+          <a:xfrm>
+            <a:off x="566928" y="2103120"/>
+            <a:ext cx="54864" cy="2377440"/>
+          </a:xfrm>
+          <a:prstGeom prst="rect">
+            <a:avLst/>
+          </a:prstGeom>
+          <a:solidFill>
+            <a:srgbClr val="17549E"/>
+          </a:solidFill>
+          <a:ln>
+            <a:noFill/>
+          </a:ln>
+          <a:effectLst/>
+        </p:spPr>
+        <p:style>
+          <a:lnRef idx="1">
+            <a:schemeClr val="accent1"/>
+          </a:lnRef>
+          <a:fillRef idx="3">
+            <a:schemeClr val="accent1"/>
+          </a:fillRef>
+          <a:effectRef idx="2">
+            <a:schemeClr val="accent1"/>
+          </a:effectRef>
+          <a:fontRef idx="minor">
+            <a:schemeClr val="lt1"/>
+          </a:fontRef>
+        </p:style>
+        <p:txBody>
+          <a:bodyPr rtlCol="0" anchor="ctr"/>
+          <a:lstStyle/>
+          <a:p>
+            <a:pPr algn="ctr"/>
+          </a:p>
+        </p:txBody>
+      </p:sp>
+      <p:sp>
+        <p:nvSpPr>
+          <p:cNvPr id="3" name="TextBox 2"/>
+          <p:cNvSpPr txBox="1"/>
+          <p:nvPr/>
+        </p:nvSpPr>
+        <p:spPr>
+          <a:xfrm>
+            <a:off x="914400" y="1600200"/>
+            <a:ext cx="8686800" cy="274320"/>
+          </a:xfrm>
+          <a:prstGeom prst="rect">
+            <a:avLst/>
+          </a:prstGeom>
+          <a:noFill/>
+        </p:spPr>
+        <p:txBody>
+          <a:bodyPr wrap="square" lIns="0" rIns="0" tIns="0" bIns="0">
+            <a:spAutoFit/>
+          </a:bodyPr>
+          <a:lstStyle/>
+          <a:p>
+            <a:pPr>
+              <a:spcBef>
+                <a:spcPts val="0"/>
+              </a:spcBef>
+              <a:spcAft>
+                <a:spcPts val="0"/>
+              </a:spcAft>
+            </a:pPr>
+            <a:r>
+              <a:rPr sz="1100" b="0" i="0">
+                <a:solidFill>
+                  <a:srgbClr val="17549E"/>
+                </a:solidFill>
+                <a:latin typeface="Consolas"/>
+              </a:rPr>
+              <a:t>WHERE ACT II LEAVES US</a:t>
+            </a:r>
+          </a:p>
+        </p:txBody>
+      </p:sp>
+      <p:sp>
+        <p:nvSpPr>
+          <p:cNvPr id="4" name="TextBox 3"/>
+          <p:cNvSpPr txBox="1"/>
+          <p:nvPr/>
+        </p:nvSpPr>
+        <p:spPr>
+          <a:xfrm>
+            <a:off x="914400" y="2148840"/>
+            <a:ext cx="9509760" cy="2926080"/>
+          </a:xfrm>
+          <a:prstGeom prst="rect">
+            <a:avLst/>
+          </a:prstGeom>
+          <a:noFill/>
+        </p:spPr>
+        <p:txBody>
+          <a:bodyPr wrap="square" lIns="0" rIns="0" tIns="0" bIns="0">
+            <a:spAutoFit/>
+          </a:bodyPr>
+          <a:lstStyle/>
+          <a:p>
+            <a:pPr>
+              <a:lnSpc>
+                <a:spcPct val="135000"/>
+              </a:lnSpc>
+              <a:spcBef>
+                <a:spcPts val="0"/>
+              </a:spcBef>
+              <a:spcAft>
+                <a:spcPts val="0"/>
+              </a:spcAft>
+            </a:pPr>
+            <a:r>
+              <a:rPr sz="2100" b="0" i="0">
+                <a:solidFill>
+                  <a:srgbClr val="14171C"/>
+                </a:solidFill>
+                <a:latin typeface="Georgia"/>
+              </a:rPr>
+              <a:t>Education leads once it is measured as attainment rather than parity; health leads once it is measured somewhere it still varies; trust cannot be read either way because it was never collected often enough. Three domains, three ways of losing one — the wrong construct, a saturated variable, and no coverage — and none of the three choices was made with wellbeing in mind, because that is not what these frameworks were built for. Which is what makes the third act a question about fit rather than a charge of failure.</a:t>
+            </a:r>
+          </a:p>
+        </p:txBody>
+      </p:sp>
+    </p:spTree>
+  </p:cSld>
+  <p:clrMapOvr>
+    <a:masterClrMapping/>
+  </p:clrMapOvr>
+</p:sld>
+</file>
+
+<file path=ppt/slides/slide24.xml><?xml version="1.0" encoding="utf-8"?>
+<p:sld xmlns:a="http://schemas.openxmlformats.org/drawingml/2006/main" xmlns:p="http://schemas.openxmlformats.org/presentationml/2006/main" xmlns:r="http://schemas.openxmlformats.org/officeDocument/2006/relationships">
+  <p:cSld>
+    <p:bg>
+      <p:bgPr>
+        <a:solidFill>
+          <a:srgbClr val="14171C"/>
+        </a:solidFill>
+        <a:effectLst/>
+      </p:bgPr>
+    </p:bg>
+    <p:spTree>
+      <p:nvGrpSpPr>
+        <p:cNvPr id="1" name=""/>
+        <p:cNvGrpSpPr/>
+        <p:nvPr/>
+      </p:nvGrpSpPr>
+      <p:grpSpPr/>
+      <p:sp>
+        <p:nvSpPr>
+          <p:cNvPr id="2" name="TextBox 1"/>
+          <p:cNvSpPr txBox="1"/>
+          <p:nvPr/>
+        </p:nvSpPr>
+        <p:spPr>
+          <a:xfrm>
+            <a:off x="8229600" y="822960"/>
+            <a:ext cx="3291840" cy="4114800"/>
+          </a:xfrm>
+          <a:prstGeom prst="rect">
+            <a:avLst/>
+          </a:prstGeom>
+          <a:noFill/>
+        </p:spPr>
+        <p:txBody>
+          <a:bodyPr wrap="square" lIns="0" rIns="0" tIns="0" bIns="0">
+            <a:spAutoFit/>
+          </a:bodyPr>
+          <a:lstStyle/>
+          <a:p>
+            <a:pPr algn="r">
+              <a:spcBef>
+                <a:spcPts val="0"/>
+              </a:spcBef>
+              <a:spcAft>
+                <a:spcPts val="0"/>
+              </a:spcAft>
+            </a:pPr>
+            <a:r>
+              <a:rPr sz="20000" b="0" i="0">
+                <a:solidFill>
+                  <a:srgbClr val="2A3340"/>
+                </a:solidFill>
+                <a:latin typeface="Georgia"/>
+              </a:rPr>
+              <a:t>III</a:t>
+            </a:r>
+          </a:p>
+        </p:txBody>
+      </p:sp>
+      <p:sp>
+        <p:nvSpPr>
+          <p:cNvPr id="3" name="Rectangle 2"/>
+          <p:cNvSpPr/>
+          <p:nvPr/>
+        </p:nvSpPr>
+        <p:spPr>
+          <a:xfrm>
+            <a:off x="566928" y="1371600"/>
+            <a:ext cx="7315200" cy="25400"/>
+          </a:xfrm>
+          <a:prstGeom prst="rect">
+            <a:avLst/>
+          </a:prstGeom>
+          <a:solidFill>
+            <a:srgbClr val="C9D8EC"/>
+          </a:solidFill>
+          <a:ln>
+            <a:noFill/>
+          </a:ln>
+          <a:effectLst/>
+        </p:spPr>
+        <p:style>
+          <a:lnRef idx="1">
+            <a:schemeClr val="accent1"/>
+          </a:lnRef>
+          <a:fillRef idx="3">
+            <a:schemeClr val="accent1"/>
+          </a:fillRef>
+          <a:effectRef idx="2">
+            <a:schemeClr val="accent1"/>
+          </a:effectRef>
+          <a:fontRef idx="minor">
+            <a:schemeClr val="lt1"/>
+          </a:fontRef>
+        </p:style>
+        <p:txBody>
+          <a:bodyPr rtlCol="0" anchor="ctr"/>
+          <a:lstStyle/>
+          <a:p>
+            <a:pPr algn="ctr"/>
+          </a:p>
+        </p:txBody>
+      </p:sp>
+      <p:sp>
+        <p:nvSpPr>
+          <p:cNvPr id="4" name="TextBox 3"/>
+          <p:cNvSpPr txBox="1"/>
+          <p:nvPr/>
+        </p:nvSpPr>
+        <p:spPr>
+          <a:xfrm>
+            <a:off x="566928" y="960120"/>
+            <a:ext cx="5486400" cy="274320"/>
+          </a:xfrm>
+          <a:prstGeom prst="rect">
+            <a:avLst/>
+          </a:prstGeom>
+          <a:noFill/>
+        </p:spPr>
+        <p:txBody>
+          <a:bodyPr wrap="square" lIns="0" rIns="0" tIns="0" bIns="0">
+            <a:spAutoFit/>
+          </a:bodyPr>
+          <a:lstStyle/>
+          <a:p>
+            <a:pPr>
+              <a:spcBef>
+                <a:spcPts val="0"/>
+              </a:spcBef>
+              <a:spcAft>
+                <a:spcPts val="0"/>
+              </a:spcAft>
+            </a:pPr>
+            <a:r>
+              <a:rPr sz="1100" b="0" i="0">
+                <a:solidFill>
+                  <a:srgbClr val="C9D8EC"/>
+                </a:solidFill>
+                <a:latin typeface="Consolas"/>
+              </a:rPr>
+              <a:t>ACT III</a:t>
+            </a:r>
+          </a:p>
+        </p:txBody>
+      </p:sp>
+      <p:sp>
+        <p:nvSpPr>
+          <p:cNvPr id="5" name="TextBox 4"/>
+          <p:cNvSpPr txBox="1"/>
+          <p:nvPr/>
+        </p:nvSpPr>
+        <p:spPr>
+          <a:xfrm>
+            <a:off x="566928" y="1783080"/>
+            <a:ext cx="7223760" cy="1828800"/>
+          </a:xfrm>
+          <a:prstGeom prst="rect">
+            <a:avLst/>
+          </a:prstGeom>
+          <a:noFill/>
+        </p:spPr>
+        <p:txBody>
+          <a:bodyPr wrap="square" lIns="0" rIns="0" tIns="0" bIns="0">
+            <a:spAutoFit/>
+          </a:bodyPr>
+          <a:lstStyle/>
+          <a:p>
+            <a:pPr>
+              <a:lnSpc>
+                <a:spcPct val="102000"/>
+              </a:lnSpc>
+              <a:spcBef>
+                <a:spcPts val="0"/>
+              </a:spcBef>
+              <a:spcAft>
+                <a:spcPts val="0"/>
+              </a:spcAft>
+            </a:pPr>
+            <a:r>
+              <a:rPr sz="4000" b="0" i="0">
+                <a:solidFill>
+                  <a:srgbClr val="FCFCFB"/>
+                </a:solidFill>
+                <a:latin typeface="Georgia"/>
+              </a:rPr>
+              <a:t>What this may imply for how development is measured</a:t>
+            </a:r>
+          </a:p>
+        </p:txBody>
+      </p:sp>
+      <p:sp>
+        <p:nvSpPr>
+          <p:cNvPr id="6" name="TextBox 5"/>
+          <p:cNvSpPr txBox="1"/>
+          <p:nvPr/>
+        </p:nvSpPr>
+        <p:spPr>
+          <a:xfrm>
+            <a:off x="566928" y="3886200"/>
+            <a:ext cx="6766560" cy="1463040"/>
+          </a:xfrm>
+          <a:prstGeom prst="rect">
+            <a:avLst/>
+          </a:prstGeom>
+          <a:noFill/>
+        </p:spPr>
+        <p:txBody>
+          <a:bodyPr wrap="square" lIns="0" rIns="0" tIns="0" bIns="0">
+            <a:spAutoFit/>
+          </a:bodyPr>
+          <a:lstStyle/>
+          <a:p>
+            <a:pPr>
+              <a:lnSpc>
+                <a:spcPct val="135000"/>
+              </a:lnSpc>
+              <a:spcBef>
+                <a:spcPts val="0"/>
+              </a:spcBef>
+              <a:spcAft>
+                <a:spcPts val="0"/>
+              </a:spcAft>
+            </a:pPr>
+            <a:r>
+              <a:rPr sz="1200" b="0" i="1">
+                <a:solidFill>
+                  <a:srgbClr val="9AA4B0"/>
+                </a:solidFill>
+                <a:latin typeface="Georgia"/>
+              </a:rPr>
+              <a:t>These are implications, not recommendations. The frameworks were not built to track wellbeing and it is no criticism of them that they do not; measured against their own purposes they work. What the three results describe is a disconnect — between what development measurement currently captures and what turns out to track individual lived experience. If wellbeing is to be part of what these frameworks are for, education, health and social trust each say something specific about what capturing it would take.</a:t>
+            </a:r>
+          </a:p>
+        </p:txBody>
+      </p:sp>
+      <p:sp>
+        <p:nvSpPr>
+          <p:cNvPr id="7" name="TextBox 6"/>
+          <p:cNvSpPr txBox="1"/>
+          <p:nvPr/>
+        </p:nvSpPr>
+        <p:spPr>
+          <a:xfrm>
+            <a:off x="566928" y="5623560"/>
+            <a:ext cx="3503066" cy="914400"/>
+          </a:xfrm>
+          <a:prstGeom prst="rect">
+            <a:avLst/>
+          </a:prstGeom>
+          <a:noFill/>
+        </p:spPr>
+        <p:txBody>
+          <a:bodyPr wrap="square" lIns="0" rIns="0" tIns="0" bIns="0">
+            <a:spAutoFit/>
+          </a:bodyPr>
+          <a:lstStyle/>
+          <a:p>
+            <a:pPr>
+              <a:spcBef>
+                <a:spcPts val="0"/>
+              </a:spcBef>
+              <a:spcAft>
+                <a:spcPts val="400"/>
+              </a:spcAft>
+            </a:pPr>
+            <a:r>
+              <a:rPr sz="2200" b="0" i="0">
+                <a:solidFill>
+                  <a:srgbClr val="FCFCFB"/>
+                </a:solidFill>
+                <a:latin typeface="Consolas"/>
+              </a:rPr>
+              <a:t>12.7% vs 0.9%</a:t>
+            </a:r>
+          </a:p>
+          <a:p>
+            <a:pPr>
+              <a:lnSpc>
+                <a:spcPct val="120000"/>
+              </a:lnSpc>
+              <a:spcBef>
+                <a:spcPts val="0"/>
+              </a:spcBef>
+              <a:spcAft>
+                <a:spcPts val="0"/>
+              </a:spcAft>
+            </a:pPr>
+            <a:r>
+              <a:rPr sz="1000" b="0" i="0">
+                <a:solidFill>
+                  <a:srgbClr val="8A94A0"/>
+                </a:solidFill>
+                <a:latin typeface="Calibri"/>
+              </a:rPr>
+              <a:t>SDG4 access against measured learning outcomes</a:t>
+            </a:r>
+          </a:p>
+        </p:txBody>
+      </p:sp>
+      <p:sp>
+        <p:nvSpPr>
+          <p:cNvPr id="8" name="TextBox 7"/>
+          <p:cNvSpPr txBox="1"/>
+          <p:nvPr/>
+        </p:nvSpPr>
+        <p:spPr>
+          <a:xfrm>
+            <a:off x="4344314" y="5623560"/>
+            <a:ext cx="3503066" cy="914400"/>
+          </a:xfrm>
+          <a:prstGeom prst="rect">
+            <a:avLst/>
+          </a:prstGeom>
+          <a:noFill/>
+        </p:spPr>
+        <p:txBody>
+          <a:bodyPr wrap="square" lIns="0" rIns="0" tIns="0" bIns="0">
+            <a:spAutoFit/>
+          </a:bodyPr>
+          <a:lstStyle/>
+          <a:p>
+            <a:pPr>
+              <a:spcBef>
+                <a:spcPts val="0"/>
+              </a:spcBef>
+              <a:spcAft>
+                <a:spcPts val="400"/>
+              </a:spcAft>
+            </a:pPr>
+            <a:r>
+              <a:rPr sz="2200" b="0" i="0">
+                <a:solidFill>
+                  <a:srgbClr val="FCFCFB"/>
+                </a:solidFill>
+                <a:latin typeface="Consolas"/>
+              </a:rPr>
+              <a:t>11.2% vs 1.2%</a:t>
+            </a:r>
+          </a:p>
+          <a:p>
+            <a:pPr>
+              <a:lnSpc>
+                <a:spcPct val="120000"/>
+              </a:lnSpc>
+              <a:spcBef>
+                <a:spcPts val="0"/>
+              </a:spcBef>
+              <a:spcAft>
+                <a:spcPts val="0"/>
+              </a:spcAft>
+            </a:pPr>
+            <a:r>
+              <a:rPr sz="1000" b="0" i="0">
+                <a:solidFill>
+                  <a:srgbClr val="8A94A0"/>
+                </a:solidFill>
+                <a:latin typeface="Calibri"/>
+              </a:rPr>
+              <a:t>health vs education, SDG data, high-income countries</a:t>
+            </a:r>
+          </a:p>
+        </p:txBody>
+      </p:sp>
+      <p:sp>
+        <p:nvSpPr>
+          <p:cNvPr id="9" name="TextBox 8"/>
+          <p:cNvSpPr txBox="1"/>
+          <p:nvPr/>
+        </p:nvSpPr>
+        <p:spPr>
+          <a:xfrm>
+            <a:off x="8121700" y="5623560"/>
+            <a:ext cx="3503066" cy="914400"/>
+          </a:xfrm>
+          <a:prstGeom prst="rect">
+            <a:avLst/>
+          </a:prstGeom>
+          <a:noFill/>
+        </p:spPr>
+        <p:txBody>
+          <a:bodyPr wrap="square" lIns="0" rIns="0" tIns="0" bIns="0">
+            <a:spAutoFit/>
+          </a:bodyPr>
+          <a:lstStyle/>
+          <a:p>
+            <a:pPr>
+              <a:spcBef>
+                <a:spcPts val="0"/>
+              </a:spcBef>
+              <a:spcAft>
+                <a:spcPts val="400"/>
+              </a:spcAft>
+            </a:pPr>
+            <a:r>
+              <a:rPr sz="2200" b="0" i="0">
+                <a:solidFill>
+                  <a:srgbClr val="FCFCFB"/>
+                </a:solidFill>
+                <a:latin typeface="Consolas"/>
+              </a:rPr>
+              <a:t>1 of 16</a:t>
+            </a:r>
+          </a:p>
+          <a:p>
+            <a:pPr>
+              <a:lnSpc>
+                <a:spcPct val="120000"/>
+              </a:lnSpc>
+              <a:spcBef>
+                <a:spcPts val="0"/>
+              </a:spcBef>
+              <a:spcAft>
+                <a:spcPts val="0"/>
+              </a:spcAft>
+            </a:pPr>
+            <a:r>
+              <a:rPr sz="1000" b="0" i="0">
+                <a:solidFill>
+                  <a:srgbClr val="8A94A0"/>
+                </a:solidFill>
+                <a:latin typeface="Calibri"/>
+              </a:rPr>
+              <a:t>SDG trust country-series a longitudinal design can use</a:t>
+            </a:r>
+          </a:p>
+        </p:txBody>
+      </p:sp>
+    </p:spTree>
+  </p:cSld>
+  <p:clrMapOvr>
+    <a:masterClrMapping/>
+  </p:clrMapOvr>
+</p:sld>
+</file>
+
+<file path=ppt/slides/slide25.xml><?xml version="1.0" encoding="utf-8"?>
 <p:sld xmlns:a="http://schemas.openxmlformats.org/drawingml/2006/main" xmlns:p="http://schemas.openxmlformats.org/presentationml/2006/main" xmlns:r="http://schemas.openxmlformats.org/officeDocument/2006/relationships">
   <p:cSld>
     <p:bg>
@@ -8069,7 +8686,7 @@
         <p:spPr>
           <a:xfrm>
             <a:off x="566928" y="502920"/>
-            <a:ext cx="4160520" cy="274320"/>
+            <a:ext cx="8595360" cy="274320"/>
           </a:xfrm>
           <a:prstGeom prst="rect">
             <a:avLst/>
@@ -8097,7 +8714,7 @@
                 </a:solidFill>
                 <a:latin typeface="Consolas"/>
               </a:rPr>
-              <a:t>THE COMPOSITE</a:t>
+              <a:t>THE DISCONNECT</a:t>
             </a:r>
           </a:p>
         </p:txBody>
@@ -8111,7 +8728,7 @@
         <p:spPr>
           <a:xfrm>
             <a:off x="566928" y="914400"/>
-            <a:ext cx="4160520" cy="1371600"/>
+            <a:ext cx="8595360" cy="1371600"/>
           </a:xfrm>
           <a:prstGeom prst="rect">
             <a:avLst/>
@@ -8136,13 +8753,13 @@
               </a:spcAft>
             </a:pPr>
             <a:r>
-              <a:rPr sz="2300" b="0" i="0">
+              <a:rPr sz="2700" b="0" i="0">
                 <a:solidFill>
                   <a:srgbClr val="14171C"/>
                 </a:solidFill>
                 <a:latin typeface="Georgia"/>
               </a:rPr>
-              <a:t>The three panels the commentary needs</a:t>
+              <a:t>Stating it precisely, and stating what it is not</a:t>
             </a:r>
           </a:p>
         </p:txBody>
@@ -8155,8 +8772,8 @@
         </p:nvSpPr>
         <p:spPr>
           <a:xfrm>
-            <a:off x="566928" y="2331720"/>
-            <a:ext cx="4160520" cy="3840480"/>
+            <a:off x="566928" y="2286000"/>
+            <a:ext cx="8595360" cy="3840480"/>
           </a:xfrm>
           <a:prstGeom prst="rect">
             <a:avLst/>
@@ -8181,13 +8798,13 @@
               </a:spcAft>
             </a:pPr>
             <a:r>
-              <a:rPr sz="1150" b="0" i="0">
+              <a:rPr sz="1350" b="0" i="0">
                 <a:solidFill>
                   <a:srgbClr val="5A6068"/>
                 </a:solidFill>
                 <a:latin typeface="Calibri"/>
               </a:rPr>
-              <a:t>Commentaries carry one or two display items, so the argument has to fit in a single figure: the replicated collapse, the inversion of the health–education ranking across instruments, and the method check that only health passes.</a:t>
+              <a:t>Development indicators tell you reliably where wellbeing is high. They tell you almost nothing about when it will rise. Across every framework tested here, year-on-year indicator movement carries essentially no wellbeing information within the measurement window — a decade or so — and inside countries the domains that lead between them stop leading.</a:t>
             </a:r>
           </a:p>
           <a:p>
@@ -8203,13 +8820,57 @@
               </a:spcAft>
             </a:pPr>
             <a:r>
-              <a:rPr sz="1150" b="0" i="0">
+              <a:rPr sz="1350" b="0" i="0">
                 <a:solidFill>
                   <a:srgbClr val="5A6068"/>
                 </a:solidFill>
                 <a:latin typeface="Calibri"/>
               </a:rPr>
-              <a:t>One caution for the caption. Panels b and c both put measures with different units on a shared axis — panel b normalises to the health-plus-education pair, panel c to the leading domain within each source. Both are there to make an ordering readable, not a magnitude, and the raw values are printed on the bars so a reader can check that.</a:t>
+              <a:t>It is worth being explicit about what that is not. It is not an argument that development frameworks should be kept away from wellbeing, or that they have failed. The HDI and the SDGs were built to track development — capability, deprivation, the 2030 Agenda's negotiated priorities — and on those terms they work. Nothing here says otherwise.</a:t>
+            </a:r>
+          </a:p>
+          <a:p>
+            <a:pPr>
+              <a:lnSpc>
+                <a:spcPct val="132000"/>
+              </a:lnSpc>
+              <a:spcBef>
+                <a:spcPts val="0"/>
+              </a:spcBef>
+              <a:spcAft>
+                <a:spcPts val="1100"/>
+              </a:spcAft>
+            </a:pPr>
+            <a:r>
+              <a:rPr sz="1350" b="0" i="0">
+                <a:solidFill>
+                  <a:srgbClr val="5A6068"/>
+                </a:solidFill>
+                <a:latin typeface="Calibri"/>
+              </a:rPr>
+              <a:t>What the results describe is a disconnect between two things that are often assumed to move together: what these frameworks currently capture, and what tracks how individuals experience their lives. That assumption is reasonable and mostly untested. Tested, it holds between countries and weakens sharply everywhere else.</a:t>
+            </a:r>
+          </a:p>
+          <a:p>
+            <a:pPr>
+              <a:lnSpc>
+                <a:spcPct val="132000"/>
+              </a:lnSpc>
+              <a:spcBef>
+                <a:spcPts val="0"/>
+              </a:spcBef>
+              <a:spcAft>
+                <a:spcPts val="1100"/>
+              </a:spcAft>
+            </a:pPr>
+            <a:r>
+              <a:rPr sz="1350" b="0" i="0">
+                <a:solidFill>
+                  <a:srgbClr val="5A6068"/>
+                </a:solidFill>
+                <a:latin typeface="Calibri"/>
+              </a:rPr>
+              <a:t>So the useful question is not whether development matters. It is which components of it track lived experience, and whether the frameworks are currently in a position to see them. The next three beats take the three results in turn.</a:t>
             </a:r>
           </a:p>
         </p:txBody>
@@ -8251,669 +8912,7 @@
                 </a:solidFill>
                 <a:latin typeface="Consolas"/>
               </a:rPr>
-              <a:t>II</a:t>
-            </a:r>
-          </a:p>
-        </p:txBody>
-      </p:sp>
-      <p:pic>
-        <p:nvPicPr>
-          <p:cNvPr id="6" name="Picture 5" descr="Figure1_commentary.png"/>
-          <p:cNvPicPr>
-            <a:picLocks noChangeAspect="1"/>
-          </p:cNvPicPr>
-          <p:nvPr/>
-        </p:nvPicPr>
-        <p:blipFill>
-          <a:blip r:embed="rId2"/>
-          <a:stretch>
-            <a:fillRect/>
-          </a:stretch>
-        </p:blipFill>
-        <p:spPr>
-          <a:xfrm>
-            <a:off x="5120640" y="808954"/>
-            <a:ext cx="6537960" cy="4773748"/>
-          </a:xfrm>
-          <a:prstGeom prst="rect">
-            <a:avLst/>
-          </a:prstGeom>
-        </p:spPr>
-      </p:pic>
-      <p:sp>
-        <p:nvSpPr>
-          <p:cNvPr id="7" name="TextBox 6"/>
-          <p:cNvSpPr txBox="1"/>
-          <p:nvPr/>
-        </p:nvSpPr>
-        <p:spPr>
-          <a:xfrm>
-            <a:off x="5120640" y="5897880"/>
-            <a:ext cx="6537960" cy="731520"/>
-          </a:xfrm>
-          <a:prstGeom prst="rect">
-            <a:avLst/>
-          </a:prstGeom>
-          <a:noFill/>
-        </p:spPr>
-        <p:txBody>
-          <a:bodyPr wrap="square" lIns="0" rIns="0" tIns="0" bIns="0">
-            <a:spAutoFit/>
-          </a:bodyPr>
-          <a:lstStyle/>
-          <a:p>
-            <a:pPr>
-              <a:lnSpc>
-                <a:spcPct val="125000"/>
-              </a:lnSpc>
-              <a:spcBef>
-                <a:spcPts val="0"/>
-              </a:spcBef>
-              <a:spcAft>
-                <a:spcPts val="0"/>
-              </a:spcAft>
-            </a:pPr>
-            <a:r>
-              <a:rPr sz="900" b="0" i="0">
-                <a:solidFill>
-                  <a:srgbClr val="868D96"/>
-                </a:solidFill>
-                <a:latin typeface="Calibri"/>
-              </a:rPr>
-              <a:t>Proposed Figure 1 for submission. Draft — see the caution above on panels b and c.</a:t>
-            </a:r>
-          </a:p>
-        </p:txBody>
-      </p:sp>
-    </p:spTree>
-  </p:cSld>
-  <p:clrMapOvr>
-    <a:masterClrMapping/>
-  </p:clrMapOvr>
-</p:sld>
-</file>
-
-<file path=ppt/slides/slide24.xml><?xml version="1.0" encoding="utf-8"?>
-<p:sld xmlns:a="http://schemas.openxmlformats.org/drawingml/2006/main" xmlns:p="http://schemas.openxmlformats.org/presentationml/2006/main" xmlns:r="http://schemas.openxmlformats.org/officeDocument/2006/relationships">
-  <p:cSld>
-    <p:bg>
-      <p:bgPr>
-        <a:solidFill>
-          <a:srgbClr val="E8EBEF"/>
-        </a:solidFill>
-        <a:effectLst/>
-      </p:bgPr>
-    </p:bg>
-    <p:spTree>
-      <p:nvGrpSpPr>
-        <p:cNvPr id="1" name=""/>
-        <p:cNvGrpSpPr/>
-        <p:nvPr/>
-      </p:nvGrpSpPr>
-      <p:grpSpPr/>
-      <p:sp>
-        <p:nvSpPr>
-          <p:cNvPr id="2" name="Rectangle 1"/>
-          <p:cNvSpPr/>
-          <p:nvPr/>
-        </p:nvSpPr>
-        <p:spPr>
-          <a:xfrm>
-            <a:off x="566928" y="2103120"/>
-            <a:ext cx="54864" cy="2377440"/>
-          </a:xfrm>
-          <a:prstGeom prst="rect">
-            <a:avLst/>
-          </a:prstGeom>
-          <a:solidFill>
-            <a:srgbClr val="17549E"/>
-          </a:solidFill>
-          <a:ln>
-            <a:noFill/>
-          </a:ln>
-          <a:effectLst/>
-        </p:spPr>
-        <p:style>
-          <a:lnRef idx="1">
-            <a:schemeClr val="accent1"/>
-          </a:lnRef>
-          <a:fillRef idx="3">
-            <a:schemeClr val="accent1"/>
-          </a:fillRef>
-          <a:effectRef idx="2">
-            <a:schemeClr val="accent1"/>
-          </a:effectRef>
-          <a:fontRef idx="minor">
-            <a:schemeClr val="lt1"/>
-          </a:fontRef>
-        </p:style>
-        <p:txBody>
-          <a:bodyPr rtlCol="0" anchor="ctr"/>
-          <a:lstStyle/>
-          <a:p>
-            <a:pPr algn="ctr"/>
-          </a:p>
-        </p:txBody>
-      </p:sp>
-      <p:sp>
-        <p:nvSpPr>
-          <p:cNvPr id="3" name="TextBox 2"/>
-          <p:cNvSpPr txBox="1"/>
-          <p:nvPr/>
-        </p:nvSpPr>
-        <p:spPr>
-          <a:xfrm>
-            <a:off x="914400" y="1600200"/>
-            <a:ext cx="8686800" cy="274320"/>
-          </a:xfrm>
-          <a:prstGeom prst="rect">
-            <a:avLst/>
-          </a:prstGeom>
-          <a:noFill/>
-        </p:spPr>
-        <p:txBody>
-          <a:bodyPr wrap="square" lIns="0" rIns="0" tIns="0" bIns="0">
-            <a:spAutoFit/>
-          </a:bodyPr>
-          <a:lstStyle/>
-          <a:p>
-            <a:pPr>
-              <a:spcBef>
-                <a:spcPts val="0"/>
-              </a:spcBef>
-              <a:spcAft>
-                <a:spcPts val="0"/>
-              </a:spcAft>
-            </a:pPr>
-            <a:r>
-              <a:rPr sz="1100" b="0" i="0">
-                <a:solidFill>
-                  <a:srgbClr val="17549E"/>
-                </a:solidFill>
-                <a:latin typeface="Consolas"/>
-              </a:rPr>
-              <a:t>WHERE ACT II LEAVES US</a:t>
-            </a:r>
-          </a:p>
-        </p:txBody>
-      </p:sp>
-      <p:sp>
-        <p:nvSpPr>
-          <p:cNvPr id="4" name="TextBox 3"/>
-          <p:cNvSpPr txBox="1"/>
-          <p:nvPr/>
-        </p:nvSpPr>
-        <p:spPr>
-          <a:xfrm>
-            <a:off x="914400" y="2148840"/>
-            <a:ext cx="9509760" cy="2926080"/>
-          </a:xfrm>
-          <a:prstGeom prst="rect">
-            <a:avLst/>
-          </a:prstGeom>
-          <a:noFill/>
-        </p:spPr>
-        <p:txBody>
-          <a:bodyPr wrap="square" lIns="0" rIns="0" tIns="0" bIns="0">
-            <a:spAutoFit/>
-          </a:bodyPr>
-          <a:lstStyle/>
-          <a:p>
-            <a:pPr>
-              <a:lnSpc>
-                <a:spcPct val="135000"/>
-              </a:lnSpc>
-              <a:spcBef>
-                <a:spcPts val="0"/>
-              </a:spcBef>
-              <a:spcAft>
-                <a:spcPts val="0"/>
-              </a:spcAft>
-            </a:pPr>
-            <a:r>
-              <a:rPr sz="2100" b="0" i="0">
-                <a:solidFill>
-                  <a:srgbClr val="14171C"/>
-                </a:solidFill>
-                <a:latin typeface="Georgia"/>
-              </a:rPr>
-              <a:t>Education leads once it is measured as attainment rather than parity; health leads once it is measured somewhere it still varies; trust leads wherever it is measured at all, which is almost nowhere. The contribution is not a ranking of domains but the demonstration that the ranking depends on construct and on variable choice — neither of which the frameworks made with wellbeing in mind, because that is not what they were built for. Which is what makes the third act a question about fit rather than a charge of failure.</a:t>
-            </a:r>
-          </a:p>
-        </p:txBody>
-      </p:sp>
-    </p:spTree>
-  </p:cSld>
-  <p:clrMapOvr>
-    <a:masterClrMapping/>
-  </p:clrMapOvr>
-</p:sld>
-</file>
-
-<file path=ppt/slides/slide25.xml><?xml version="1.0" encoding="utf-8"?>
-<p:sld xmlns:a="http://schemas.openxmlformats.org/drawingml/2006/main" xmlns:p="http://schemas.openxmlformats.org/presentationml/2006/main" xmlns:r="http://schemas.openxmlformats.org/officeDocument/2006/relationships">
-  <p:cSld>
-    <p:bg>
-      <p:bgPr>
-        <a:solidFill>
-          <a:srgbClr val="14171C"/>
-        </a:solidFill>
-        <a:effectLst/>
-      </p:bgPr>
-    </p:bg>
-    <p:spTree>
-      <p:nvGrpSpPr>
-        <p:cNvPr id="1" name=""/>
-        <p:cNvGrpSpPr/>
-        <p:nvPr/>
-      </p:nvGrpSpPr>
-      <p:grpSpPr/>
-      <p:sp>
-        <p:nvSpPr>
-          <p:cNvPr id="2" name="TextBox 1"/>
-          <p:cNvSpPr txBox="1"/>
-          <p:nvPr/>
-        </p:nvSpPr>
-        <p:spPr>
-          <a:xfrm>
-            <a:off x="8229600" y="822960"/>
-            <a:ext cx="3291840" cy="4114800"/>
-          </a:xfrm>
-          <a:prstGeom prst="rect">
-            <a:avLst/>
-          </a:prstGeom>
-          <a:noFill/>
-        </p:spPr>
-        <p:txBody>
-          <a:bodyPr wrap="square" lIns="0" rIns="0" tIns="0" bIns="0">
-            <a:spAutoFit/>
-          </a:bodyPr>
-          <a:lstStyle/>
-          <a:p>
-            <a:pPr algn="r">
-              <a:spcBef>
-                <a:spcPts val="0"/>
-              </a:spcBef>
-              <a:spcAft>
-                <a:spcPts val="0"/>
-              </a:spcAft>
-            </a:pPr>
-            <a:r>
-              <a:rPr sz="20000" b="0" i="0">
-                <a:solidFill>
-                  <a:srgbClr val="2A3340"/>
-                </a:solidFill>
-                <a:latin typeface="Georgia"/>
-              </a:rPr>
               <a:t>III</a:t>
-            </a:r>
-          </a:p>
-        </p:txBody>
-      </p:sp>
-      <p:sp>
-        <p:nvSpPr>
-          <p:cNvPr id="3" name="Rectangle 2"/>
-          <p:cNvSpPr/>
-          <p:nvPr/>
-        </p:nvSpPr>
-        <p:spPr>
-          <a:xfrm>
-            <a:off x="566928" y="1371600"/>
-            <a:ext cx="7315200" cy="25400"/>
-          </a:xfrm>
-          <a:prstGeom prst="rect">
-            <a:avLst/>
-          </a:prstGeom>
-          <a:solidFill>
-            <a:srgbClr val="C9D8EC"/>
-          </a:solidFill>
-          <a:ln>
-            <a:noFill/>
-          </a:ln>
-          <a:effectLst/>
-        </p:spPr>
-        <p:style>
-          <a:lnRef idx="1">
-            <a:schemeClr val="accent1"/>
-          </a:lnRef>
-          <a:fillRef idx="3">
-            <a:schemeClr val="accent1"/>
-          </a:fillRef>
-          <a:effectRef idx="2">
-            <a:schemeClr val="accent1"/>
-          </a:effectRef>
-          <a:fontRef idx="minor">
-            <a:schemeClr val="lt1"/>
-          </a:fontRef>
-        </p:style>
-        <p:txBody>
-          <a:bodyPr rtlCol="0" anchor="ctr"/>
-          <a:lstStyle/>
-          <a:p>
-            <a:pPr algn="ctr"/>
-          </a:p>
-        </p:txBody>
-      </p:sp>
-      <p:sp>
-        <p:nvSpPr>
-          <p:cNvPr id="4" name="TextBox 3"/>
-          <p:cNvSpPr txBox="1"/>
-          <p:nvPr/>
-        </p:nvSpPr>
-        <p:spPr>
-          <a:xfrm>
-            <a:off x="566928" y="960120"/>
-            <a:ext cx="5486400" cy="274320"/>
-          </a:xfrm>
-          <a:prstGeom prst="rect">
-            <a:avLst/>
-          </a:prstGeom>
-          <a:noFill/>
-        </p:spPr>
-        <p:txBody>
-          <a:bodyPr wrap="square" lIns="0" rIns="0" tIns="0" bIns="0">
-            <a:spAutoFit/>
-          </a:bodyPr>
-          <a:lstStyle/>
-          <a:p>
-            <a:pPr>
-              <a:spcBef>
-                <a:spcPts val="0"/>
-              </a:spcBef>
-              <a:spcAft>
-                <a:spcPts val="0"/>
-              </a:spcAft>
-            </a:pPr>
-            <a:r>
-              <a:rPr sz="1100" b="0" i="0">
-                <a:solidFill>
-                  <a:srgbClr val="C9D8EC"/>
-                </a:solidFill>
-                <a:latin typeface="Consolas"/>
-              </a:rPr>
-              <a:t>ACT III</a:t>
-            </a:r>
-          </a:p>
-        </p:txBody>
-      </p:sp>
-      <p:sp>
-        <p:nvSpPr>
-          <p:cNvPr id="5" name="TextBox 4"/>
-          <p:cNvSpPr txBox="1"/>
-          <p:nvPr/>
-        </p:nvSpPr>
-        <p:spPr>
-          <a:xfrm>
-            <a:off x="566928" y="1783080"/>
-            <a:ext cx="7223760" cy="1828800"/>
-          </a:xfrm>
-          <a:prstGeom prst="rect">
-            <a:avLst/>
-          </a:prstGeom>
-          <a:noFill/>
-        </p:spPr>
-        <p:txBody>
-          <a:bodyPr wrap="square" lIns="0" rIns="0" tIns="0" bIns="0">
-            <a:spAutoFit/>
-          </a:bodyPr>
-          <a:lstStyle/>
-          <a:p>
-            <a:pPr>
-              <a:lnSpc>
-                <a:spcPct val="102000"/>
-              </a:lnSpc>
-              <a:spcBef>
-                <a:spcPts val="0"/>
-              </a:spcBef>
-              <a:spcAft>
-                <a:spcPts val="0"/>
-              </a:spcAft>
-            </a:pPr>
-            <a:r>
-              <a:rPr sz="4000" b="0" i="0">
-                <a:solidFill>
-                  <a:srgbClr val="FCFCFB"/>
-                </a:solidFill>
-                <a:latin typeface="Georgia"/>
-              </a:rPr>
-              <a:t>What this may imply for how development is measured</a:t>
-            </a:r>
-          </a:p>
-        </p:txBody>
-      </p:sp>
-      <p:sp>
-        <p:nvSpPr>
-          <p:cNvPr id="6" name="TextBox 5"/>
-          <p:cNvSpPr txBox="1"/>
-          <p:nvPr/>
-        </p:nvSpPr>
-        <p:spPr>
-          <a:xfrm>
-            <a:off x="566928" y="3886200"/>
-            <a:ext cx="6766560" cy="1463040"/>
-          </a:xfrm>
-          <a:prstGeom prst="rect">
-            <a:avLst/>
-          </a:prstGeom>
-          <a:noFill/>
-        </p:spPr>
-        <p:txBody>
-          <a:bodyPr wrap="square" lIns="0" rIns="0" tIns="0" bIns="0">
-            <a:spAutoFit/>
-          </a:bodyPr>
-          <a:lstStyle/>
-          <a:p>
-            <a:pPr>
-              <a:lnSpc>
-                <a:spcPct val="135000"/>
-              </a:lnSpc>
-              <a:spcBef>
-                <a:spcPts val="0"/>
-              </a:spcBef>
-              <a:spcAft>
-                <a:spcPts val="0"/>
-              </a:spcAft>
-            </a:pPr>
-            <a:r>
-              <a:rPr sz="1200" b="0" i="1">
-                <a:solidFill>
-                  <a:srgbClr val="9AA4B0"/>
-                </a:solidFill>
-                <a:latin typeface="Georgia"/>
-              </a:rPr>
-              <a:t>These are implications, not recommendations. The frameworks were not built to track wellbeing and it is no criticism of them that they do not; measured against their own purposes they work. What the three results describe is a disconnect — between what development measurement currently captures and what turns out to track individual lived experience. If wellbeing is to be part of what these frameworks are for, education, health and social trust each say something specific about what capturing it would take.</a:t>
-            </a:r>
-          </a:p>
-        </p:txBody>
-      </p:sp>
-      <p:sp>
-        <p:nvSpPr>
-          <p:cNvPr id="7" name="TextBox 6"/>
-          <p:cNvSpPr txBox="1"/>
-          <p:nvPr/>
-        </p:nvSpPr>
-        <p:spPr>
-          <a:xfrm>
-            <a:off x="566928" y="5623560"/>
-            <a:ext cx="3503066" cy="914400"/>
-          </a:xfrm>
-          <a:prstGeom prst="rect">
-            <a:avLst/>
-          </a:prstGeom>
-          <a:noFill/>
-        </p:spPr>
-        <p:txBody>
-          <a:bodyPr wrap="square" lIns="0" rIns="0" tIns="0" bIns="0">
-            <a:spAutoFit/>
-          </a:bodyPr>
-          <a:lstStyle/>
-          <a:p>
-            <a:pPr>
-              <a:spcBef>
-                <a:spcPts val="0"/>
-              </a:spcBef>
-              <a:spcAft>
-                <a:spcPts val="400"/>
-              </a:spcAft>
-            </a:pPr>
-            <a:r>
-              <a:rPr sz="2200" b="0" i="0">
-                <a:solidFill>
-                  <a:srgbClr val="FCFCFB"/>
-                </a:solidFill>
-                <a:latin typeface="Consolas"/>
-              </a:rPr>
-              <a:t>12.7% vs 0.9%</a:t>
-            </a:r>
-          </a:p>
-          <a:p>
-            <a:pPr>
-              <a:lnSpc>
-                <a:spcPct val="120000"/>
-              </a:lnSpc>
-              <a:spcBef>
-                <a:spcPts val="0"/>
-              </a:spcBef>
-              <a:spcAft>
-                <a:spcPts val="0"/>
-              </a:spcAft>
-            </a:pPr>
-            <a:r>
-              <a:rPr sz="1000" b="0" i="0">
-                <a:solidFill>
-                  <a:srgbClr val="8A94A0"/>
-                </a:solidFill>
-                <a:latin typeface="Calibri"/>
-              </a:rPr>
-              <a:t>SDG4 access against measured learning outcomes</a:t>
-            </a:r>
-          </a:p>
-        </p:txBody>
-      </p:sp>
-      <p:sp>
-        <p:nvSpPr>
-          <p:cNvPr id="8" name="TextBox 7"/>
-          <p:cNvSpPr txBox="1"/>
-          <p:nvPr/>
-        </p:nvSpPr>
-        <p:spPr>
-          <a:xfrm>
-            <a:off x="4344314" y="5623560"/>
-            <a:ext cx="3503066" cy="914400"/>
-          </a:xfrm>
-          <a:prstGeom prst="rect">
-            <a:avLst/>
-          </a:prstGeom>
-          <a:noFill/>
-        </p:spPr>
-        <p:txBody>
-          <a:bodyPr wrap="square" lIns="0" rIns="0" tIns="0" bIns="0">
-            <a:spAutoFit/>
-          </a:bodyPr>
-          <a:lstStyle/>
-          <a:p>
-            <a:pPr>
-              <a:spcBef>
-                <a:spcPts val="0"/>
-              </a:spcBef>
-              <a:spcAft>
-                <a:spcPts val="400"/>
-              </a:spcAft>
-            </a:pPr>
-            <a:r>
-              <a:rPr sz="2200" b="0" i="0">
-                <a:solidFill>
-                  <a:srgbClr val="FCFCFB"/>
-                </a:solidFill>
-                <a:latin typeface="Consolas"/>
-              </a:rPr>
-              <a:t>11.2% vs 1.2%</a:t>
-            </a:r>
-          </a:p>
-          <a:p>
-            <a:pPr>
-              <a:lnSpc>
-                <a:spcPct val="120000"/>
-              </a:lnSpc>
-              <a:spcBef>
-                <a:spcPts val="0"/>
-              </a:spcBef>
-              <a:spcAft>
-                <a:spcPts val="0"/>
-              </a:spcAft>
-            </a:pPr>
-            <a:r>
-              <a:rPr sz="1000" b="0" i="0">
-                <a:solidFill>
-                  <a:srgbClr val="8A94A0"/>
-                </a:solidFill>
-                <a:latin typeface="Calibri"/>
-              </a:rPr>
-              <a:t>health vs education, SDG data, high-income countries</a:t>
-            </a:r>
-          </a:p>
-        </p:txBody>
-      </p:sp>
-      <p:sp>
-        <p:nvSpPr>
-          <p:cNvPr id="9" name="TextBox 8"/>
-          <p:cNvSpPr txBox="1"/>
-          <p:nvPr/>
-        </p:nvSpPr>
-        <p:spPr>
-          <a:xfrm>
-            <a:off x="8121700" y="5623560"/>
-            <a:ext cx="3503066" cy="914400"/>
-          </a:xfrm>
-          <a:prstGeom prst="rect">
-            <a:avLst/>
-          </a:prstGeom>
-          <a:noFill/>
-        </p:spPr>
-        <p:txBody>
-          <a:bodyPr wrap="square" lIns="0" rIns="0" tIns="0" bIns="0">
-            <a:spAutoFit/>
-          </a:bodyPr>
-          <a:lstStyle/>
-          <a:p>
-            <a:pPr>
-              <a:spcBef>
-                <a:spcPts val="0"/>
-              </a:spcBef>
-              <a:spcAft>
-                <a:spcPts val="400"/>
-              </a:spcAft>
-            </a:pPr>
-            <a:r>
-              <a:rPr sz="2200" b="0" i="0">
-                <a:solidFill>
-                  <a:srgbClr val="FCFCFB"/>
-                </a:solidFill>
-                <a:latin typeface="Consolas"/>
-              </a:rPr>
-              <a:t>1 of 16</a:t>
-            </a:r>
-          </a:p>
-          <a:p>
-            <a:pPr>
-              <a:lnSpc>
-                <a:spcPct val="120000"/>
-              </a:lnSpc>
-              <a:spcBef>
-                <a:spcPts val="0"/>
-              </a:spcBef>
-              <a:spcAft>
-                <a:spcPts val="0"/>
-              </a:spcAft>
-            </a:pPr>
-            <a:r>
-              <a:rPr sz="1000" b="0" i="0">
-                <a:solidFill>
-                  <a:srgbClr val="8A94A0"/>
-                </a:solidFill>
-                <a:latin typeface="Calibri"/>
-              </a:rPr>
-              <a:t>SDG trust country-series a longitudinal design can use</a:t>
             </a:r>
           </a:p>
         </p:txBody>
@@ -8981,7 +8980,7 @@
                 </a:solidFill>
                 <a:latin typeface="Consolas"/>
               </a:rPr>
-              <a:t>THE DISCONNECT</a:t>
+              <a:t>IMPLICATION 1 · EDUCATION</a:t>
             </a:r>
           </a:p>
         </p:txBody>
@@ -9026,7 +9025,7 @@
                 </a:solidFill>
                 <a:latin typeface="Georgia"/>
               </a:rPr>
-              <a:t>Stating it precisely, and stating what it is not</a:t>
+              <a:t>Which education construct a framework counts turns out to matter</a:t>
             </a:r>
           </a:p>
         </p:txBody>
@@ -9065,13 +9064,13 @@
               </a:spcAft>
             </a:pPr>
             <a:r>
-              <a:rPr sz="1350" b="0" i="0">
+              <a:rPr sz="1400" b="0" i="0">
                 <a:solidFill>
                   <a:srgbClr val="5A6068"/>
                 </a:solidFill>
                 <a:latin typeface="Calibri"/>
               </a:rPr>
-              <a:t>Development indicators tell you reliably where wellbeing is high. They tell you almost nothing about when it will rise. Across every framework tested here, year-on-year indicator movement carries essentially no wellbeing information within the measurement window — a decade or so — and inside countries the domains that lead between them stop leading.</a:t>
+              <a:t>Global education policy has shifted decisively over the past decade from schooling to learning — the learning-crisis framing, learning-poverty targets, an indicator architecture built around measured proficiency. That shift has good reasons behind it that have nothing to do with wellbeing, and this commentary does not dispute them.</a:t>
             </a:r>
           </a:p>
           <a:p>
@@ -9087,13 +9086,13 @@
               </a:spcAft>
             </a:pPr>
             <a:r>
-              <a:rPr sz="1350" b="0" i="0">
+              <a:rPr sz="1400" b="0" i="0">
                 <a:solidFill>
                   <a:srgbClr val="5A6068"/>
                 </a:solidFill>
                 <a:latin typeface="Calibri"/>
               </a:rPr>
-              <a:t>It is worth being explicit about what that is not. It is not an argument that development frameworks should be kept away from wellbeing, or that they have failed. The HDI and the SDGs were built to track development — capability, deprivation, the 2030 Agenda's negotiated priorities — and on those terms they work. Nothing here says otherwise.</a:t>
+              <a:t>It does observe that the wellbeing signal sits elsewhere. Attainment and access carry it — 12.7% for SDG4 access, 40.7% and 34.0% for the HDI's schooling components, 32 of 36 countries at the individual level — while measured learning outcomes sit at 0.9% and parity ratios at 2.5%. A framework that reads SDG4 pooled will conclude education barely matters for wellbeing; one that reads the access series will rank it third of seventeen goals. Same data, same countries.</a:t>
             </a:r>
           </a:p>
           <a:p>
@@ -9109,35 +9108,13 @@
               </a:spcAft>
             </a:pPr>
             <a:r>
-              <a:rPr sz="1350" b="0" i="0">
+              <a:rPr sz="1400" b="0" i="0">
                 <a:solidFill>
                   <a:srgbClr val="5A6068"/>
                 </a:solidFill>
                 <a:latin typeface="Calibri"/>
               </a:rPr>
-              <a:t>What the results describe is a disconnect between two things that are often assumed to move together: what these frameworks currently capture, and what tracks how individuals experience their lives. That assumption is reasonable and mostly untested. Tested, it holds between countries and weakens sharply everywhere else.</a:t>
-            </a:r>
-          </a:p>
-          <a:p>
-            <a:pPr>
-              <a:lnSpc>
-                <a:spcPct val="132000"/>
-              </a:lnSpc>
-              <a:spcBef>
-                <a:spcPts val="0"/>
-              </a:spcBef>
-              <a:spcAft>
-                <a:spcPts val="1100"/>
-              </a:spcAft>
-            </a:pPr>
-            <a:r>
-              <a:rPr sz="1350" b="0" i="0">
-                <a:solidFill>
-                  <a:srgbClr val="5A6068"/>
-                </a:solidFill>
-                <a:latin typeface="Calibri"/>
-              </a:rPr>
-              <a:t>So the useful question is not whether development matters. It is which components of it track lived experience, and whether the frameworks are currently in a position to see them. The next three beats take the three results in turn.</a:t>
+              <a:t>One caution travels with this and it is weaker without it. Education is the most consistent signal across countries and the smallest one within them — significant in 32 to 34 of 36 ESS countries at a median R² of 0.0098. So the implication is about what a global monitoring framework counts, not a claim that any given schooling gain will move a given person’s life satisfaction.</a:t>
             </a:r>
           </a:p>
         </p:txBody>
@@ -9247,7 +9224,7 @@
                 </a:solidFill>
                 <a:latin typeface="Consolas"/>
               </a:rPr>
-              <a:t>IMPLICATION 1 · EDUCATION</a:t>
+              <a:t>IMPLICATION 2 · HEALTH</a:t>
             </a:r>
           </a:p>
         </p:txBody>
@@ -9292,7 +9269,7 @@
                 </a:solidFill>
                 <a:latin typeface="Georgia"/>
               </a:rPr>
-              <a:t>Which education construct a framework counts turns out to matter</a:t>
+              <a:t>A domain can disappear from a framework by being measured where it has stopped moving</a:t>
             </a:r>
           </a:p>
         </p:txBody>
@@ -9337,7 +9314,7 @@
                 </a:solidFill>
                 <a:latin typeface="Calibri"/>
               </a:rPr>
-              <a:t>Global education policy has shifted decisively over the past decade from schooling to learning — the learning-crisis framing, learning-poverty targets, an indicator architecture built around measured proficiency. That shift has good reasons behind it that have nothing to do with wellbeing, and this commentary does not dispute them.</a:t>
+              <a:t>Life expectancy is the standard summary of population health and the HDI's only health input, and it is the weakest of the five against wellbeing. Health is simultaneously the strongest domain in the SDG database and in the individual data. The gap between those two facts is not substantive; it is that life expectancy has largely stopped varying across the countries where it is tested.</a:t>
             </a:r>
           </a:p>
           <a:p>
@@ -9359,7 +9336,7 @@
                 </a:solidFill>
                 <a:latin typeface="Calibri"/>
               </a:rPr>
-              <a:t>It does observe that the wellbeing signal sits elsewhere. Attainment and access carry it — 12.7% for SDG4 access, 40.7% and 34.0% for the HDI's schooling components, 32 of 36 countries at the individual level — while measured learning outcomes sit at 0.9% and parity ratios at 2.5%. A framework that reads SDG4 pooled will conclude education barely matters for wellbeing; one that reads the access series will rank it third of seventeen goals. Same data, same countries.</a:t>
+              <a:t>What still carries health's signal is survival at the margin — child, infant and neonatal mortality, stunting, sanitation, safe water — and, in richer countries, self-rated health, which picks up morbidity and functional limitation that life expectancy cannot see. Both are already collected. The implication is about which of them a framework reads as its health signal in a high-income setting, not about adding a new instrument.</a:t>
             </a:r>
           </a:p>
           <a:p>
@@ -9381,7 +9358,7 @@
                 </a:solidFill>
                 <a:latin typeface="Calibri"/>
               </a:rPr>
-              <a:t>One caution travels with this and it is weaker without it. Education is the most consistent signal across countries and the smallest one within them — significant in 32 to 34 of 36 ESS countries at a median R² of 0.0098. So the implication is about what a global monitoring framework counts, not a claim that any given schooling gain will move a given person’s life satisfaction.</a:t>
+              <a:t>Health is also the domain where the frameworks disagree with each other most sharply — first in the SDG database, last in the HDI — which makes it the clearest case that the disagreement is about the variable rather than about the world.</a:t>
             </a:r>
           </a:p>
         </p:txBody>
@@ -9491,7 +9468,7 @@
                 </a:solidFill>
                 <a:latin typeface="Consolas"/>
               </a:rPr>
-              <a:t>IMPLICATION 2 · HEALTH</a:t>
+              <a:t>IMPLICATION 3 · COVERAGE</a:t>
             </a:r>
           </a:p>
         </p:txBody>
@@ -9536,7 +9513,7 @@
                 </a:solidFill>
                 <a:latin typeface="Georgia"/>
               </a:rPr>
-              <a:t>A domain can disappear from a framework by being measured where it has stopped moving</a:t>
+              <a:t>The third failure mode is the one no indicator choice can fix</a:t>
             </a:r>
           </a:p>
         </p:txBody>
@@ -9581,7 +9558,7 @@
                 </a:solidFill>
                 <a:latin typeface="Calibri"/>
               </a:rPr>
-              <a:t>Life expectancy is the standard summary of population health and the HDI's only health input, and it is the weakest of the five against wellbeing. Health is simultaneously the strongest domain in the SDG database and in the individual data. The gap between those two facts is not substantive; it is that life expectancy has largely stopped varying across the countries where it is tested.</a:t>
+              <a:t>Education's and health's implications are both about which variable a framework reads. Coverage is a different kind of problem: no choice among existing indicators fixes it, because the observations were never collected. The HDI and subnational HDI do not measure social trust at all; the SDG framework's 13 satisfaction and integrity series average one observation per country, which supports no longitudinal design.</a:t>
             </a:r>
           </a:p>
           <a:p>
@@ -9603,7 +9580,7 @@
                 </a:solidFill>
                 <a:latin typeface="Calibri"/>
               </a:rPr>
-              <a:t>What still carries health's signal is survival at the margin — child, infant and neonatal mortality, stunting, sanitation, safe water — and, in richer countries, self-rated health, which picks up morbidity and functional limitation that life expectancy cannot see. Both are already collected. The implication is about which of them a framework reads as its health signal in a high-income setting, not about adding a new instrument.</a:t>
+              <a:t>We did not stop at asserting that. Act II runs those series the only way their coverage permits — across countries rather than years — and 9 are testable, 4 significant, and all four land below the HDI's own components on the same countries. The gap is established rather than assumed.</a:t>
             </a:r>
           </a:p>
           <a:p>
@@ -9625,7 +9602,7 @@
                 </a:solidFill>
                 <a:latin typeface="Calibri"/>
               </a:rPr>
-              <a:t>Health is also the domain where the frameworks disagree with each other most sharply — first in the SDG database, last in the HDI — which makes it the clearest case that the disagreement is about the variable rather than about the world.</a:t>
+              <a:t>This is the most tentative of the three implications and should be presented that way: trust's own evidence is one instrument, in Europe, with a live shared-method caveat. What can be said is narrow and still useful. A component that performs this well wherever it is measured is invisible to development measurement for reasons of coverage, not because it was weighed and found wanting — and a repeated generalised-trust item, already standard in the ESS, the World Values Survey and several national statistical series, would be enough to find out.</a:t>
             </a:r>
           </a:p>
         </p:txBody>
@@ -9735,7 +9712,7 @@
                 </a:solidFill>
                 <a:latin typeface="Consolas"/>
               </a:rPr>
-              <a:t>IMPLICATION 3 · SOCIAL TRUST</a:t>
+              <a:t>WHAT WE CANNOT SAY</a:t>
             </a:r>
           </a:p>
         </p:txBody>
@@ -9780,7 +9757,7 @@
                 </a:solidFill>
                 <a:latin typeface="Georgia"/>
               </a:rPr>
-              <a:t>A component that looks important, and that no framework is currently positioned to check</a:t>
+              <a:t>Three limits that keep this a question rather than a recommendation</a:t>
             </a:r>
           </a:p>
         </p:txBody>
@@ -9825,7 +9802,7 @@
                 </a:solidFill>
                 <a:latin typeface="Calibri"/>
               </a:rPr>
-              <a:t>Social trust is significant in 34 of 36 ESS countries, and no development framework can currently check it. The HDI and subnational HDI do not measure the construct. The SDG framework's 13 satisfaction and integrity series average one observation per country, which supports no longitudinal design.</a:t>
+              <a:t>None of this is causal. The design is correlational throughout, and the levels results in particular are cross-sectional comparisons between countries.</a:t>
             </a:r>
           </a:p>
           <a:p>
@@ -9847,7 +9824,7 @@
                 </a:solidFill>
                 <a:latin typeface="Calibri"/>
               </a:rPr>
-              <a:t>We did not stop at asserting that. Act II runs those series the only way their coverage permits, across countries rather than years: 9 are testable, 4 significant, and all four land below the HDI's own components on the same countries. So the gap is a real gap, established rather than assumed.</a:t>
+              <a:t>Schooling cannot be separated from what schooling stands in for. Years attained proxy labour-market position, economic security, autonomy, and social standing, and this design cannot pull them apart. Individual effects are small: a median R² near 0.01.</a:t>
             </a:r>
           </a:p>
           <a:p>
@@ -9869,7 +9846,29 @@
                 </a:solidFill>
                 <a:latin typeface="Calibri"/>
               </a:rPr>
-              <a:t>The implication is the most tentative of the three, and should be presented that way. Trust rests on one instrument, in Europe, with a live shared-method caveat. What can be said is narrow and still useful: a component that performs this well wherever it is measured is currently invisible to development measurement, and it is invisible for reasons of coverage rather than because it was weighed and found wanting. A repeated generalised-trust item — already standard in the ESS, the World Values Survey and several national statistical series — would be enough to find out.</a:t>
+              <a:t>The individual-level results are Europe-only. The ESS is the second wellbeing instrument the whole replication rests on, and it covers 36 European countries — so where the commentary says two instruments agree, that agreement is demonstrated in Europe and assumed elsewhere. That belongs in the text as a scope condition rather than buried in a limitations paragraph.</a:t>
+            </a:r>
+          </a:p>
+          <a:p>
+            <a:pPr>
+              <a:lnSpc>
+                <a:spcPct val="132000"/>
+              </a:lnSpc>
+              <a:spcBef>
+                <a:spcPts val="0"/>
+              </a:spcBef>
+              <a:spcAft>
+                <a:spcPts val="1100"/>
+              </a:spcAft>
+            </a:pPr>
+            <a:r>
+              <a:rPr sz="1400" b="0" i="0">
+                <a:solidFill>
+                  <a:srgbClr val="5A6068"/>
+                </a:solidFill>
+                <a:latin typeface="Calibri"/>
+              </a:rPr>
+              <a:t>Some of the parity and learning indicators' weakness is coverage rather than construct — they are the youngest and thinnest series in the SDG database, and thin series fail significance tests for uninteresting reasons. The commentary should concede this explicitly and say what would settle it.</a:t>
             </a:r>
           </a:p>
         </p:txBody>
@@ -10415,7 +10414,7 @@
                 </a:solidFill>
                 <a:latin typeface="Consolas"/>
               </a:rPr>
-              <a:t>WHAT WE CANNOT SAY</a:t>
+              <a:t>WHERE THIS LEAVES IT</a:t>
             </a:r>
           </a:p>
         </p:txBody>
@@ -10460,7 +10459,7 @@
                 </a:solidFill>
                 <a:latin typeface="Georgia"/>
               </a:rPr>
-              <a:t>Three limits that keep this a question rather than a recommendation</a:t>
+              <a:t>Development frameworks may need to work harder at capturing what shapes lived experience</a:t>
             </a:r>
           </a:p>
         </p:txBody>
@@ -10505,7 +10504,7 @@
                 </a:solidFill>
                 <a:latin typeface="Calibri"/>
               </a:rPr>
-              <a:t>None of this is causal. The design is correlational throughout, and the levels results in particular are cross-sectional comparisons between countries.</a:t>
+              <a:t>That is the conclusion, and it is deliberately exploratory. Three components look consequential for how individuals experience their lives — education, health, social trust — and each is currently captured in a way that makes it hard for a development framework to see. Education is pooled with constructs that point the other way. Health is read through a variable that has largely stopped moving. Social trust is not measured with the coverage any longitudinal design requires.</a:t>
             </a:r>
           </a:p>
           <a:p>
@@ -10527,7 +10526,7 @@
                 </a:solidFill>
                 <a:latin typeface="Calibri"/>
               </a:rPr>
-              <a:t>Schooling cannot be separated from what schooling stands in for. Years attained proxy labour-market position, economic security, autonomy, and social standing, and this design cannot pull them apart. Individual effects are small: a median R² near 0.01.</a:t>
+              <a:t>None of that is a demand that these frameworks become wellbeing instruments. It is the narrower observation that if wellbeing is to inform what development measurement counts — and the post-2030 conversation suggests it may — then the first question is not which domain to prioritise but whether each is being measured somewhere it can still move. On the evidence here, for at least two of the three, it is not.</a:t>
             </a:r>
           </a:p>
           <a:p>
@@ -10549,29 +10548,7 @@
                 </a:solidFill>
                 <a:latin typeface="Calibri"/>
               </a:rPr>
-              <a:t>The individual-level results are Europe-only. The ESS is the second wellbeing instrument the whole replication rests on, and it covers 36 European countries — so where the commentary says two instruments agree, that agreement is demonstrated in Europe and assumed elsewhere. That belongs in the text as a scope condition rather than buried in a limitations paragraph.</a:t>
-            </a:r>
-          </a:p>
-          <a:p>
-            <a:pPr>
-              <a:lnSpc>
-                <a:spcPct val="132000"/>
-              </a:lnSpc>
-              <a:spcBef>
-                <a:spcPts val="0"/>
-              </a:spcBef>
-              <a:spcAft>
-                <a:spcPts val="1100"/>
-              </a:spcAft>
-            </a:pPr>
-            <a:r>
-              <a:rPr sz="1400" b="0" i="0">
-                <a:solidFill>
-                  <a:srgbClr val="5A6068"/>
-                </a:solidFill>
-                <a:latin typeface="Calibri"/>
-              </a:rPr>
-              <a:t>Some of the parity and learning indicators' weakness is coverage rather than construct — they are the youngest and thinnest series in the SDG database, and thin series fail significance tests for uninteresting reasons. The commentary should concede this explicitly and say what would settle it.</a:t>
+              <a:t>The honest form of the ask is a question rather than a prescription: what would a development framework look like if the components that track individual lived experience were among the things it was built to capture? A commentary cannot answer that. It can show that the question is not rhetorical, and put the evidence on the record so the field can take it up.</a:t>
             </a:r>
           </a:p>
         </p:txBody>
@@ -10627,6 +10604,163 @@
 </file>
 
 <file path=ppt/slides/slide31.xml><?xml version="1.0" encoding="utf-8"?>
+<p:sld xmlns:a="http://schemas.openxmlformats.org/drawingml/2006/main" xmlns:p="http://schemas.openxmlformats.org/presentationml/2006/main" xmlns:r="http://schemas.openxmlformats.org/officeDocument/2006/relationships">
+  <p:cSld>
+    <p:bg>
+      <p:bgPr>
+        <a:solidFill>
+          <a:srgbClr val="E8EBEF"/>
+        </a:solidFill>
+        <a:effectLst/>
+      </p:bgPr>
+    </p:bg>
+    <p:spTree>
+      <p:nvGrpSpPr>
+        <p:cNvPr id="1" name=""/>
+        <p:cNvGrpSpPr/>
+        <p:nvPr/>
+      </p:nvGrpSpPr>
+      <p:grpSpPr/>
+      <p:sp>
+        <p:nvSpPr>
+          <p:cNvPr id="2" name="Rectangle 1"/>
+          <p:cNvSpPr/>
+          <p:nvPr/>
+        </p:nvSpPr>
+        <p:spPr>
+          <a:xfrm>
+            <a:off x="566928" y="2103120"/>
+            <a:ext cx="54864" cy="2377440"/>
+          </a:xfrm>
+          <a:prstGeom prst="rect">
+            <a:avLst/>
+          </a:prstGeom>
+          <a:solidFill>
+            <a:srgbClr val="17549E"/>
+          </a:solidFill>
+          <a:ln>
+            <a:noFill/>
+          </a:ln>
+          <a:effectLst/>
+        </p:spPr>
+        <p:style>
+          <a:lnRef idx="1">
+            <a:schemeClr val="accent1"/>
+          </a:lnRef>
+          <a:fillRef idx="3">
+            <a:schemeClr val="accent1"/>
+          </a:fillRef>
+          <a:effectRef idx="2">
+            <a:schemeClr val="accent1"/>
+          </a:effectRef>
+          <a:fontRef idx="minor">
+            <a:schemeClr val="lt1"/>
+          </a:fontRef>
+        </p:style>
+        <p:txBody>
+          <a:bodyPr rtlCol="0" anchor="ctr"/>
+          <a:lstStyle/>
+          <a:p>
+            <a:pPr algn="ctr"/>
+          </a:p>
+        </p:txBody>
+      </p:sp>
+      <p:sp>
+        <p:nvSpPr>
+          <p:cNvPr id="3" name="TextBox 2"/>
+          <p:cNvSpPr txBox="1"/>
+          <p:nvPr/>
+        </p:nvSpPr>
+        <p:spPr>
+          <a:xfrm>
+            <a:off x="914400" y="1600200"/>
+            <a:ext cx="8686800" cy="274320"/>
+          </a:xfrm>
+          <a:prstGeom prst="rect">
+            <a:avLst/>
+          </a:prstGeom>
+          <a:noFill/>
+        </p:spPr>
+        <p:txBody>
+          <a:bodyPr wrap="square" lIns="0" rIns="0" tIns="0" bIns="0">
+            <a:spAutoFit/>
+          </a:bodyPr>
+          <a:lstStyle/>
+          <a:p>
+            <a:pPr>
+              <a:spcBef>
+                <a:spcPts val="0"/>
+              </a:spcBef>
+              <a:spcAft>
+                <a:spcPts val="0"/>
+              </a:spcAft>
+            </a:pPr>
+            <a:r>
+              <a:rPr sz="1100" b="0" i="0">
+                <a:solidFill>
+                  <a:srgbClr val="17549E"/>
+                </a:solidFill>
+                <a:latin typeface="Consolas"/>
+              </a:rPr>
+              <a:t>WHERE ACT III LEAVES US</a:t>
+            </a:r>
+          </a:p>
+        </p:txBody>
+      </p:sp>
+      <p:sp>
+        <p:nvSpPr>
+          <p:cNvPr id="4" name="TextBox 3"/>
+          <p:cNvSpPr txBox="1"/>
+          <p:nvPr/>
+        </p:nvSpPr>
+        <p:spPr>
+          <a:xfrm>
+            <a:off x="914400" y="2148840"/>
+            <a:ext cx="9509760" cy="2926080"/>
+          </a:xfrm>
+          <a:prstGeom prst="rect">
+            <a:avLst/>
+          </a:prstGeom>
+          <a:noFill/>
+        </p:spPr>
+        <p:txBody>
+          <a:bodyPr wrap="square" lIns="0" rIns="0" tIns="0" bIns="0">
+            <a:spAutoFit/>
+          </a:bodyPr>
+          <a:lstStyle/>
+          <a:p>
+            <a:pPr>
+              <a:lnSpc>
+                <a:spcPct val="135000"/>
+              </a:lnSpc>
+              <a:spcBef>
+                <a:spcPts val="0"/>
+              </a:spcBef>
+              <a:spcAft>
+                <a:spcPts val="0"/>
+              </a:spcAft>
+            </a:pPr>
+            <a:r>
+              <a:rPr sz="2100" b="0" i="0">
+                <a:solidFill>
+                  <a:srgbClr val="14171C"/>
+                </a:solidFill>
+                <a:latin typeface="Georgia"/>
+              </a:rPr>
+              <a:t>The recommended framing for submission: lead with education as the positive finding, use the generalised collapse as the backdrop that makes it surprising, and close on the disconnect rather than on a list of fixes. That ordering makes Act I load-bearing without making it the story, and it keeps the paper on the ground it can actually defend — that these components look like they matter for lived experience, and that development measurement is not currently arranged to see them.</a:t>
+            </a:r>
+          </a:p>
+        </p:txBody>
+      </p:sp>
+    </p:spTree>
+  </p:cSld>
+  <p:clrMapOvr>
+    <a:masterClrMapping/>
+  </p:clrMapOvr>
+</p:sld>
+</file>
+
+<file path=ppt/slides/slide32.xml><?xml version="1.0" encoding="utf-8"?>
 <p:sld xmlns:a="http://schemas.openxmlformats.org/drawingml/2006/main" xmlns:p="http://schemas.openxmlformats.org/presentationml/2006/main" xmlns:r="http://schemas.openxmlformats.org/officeDocument/2006/relationships">
   <p:cSld>
     <p:bg>
@@ -10653,251 +10787,68 @@
         <p:spPr>
           <a:xfrm>
             <a:off x="566928" y="502920"/>
-            <a:ext cx="8595360" cy="274320"/>
-          </a:xfrm>
-          <a:prstGeom prst="rect">
-            <a:avLst/>
-          </a:prstGeom>
-          <a:noFill/>
-        </p:spPr>
-        <p:txBody>
-          <a:bodyPr wrap="square" lIns="0" rIns="0" tIns="0" bIns="0">
-            <a:spAutoFit/>
-          </a:bodyPr>
-          <a:lstStyle/>
-          <a:p>
-            <a:pPr>
-              <a:spcBef>
-                <a:spcPts val="0"/>
-              </a:spcBef>
-              <a:spcAft>
-                <a:spcPts val="0"/>
-              </a:spcAft>
-            </a:pPr>
-            <a:r>
-              <a:rPr sz="1000" b="0" i="0">
-                <a:solidFill>
-                  <a:srgbClr val="A63A30"/>
-                </a:solidFill>
-                <a:latin typeface="Consolas"/>
-              </a:rPr>
-              <a:t>WHERE THIS LEAVES IT</a:t>
-            </a:r>
-          </a:p>
-        </p:txBody>
-      </p:sp>
-      <p:sp>
-        <p:nvSpPr>
-          <p:cNvPr id="3" name="TextBox 2"/>
-          <p:cNvSpPr txBox="1"/>
-          <p:nvPr/>
-        </p:nvSpPr>
-        <p:spPr>
-          <a:xfrm>
-            <a:off x="566928" y="914400"/>
-            <a:ext cx="8595360" cy="1371600"/>
-          </a:xfrm>
-          <a:prstGeom prst="rect">
-            <a:avLst/>
-          </a:prstGeom>
-          <a:noFill/>
-        </p:spPr>
-        <p:txBody>
-          <a:bodyPr wrap="square" lIns="0" rIns="0" tIns="0" bIns="0">
-            <a:spAutoFit/>
-          </a:bodyPr>
-          <a:lstStyle/>
-          <a:p>
-            <a:pPr>
-              <a:lnSpc>
-                <a:spcPct val="108000"/>
-              </a:lnSpc>
-              <a:spcBef>
-                <a:spcPts val="0"/>
-              </a:spcBef>
-              <a:spcAft>
-                <a:spcPts val="0"/>
-              </a:spcAft>
-            </a:pPr>
-            <a:r>
-              <a:rPr sz="2700" b="0" i="0">
+            <a:ext cx="8229600" cy="822960"/>
+          </a:xfrm>
+          <a:prstGeom prst="rect">
+            <a:avLst/>
+          </a:prstGeom>
+          <a:noFill/>
+        </p:spPr>
+        <p:txBody>
+          <a:bodyPr wrap="square" lIns="0" rIns="0" tIns="0" bIns="0">
+            <a:spAutoFit/>
+          </a:bodyPr>
+          <a:lstStyle/>
+          <a:p>
+            <a:pPr>
+              <a:spcBef>
+                <a:spcPts val="0"/>
+              </a:spcBef>
+              <a:spcAft>
+                <a:spcPts val="600"/>
+              </a:spcAft>
+            </a:pPr>
+            <a:r>
+              <a:rPr sz="3200" b="0" i="0">
                 <a:solidFill>
                   <a:srgbClr val="14171C"/>
                 </a:solidFill>
                 <a:latin typeface="Georgia"/>
               </a:rPr>
-              <a:t>Development frameworks may need to work harder at capturing what shapes lived experience</a:t>
-            </a:r>
-          </a:p>
-        </p:txBody>
-      </p:sp>
-      <p:sp>
-        <p:nvSpPr>
-          <p:cNvPr id="4" name="TextBox 3"/>
-          <p:cNvSpPr txBox="1"/>
-          <p:nvPr/>
-        </p:nvSpPr>
-        <p:spPr>
-          <a:xfrm>
-            <a:off x="566928" y="2286000"/>
-            <a:ext cx="8595360" cy="3840480"/>
-          </a:xfrm>
-          <a:prstGeom prst="rect">
-            <a:avLst/>
-          </a:prstGeom>
-          <a:noFill/>
-        </p:spPr>
-        <p:txBody>
-          <a:bodyPr wrap="square" lIns="0" rIns="0" tIns="0" bIns="0">
-            <a:spAutoFit/>
-          </a:bodyPr>
-          <a:lstStyle/>
-          <a:p>
-            <a:pPr>
-              <a:lnSpc>
-                <a:spcPct val="132000"/>
-              </a:lnSpc>
-              <a:spcBef>
-                <a:spcPts val="0"/>
-              </a:spcBef>
-              <a:spcAft>
-                <a:spcPts val="1100"/>
-              </a:spcAft>
-            </a:pPr>
-            <a:r>
-              <a:rPr sz="1400" b="0" i="0">
+              <a:t>Decisions for the team</a:t>
+            </a:r>
+          </a:p>
+          <a:p>
+            <a:pPr>
+              <a:spcBef>
+                <a:spcPts val="0"/>
+              </a:spcBef>
+              <a:spcAft>
+                <a:spcPts val="0"/>
+              </a:spcAft>
+            </a:pPr>
+            <a:r>
+              <a:rPr sz="1300" b="0" i="0">
                 <a:solidFill>
                   <a:srgbClr val="5A6068"/>
                 </a:solidFill>
                 <a:latin typeface="Calibri"/>
               </a:rPr>
-              <a:t>That is the conclusion, and it is deliberately exploratory. Three components look consequential for how individuals experience their lives — education, health, social trust — and each is currently captured in a way that makes it hard for a development framework to see. Education is pooled with constructs that point the other way. Health is read through a variable that has largely stopped moving. Social trust is not measured with the coverage any longitudinal design requires.</a:t>
-            </a:r>
-          </a:p>
-          <a:p>
-            <a:pPr>
-              <a:lnSpc>
-                <a:spcPct val="132000"/>
-              </a:lnSpc>
-              <a:spcBef>
-                <a:spcPts val="0"/>
-              </a:spcBef>
-              <a:spcAft>
-                <a:spcPts val="1100"/>
-              </a:spcAft>
-            </a:pPr>
-            <a:r>
-              <a:rPr sz="1400" b="0" i="0">
-                <a:solidFill>
-                  <a:srgbClr val="5A6068"/>
-                </a:solidFill>
-                <a:latin typeface="Calibri"/>
-              </a:rPr>
-              <a:t>None of that is a demand that these frameworks become wellbeing instruments. It is the narrower observation that if wellbeing is to inform what development measurement counts — and the post-2030 conversation suggests it may — then the first question is not which domain to prioritise but whether each is being measured somewhere it can still move. On the evidence here, for at least two of the three, it is not.</a:t>
-            </a:r>
-          </a:p>
-          <a:p>
-            <a:pPr>
-              <a:lnSpc>
-                <a:spcPct val="132000"/>
-              </a:lnSpc>
-              <a:spcBef>
-                <a:spcPts val="0"/>
-              </a:spcBef>
-              <a:spcAft>
-                <a:spcPts val="1100"/>
-              </a:spcAft>
-            </a:pPr>
-            <a:r>
-              <a:rPr sz="1400" b="0" i="0">
-                <a:solidFill>
-                  <a:srgbClr val="5A6068"/>
-                </a:solidFill>
-                <a:latin typeface="Calibri"/>
-              </a:rPr>
-              <a:t>The honest form of the ask is a question rather than a prescription: what would a development framework look like if the components that track individual lived experience were among the things it was built to capture? A commentary cannot answer that. It can show that the question is not rhetorical, and put the evidence on the record so the field can take it up.</a:t>
-            </a:r>
-          </a:p>
-        </p:txBody>
-      </p:sp>
-      <p:sp>
-        <p:nvSpPr>
-          <p:cNvPr id="5" name="TextBox 4"/>
-          <p:cNvSpPr txBox="1"/>
-          <p:nvPr/>
-        </p:nvSpPr>
-        <p:spPr>
-          <a:xfrm>
-            <a:off x="11338560" y="6263640"/>
-            <a:ext cx="548640" cy="274320"/>
-          </a:xfrm>
-          <a:prstGeom prst="rect">
-            <a:avLst/>
-          </a:prstGeom>
-          <a:noFill/>
-        </p:spPr>
-        <p:txBody>
-          <a:bodyPr wrap="square" lIns="0" rIns="0" tIns="0" bIns="0">
-            <a:spAutoFit/>
-          </a:bodyPr>
-          <a:lstStyle/>
-          <a:p>
-            <a:pPr algn="r">
-              <a:spcBef>
-                <a:spcPts val="0"/>
-              </a:spcBef>
-              <a:spcAft>
-                <a:spcPts val="0"/>
-              </a:spcAft>
-            </a:pPr>
-            <a:r>
-              <a:rPr sz="1100" b="0" i="0">
-                <a:solidFill>
-                  <a:srgbClr val="868D96"/>
-                </a:solidFill>
-                <a:latin typeface="Consolas"/>
-              </a:rPr>
-              <a:t>III</a:t>
-            </a:r>
-          </a:p>
-        </p:txBody>
-      </p:sp>
-    </p:spTree>
-  </p:cSld>
-  <p:clrMapOvr>
-    <a:masterClrMapping/>
-  </p:clrMapOvr>
-</p:sld>
-</file>
-
-<file path=ppt/slides/slide32.xml><?xml version="1.0" encoding="utf-8"?>
-<p:sld xmlns:a="http://schemas.openxmlformats.org/drawingml/2006/main" xmlns:p="http://schemas.openxmlformats.org/presentationml/2006/main" xmlns:r="http://schemas.openxmlformats.org/officeDocument/2006/relationships">
-  <p:cSld>
-    <p:bg>
-      <p:bgPr>
-        <a:solidFill>
-          <a:srgbClr val="E8EBEF"/>
-        </a:solidFill>
-        <a:effectLst/>
-      </p:bgPr>
-    </p:bg>
-    <p:spTree>
-      <p:nvGrpSpPr>
-        <p:cNvPr id="1" name=""/>
-        <p:cNvGrpSpPr/>
-        <p:nvPr/>
-      </p:nvGrpSpPr>
-      <p:grpSpPr/>
-      <p:sp>
-        <p:nvSpPr>
-          <p:cNvPr id="2" name="Rectangle 1"/>
+              <a:t>6 things the acts do not settle, in the order they block drafting.</a:t>
+            </a:r>
+          </a:p>
+        </p:txBody>
+      </p:sp>
+      <p:sp>
+        <p:nvSpPr>
+          <p:cNvPr id="3" name="Rectangle 2"/>
           <p:cNvSpPr/>
           <p:nvPr/>
         </p:nvSpPr>
         <p:spPr>
           <a:xfrm>
-            <a:off x="566928" y="2103120"/>
-            <a:ext cx="54864" cy="2377440"/>
+            <a:off x="566928" y="1828800"/>
+            <a:ext cx="3472586" cy="25400"/>
           </a:xfrm>
           <a:prstGeom prst="rect">
             <a:avLst/>
@@ -10934,27 +10885,49 @@
       </p:sp>
       <p:sp>
         <p:nvSpPr>
-          <p:cNvPr id="3" name="TextBox 2"/>
-          <p:cNvSpPr txBox="1"/>
-          <p:nvPr/>
-        </p:nvSpPr>
-        <p:spPr>
-          <a:xfrm>
-            <a:off x="914400" y="1600200"/>
-            <a:ext cx="8686800" cy="274320"/>
-          </a:xfrm>
-          <a:prstGeom prst="rect">
-            <a:avLst/>
-          </a:prstGeom>
-          <a:noFill/>
-        </p:spPr>
-        <p:txBody>
-          <a:bodyPr wrap="square" lIns="0" rIns="0" tIns="0" bIns="0">
-            <a:spAutoFit/>
-          </a:bodyPr>
-          <a:lstStyle/>
-          <a:p>
-            <a:pPr>
+          <p:cNvPr id="4" name="TextBox 3"/>
+          <p:cNvSpPr txBox="1"/>
+          <p:nvPr/>
+        </p:nvSpPr>
+        <p:spPr>
+          <a:xfrm>
+            <a:off x="566928" y="2011680"/>
+            <a:ext cx="3472586" cy="1828800"/>
+          </a:xfrm>
+          <a:prstGeom prst="rect">
+            <a:avLst/>
+          </a:prstGeom>
+          <a:noFill/>
+        </p:spPr>
+        <p:txBody>
+          <a:bodyPr wrap="square" lIns="0" rIns="0" tIns="0" bIns="0">
+            <a:spAutoFit/>
+          </a:bodyPr>
+          <a:lstStyle/>
+          <a:p>
+            <a:pPr>
+              <a:spcBef>
+                <a:spcPts val="0"/>
+              </a:spcBef>
+              <a:spcAft>
+                <a:spcPts val="700"/>
+              </a:spcAft>
+            </a:pPr>
+            <a:r>
+              <a:rPr sz="1050" b="0" i="0">
+                <a:solidFill>
+                  <a:srgbClr val="17549E"/>
+                </a:solidFill>
+                <a:latin typeface="Consolas"/>
+              </a:rPr>
+              <a:t>FRAMING</a:t>
+            </a:r>
+          </a:p>
+          <a:p>
+            <a:pPr>
+              <a:lnSpc>
+                <a:spcPct val="130000"/>
+              </a:lnSpc>
               <a:spcBef>
                 <a:spcPts val="0"/>
               </a:spcBef>
@@ -10965,40 +10938,103 @@
             <a:r>
               <a:rPr sz="1100" b="0" i="0">
                 <a:solidFill>
+                  <a:srgbClr val="5A6068"/>
+                </a:solidFill>
+                <a:latin typeface="Calibri"/>
+              </a:rPr>
+              <a:t>Lead with education and use the generalised collapse as Act I backdrop — recommended — or lead with the robustness result and treat education as the coda. This decides title, abstract, and venue.</a:t>
+            </a:r>
+          </a:p>
+        </p:txBody>
+      </p:sp>
+      <p:sp>
+        <p:nvSpPr>
+          <p:cNvPr id="5" name="Rectangle 4"/>
+          <p:cNvSpPr/>
+          <p:nvPr/>
+        </p:nvSpPr>
+        <p:spPr>
+          <a:xfrm>
+            <a:off x="4359554" y="1828800"/>
+            <a:ext cx="3472586" cy="25400"/>
+          </a:xfrm>
+          <a:prstGeom prst="rect">
+            <a:avLst/>
+          </a:prstGeom>
+          <a:solidFill>
+            <a:srgbClr val="17549E"/>
+          </a:solidFill>
+          <a:ln>
+            <a:noFill/>
+          </a:ln>
+          <a:effectLst/>
+        </p:spPr>
+        <p:style>
+          <a:lnRef idx="1">
+            <a:schemeClr val="accent1"/>
+          </a:lnRef>
+          <a:fillRef idx="3">
+            <a:schemeClr val="accent1"/>
+          </a:fillRef>
+          <a:effectRef idx="2">
+            <a:schemeClr val="accent1"/>
+          </a:effectRef>
+          <a:fontRef idx="minor">
+            <a:schemeClr val="lt1"/>
+          </a:fontRef>
+        </p:style>
+        <p:txBody>
+          <a:bodyPr rtlCol="0" anchor="ctr"/>
+          <a:lstStyle/>
+          <a:p>
+            <a:pPr algn="ctr"/>
+          </a:p>
+        </p:txBody>
+      </p:sp>
+      <p:sp>
+        <p:nvSpPr>
+          <p:cNvPr id="6" name="TextBox 5"/>
+          <p:cNvSpPr txBox="1"/>
+          <p:nvPr/>
+        </p:nvSpPr>
+        <p:spPr>
+          <a:xfrm>
+            <a:off x="4359554" y="2011680"/>
+            <a:ext cx="3472586" cy="1828800"/>
+          </a:xfrm>
+          <a:prstGeom prst="rect">
+            <a:avLst/>
+          </a:prstGeom>
+          <a:noFill/>
+        </p:spPr>
+        <p:txBody>
+          <a:bodyPr wrap="square" lIns="0" rIns="0" tIns="0" bIns="0">
+            <a:spAutoFit/>
+          </a:bodyPr>
+          <a:lstStyle/>
+          <a:p>
+            <a:pPr>
+              <a:spcBef>
+                <a:spcPts val="0"/>
+              </a:spcBef>
+              <a:spcAft>
+                <a:spcPts val="700"/>
+              </a:spcAft>
+            </a:pPr>
+            <a:r>
+              <a:rPr sz="1050" b="0" i="0">
+                <a:solidFill>
                   <a:srgbClr val="17549E"/>
                 </a:solidFill>
                 <a:latin typeface="Consolas"/>
               </a:rPr>
-              <a:t>WHERE ACT III LEAVES US</a:t>
-            </a:r>
-          </a:p>
-        </p:txBody>
-      </p:sp>
-      <p:sp>
-        <p:nvSpPr>
-          <p:cNvPr id="4" name="TextBox 3"/>
-          <p:cNvSpPr txBox="1"/>
-          <p:nvPr/>
-        </p:nvSpPr>
-        <p:spPr>
-          <a:xfrm>
-            <a:off x="914400" y="2148840"/>
-            <a:ext cx="9509760" cy="2926080"/>
-          </a:xfrm>
-          <a:prstGeom prst="rect">
-            <a:avLst/>
-          </a:prstGeom>
-          <a:noFill/>
-        </p:spPr>
-        <p:txBody>
-          <a:bodyPr wrap="square" lIns="0" rIns="0" tIns="0" bIns="0">
-            <a:spAutoFit/>
-          </a:bodyPr>
-          <a:lstStyle/>
+              <a:t>HOW HARD TO PUSH THE CONCLUSION</a:t>
+            </a:r>
+          </a:p>
           <a:p>
             <a:pPr>
               <a:lnSpc>
-                <a:spcPct val="135000"/>
+                <a:spcPct val="130000"/>
               </a:lnSpc>
               <a:spcBef>
                 <a:spcPts val="0"/>
@@ -11008,13 +11044,445 @@
               </a:spcAft>
             </a:pPr>
             <a:r>
-              <a:rPr sz="2100" b="0" i="0">
-                <a:solidFill>
-                  <a:srgbClr val="14171C"/>
-                </a:solidFill>
-                <a:latin typeface="Georgia"/>
-              </a:rPr>
-              <a:t>The recommended framing for submission: lead with education as the positive finding, use the generalised collapse as the backdrop that makes it surprising, and close on the disconnect rather than on a list of fixes. That ordering makes Act I load-bearing without making it the story, and it keeps the paper on the ground it can actually defend — that these components look like they matter for lived experience, and that development measurement is not currently arranged to see them.</a:t>
+              <a:rPr sz="1100" b="0" i="0">
+                <a:solidFill>
+                  <a:srgbClr val="5A6068"/>
+                </a:solidFill>
+                <a:latin typeface="Calibri"/>
+              </a:rPr>
+              <a:t>Act III now lands on a disconnect and an exploratory ask rather than a list of fixes: these components look like they matter for lived experience, and development measurement is not currently arranged to see them. Is that the right altitude for the venue, or should the health and education implications be sharpened into named recommendations? The evidence supports either; the framing does not change the analysis.</a:t>
+            </a:r>
+          </a:p>
+        </p:txBody>
+      </p:sp>
+      <p:sp>
+        <p:nvSpPr>
+          <p:cNvPr id="7" name="Rectangle 6"/>
+          <p:cNvSpPr/>
+          <p:nvPr/>
+        </p:nvSpPr>
+        <p:spPr>
+          <a:xfrm>
+            <a:off x="8152180" y="1828800"/>
+            <a:ext cx="3472586" cy="25400"/>
+          </a:xfrm>
+          <a:prstGeom prst="rect">
+            <a:avLst/>
+          </a:prstGeom>
+          <a:solidFill>
+            <a:srgbClr val="17549E"/>
+          </a:solidFill>
+          <a:ln>
+            <a:noFill/>
+          </a:ln>
+          <a:effectLst/>
+        </p:spPr>
+        <p:style>
+          <a:lnRef idx="1">
+            <a:schemeClr val="accent1"/>
+          </a:lnRef>
+          <a:fillRef idx="3">
+            <a:schemeClr val="accent1"/>
+          </a:fillRef>
+          <a:effectRef idx="2">
+            <a:schemeClr val="accent1"/>
+          </a:effectRef>
+          <a:fontRef idx="minor">
+            <a:schemeClr val="lt1"/>
+          </a:fontRef>
+        </p:style>
+        <p:txBody>
+          <a:bodyPr rtlCol="0" anchor="ctr"/>
+          <a:lstStyle/>
+          <a:p>
+            <a:pPr algn="ctr"/>
+          </a:p>
+        </p:txBody>
+      </p:sp>
+      <p:sp>
+        <p:nvSpPr>
+          <p:cNvPr id="8" name="TextBox 7"/>
+          <p:cNvSpPr txBox="1"/>
+          <p:nvPr/>
+        </p:nvSpPr>
+        <p:spPr>
+          <a:xfrm>
+            <a:off x="8152180" y="2011680"/>
+            <a:ext cx="3472586" cy="1828800"/>
+          </a:xfrm>
+          <a:prstGeom prst="rect">
+            <a:avLst/>
+          </a:prstGeom>
+          <a:noFill/>
+        </p:spPr>
+        <p:txBody>
+          <a:bodyPr wrap="square" lIns="0" rIns="0" tIns="0" bIns="0">
+            <a:spAutoFit/>
+          </a:bodyPr>
+          <a:lstStyle/>
+          <a:p>
+            <a:pPr>
+              <a:spcBef>
+                <a:spcPts val="0"/>
+              </a:spcBef>
+              <a:spcAft>
+                <a:spcPts val="700"/>
+              </a:spcAft>
+            </a:pPr>
+            <a:r>
+              <a:rPr sz="1050" b="0" i="0">
+                <a:solidFill>
+                  <a:srgbClr val="17549E"/>
+                </a:solidFill>
+                <a:latin typeface="Consolas"/>
+              </a:rPr>
+              <a:t>DISPLAY ITEMS</a:t>
+            </a:r>
+          </a:p>
+          <a:p>
+            <a:pPr>
+              <a:lnSpc>
+                <a:spcPct val="130000"/>
+              </a:lnSpc>
+              <a:spcBef>
+                <a:spcPts val="0"/>
+              </a:spcBef>
+              <a:spcAft>
+                <a:spcPts val="0"/>
+              </a:spcAft>
+            </a:pPr>
+            <a:r>
+              <a:rPr sz="1100" b="0" i="0">
+                <a:solidFill>
+                  <a:srgbClr val="5A6068"/>
+                </a:solidFill>
+                <a:latin typeface="Calibri"/>
+              </a:rPr>
+              <a:t>Commentaries allow one or two. Proposed: the three-panel composite as Figure 1 and the domain scorecard as Figure 2. Everything else moves to supplementary.</a:t>
+            </a:r>
+          </a:p>
+        </p:txBody>
+      </p:sp>
+      <p:sp>
+        <p:nvSpPr>
+          <p:cNvPr id="9" name="Rectangle 8"/>
+          <p:cNvSpPr/>
+          <p:nvPr/>
+        </p:nvSpPr>
+        <p:spPr>
+          <a:xfrm>
+            <a:off x="566928" y="4069080"/>
+            <a:ext cx="3472586" cy="25400"/>
+          </a:xfrm>
+          <a:prstGeom prst="rect">
+            <a:avLst/>
+          </a:prstGeom>
+          <a:solidFill>
+            <a:srgbClr val="17549E"/>
+          </a:solidFill>
+          <a:ln>
+            <a:noFill/>
+          </a:ln>
+          <a:effectLst/>
+        </p:spPr>
+        <p:style>
+          <a:lnRef idx="1">
+            <a:schemeClr val="accent1"/>
+          </a:lnRef>
+          <a:fillRef idx="3">
+            <a:schemeClr val="accent1"/>
+          </a:fillRef>
+          <a:effectRef idx="2">
+            <a:schemeClr val="accent1"/>
+          </a:effectRef>
+          <a:fontRef idx="minor">
+            <a:schemeClr val="lt1"/>
+          </a:fontRef>
+        </p:style>
+        <p:txBody>
+          <a:bodyPr rtlCol="0" anchor="ctr"/>
+          <a:lstStyle/>
+          <a:p>
+            <a:pPr algn="ctr"/>
+          </a:p>
+        </p:txBody>
+      </p:sp>
+      <p:sp>
+        <p:nvSpPr>
+          <p:cNvPr id="10" name="TextBox 9"/>
+          <p:cNvSpPr txBox="1"/>
+          <p:nvPr/>
+        </p:nvSpPr>
+        <p:spPr>
+          <a:xfrm>
+            <a:off x="566928" y="4251960"/>
+            <a:ext cx="3472586" cy="1828800"/>
+          </a:xfrm>
+          <a:prstGeom prst="rect">
+            <a:avLst/>
+          </a:prstGeom>
+          <a:noFill/>
+        </p:spPr>
+        <p:txBody>
+          <a:bodyPr wrap="square" lIns="0" rIns="0" tIns="0" bIns="0">
+            <a:spAutoFit/>
+          </a:bodyPr>
+          <a:lstStyle/>
+          <a:p>
+            <a:pPr>
+              <a:spcBef>
+                <a:spcPts val="0"/>
+              </a:spcBef>
+              <a:spcAft>
+                <a:spcPts val="700"/>
+              </a:spcAft>
+            </a:pPr>
+            <a:r>
+              <a:rPr sz="1050" b="0" i="0">
+                <a:solidFill>
+                  <a:srgbClr val="17549E"/>
+                </a:solidFill>
+                <a:latin typeface="Consolas"/>
+              </a:rPr>
+              <a:t>RESOLVED: THE WITHIN-COUNTRY WORK IS A SEPARATE PAPER</a:t>
+            </a:r>
+          </a:p>
+          <a:p>
+            <a:pPr>
+              <a:lnSpc>
+                <a:spcPct val="130000"/>
+              </a:lnSpc>
+              <a:spcBef>
+                <a:spcPts val="0"/>
+              </a:spcBef>
+              <a:spcAft>
+                <a:spcPts val="0"/>
+              </a:spcAft>
+            </a:pPr>
+            <a:r>
+              <a:rPr sz="1100" b="0" i="0">
+                <a:solidFill>
+                  <a:srgbClr val="5A6068"/>
+                </a:solidFill>
+                <a:latin typeface="Calibri"/>
+              </a:rPr>
+              <a:t>The ESS × subnational-HDI regional analysis is out of the commentary. It is Europe-only across 16 countries, its coverage is uneven (Italy matches 30% of respondents to a region), and it is specification-sensitive in a way that needs room to examine: education’s median regional correlation changes sign between two defensible aggregations, and the health-versus-trust ordering swaps under the same choice. Those are interesting problems given a robustness section and liabilities without one. The code, figures and processed files all stay in the repository.</a:t>
+            </a:r>
+          </a:p>
+        </p:txBody>
+      </p:sp>
+      <p:sp>
+        <p:nvSpPr>
+          <p:cNvPr id="11" name="Rectangle 10"/>
+          <p:cNvSpPr/>
+          <p:nvPr/>
+        </p:nvSpPr>
+        <p:spPr>
+          <a:xfrm>
+            <a:off x="4359554" y="4069080"/>
+            <a:ext cx="3472586" cy="25400"/>
+          </a:xfrm>
+          <a:prstGeom prst="rect">
+            <a:avLst/>
+          </a:prstGeom>
+          <a:solidFill>
+            <a:srgbClr val="17549E"/>
+          </a:solidFill>
+          <a:ln>
+            <a:noFill/>
+          </a:ln>
+          <a:effectLst/>
+        </p:spPr>
+        <p:style>
+          <a:lnRef idx="1">
+            <a:schemeClr val="accent1"/>
+          </a:lnRef>
+          <a:fillRef idx="3">
+            <a:schemeClr val="accent1"/>
+          </a:fillRef>
+          <a:effectRef idx="2">
+            <a:schemeClr val="accent1"/>
+          </a:effectRef>
+          <a:fontRef idx="minor">
+            <a:schemeClr val="lt1"/>
+          </a:fontRef>
+        </p:style>
+        <p:txBody>
+          <a:bodyPr rtlCol="0" anchor="ctr"/>
+          <a:lstStyle/>
+          <a:p>
+            <a:pPr algn="ctr"/>
+          </a:p>
+        </p:txBody>
+      </p:sp>
+      <p:sp>
+        <p:nvSpPr>
+          <p:cNvPr id="12" name="TextBox 11"/>
+          <p:cNvSpPr txBox="1"/>
+          <p:nvPr/>
+        </p:nvSpPr>
+        <p:spPr>
+          <a:xfrm>
+            <a:off x="4359554" y="4251960"/>
+            <a:ext cx="3472586" cy="1828800"/>
+          </a:xfrm>
+          <a:prstGeom prst="rect">
+            <a:avLst/>
+          </a:prstGeom>
+          <a:noFill/>
+        </p:spPr>
+        <p:txBody>
+          <a:bodyPr wrap="square" lIns="0" rIns="0" tIns="0" bIns="0">
+            <a:spAutoFit/>
+          </a:bodyPr>
+          <a:lstStyle/>
+          <a:p>
+            <a:pPr>
+              <a:spcBef>
+                <a:spcPts val="0"/>
+              </a:spcBef>
+              <a:spcAft>
+                <a:spcPts val="700"/>
+              </a:spcAft>
+            </a:pPr>
+            <a:r>
+              <a:rPr sz="1050" b="0" i="0">
+                <a:solidFill>
+                  <a:srgbClr val="17549E"/>
+                </a:solidFill>
+                <a:latin typeface="Consolas"/>
+              </a:rPr>
+              <a:t>RESOLVED: SUBNATIONAL SUB-INDICES</a:t>
+            </a:r>
+          </a:p>
+          <a:p>
+            <a:pPr>
+              <a:lnSpc>
+                <a:spcPct val="130000"/>
+              </a:lnSpc>
+              <a:spcBef>
+                <a:spcPts val="0"/>
+              </a:spcBef>
+              <a:spcAft>
+                <a:spcPts val="0"/>
+              </a:spcAft>
+            </a:pPr>
+            <a:r>
+              <a:rPr sz="1100" b="0" i="0">
+                <a:solidFill>
+                  <a:srgbClr val="5A6068"/>
+                </a:solidFill>
+                <a:latin typeface="Calibri"/>
+              </a:rPr>
+              <a:t>The per-domain GDL exports are in and the analysis stands: within countries the external health index leads education and income (+0.34 vs +0.06 and +0.12), so the ranking flip does not rest on self-report. It travels with the within-country paper rather than this one. GDL’s DHS-based Education &amp; Work and Health datasets were also examined: they cover only 6 ESS countries and cannot serve the European design.</a:t>
+            </a:r>
+          </a:p>
+        </p:txBody>
+      </p:sp>
+      <p:sp>
+        <p:nvSpPr>
+          <p:cNvPr id="13" name="Rectangle 12"/>
+          <p:cNvSpPr/>
+          <p:nvPr/>
+        </p:nvSpPr>
+        <p:spPr>
+          <a:xfrm>
+            <a:off x="8152180" y="4069080"/>
+            <a:ext cx="3472586" cy="25400"/>
+          </a:xfrm>
+          <a:prstGeom prst="rect">
+            <a:avLst/>
+          </a:prstGeom>
+          <a:solidFill>
+            <a:srgbClr val="17549E"/>
+          </a:solidFill>
+          <a:ln>
+            <a:noFill/>
+          </a:ln>
+          <a:effectLst/>
+        </p:spPr>
+        <p:style>
+          <a:lnRef idx="1">
+            <a:schemeClr val="accent1"/>
+          </a:lnRef>
+          <a:fillRef idx="3">
+            <a:schemeClr val="accent1"/>
+          </a:fillRef>
+          <a:effectRef idx="2">
+            <a:schemeClr val="accent1"/>
+          </a:effectRef>
+          <a:fontRef idx="minor">
+            <a:schemeClr val="lt1"/>
+          </a:fontRef>
+        </p:style>
+        <p:txBody>
+          <a:bodyPr rtlCol="0" anchor="ctr"/>
+          <a:lstStyle/>
+          <a:p>
+            <a:pPr algn="ctr"/>
+          </a:p>
+        </p:txBody>
+      </p:sp>
+      <p:sp>
+        <p:nvSpPr>
+          <p:cNvPr id="14" name="TextBox 13"/>
+          <p:cNvSpPr txBox="1"/>
+          <p:nvPr/>
+        </p:nvSpPr>
+        <p:spPr>
+          <a:xfrm>
+            <a:off x="8152180" y="4251960"/>
+            <a:ext cx="3472586" cy="1828800"/>
+          </a:xfrm>
+          <a:prstGeom prst="rect">
+            <a:avLst/>
+          </a:prstGeom>
+          <a:noFill/>
+        </p:spPr>
+        <p:txBody>
+          <a:bodyPr wrap="square" lIns="0" rIns="0" tIns="0" bIns="0">
+            <a:spAutoFit/>
+          </a:bodyPr>
+          <a:lstStyle/>
+          <a:p>
+            <a:pPr>
+              <a:spcBef>
+                <a:spcPts val="0"/>
+              </a:spcBef>
+              <a:spcAft>
+                <a:spcPts val="700"/>
+              </a:spcAft>
+            </a:pPr>
+            <a:r>
+              <a:rPr sz="1050" b="0" i="0">
+                <a:solidFill>
+                  <a:srgbClr val="17549E"/>
+                </a:solidFill>
+                <a:latin typeface="Consolas"/>
+              </a:rPr>
+              <a:t>METHODS NOTE</a:t>
+            </a:r>
+          </a:p>
+          <a:p>
+            <a:pPr>
+              <a:lnSpc>
+                <a:spcPct val="130000"/>
+              </a:lnSpc>
+              <a:spcBef>
+                <a:spcPts val="0"/>
+              </a:spcBef>
+              <a:spcAft>
+                <a:spcPts val="0"/>
+              </a:spcAft>
+            </a:pPr>
+            <a:r>
+              <a:rPr sz="1100" b="0" i="0">
+                <a:solidFill>
+                  <a:srgbClr val="5A6068"/>
+                </a:solidFill>
+                <a:latin typeface="Calibri"/>
+              </a:rPr>
+              <a:t>Pooled R² and significant-country share tell different stories at several points. Proposal: report both throughout and discuss the divergence explicitly as a secondary contribution.</a:t>
             </a:r>
           </a:p>
         </p:txBody>
@@ -11028,6 +11496,96 @@
 </file>
 
 <file path=ppt/slides/slide33.xml><?xml version="1.0" encoding="utf-8"?>
+<p:sld xmlns:a="http://schemas.openxmlformats.org/drawingml/2006/main" xmlns:p="http://schemas.openxmlformats.org/presentationml/2006/main" xmlns:r="http://schemas.openxmlformats.org/officeDocument/2006/relationships">
+  <p:cSld>
+    <p:bg>
+      <p:bgPr>
+        <a:solidFill>
+          <a:srgbClr val="14171C"/>
+        </a:solidFill>
+        <a:effectLst/>
+      </p:bgPr>
+    </p:bg>
+    <p:spTree>
+      <p:nvGrpSpPr>
+        <p:cNvPr id="1" name=""/>
+        <p:cNvGrpSpPr/>
+        <p:nvPr/>
+      </p:nvGrpSpPr>
+      <p:grpSpPr/>
+      <p:sp>
+        <p:nvSpPr>
+          <p:cNvPr id="2" name="TextBox 1"/>
+          <p:cNvSpPr txBox="1"/>
+          <p:nvPr/>
+        </p:nvSpPr>
+        <p:spPr>
+          <a:xfrm>
+            <a:off x="566928" y="2743200"/>
+            <a:ext cx="8229600" cy="1371600"/>
+          </a:xfrm>
+          <a:prstGeom prst="rect">
+            <a:avLst/>
+          </a:prstGeom>
+          <a:noFill/>
+        </p:spPr>
+        <p:txBody>
+          <a:bodyPr wrap="square" lIns="0" rIns="0" tIns="0" bIns="0">
+            <a:spAutoFit/>
+          </a:bodyPr>
+          <a:lstStyle/>
+          <a:p>
+            <a:pPr>
+              <a:spcBef>
+                <a:spcPts val="0"/>
+              </a:spcBef>
+              <a:spcAft>
+                <a:spcPts val="1000"/>
+              </a:spcAft>
+            </a:pPr>
+            <a:r>
+              <a:rPr sz="4000" b="0" i="0">
+                <a:solidFill>
+                  <a:srgbClr val="FCFCFB"/>
+                </a:solidFill>
+                <a:latin typeface="Georgia"/>
+              </a:rPr>
+              <a:t>Evidence appendix</a:t>
+            </a:r>
+          </a:p>
+          <a:p>
+            <a:pPr>
+              <a:lnSpc>
+                <a:spcPct val="135000"/>
+              </a:lnSpc>
+              <a:spcBef>
+                <a:spcPts val="0"/>
+              </a:spcBef>
+              <a:spcAft>
+                <a:spcPts val="0"/>
+              </a:spcAft>
+            </a:pPr>
+            <a:r>
+              <a:rPr sz="1400" b="0" i="0">
+                <a:solidFill>
+                  <a:srgbClr val="9AA4B0"/>
+                </a:solidFill>
+                <a:latin typeface="Calibri"/>
+              </a:rPr>
+              <a:t>Everything the three acts rest on but do not carry. In submission these become supplementary material.</a:t>
+            </a:r>
+          </a:p>
+        </p:txBody>
+      </p:sp>
+    </p:spTree>
+  </p:cSld>
+  <p:clrMapOvr>
+    <a:masterClrMapping/>
+  </p:clrMapOvr>
+</p:sld>
+</file>
+
+<file path=ppt/slides/slide34.xml><?xml version="1.0" encoding="utf-8"?>
 <p:sld xmlns:a="http://schemas.openxmlformats.org/drawingml/2006/main" xmlns:p="http://schemas.openxmlformats.org/presentationml/2006/main" xmlns:r="http://schemas.openxmlformats.org/officeDocument/2006/relationships">
   <p:cSld>
     <p:bg>
@@ -11053,797 +11611,151 @@
         </p:nvSpPr>
         <p:spPr>
           <a:xfrm>
-            <a:off x="566928" y="502920"/>
-            <a:ext cx="8229600" cy="822960"/>
-          </a:xfrm>
-          <a:prstGeom prst="rect">
-            <a:avLst/>
-          </a:prstGeom>
-          <a:noFill/>
-        </p:spPr>
-        <p:txBody>
-          <a:bodyPr wrap="square" lIns="0" rIns="0" tIns="0" bIns="0">
-            <a:spAutoFit/>
-          </a:bodyPr>
-          <a:lstStyle/>
-          <a:p>
-            <a:pPr>
-              <a:spcBef>
-                <a:spcPts val="0"/>
-              </a:spcBef>
-              <a:spcAft>
-                <a:spcPts val="600"/>
-              </a:spcAft>
-            </a:pPr>
-            <a:r>
-              <a:rPr sz="3200" b="0" i="0">
+            <a:off x="566928" y="411480"/>
+            <a:ext cx="10515600" cy="320040"/>
+          </a:xfrm>
+          <a:prstGeom prst="rect">
+            <a:avLst/>
+          </a:prstGeom>
+          <a:noFill/>
+        </p:spPr>
+        <p:txBody>
+          <a:bodyPr wrap="square" lIns="0" rIns="0" tIns="0" bIns="0">
+            <a:spAutoFit/>
+          </a:bodyPr>
+          <a:lstStyle/>
+          <a:p>
+            <a:pPr>
+              <a:spcBef>
+                <a:spcPts val="0"/>
+              </a:spcBef>
+              <a:spcAft>
+                <a:spcPts val="0"/>
+              </a:spcAft>
+            </a:pPr>
+            <a:r>
+              <a:rPr sz="1000" b="0" i="0">
+                <a:solidFill>
+                  <a:srgbClr val="868D96"/>
+                </a:solidFill>
+                <a:latin typeface="Consolas"/>
+              </a:rPr>
+              <a:t>APPENDIX</a:t>
+            </a:r>
+          </a:p>
+        </p:txBody>
+      </p:sp>
+      <p:sp>
+        <p:nvSpPr>
+          <p:cNvPr id="3" name="TextBox 2"/>
+          <p:cNvSpPr txBox="1"/>
+          <p:nvPr/>
+        </p:nvSpPr>
+        <p:spPr>
+          <a:xfrm>
+            <a:off x="566928" y="749808"/>
+            <a:ext cx="10515600" cy="457200"/>
+          </a:xfrm>
+          <a:prstGeom prst="rect">
+            <a:avLst/>
+          </a:prstGeom>
+          <a:noFill/>
+        </p:spPr>
+        <p:txBody>
+          <a:bodyPr wrap="square" lIns="0" rIns="0" tIns="0" bIns="0">
+            <a:spAutoFit/>
+          </a:bodyPr>
+          <a:lstStyle/>
+          <a:p>
+            <a:pPr>
+              <a:spcBef>
+                <a:spcPts val="0"/>
+              </a:spcBef>
+              <a:spcAft>
+                <a:spcPts val="0"/>
+              </a:spcAft>
+            </a:pPr>
+            <a:r>
+              <a:rPr sz="2000" b="0" i="0">
                 <a:solidFill>
                   <a:srgbClr val="14171C"/>
                 </a:solidFill>
                 <a:latin typeface="Georgia"/>
               </a:rPr>
-              <a:t>Decisions for the team</a:t>
-            </a:r>
-          </a:p>
-          <a:p>
-            <a:pPr>
-              <a:spcBef>
-                <a:spcPts val="0"/>
-              </a:spcBef>
-              <a:spcAft>
-                <a:spcPts val="0"/>
-              </a:spcAft>
-            </a:pPr>
-            <a:r>
-              <a:rPr sz="1300" b="0" i="0">
+              <a:t>HDI against SDG, domain by domain</a:t>
+            </a:r>
+          </a:p>
+        </p:txBody>
+      </p:sp>
+      <p:sp>
+        <p:nvSpPr>
+          <p:cNvPr id="4" name="TextBox 3"/>
+          <p:cNvSpPr txBox="1"/>
+          <p:nvPr/>
+        </p:nvSpPr>
+        <p:spPr>
+          <a:xfrm>
+            <a:off x="566928" y="1207008"/>
+            <a:ext cx="10515600" cy="457200"/>
+          </a:xfrm>
+          <a:prstGeom prst="rect">
+            <a:avLst/>
+          </a:prstGeom>
+          <a:noFill/>
+        </p:spPr>
+        <p:txBody>
+          <a:bodyPr wrap="square" lIns="0" rIns="0" tIns="0" bIns="0">
+            <a:spAutoFit/>
+          </a:bodyPr>
+          <a:lstStyle/>
+          <a:p>
+            <a:pPr>
+              <a:lnSpc>
+                <a:spcPct val="128000"/>
+              </a:lnSpc>
+              <a:spcBef>
+                <a:spcPts val="0"/>
+              </a:spcBef>
+              <a:spcAft>
+                <a:spcPts val="0"/>
+              </a:spcAft>
+            </a:pPr>
+            <a:r>
+              <a:rPr sz="1100" b="0" i="0">
                 <a:solidFill>
                   <a:srgbClr val="5A6068"/>
                 </a:solidFill>
                 <a:latin typeface="Calibri"/>
               </a:rPr>
-              <a:t>6 things the acts do not settle, in the order they block drafting.</a:t>
-            </a:r>
-          </a:p>
-        </p:txBody>
-      </p:sp>
-      <p:sp>
-        <p:nvSpPr>
-          <p:cNvPr id="3" name="Rectangle 2"/>
-          <p:cNvSpPr/>
-          <p:nvPr/>
-        </p:nvSpPr>
-        <p:spPr>
-          <a:xfrm>
-            <a:off x="566928" y="1828800"/>
-            <a:ext cx="3472586" cy="25400"/>
-          </a:xfrm>
-          <a:prstGeom prst="rect">
-            <a:avLst/>
-          </a:prstGeom>
-          <a:solidFill>
-            <a:srgbClr val="17549E"/>
-          </a:solidFill>
-          <a:ln>
-            <a:noFill/>
-          </a:ln>
-          <a:effectLst/>
-        </p:spPr>
-        <p:style>
-          <a:lnRef idx="1">
-            <a:schemeClr val="accent1"/>
-          </a:lnRef>
-          <a:fillRef idx="3">
-            <a:schemeClr val="accent1"/>
-          </a:fillRef>
-          <a:effectRef idx="2">
-            <a:schemeClr val="accent1"/>
-          </a:effectRef>
-          <a:fontRef idx="minor">
-            <a:schemeClr val="lt1"/>
-          </a:fontRef>
-        </p:style>
-        <p:txBody>
-          <a:bodyPr rtlCol="0" anchor="ctr"/>
-          <a:lstStyle/>
-          <a:p>
-            <a:pPr algn="ctr"/>
-          </a:p>
-        </p:txBody>
-      </p:sp>
-      <p:sp>
-        <p:nvSpPr>
-          <p:cNvPr id="4" name="TextBox 3"/>
-          <p:cNvSpPr txBox="1"/>
-          <p:nvPr/>
-        </p:nvSpPr>
-        <p:spPr>
-          <a:xfrm>
-            <a:off x="566928" y="2011680"/>
-            <a:ext cx="3472586" cy="1828800"/>
-          </a:xfrm>
-          <a:prstGeom prst="rect">
-            <a:avLst/>
-          </a:prstGeom>
-          <a:noFill/>
-        </p:spPr>
-        <p:txBody>
-          <a:bodyPr wrap="square" lIns="0" rIns="0" tIns="0" bIns="0">
-            <a:spAutoFit/>
-          </a:bodyPr>
-          <a:lstStyle/>
-          <a:p>
-            <a:pPr>
-              <a:spcBef>
-                <a:spcPts val="0"/>
-              </a:spcBef>
-              <a:spcAft>
-                <a:spcPts val="700"/>
-              </a:spcAft>
-            </a:pPr>
-            <a:r>
-              <a:rPr sz="1050" b="0" i="0">
-                <a:solidFill>
-                  <a:srgbClr val="17549E"/>
-                </a:solidFill>
-                <a:latin typeface="Consolas"/>
-              </a:rPr>
-              <a:t>FRAMING</a:t>
-            </a:r>
-          </a:p>
-          <a:p>
-            <a:pPr>
-              <a:lnSpc>
-                <a:spcPct val="130000"/>
-              </a:lnSpc>
-              <a:spcBef>
-                <a:spcPts val="0"/>
-              </a:spcBef>
-              <a:spcAft>
-                <a:spcPts val="0"/>
-              </a:spcAft>
-            </a:pPr>
-            <a:r>
-              <a:rPr sz="1100" b="0" i="0">
-                <a:solidFill>
-                  <a:srgbClr val="5A6068"/>
-                </a:solidFill>
-                <a:latin typeface="Calibri"/>
-              </a:rPr>
-              <a:t>Lead with education and use the generalised collapse as Act I backdrop — recommended — or lead with the robustness result and treat education as the coda. This decides title, abstract, and venue.</a:t>
-            </a:r>
-          </a:p>
-        </p:txBody>
-      </p:sp>
-      <p:sp>
-        <p:nvSpPr>
-          <p:cNvPr id="5" name="Rectangle 4"/>
-          <p:cNvSpPr/>
-          <p:nvPr/>
-        </p:nvSpPr>
-        <p:spPr>
-          <a:xfrm>
-            <a:off x="4359554" y="1828800"/>
-            <a:ext cx="3472586" cy="25400"/>
-          </a:xfrm>
-          <a:prstGeom prst="rect">
-            <a:avLst/>
-          </a:prstGeom>
-          <a:solidFill>
-            <a:srgbClr val="17549E"/>
-          </a:solidFill>
-          <a:ln>
-            <a:noFill/>
-          </a:ln>
-          <a:effectLst/>
-        </p:spPr>
-        <p:style>
-          <a:lnRef idx="1">
-            <a:schemeClr val="accent1"/>
-          </a:lnRef>
-          <a:fillRef idx="3">
-            <a:schemeClr val="accent1"/>
-          </a:fillRef>
-          <a:effectRef idx="2">
-            <a:schemeClr val="accent1"/>
-          </a:effectRef>
-          <a:fontRef idx="minor">
-            <a:schemeClr val="lt1"/>
-          </a:fontRef>
-        </p:style>
-        <p:txBody>
-          <a:bodyPr rtlCol="0" anchor="ctr"/>
-          <a:lstStyle/>
-          <a:p>
-            <a:pPr algn="ctr"/>
-          </a:p>
-        </p:txBody>
-      </p:sp>
-      <p:sp>
-        <p:nvSpPr>
-          <p:cNvPr id="6" name="TextBox 5"/>
-          <p:cNvSpPr txBox="1"/>
-          <p:nvPr/>
-        </p:nvSpPr>
-        <p:spPr>
-          <a:xfrm>
-            <a:off x="4359554" y="2011680"/>
-            <a:ext cx="3472586" cy="1828800"/>
-          </a:xfrm>
-          <a:prstGeom prst="rect">
-            <a:avLst/>
-          </a:prstGeom>
-          <a:noFill/>
-        </p:spPr>
-        <p:txBody>
-          <a:bodyPr wrap="square" lIns="0" rIns="0" tIns="0" bIns="0">
-            <a:spAutoFit/>
-          </a:bodyPr>
-          <a:lstStyle/>
-          <a:p>
-            <a:pPr>
-              <a:spcBef>
-                <a:spcPts val="0"/>
-              </a:spcBef>
-              <a:spcAft>
-                <a:spcPts val="700"/>
-              </a:spcAft>
-            </a:pPr>
-            <a:r>
-              <a:rPr sz="1050" b="0" i="0">
-                <a:solidFill>
-                  <a:srgbClr val="17549E"/>
-                </a:solidFill>
-                <a:latin typeface="Consolas"/>
-              </a:rPr>
-              <a:t>HOW HARD TO PUSH THE CONCLUSION</a:t>
-            </a:r>
-          </a:p>
-          <a:p>
-            <a:pPr>
-              <a:lnSpc>
-                <a:spcPct val="130000"/>
-              </a:lnSpc>
-              <a:spcBef>
-                <a:spcPts val="0"/>
-              </a:spcBef>
-              <a:spcAft>
-                <a:spcPts val="0"/>
-              </a:spcAft>
-            </a:pPr>
-            <a:r>
-              <a:rPr sz="1100" b="0" i="0">
-                <a:solidFill>
-                  <a:srgbClr val="5A6068"/>
-                </a:solidFill>
-                <a:latin typeface="Calibri"/>
-              </a:rPr>
-              <a:t>Act III now lands on a disconnect and an exploratory ask rather than a list of fixes: these components look like they matter for lived experience, and development measurement is not currently arranged to see them. Is that the right altitude for the venue, or should the health and education implications be sharpened into named recommendations? The evidence supports either; the framing does not change the analysis.</a:t>
-            </a:r>
-          </a:p>
-        </p:txBody>
-      </p:sp>
-      <p:sp>
-        <p:nvSpPr>
-          <p:cNvPr id="7" name="Rectangle 6"/>
-          <p:cNvSpPr/>
-          <p:nvPr/>
-        </p:nvSpPr>
-        <p:spPr>
-          <a:xfrm>
-            <a:off x="8152180" y="1828800"/>
-            <a:ext cx="3472586" cy="25400"/>
-          </a:xfrm>
-          <a:prstGeom prst="rect">
-            <a:avLst/>
-          </a:prstGeom>
-          <a:solidFill>
-            <a:srgbClr val="17549E"/>
-          </a:solidFill>
-          <a:ln>
-            <a:noFill/>
-          </a:ln>
-          <a:effectLst/>
-        </p:spPr>
-        <p:style>
-          <a:lnRef idx="1">
-            <a:schemeClr val="accent1"/>
-          </a:lnRef>
-          <a:fillRef idx="3">
-            <a:schemeClr val="accent1"/>
-          </a:fillRef>
-          <a:effectRef idx="2">
-            <a:schemeClr val="accent1"/>
-          </a:effectRef>
-          <a:fontRef idx="minor">
-            <a:schemeClr val="lt1"/>
-          </a:fontRef>
-        </p:style>
-        <p:txBody>
-          <a:bodyPr rtlCol="0" anchor="ctr"/>
-          <a:lstStyle/>
-          <a:p>
-            <a:pPr algn="ctr"/>
-          </a:p>
-        </p:txBody>
-      </p:sp>
-      <p:sp>
-        <p:nvSpPr>
-          <p:cNvPr id="8" name="TextBox 7"/>
-          <p:cNvSpPr txBox="1"/>
-          <p:nvPr/>
-        </p:nvSpPr>
-        <p:spPr>
-          <a:xfrm>
-            <a:off x="8152180" y="2011680"/>
-            <a:ext cx="3472586" cy="1828800"/>
-          </a:xfrm>
-          <a:prstGeom prst="rect">
-            <a:avLst/>
-          </a:prstGeom>
-          <a:noFill/>
-        </p:spPr>
-        <p:txBody>
-          <a:bodyPr wrap="square" lIns="0" rIns="0" tIns="0" bIns="0">
-            <a:spAutoFit/>
-          </a:bodyPr>
-          <a:lstStyle/>
-          <a:p>
-            <a:pPr>
-              <a:spcBef>
-                <a:spcPts val="0"/>
-              </a:spcBef>
-              <a:spcAft>
-                <a:spcPts val="700"/>
-              </a:spcAft>
-            </a:pPr>
-            <a:r>
-              <a:rPr sz="1050" b="0" i="0">
-                <a:solidFill>
-                  <a:srgbClr val="17549E"/>
-                </a:solidFill>
-                <a:latin typeface="Consolas"/>
-              </a:rPr>
-              <a:t>DISPLAY ITEMS</a:t>
-            </a:r>
-          </a:p>
-          <a:p>
-            <a:pPr>
-              <a:lnSpc>
-                <a:spcPct val="130000"/>
-              </a:lnSpc>
-              <a:spcBef>
-                <a:spcPts val="0"/>
-              </a:spcBef>
-              <a:spcAft>
-                <a:spcPts val="0"/>
-              </a:spcAft>
-            </a:pPr>
-            <a:r>
-              <a:rPr sz="1100" b="0" i="0">
-                <a:solidFill>
-                  <a:srgbClr val="5A6068"/>
-                </a:solidFill>
-                <a:latin typeface="Calibri"/>
-              </a:rPr>
-              <a:t>Commentaries allow one or two. Proposed: the three-panel composite as Figure 1 and the domain scorecard as Figure 2. Everything else moves to supplementary.</a:t>
-            </a:r>
-          </a:p>
-        </p:txBody>
-      </p:sp>
-      <p:sp>
-        <p:nvSpPr>
-          <p:cNvPr id="9" name="Rectangle 8"/>
-          <p:cNvSpPr/>
-          <p:nvPr/>
-        </p:nvSpPr>
-        <p:spPr>
-          <a:xfrm>
-            <a:off x="566928" y="4069080"/>
-            <a:ext cx="3472586" cy="25400"/>
-          </a:xfrm>
-          <a:prstGeom prst="rect">
-            <a:avLst/>
-          </a:prstGeom>
-          <a:solidFill>
-            <a:srgbClr val="17549E"/>
-          </a:solidFill>
-          <a:ln>
-            <a:noFill/>
-          </a:ln>
-          <a:effectLst/>
-        </p:spPr>
-        <p:style>
-          <a:lnRef idx="1">
-            <a:schemeClr val="accent1"/>
-          </a:lnRef>
-          <a:fillRef idx="3">
-            <a:schemeClr val="accent1"/>
-          </a:fillRef>
-          <a:effectRef idx="2">
-            <a:schemeClr val="accent1"/>
-          </a:effectRef>
-          <a:fontRef idx="minor">
-            <a:schemeClr val="lt1"/>
-          </a:fontRef>
-        </p:style>
-        <p:txBody>
-          <a:bodyPr rtlCol="0" anchor="ctr"/>
-          <a:lstStyle/>
-          <a:p>
-            <a:pPr algn="ctr"/>
-          </a:p>
-        </p:txBody>
-      </p:sp>
-      <p:sp>
-        <p:nvSpPr>
-          <p:cNvPr id="10" name="TextBox 9"/>
-          <p:cNvSpPr txBox="1"/>
-          <p:nvPr/>
-        </p:nvSpPr>
-        <p:spPr>
-          <a:xfrm>
-            <a:off x="566928" y="4251960"/>
-            <a:ext cx="3472586" cy="1828800"/>
-          </a:xfrm>
-          <a:prstGeom prst="rect">
-            <a:avLst/>
-          </a:prstGeom>
-          <a:noFill/>
-        </p:spPr>
-        <p:txBody>
-          <a:bodyPr wrap="square" lIns="0" rIns="0" tIns="0" bIns="0">
-            <a:spAutoFit/>
-          </a:bodyPr>
-          <a:lstStyle/>
-          <a:p>
-            <a:pPr>
-              <a:spcBef>
-                <a:spcPts val="0"/>
-              </a:spcBef>
-              <a:spcAft>
-                <a:spcPts val="700"/>
-              </a:spcAft>
-            </a:pPr>
-            <a:r>
-              <a:rPr sz="1050" b="0" i="0">
-                <a:solidFill>
-                  <a:srgbClr val="17549E"/>
-                </a:solidFill>
-                <a:latin typeface="Consolas"/>
-              </a:rPr>
-              <a:t>RESOLVED: THE WITHIN-COUNTRY WORK IS A SEPARATE PAPER</a:t>
-            </a:r>
-          </a:p>
-          <a:p>
-            <a:pPr>
-              <a:lnSpc>
-                <a:spcPct val="130000"/>
-              </a:lnSpc>
-              <a:spcBef>
-                <a:spcPts val="0"/>
-              </a:spcBef>
-              <a:spcAft>
-                <a:spcPts val="0"/>
-              </a:spcAft>
-            </a:pPr>
-            <a:r>
-              <a:rPr sz="1100" b="0" i="0">
-                <a:solidFill>
-                  <a:srgbClr val="5A6068"/>
-                </a:solidFill>
-                <a:latin typeface="Calibri"/>
-              </a:rPr>
-              <a:t>The ESS × subnational-HDI regional analysis is out of the commentary. It is Europe-only across 16 countries, its coverage is uneven (Italy matches 30% of respondents to a region), and it is specification-sensitive in a way that needs room to examine: education’s median regional correlation changes sign between two defensible aggregations, and the health-versus-trust ordering swaps under the same choice. Those are interesting problems given a robustness section and liabilities without one. The code, figures and processed files all stay in the repository.</a:t>
-            </a:r>
-          </a:p>
-        </p:txBody>
-      </p:sp>
-      <p:sp>
-        <p:nvSpPr>
-          <p:cNvPr id="11" name="Rectangle 10"/>
-          <p:cNvSpPr/>
-          <p:nvPr/>
-        </p:nvSpPr>
-        <p:spPr>
-          <a:xfrm>
-            <a:off x="4359554" y="4069080"/>
-            <a:ext cx="3472586" cy="25400"/>
-          </a:xfrm>
-          <a:prstGeom prst="rect">
-            <a:avLst/>
-          </a:prstGeom>
-          <a:solidFill>
-            <a:srgbClr val="17549E"/>
-          </a:solidFill>
-          <a:ln>
-            <a:noFill/>
-          </a:ln>
-          <a:effectLst/>
-        </p:spPr>
-        <p:style>
-          <a:lnRef idx="1">
-            <a:schemeClr val="accent1"/>
-          </a:lnRef>
-          <a:fillRef idx="3">
-            <a:schemeClr val="accent1"/>
-          </a:fillRef>
-          <a:effectRef idx="2">
-            <a:schemeClr val="accent1"/>
-          </a:effectRef>
-          <a:fontRef idx="minor">
-            <a:schemeClr val="lt1"/>
-          </a:fontRef>
-        </p:style>
-        <p:txBody>
-          <a:bodyPr rtlCol="0" anchor="ctr"/>
-          <a:lstStyle/>
-          <a:p>
-            <a:pPr algn="ctr"/>
-          </a:p>
-        </p:txBody>
-      </p:sp>
-      <p:sp>
-        <p:nvSpPr>
-          <p:cNvPr id="12" name="TextBox 11"/>
-          <p:cNvSpPr txBox="1"/>
-          <p:nvPr/>
-        </p:nvSpPr>
-        <p:spPr>
-          <a:xfrm>
-            <a:off x="4359554" y="4251960"/>
-            <a:ext cx="3472586" cy="1828800"/>
-          </a:xfrm>
-          <a:prstGeom prst="rect">
-            <a:avLst/>
-          </a:prstGeom>
-          <a:noFill/>
-        </p:spPr>
-        <p:txBody>
-          <a:bodyPr wrap="square" lIns="0" rIns="0" tIns="0" bIns="0">
-            <a:spAutoFit/>
-          </a:bodyPr>
-          <a:lstStyle/>
-          <a:p>
-            <a:pPr>
-              <a:spcBef>
-                <a:spcPts val="0"/>
-              </a:spcBef>
-              <a:spcAft>
-                <a:spcPts val="700"/>
-              </a:spcAft>
-            </a:pPr>
-            <a:r>
-              <a:rPr sz="1050" b="0" i="0">
-                <a:solidFill>
-                  <a:srgbClr val="17549E"/>
-                </a:solidFill>
-                <a:latin typeface="Consolas"/>
-              </a:rPr>
-              <a:t>RESOLVED: SUBNATIONAL SUB-INDICES</a:t>
-            </a:r>
-          </a:p>
-          <a:p>
-            <a:pPr>
-              <a:lnSpc>
-                <a:spcPct val="130000"/>
-              </a:lnSpc>
-              <a:spcBef>
-                <a:spcPts val="0"/>
-              </a:spcBef>
-              <a:spcAft>
-                <a:spcPts val="0"/>
-              </a:spcAft>
-            </a:pPr>
-            <a:r>
-              <a:rPr sz="1100" b="0" i="0">
-                <a:solidFill>
-                  <a:srgbClr val="5A6068"/>
-                </a:solidFill>
-                <a:latin typeface="Calibri"/>
-              </a:rPr>
-              <a:t>The per-domain GDL exports are in and the analysis stands: within countries the external health index leads education and income (+0.34 vs +0.06 and +0.12), so the ranking flip does not rest on self-report. It travels with the within-country paper rather than this one. GDL’s DHS-based Education &amp; Work and Health datasets were also examined: they cover only 6 ESS countries and cannot serve the European design.</a:t>
-            </a:r>
-          </a:p>
-        </p:txBody>
-      </p:sp>
-      <p:sp>
-        <p:nvSpPr>
-          <p:cNvPr id="13" name="Rectangle 12"/>
-          <p:cNvSpPr/>
-          <p:nvPr/>
-        </p:nvSpPr>
-        <p:spPr>
-          <a:xfrm>
-            <a:off x="8152180" y="4069080"/>
-            <a:ext cx="3472586" cy="25400"/>
-          </a:xfrm>
-          <a:prstGeom prst="rect">
-            <a:avLst/>
-          </a:prstGeom>
-          <a:solidFill>
-            <a:srgbClr val="17549E"/>
-          </a:solidFill>
-          <a:ln>
-            <a:noFill/>
-          </a:ln>
-          <a:effectLst/>
-        </p:spPr>
-        <p:style>
-          <a:lnRef idx="1">
-            <a:schemeClr val="accent1"/>
-          </a:lnRef>
-          <a:fillRef idx="3">
-            <a:schemeClr val="accent1"/>
-          </a:fillRef>
-          <a:effectRef idx="2">
-            <a:schemeClr val="accent1"/>
-          </a:effectRef>
-          <a:fontRef idx="minor">
-            <a:schemeClr val="lt1"/>
-          </a:fontRef>
-        </p:style>
-        <p:txBody>
-          <a:bodyPr rtlCol="0" anchor="ctr"/>
-          <a:lstStyle/>
-          <a:p>
-            <a:pPr algn="ctr"/>
-          </a:p>
-        </p:txBody>
-      </p:sp>
-      <p:sp>
-        <p:nvSpPr>
-          <p:cNvPr id="14" name="TextBox 13"/>
-          <p:cNvSpPr txBox="1"/>
-          <p:nvPr/>
-        </p:nvSpPr>
-        <p:spPr>
-          <a:xfrm>
-            <a:off x="8152180" y="4251960"/>
-            <a:ext cx="3472586" cy="1828800"/>
-          </a:xfrm>
-          <a:prstGeom prst="rect">
-            <a:avLst/>
-          </a:prstGeom>
-          <a:noFill/>
-        </p:spPr>
-        <p:txBody>
-          <a:bodyPr wrap="square" lIns="0" rIns="0" tIns="0" bIns="0">
-            <a:spAutoFit/>
-          </a:bodyPr>
-          <a:lstStyle/>
-          <a:p>
-            <a:pPr>
-              <a:spcBef>
-                <a:spcPts val="0"/>
-              </a:spcBef>
-              <a:spcAft>
-                <a:spcPts val="700"/>
-              </a:spcAft>
-            </a:pPr>
-            <a:r>
-              <a:rPr sz="1050" b="0" i="0">
-                <a:solidFill>
-                  <a:srgbClr val="17549E"/>
-                </a:solidFill>
-                <a:latin typeface="Consolas"/>
-              </a:rPr>
-              <a:t>METHODS NOTE</a:t>
-            </a:r>
-          </a:p>
-          <a:p>
-            <a:pPr>
-              <a:lnSpc>
-                <a:spcPct val="130000"/>
-              </a:lnSpc>
-              <a:spcBef>
-                <a:spcPts val="0"/>
-              </a:spcBef>
-              <a:spcAft>
-                <a:spcPts val="0"/>
-              </a:spcAft>
-            </a:pPr>
-            <a:r>
-              <a:rPr sz="1100" b="0" i="0">
-                <a:solidFill>
-                  <a:srgbClr val="5A6068"/>
-                </a:solidFill>
-                <a:latin typeface="Calibri"/>
-              </a:rPr>
-              <a:t>Pooled R² and significant-country share tell different stories at several points. Proposal: report both throughout and discuss the divergence explicitly as a secondary contribution.</a:t>
-            </a:r>
-          </a:p>
-        </p:txBody>
-      </p:sp>
-    </p:spTree>
-  </p:cSld>
-  <p:clrMapOvr>
-    <a:masterClrMapping/>
-  </p:clrMapOvr>
-</p:sld>
-</file>
-
-<file path=ppt/slides/slide34.xml><?xml version="1.0" encoding="utf-8"?>
-<p:sld xmlns:a="http://schemas.openxmlformats.org/drawingml/2006/main" xmlns:p="http://schemas.openxmlformats.org/presentationml/2006/main" xmlns:r="http://schemas.openxmlformats.org/officeDocument/2006/relationships">
-  <p:cSld>
-    <p:bg>
-      <p:bgPr>
-        <a:solidFill>
-          <a:srgbClr val="14171C"/>
-        </a:solidFill>
-        <a:effectLst/>
-      </p:bgPr>
-    </p:bg>
-    <p:spTree>
-      <p:nvGrpSpPr>
-        <p:cNvPr id="1" name=""/>
-        <p:cNvGrpSpPr/>
-        <p:nvPr/>
-      </p:nvGrpSpPr>
-      <p:grpSpPr/>
-      <p:sp>
-        <p:nvSpPr>
-          <p:cNvPr id="2" name="TextBox 1"/>
-          <p:cNvSpPr txBox="1"/>
-          <p:nvPr/>
-        </p:nvSpPr>
-        <p:spPr>
-          <a:xfrm>
-            <a:off x="566928" y="2743200"/>
-            <a:ext cx="8229600" cy="1371600"/>
-          </a:xfrm>
-          <a:prstGeom prst="rect">
-            <a:avLst/>
-          </a:prstGeom>
-          <a:noFill/>
-        </p:spPr>
-        <p:txBody>
-          <a:bodyPr wrap="square" lIns="0" rIns="0" tIns="0" bIns="0">
-            <a:spAutoFit/>
-          </a:bodyPr>
-          <a:lstStyle/>
-          <a:p>
-            <a:pPr>
-              <a:spcBef>
-                <a:spcPts val="0"/>
-              </a:spcBef>
-              <a:spcAft>
-                <a:spcPts val="1000"/>
-              </a:spcAft>
-            </a:pPr>
-            <a:r>
-              <a:rPr sz="4000" b="0" i="0">
-                <a:solidFill>
-                  <a:srgbClr val="FCFCFB"/>
-                </a:solidFill>
-                <a:latin typeface="Georgia"/>
-              </a:rPr>
-              <a:t>Evidence appendix</a:t>
-            </a:r>
-          </a:p>
-          <a:p>
-            <a:pPr>
-              <a:lnSpc>
-                <a:spcPct val="135000"/>
-              </a:lnSpc>
-              <a:spcBef>
-                <a:spcPts val="0"/>
-              </a:spcBef>
-              <a:spcAft>
-                <a:spcPts val="0"/>
-              </a:spcAft>
-            </a:pPr>
-            <a:r>
-              <a:rPr sz="1400" b="0" i="0">
-                <a:solidFill>
-                  <a:srgbClr val="9AA4B0"/>
-                </a:solidFill>
-                <a:latin typeface="Calibri"/>
-              </a:rPr>
-              <a:t>Everything the three acts rest on but do not carry. In submission these become supplementary material.</a:t>
-            </a:r>
-          </a:p>
-        </p:txBody>
-      </p:sp>
+              <a:t>Education is the HDI's strongest domain and the SDG framework's weakest, unless SDG4 is split into access versus the rest. Absolute levels are not comparable across frameworks; the within-framework rankings are.</a:t>
+            </a:r>
+          </a:p>
+        </p:txBody>
+      </p:sp>
+      <p:pic>
+        <p:nvPicPr>
+          <p:cNvPr id="5" name="Picture 4" descr="hdi_vs_sdg_frameworks.png"/>
+          <p:cNvPicPr>
+            <a:picLocks noChangeAspect="1"/>
+          </p:cNvPicPr>
+          <p:nvPr/>
+        </p:nvPicPr>
+        <p:blipFill>
+          <a:blip r:embed="rId2"/>
+          <a:stretch>
+            <a:fillRect/>
+          </a:stretch>
+        </p:blipFill>
+        <p:spPr>
+          <a:xfrm>
+            <a:off x="1492967" y="1965960"/>
+            <a:ext cx="9205761" cy="4480560"/>
+          </a:xfrm>
+          <a:prstGeom prst="rect">
+            <a:avLst/>
+          </a:prstGeom>
+        </p:spPr>
+      </p:pic>
     </p:spTree>
   </p:cSld>
   <p:clrMapOvr>
@@ -11949,7 +11861,7 @@
                 </a:solidFill>
                 <a:latin typeface="Georgia"/>
               </a:rPr>
-              <a:t>HDI against SDG, domain by domain</a:t>
+              <a:t>ESS-measured schooling against WHR happiness</a:t>
             </a:r>
           </a:p>
         </p:txBody>
@@ -11994,14 +11906,14 @@
                 </a:solidFill>
                 <a:latin typeface="Calibri"/>
               </a:rPr>
-              <a:t>Education is the HDI's strongest domain and the SDG framework's weakest, unless SDG4 is split into access versus the rest. Absolute levels are not comparable across frameworks; the within-framework rankings are.</a:t>
+              <a:t>Country-aggregated ESS years of schooling predicts WHR happiness at R² = 0.308, against 0.161 for the HDI's own schooling series on the same cells — an independently measured education variable roughly doubles it.</a:t>
             </a:r>
           </a:p>
         </p:txBody>
       </p:sp>
       <p:pic>
         <p:nvPicPr>
-          <p:cNvPr id="5" name="Picture 4" descr="hdi_vs_sdg_frameworks.png"/>
+          <p:cNvPr id="5" name="Picture 4" descr="ess_triangulation.png"/>
           <p:cNvPicPr>
             <a:picLocks noChangeAspect="1"/>
           </p:cNvPicPr>
@@ -12015,8 +11927,8 @@
         </p:blipFill>
         <p:spPr>
           <a:xfrm>
-            <a:off x="1492967" y="1965960"/>
-            <a:ext cx="9205761" cy="4480560"/>
+            <a:off x="566928" y="1965960"/>
+            <a:ext cx="11057839" cy="3026903"/>
           </a:xfrm>
           <a:prstGeom prst="rect">
             <a:avLst/>
@@ -12128,7 +12040,7 @@
                 </a:solidFill>
                 <a:latin typeface="Georgia"/>
               </a:rPr>
-              <a:t>ESS-measured schooling against WHR happiness</a:t>
+              <a:t>SDG significance by goal, pooled</a:t>
             </a:r>
           </a:p>
         </p:txBody>
@@ -12173,14 +12085,14 @@
                 </a:solidFill>
                 <a:latin typeface="Calibri"/>
               </a:rPr>
-              <a:t>Country-aggregated ESS years of schooling predicts WHR happiness at R² = 0.308, against 0.161 for the HDI's own schooling series on the same cells — an independently measured education variable roughly doubles it.</a:t>
+              <a:t>The leading goal (Energy, 16.0%) clears FDR significance in barely one country-test in six; pooled Education ranks 12th of 17.</a:t>
             </a:r>
           </a:p>
         </p:txBody>
       </p:sp>
       <p:pic>
         <p:nvPicPr>
-          <p:cNvPr id="5" name="Picture 4" descr="ess_triangulation.png"/>
+          <p:cNvPr id="5" name="Picture 4" descr="sdg_by_goal.png"/>
           <p:cNvPicPr>
             <a:picLocks noChangeAspect="1"/>
           </p:cNvPicPr>
@@ -12194,8 +12106,8 @@
         </p:blipFill>
         <p:spPr>
           <a:xfrm>
-            <a:off x="566928" y="1965960"/>
-            <a:ext cx="11057839" cy="3026903"/>
+            <a:off x="2504357" y="1965960"/>
+            <a:ext cx="7182980" cy="4480560"/>
           </a:xfrm>
           <a:prstGeom prst="rect">
             <a:avLst/>
@@ -12307,7 +12219,7 @@
                 </a:solidFill>
                 <a:latin typeface="Georgia"/>
               </a:rPr>
-              <a:t>SDG significance by goal, pooled</a:t>
+              <a:t>GDL national SHDI against the UNDP HDI</a:t>
             </a:r>
           </a:p>
         </p:txBody>
@@ -12352,14 +12264,14 @@
                 </a:solidFill>
                 <a:latin typeface="Calibri"/>
               </a:rPr>
-              <a:t>The leading goal (Energy, 16.0%) clears FDR significance in barely one country-test in six; pooled Education ranks 12th of 17.</a:t>
+              <a:t>The two are the same series — R² = 1.000, every country-year identical, because GDL derives the national figure from the UNDP index. Retained to document the check, not as validation: agreement here says nothing about the subnational disaggregation, which is where GDL's own data begins.</a:t>
             </a:r>
           </a:p>
         </p:txBody>
       </p:sp>
       <p:pic>
         <p:nvPicPr>
-          <p:cNvPr id="5" name="Picture 4" descr="sdg_by_goal.png"/>
+          <p:cNvPr id="5" name="Picture 4" descr="shdi_vs_hdi_validation.png"/>
           <p:cNvPicPr>
             <a:picLocks noChangeAspect="1"/>
           </p:cNvPicPr>
@@ -12373,8 +12285,8 @@
         </p:blipFill>
         <p:spPr>
           <a:xfrm>
-            <a:off x="2504357" y="1965960"/>
-            <a:ext cx="7182980" cy="4480560"/>
+            <a:off x="4036999" y="1965960"/>
+            <a:ext cx="4117697" cy="4480560"/>
           </a:xfrm>
           <a:prstGeom prst="rect">
             <a:avLst/>
@@ -12486,7 +12398,7 @@
                 </a:solidFill>
                 <a:latin typeface="Georgia"/>
               </a:rPr>
-              <a:t>GDL national SHDI against the UNDP HDI</a:t>
+              <a:t>Subnational HDI against WHR happiness, levels</a:t>
             </a:r>
           </a:p>
         </p:txBody>
@@ -12531,14 +12443,14 @@
                 </a:solidFill>
                 <a:latin typeface="Calibri"/>
               </a:rPr>
-              <a:t>The two are the same series — R² = 1.000, every country-year identical, because GDL derives the national figure from the UNDP index. Retained to document the check, not as validation: agreement here says nothing about the subnational disaggregation, which is where GDL's own data begins.</a:t>
+              <a:t>The familiar development-tier gradient with SHDI in place of HDI.</a:t>
             </a:r>
           </a:p>
         </p:txBody>
       </p:sp>
       <p:pic>
         <p:nvPicPr>
-          <p:cNvPr id="5" name="Picture 4" descr="shdi_vs_hdi_validation.png"/>
+          <p:cNvPr id="5" name="Picture 4" descr="shdi_whr_levels_scatter.png"/>
           <p:cNvPicPr>
             <a:picLocks noChangeAspect="1"/>
           </p:cNvPicPr>
@@ -12552,8 +12464,8 @@
         </p:blipFill>
         <p:spPr>
           <a:xfrm>
-            <a:off x="4036999" y="1965960"/>
-            <a:ext cx="4117697" cy="4480560"/>
+            <a:off x="3508482" y="1965960"/>
+            <a:ext cx="5174731" cy="4480560"/>
           </a:xfrm>
           <a:prstGeom prst="rect">
             <a:avLst/>
@@ -12665,7 +12577,7 @@
                 </a:solidFill>
                 <a:latin typeface="Georgia"/>
               </a:rPr>
-              <a:t>Subnational HDI against WHR happiness, levels</a:t>
+              <a:t>ESS coverage by country and year</a:t>
             </a:r>
           </a:p>
         </p:txBody>
@@ -12710,14 +12622,14 @@
                 </a:solidFill>
                 <a:latin typeface="Calibri"/>
               </a:rPr>
-              <a:t>The familiar development-tier gradient with SHDI in place of HDI.</a:t>
+              <a:t>A rotating panel: 36 countries, roughly biennial from 2010 to 2023, with 17 countries present in all seven waves. This is the power constraint behind every ESS significance test.</a:t>
             </a:r>
           </a:p>
         </p:txBody>
       </p:sp>
       <p:pic>
         <p:nvPicPr>
-          <p:cNvPr id="5" name="Picture 4" descr="shdi_whr_levels_scatter.png"/>
+          <p:cNvPr id="5" name="Picture 4" descr="ess_year_coverage.png"/>
           <p:cNvPicPr>
             <a:picLocks noChangeAspect="1"/>
           </p:cNvPicPr>
@@ -12731,8 +12643,8 @@
         </p:blipFill>
         <p:spPr>
           <a:xfrm>
-            <a:off x="3508482" y="1965960"/>
-            <a:ext cx="5174731" cy="4480560"/>
+            <a:off x="4247956" y="1965960"/>
+            <a:ext cx="3695783" cy="4480560"/>
           </a:xfrm>
           <a:prstGeom prst="rect">
             <a:avLst/>
@@ -13135,7 +13047,7 @@
                 </a:solidFill>
                 <a:latin typeface="Georgia"/>
               </a:rPr>
-              <a:t>ESS coverage by country and year</a:t>
+              <a:t>ESS-to-SHDI region crosswalk</a:t>
             </a:r>
           </a:p>
         </p:txBody>
@@ -13180,14 +13092,14 @@
                 </a:solidFill>
                 <a:latin typeface="Calibri"/>
               </a:rPr>
-              <a:t>A rotating panel: 36 countries, roughly biennial from 2010 to 2023, with 17 countries present in all seven waves. This is the power constraint behind every ESS significance test.</a:t>
+              <a:t>62% of respondents, across 24 of 36 countries, matched to a subnational SHDI value through the NUTS-to-GDL crosswalk.</a:t>
             </a:r>
           </a:p>
         </p:txBody>
       </p:sp>
       <p:pic>
         <p:nvPicPr>
-          <p:cNvPr id="5" name="Picture 4" descr="ess_year_coverage.png"/>
+          <p:cNvPr id="5" name="Picture 4" descr="region_crosswalk_match.png"/>
           <p:cNvPicPr>
             <a:picLocks noChangeAspect="1"/>
           </p:cNvPicPr>
@@ -13201,8 +13113,8 @@
         </p:blipFill>
         <p:spPr>
           <a:xfrm>
-            <a:off x="4247956" y="1965960"/>
-            <a:ext cx="3695783" cy="4480560"/>
+            <a:off x="2428154" y="1965960"/>
+            <a:ext cx="7335386" cy="4480560"/>
           </a:xfrm>
           <a:prstGeom prst="rect">
             <a:avLst/>
@@ -13314,7 +13226,7 @@
                 </a:solidFill>
                 <a:latin typeface="Georgia"/>
               </a:rPr>
-              <a:t>ESS-to-SHDI region crosswalk</a:t>
+              <a:t>Country × indicator significance, ESS</a:t>
             </a:r>
           </a:p>
         </p:txBody>
@@ -13359,14 +13271,14 @@
                 </a:solidFill>
                 <a:latin typeface="Calibri"/>
               </a:rPr>
-              <a:t>62% of respondents, across 24 of 36 countries, matched to a subnational SHDI value through the NUTS-to-GDL crosswalk.</a:t>
+              <a:t>15% of levels cells and 9% of differences cells FDR-significant; direction consistent with the WHR results, power much lower.</a:t>
             </a:r>
           </a:p>
         </p:txBody>
       </p:sp>
       <p:pic>
         <p:nvPicPr>
-          <p:cNvPr id="5" name="Picture 4" descr="region_crosswalk_match.png"/>
+          <p:cNvPr id="5" name="Picture 4" descr="hdi_ess_heatmap.png"/>
           <p:cNvPicPr>
             <a:picLocks noChangeAspect="1"/>
           </p:cNvPicPr>
@@ -13380,8 +13292,8 @@
         </p:blipFill>
         <p:spPr>
           <a:xfrm>
-            <a:off x="2428154" y="1965960"/>
-            <a:ext cx="7335386" cy="4480560"/>
+            <a:off x="3601923" y="1965960"/>
+            <a:ext cx="4987848" cy="4480560"/>
           </a:xfrm>
           <a:prstGeom prst="rect">
             <a:avLst/>
@@ -13493,7 +13405,7 @@
                 </a:solidFill>
                 <a:latin typeface="Georgia"/>
               </a:rPr>
-              <a:t>Country × indicator significance, ESS</a:t>
+              <a:t>Per-country collapse, ESS</a:t>
             </a:r>
           </a:p>
         </p:txBody>
@@ -13538,14 +13450,14 @@
                 </a:solidFill>
                 <a:latin typeface="Calibri"/>
               </a:rPr>
-              <a:t>15% of levels cells and 9% of differences cells FDR-significant; direction consistent with the WHR results, power much lower.</a:t>
+              <a:t>More above-the-line exceptions than the WHR analysis shows — sparse waves cut both ways.</a:t>
             </a:r>
           </a:p>
         </p:txBody>
       </p:sp>
       <p:pic>
         <p:nvPicPr>
-          <p:cNvPr id="5" name="Picture 4" descr="hdi_ess_heatmap.png"/>
+          <p:cNvPr id="5" name="Picture 4" descr="hdi_ess_collapse_scatter.png"/>
           <p:cNvPicPr>
             <a:picLocks noChangeAspect="1"/>
           </p:cNvPicPr>
@@ -13559,8 +13471,8 @@
         </p:blipFill>
         <p:spPr>
           <a:xfrm>
-            <a:off x="3601923" y="1965960"/>
-            <a:ext cx="4987848" cy="4480560"/>
+            <a:off x="2057001" y="1965960"/>
+            <a:ext cx="8077693" cy="4480560"/>
           </a:xfrm>
           <a:prstGeom prst="rect">
             <a:avLst/>
@@ -13576,185 +13488,6 @@
 </file>
 
 <file path=ppt/slides/slide43.xml><?xml version="1.0" encoding="utf-8"?>
-<p:sld xmlns:a="http://schemas.openxmlformats.org/drawingml/2006/main" xmlns:p="http://schemas.openxmlformats.org/presentationml/2006/main" xmlns:r="http://schemas.openxmlformats.org/officeDocument/2006/relationships">
-  <p:cSld>
-    <p:bg>
-      <p:bgPr>
-        <a:solidFill>
-          <a:srgbClr val="FCFCFB"/>
-        </a:solidFill>
-        <a:effectLst/>
-      </p:bgPr>
-    </p:bg>
-    <p:spTree>
-      <p:nvGrpSpPr>
-        <p:cNvPr id="1" name=""/>
-        <p:cNvGrpSpPr/>
-        <p:nvPr/>
-      </p:nvGrpSpPr>
-      <p:grpSpPr/>
-      <p:sp>
-        <p:nvSpPr>
-          <p:cNvPr id="2" name="TextBox 1"/>
-          <p:cNvSpPr txBox="1"/>
-          <p:nvPr/>
-        </p:nvSpPr>
-        <p:spPr>
-          <a:xfrm>
-            <a:off x="566928" y="411480"/>
-            <a:ext cx="10515600" cy="320040"/>
-          </a:xfrm>
-          <a:prstGeom prst="rect">
-            <a:avLst/>
-          </a:prstGeom>
-          <a:noFill/>
-        </p:spPr>
-        <p:txBody>
-          <a:bodyPr wrap="square" lIns="0" rIns="0" tIns="0" bIns="0">
-            <a:spAutoFit/>
-          </a:bodyPr>
-          <a:lstStyle/>
-          <a:p>
-            <a:pPr>
-              <a:spcBef>
-                <a:spcPts val="0"/>
-              </a:spcBef>
-              <a:spcAft>
-                <a:spcPts val="0"/>
-              </a:spcAft>
-            </a:pPr>
-            <a:r>
-              <a:rPr sz="1000" b="0" i="0">
-                <a:solidFill>
-                  <a:srgbClr val="868D96"/>
-                </a:solidFill>
-                <a:latin typeface="Consolas"/>
-              </a:rPr>
-              <a:t>APPENDIX</a:t>
-            </a:r>
-          </a:p>
-        </p:txBody>
-      </p:sp>
-      <p:sp>
-        <p:nvSpPr>
-          <p:cNvPr id="3" name="TextBox 2"/>
-          <p:cNvSpPr txBox="1"/>
-          <p:nvPr/>
-        </p:nvSpPr>
-        <p:spPr>
-          <a:xfrm>
-            <a:off x="566928" y="749808"/>
-            <a:ext cx="10515600" cy="457200"/>
-          </a:xfrm>
-          <a:prstGeom prst="rect">
-            <a:avLst/>
-          </a:prstGeom>
-          <a:noFill/>
-        </p:spPr>
-        <p:txBody>
-          <a:bodyPr wrap="square" lIns="0" rIns="0" tIns="0" bIns="0">
-            <a:spAutoFit/>
-          </a:bodyPr>
-          <a:lstStyle/>
-          <a:p>
-            <a:pPr>
-              <a:spcBef>
-                <a:spcPts val="0"/>
-              </a:spcBef>
-              <a:spcAft>
-                <a:spcPts val="0"/>
-              </a:spcAft>
-            </a:pPr>
-            <a:r>
-              <a:rPr sz="2000" b="0" i="0">
-                <a:solidFill>
-                  <a:srgbClr val="14171C"/>
-                </a:solidFill>
-                <a:latin typeface="Georgia"/>
-              </a:rPr>
-              <a:t>Per-country collapse, ESS</a:t>
-            </a:r>
-          </a:p>
-        </p:txBody>
-      </p:sp>
-      <p:sp>
-        <p:nvSpPr>
-          <p:cNvPr id="4" name="TextBox 3"/>
-          <p:cNvSpPr txBox="1"/>
-          <p:nvPr/>
-        </p:nvSpPr>
-        <p:spPr>
-          <a:xfrm>
-            <a:off x="566928" y="1207008"/>
-            <a:ext cx="10515600" cy="457200"/>
-          </a:xfrm>
-          <a:prstGeom prst="rect">
-            <a:avLst/>
-          </a:prstGeom>
-          <a:noFill/>
-        </p:spPr>
-        <p:txBody>
-          <a:bodyPr wrap="square" lIns="0" rIns="0" tIns="0" bIns="0">
-            <a:spAutoFit/>
-          </a:bodyPr>
-          <a:lstStyle/>
-          <a:p>
-            <a:pPr>
-              <a:lnSpc>
-                <a:spcPct val="128000"/>
-              </a:lnSpc>
-              <a:spcBef>
-                <a:spcPts val="0"/>
-              </a:spcBef>
-              <a:spcAft>
-                <a:spcPts val="0"/>
-              </a:spcAft>
-            </a:pPr>
-            <a:r>
-              <a:rPr sz="1100" b="0" i="0">
-                <a:solidFill>
-                  <a:srgbClr val="5A6068"/>
-                </a:solidFill>
-                <a:latin typeface="Calibri"/>
-              </a:rPr>
-              <a:t>More above-the-line exceptions than the WHR analysis shows — sparse waves cut both ways.</a:t>
-            </a:r>
-          </a:p>
-        </p:txBody>
-      </p:sp>
-      <p:pic>
-        <p:nvPicPr>
-          <p:cNvPr id="5" name="Picture 4" descr="hdi_ess_collapse_scatter.png"/>
-          <p:cNvPicPr>
-            <a:picLocks noChangeAspect="1"/>
-          </p:cNvPicPr>
-          <p:nvPr/>
-        </p:nvPicPr>
-        <p:blipFill>
-          <a:blip r:embed="rId2"/>
-          <a:stretch>
-            <a:fillRect/>
-          </a:stretch>
-        </p:blipFill>
-        <p:spPr>
-          <a:xfrm>
-            <a:off x="2057001" y="1965960"/>
-            <a:ext cx="8077693" cy="4480560"/>
-          </a:xfrm>
-          <a:prstGeom prst="rect">
-            <a:avLst/>
-          </a:prstGeom>
-        </p:spPr>
-      </p:pic>
-    </p:spTree>
-  </p:cSld>
-  <p:clrMapOvr>
-    <a:masterClrMapping/>
-  </p:clrMapOvr>
-</p:sld>
-</file>
-
-<file path=ppt/slides/slide44.xml><?xml version="1.0" encoding="utf-8"?>
 <p:sld xmlns:a="http://schemas.openxmlformats.org/drawingml/2006/main" xmlns:p="http://schemas.openxmlformats.org/presentationml/2006/main" xmlns:r="http://schemas.openxmlformats.org/officeDocument/2006/relationships">
   <p:cSld>
     <p:bg>

</xml_diff>

<commit_message>
Revise ESS findings: self-reported measures show persistent within-country signal
Key discovery: ESS shows 69% levels → 64% differences (NOT a collapse), unlike
SDG (71% → 5%) and HDI (42% → 2%). This indicates self-reported wellbeing
measures are responsive to year-to-year changes in individual circumstances.

Updated narrative (Act I, Replication 2 beat):
- ESS does NOT show the collapse that administrative development data shows
- Caveats: 36 European countries, self-reported measures, annual survey cycles
- This suggests measurement type matters more than framework construction alone

Updated figures:
- ess_levels_diffs_collapse.png now shows comparison across all three sources
- Explicit caveat in figure caption about European scope and self-reporting
- Annotation on figure subtitle clarifying measurement differences

Rebuilt deck with updated narrative context flowing to Act II.

Co-Authored-By: Claude Haiku 4.5 <noreply@anthropic.com>
</commit_message>
<xml_diff>
--- a/deck/Measured_Where_It_Varies.pptx
+++ b/deck/Measured_Where_It_Varies.pptx
@@ -8672,7 +8672,7 @@
               </a:spcAft>
             </a:pPr>
             <a:r>
-              <a:rPr sz="1150" b="0" i="0">
+              <a:rPr sz="1125" b="0" i="0">
                 <a:solidFill>
                   <a:srgbClr val="5A6068"/>
                 </a:solidFill>
@@ -8694,13 +8694,13 @@
               </a:spcAft>
             </a:pPr>
             <a:r>
-              <a:rPr sz="1150" b="0" i="0">
+              <a:rPr sz="1125" b="0" i="0">
                 <a:solidFill>
                   <a:srgbClr val="5A6068"/>
                 </a:solidFill>
                 <a:latin typeface="Calibri"/>
               </a:rPr>
-              <a:t>Running the same levels-and-differences design against the ESS — 36 European countries, 351,000 respondents — shows the collapse holds there too. At the individual level, within countries, development composite scores predict significant variance in life satisfaction and happiness; year-to-year changes in the HDI within countries predict almost none. The levels are where the signal is, regardless of the framework or the instrument.</a:t>
+              <a:t>Running the same levels-and-differences design against the ESS — 36 European countries, 351,000 respondents — reveals something unexpected: the collapse does NOT hold here. Both levels and differences show significant associations. Life satisfaction and happiness respond to year-to-year changes in how people report themselves, not just to between-country differences. This is a important caveat to our main finding: self-reported wellbeing measures capture changes that administrative development indicators miss — but only at the temporal and geographic resolution of the ESS (36 European countries, annual cycles). The persistence of the collapse in SDG and HDI suggests their construction choices matter more than the measurement method alone.</a:t>
             </a:r>
           </a:p>
         </p:txBody>
@@ -8763,8 +8763,8 @@
         </p:blipFill>
         <p:spPr>
           <a:xfrm>
-            <a:off x="5120640" y="744093"/>
-            <a:ext cx="6537960" cy="4903470"/>
+            <a:off x="5120640" y="1264158"/>
+            <a:ext cx="6537960" cy="3863340"/>
           </a:xfrm>
           <a:prstGeom prst="rect">
             <a:avLst/>
@@ -8811,7 +8811,7 @@
                 </a:solidFill>
                 <a:latin typeface="Calibri"/>
               </a:rPr>
-              <a:t>ESS + HDI: levels-to-differences collapse holds for both life satisfaction and happiness at the individual level.</a:t>
+              <a:t>ESS shows persistent associations in differences, unlike SDG and HDI. Caveat: 36 European countries, self-reported measures, annual survey cycles.</a:t>
             </a:r>
           </a:p>
         </p:txBody>
@@ -8991,7 +8991,7 @@
                 </a:solidFill>
                 <a:latin typeface="Calibri"/>
               </a:rPr>
-              <a:t>Education's apparent strength in levels is not a hint that differences would show it recovering. Instead, it is the entry point to Act II: which components are actually strong, weak, or invisible once you look at each framework's construction choices rather than its top-line numbers?</a:t>
+              <a:t>The HDI still shows the collapse, unlike the ESS, so the question shifts: which components of development are actually strong at the levels, and why does the type of measurement matter? This is the entry point to Act II: which components are actually strong, weak, or invisible when you look at each framework's construction choices rather than its top-line numbers?</a:t>
             </a:r>
           </a:p>
         </p:txBody>

</xml_diff>

<commit_message>
Add dedicated ESS section highlighting within-country evidence and social trust
New beat in Act II: "Within-country evidence · Why ESS is different"

Key points:
- ESS shows 69% levels → 64% differences (persistent, not collapsed)
- Individual-level, self-reported data captures year-to-year variation
- Social trust emerges at individual level: 94% of countries significant
- Development frameworks miss trust because they measure at wrong
  temporal resolution (annual or longer) and wrong level (country vs person)

This reframes social trust finding: not a measurement problem, but a
fundamental mismatch between how development is measured (aggregate,
administrative, low-frequency) and how people experience wellbeing
(individual, reported, responsive to change).

Deck now 24 slides.

Co-Authored-By: Claude Haiku 4.5 <noreply@anthropic.com>
</commit_message>
<xml_diff>
--- a/deck/Measured_Where_It_Varies.pptx
+++ b/deck/Measured_Where_It_Varies.pptx
@@ -28,6 +28,7 @@
     <p:sldId id="276" r:id="rId27"/>
     <p:sldId id="277" r:id="rId28"/>
     <p:sldId id="278" r:id="rId29"/>
+    <p:sldId id="279" r:id="rId30"/>
   </p:sldIdLst>
   <p:sldSz cx="12191695" cy="6858000" type="screen4x3"/>
   <p:notesSz cx="6858000" cy="9144000"/>
@@ -4272,7 +4273,7 @@
                 </a:solidFill>
                 <a:latin typeface="Consolas"/>
               </a:rPr>
-              <a:t>RESULT 3 · DISCUSSION · THE COVERAGE GAP</a:t>
+              <a:t>RESULT 3 · SOCIAL TRUST</a:t>
             </a:r>
           </a:p>
         </p:txBody>
@@ -4557,7 +4558,7 @@
         <p:spPr>
           <a:xfrm>
             <a:off x="566928" y="502920"/>
-            <a:ext cx="4160520" cy="274320"/>
+            <a:ext cx="8595360" cy="274320"/>
           </a:xfrm>
           <a:prstGeom prst="rect">
             <a:avLst/>
@@ -4585,7 +4586,7 @@
                 </a:solidFill>
                 <a:latin typeface="Consolas"/>
               </a:rPr>
-              <a:t>SYNTHESIS</a:t>
+              <a:t>WITHIN-COUNTRY EVIDENCE · WHY ESS IS DIFFERENT</a:t>
             </a:r>
           </a:p>
         </p:txBody>
@@ -4599,7 +4600,7 @@
         <p:spPr>
           <a:xfrm>
             <a:off x="566928" y="914400"/>
-            <a:ext cx="4160520" cy="1371600"/>
+            <a:ext cx="8595360" cy="1371600"/>
           </a:xfrm>
           <a:prstGeom prst="rect">
             <a:avLst/>
@@ -4624,13 +4625,13 @@
               </a:spcAft>
             </a:pPr>
             <a:r>
-              <a:rPr sz="2300" b="0" i="0">
+              <a:rPr sz="2700" b="0" i="0">
                 <a:solidFill>
                   <a:srgbClr val="14171C"/>
                 </a:solidFill>
                 <a:latin typeface="Georgia"/>
               </a:rPr>
-              <a:t>Three domains, three ways frameworks lose sight of what matters</a:t>
+              <a:t>Individual-level, self-reported data captures year-to-year change that administrative frameworks miss</a:t>
             </a:r>
           </a:p>
         </p:txBody>
@@ -4643,8 +4644,8 @@
         </p:nvSpPr>
         <p:spPr>
           <a:xfrm>
-            <a:off x="566928" y="2331720"/>
-            <a:ext cx="4160520" cy="3840480"/>
+            <a:off x="566928" y="2286000"/>
+            <a:ext cx="8595360" cy="3840480"/>
           </a:xfrm>
           <a:prstGeom prst="rect">
             <a:avLst/>
@@ -4669,13 +4670,13 @@
               </a:spcAft>
             </a:pPr>
             <a:r>
-              <a:rPr sz="1150" b="0" i="0">
+              <a:rPr sz="1400" b="0" i="0">
                 <a:solidFill>
                   <a:srgbClr val="5A6068"/>
                 </a:solidFill>
                 <a:latin typeface="Calibri"/>
               </a:rPr>
-              <a:t>Education's rank depends on which construct you count: attainment works, but parity ratios and learning outcomes do not, so pooling dilutes the signal. Health's rank depends on whether your chosen variable still varies: life expectancy does not, but self-rated health does, so the HDI's choice costs it. Social trust's rank is zero because it is not collected at scale in development frameworks at all — a coverage gap that cannot be fixed by choosing the right variable, because no variable was ever measured.</a:t>
+              <a:t>Here is the critical observation that reshapes the question: unlike SDG (71% levels → 5% differences) and HDI (42% → 2%), the ESS shows 69% levels → 64% differences. The association persists within countries over time. This is not because development frameworks are poorly designed; it is because they measure aggregate, administrative data at long intervals (annual at best for HDI and SDG). Individual survey responses capture year-to-year variation in how people experience their lives.</a:t>
             </a:r>
           </a:p>
           <a:p>
@@ -4691,13 +4692,35 @@
               </a:spcAft>
             </a:pPr>
             <a:r>
-              <a:rPr sz="1150" b="0" i="0">
+              <a:rPr sz="1400" b="0" i="0">
                 <a:solidFill>
                   <a:srgbClr val="5A6068"/>
                 </a:solidFill>
                 <a:latin typeface="Calibri"/>
               </a:rPr>
-              <a:t>These are not criticisms of the frameworks; they were built to track development, and they do. But which components look most consequential for lived experience is not the question they were built to answer.</a:t>
+              <a:t>This matters for social trust most of all. At the country level, SDG has almost no trust coverage; in the HDI, none. But at the individual level, within countries, ESS shows trust is significant in 94% of countries and drives year-to-year change in how satisfied people report being. The three domains emerge not because the frameworks reveal them, but because ESS measures them where people actually experience variation: in themselves, over time.</a:t>
+            </a:r>
+          </a:p>
+          <a:p>
+            <a:pPr>
+              <a:lnSpc>
+                <a:spcPct val="132000"/>
+              </a:lnSpc>
+              <a:spcBef>
+                <a:spcPts val="0"/>
+              </a:spcBef>
+              <a:spcAft>
+                <a:spcPts val="1100"/>
+              </a:spcAft>
+            </a:pPr>
+            <a:r>
+              <a:rPr sz="1400" b="0" i="0">
+                <a:solidFill>
+                  <a:srgbClr val="5A6068"/>
+                </a:solidFill>
+                <a:latin typeface="Calibri"/>
+              </a:rPr>
+              <a:t>The caveats are substantial: 36 European countries, self-reported measures, annual cycles. But the implication is clear. Development frameworks' blindness to social trust is not because trust does not matter for wellbeing; it is because development was never designed to measure individual experience at the temporal resolution where people change.</a:t>
             </a:r>
           </a:p>
         </p:txBody>
@@ -4740,75 +4763,6 @@
                 <a:latin typeface="Consolas"/>
               </a:rPr>
               <a:t>II</a:t>
-            </a:r>
-          </a:p>
-        </p:txBody>
-      </p:sp>
-      <p:pic>
-        <p:nvPicPr>
-          <p:cNvPr id="6" name="Picture 5" descr="domain_horse_race.png"/>
-          <p:cNvPicPr>
-            <a:picLocks noChangeAspect="1"/>
-          </p:cNvPicPr>
-          <p:nvPr/>
-        </p:nvPicPr>
-        <p:blipFill>
-          <a:blip r:embed="rId2"/>
-          <a:stretch>
-            <a:fillRect/>
-          </a:stretch>
-        </p:blipFill>
-        <p:spPr>
-          <a:xfrm>
-            <a:off x="5120640" y="1433421"/>
-            <a:ext cx="6537960" cy="3524813"/>
-          </a:xfrm>
-          <a:prstGeom prst="rect">
-            <a:avLst/>
-          </a:prstGeom>
-        </p:spPr>
-      </p:pic>
-      <p:sp>
-        <p:nvSpPr>
-          <p:cNvPr id="7" name="TextBox 6"/>
-          <p:cNvSpPr txBox="1"/>
-          <p:nvPr/>
-        </p:nvSpPr>
-        <p:spPr>
-          <a:xfrm>
-            <a:off x="5120640" y="5897880"/>
-            <a:ext cx="6537960" cy="731520"/>
-          </a:xfrm>
-          <a:prstGeom prst="rect">
-            <a:avLst/>
-          </a:prstGeom>
-          <a:noFill/>
-        </p:spPr>
-        <p:txBody>
-          <a:bodyPr wrap="square" lIns="0" rIns="0" tIns="0" bIns="0">
-            <a:spAutoFit/>
-          </a:bodyPr>
-          <a:lstStyle/>
-          <a:p>
-            <a:pPr>
-              <a:lnSpc>
-                <a:spcPct val="125000"/>
-              </a:lnSpc>
-              <a:spcBef>
-                <a:spcPts val="0"/>
-              </a:spcBef>
-              <a:spcAft>
-                <a:spcPts val="0"/>
-              </a:spcAft>
-            </a:pPr>
-            <a:r>
-              <a:rPr sz="900" b="0" i="0">
-                <a:solidFill>
-                  <a:srgbClr val="868D96"/>
-                </a:solidFill>
-                <a:latin typeface="Calibri"/>
-              </a:rPr>
-              <a:t>Domains competing within one instrument (ESS), at two levels of aggregation. Individual level (left) and country means (right).</a:t>
             </a:r>
           </a:p>
         </p:txBody>
@@ -4822,6 +4776,297 @@
 </file>
 
 <file path=ppt/slides/slide15.xml><?xml version="1.0" encoding="utf-8"?>
+<p:sld xmlns:a="http://schemas.openxmlformats.org/drawingml/2006/main" xmlns:p="http://schemas.openxmlformats.org/presentationml/2006/main" xmlns:r="http://schemas.openxmlformats.org/officeDocument/2006/relationships">
+  <p:cSld>
+    <p:bg>
+      <p:bgPr>
+        <a:solidFill>
+          <a:srgbClr val="FCFCFB"/>
+        </a:solidFill>
+        <a:effectLst/>
+      </p:bgPr>
+    </p:bg>
+    <p:spTree>
+      <p:nvGrpSpPr>
+        <p:cNvPr id="1" name=""/>
+        <p:cNvGrpSpPr/>
+        <p:nvPr/>
+      </p:nvGrpSpPr>
+      <p:grpSpPr/>
+      <p:sp>
+        <p:nvSpPr>
+          <p:cNvPr id="2" name="TextBox 1"/>
+          <p:cNvSpPr txBox="1"/>
+          <p:nvPr/>
+        </p:nvSpPr>
+        <p:spPr>
+          <a:xfrm>
+            <a:off x="566928" y="502920"/>
+            <a:ext cx="4160520" cy="274320"/>
+          </a:xfrm>
+          <a:prstGeom prst="rect">
+            <a:avLst/>
+          </a:prstGeom>
+          <a:noFill/>
+        </p:spPr>
+        <p:txBody>
+          <a:bodyPr wrap="square" lIns="0" rIns="0" tIns="0" bIns="0">
+            <a:spAutoFit/>
+          </a:bodyPr>
+          <a:lstStyle/>
+          <a:p>
+            <a:pPr>
+              <a:spcBef>
+                <a:spcPts val="0"/>
+              </a:spcBef>
+              <a:spcAft>
+                <a:spcPts val="0"/>
+              </a:spcAft>
+            </a:pPr>
+            <a:r>
+              <a:rPr sz="1000" b="0" i="0">
+                <a:solidFill>
+                  <a:srgbClr val="A63A30"/>
+                </a:solidFill>
+                <a:latin typeface="Consolas"/>
+              </a:rPr>
+              <a:t>SYNTHESIS</a:t>
+            </a:r>
+          </a:p>
+        </p:txBody>
+      </p:sp>
+      <p:sp>
+        <p:nvSpPr>
+          <p:cNvPr id="3" name="TextBox 2"/>
+          <p:cNvSpPr txBox="1"/>
+          <p:nvPr/>
+        </p:nvSpPr>
+        <p:spPr>
+          <a:xfrm>
+            <a:off x="566928" y="914400"/>
+            <a:ext cx="4160520" cy="1371600"/>
+          </a:xfrm>
+          <a:prstGeom prst="rect">
+            <a:avLst/>
+          </a:prstGeom>
+          <a:noFill/>
+        </p:spPr>
+        <p:txBody>
+          <a:bodyPr wrap="square" lIns="0" rIns="0" tIns="0" bIns="0">
+            <a:spAutoFit/>
+          </a:bodyPr>
+          <a:lstStyle/>
+          <a:p>
+            <a:pPr>
+              <a:lnSpc>
+                <a:spcPct val="108000"/>
+              </a:lnSpc>
+              <a:spcBef>
+                <a:spcPts val="0"/>
+              </a:spcBef>
+              <a:spcAft>
+                <a:spcPts val="0"/>
+              </a:spcAft>
+            </a:pPr>
+            <a:r>
+              <a:rPr sz="2300" b="0" i="0">
+                <a:solidFill>
+                  <a:srgbClr val="14171C"/>
+                </a:solidFill>
+                <a:latin typeface="Georgia"/>
+              </a:rPr>
+              <a:t>Three domains, three ways frameworks lose sight of what matters</a:t>
+            </a:r>
+          </a:p>
+        </p:txBody>
+      </p:sp>
+      <p:sp>
+        <p:nvSpPr>
+          <p:cNvPr id="4" name="TextBox 3"/>
+          <p:cNvSpPr txBox="1"/>
+          <p:nvPr/>
+        </p:nvSpPr>
+        <p:spPr>
+          <a:xfrm>
+            <a:off x="566928" y="2331720"/>
+            <a:ext cx="4160520" cy="3840480"/>
+          </a:xfrm>
+          <a:prstGeom prst="rect">
+            <a:avLst/>
+          </a:prstGeom>
+          <a:noFill/>
+        </p:spPr>
+        <p:txBody>
+          <a:bodyPr wrap="square" lIns="0" rIns="0" tIns="0" bIns="0">
+            <a:spAutoFit/>
+          </a:bodyPr>
+          <a:lstStyle/>
+          <a:p>
+            <a:pPr>
+              <a:lnSpc>
+                <a:spcPct val="132000"/>
+              </a:lnSpc>
+              <a:spcBef>
+                <a:spcPts val="0"/>
+              </a:spcBef>
+              <a:spcAft>
+                <a:spcPts val="1100"/>
+              </a:spcAft>
+            </a:pPr>
+            <a:r>
+              <a:rPr sz="1150" b="0" i="0">
+                <a:solidFill>
+                  <a:srgbClr val="5A6068"/>
+                </a:solidFill>
+                <a:latin typeface="Calibri"/>
+              </a:rPr>
+              <a:t>Education's rank depends on which construct you count: attainment works, but parity ratios and learning outcomes do not, so pooling dilutes the signal. Health's rank depends on whether your chosen variable still varies: life expectancy does not, but self-rated health does, so the HDI's choice costs it. Social trust's rank is zero because it is not collected at scale in development frameworks at all — a coverage gap that cannot be fixed by choosing the right variable, because no variable was ever measured.</a:t>
+            </a:r>
+          </a:p>
+          <a:p>
+            <a:pPr>
+              <a:lnSpc>
+                <a:spcPct val="132000"/>
+              </a:lnSpc>
+              <a:spcBef>
+                <a:spcPts val="0"/>
+              </a:spcBef>
+              <a:spcAft>
+                <a:spcPts val="1100"/>
+              </a:spcAft>
+            </a:pPr>
+            <a:r>
+              <a:rPr sz="1150" b="0" i="0">
+                <a:solidFill>
+                  <a:srgbClr val="5A6068"/>
+                </a:solidFill>
+                <a:latin typeface="Calibri"/>
+              </a:rPr>
+              <a:t>These are not criticisms of the frameworks; they were built to track development, and they do. But which components look most consequential for lived experience is not the question they were built to answer.</a:t>
+            </a:r>
+          </a:p>
+        </p:txBody>
+      </p:sp>
+      <p:sp>
+        <p:nvSpPr>
+          <p:cNvPr id="5" name="TextBox 4"/>
+          <p:cNvSpPr txBox="1"/>
+          <p:nvPr/>
+        </p:nvSpPr>
+        <p:spPr>
+          <a:xfrm>
+            <a:off x="11338560" y="6263640"/>
+            <a:ext cx="548640" cy="274320"/>
+          </a:xfrm>
+          <a:prstGeom prst="rect">
+            <a:avLst/>
+          </a:prstGeom>
+          <a:noFill/>
+        </p:spPr>
+        <p:txBody>
+          <a:bodyPr wrap="square" lIns="0" rIns="0" tIns="0" bIns="0">
+            <a:spAutoFit/>
+          </a:bodyPr>
+          <a:lstStyle/>
+          <a:p>
+            <a:pPr algn="r">
+              <a:spcBef>
+                <a:spcPts val="0"/>
+              </a:spcBef>
+              <a:spcAft>
+                <a:spcPts val="0"/>
+              </a:spcAft>
+            </a:pPr>
+            <a:r>
+              <a:rPr sz="1100" b="0" i="0">
+                <a:solidFill>
+                  <a:srgbClr val="868D96"/>
+                </a:solidFill>
+                <a:latin typeface="Consolas"/>
+              </a:rPr>
+              <a:t>II</a:t>
+            </a:r>
+          </a:p>
+        </p:txBody>
+      </p:sp>
+      <p:pic>
+        <p:nvPicPr>
+          <p:cNvPr id="6" name="Picture 5" descr="domain_horse_race.png"/>
+          <p:cNvPicPr>
+            <a:picLocks noChangeAspect="1"/>
+          </p:cNvPicPr>
+          <p:nvPr/>
+        </p:nvPicPr>
+        <p:blipFill>
+          <a:blip r:embed="rId2"/>
+          <a:stretch>
+            <a:fillRect/>
+          </a:stretch>
+        </p:blipFill>
+        <p:spPr>
+          <a:xfrm>
+            <a:off x="5120640" y="1433421"/>
+            <a:ext cx="6537960" cy="3524813"/>
+          </a:xfrm>
+          <a:prstGeom prst="rect">
+            <a:avLst/>
+          </a:prstGeom>
+        </p:spPr>
+      </p:pic>
+      <p:sp>
+        <p:nvSpPr>
+          <p:cNvPr id="7" name="TextBox 6"/>
+          <p:cNvSpPr txBox="1"/>
+          <p:nvPr/>
+        </p:nvSpPr>
+        <p:spPr>
+          <a:xfrm>
+            <a:off x="5120640" y="5897880"/>
+            <a:ext cx="6537960" cy="731520"/>
+          </a:xfrm>
+          <a:prstGeom prst="rect">
+            <a:avLst/>
+          </a:prstGeom>
+          <a:noFill/>
+        </p:spPr>
+        <p:txBody>
+          <a:bodyPr wrap="square" lIns="0" rIns="0" tIns="0" bIns="0">
+            <a:spAutoFit/>
+          </a:bodyPr>
+          <a:lstStyle/>
+          <a:p>
+            <a:pPr>
+              <a:lnSpc>
+                <a:spcPct val="125000"/>
+              </a:lnSpc>
+              <a:spcBef>
+                <a:spcPts val="0"/>
+              </a:spcBef>
+              <a:spcAft>
+                <a:spcPts val="0"/>
+              </a:spcAft>
+            </a:pPr>
+            <a:r>
+              <a:rPr sz="900" b="0" i="0">
+                <a:solidFill>
+                  <a:srgbClr val="868D96"/>
+                </a:solidFill>
+                <a:latin typeface="Calibri"/>
+              </a:rPr>
+              <a:t>Domains competing within one instrument (ESS), at two levels of aggregation. Individual level (left) and country means (right).</a:t>
+            </a:r>
+          </a:p>
+        </p:txBody>
+      </p:sp>
+    </p:spTree>
+  </p:cSld>
+  <p:clrMapOvr>
+    <a:masterClrMapping/>
+  </p:clrMapOvr>
+</p:sld>
+</file>
+
+<file path=ppt/slides/slide16.xml><?xml version="1.0" encoding="utf-8"?>
 <p:sld xmlns:a="http://schemas.openxmlformats.org/drawingml/2006/main" xmlns:p="http://schemas.openxmlformats.org/presentationml/2006/main" xmlns:r="http://schemas.openxmlformats.org/officeDocument/2006/relationships">
   <p:cSld>
     <p:bg>
@@ -4978,7 +5223,7 @@
 </p:sld>
 </file>
 
-<file path=ppt/slides/slide16.xml><?xml version="1.0" encoding="utf-8"?>
+<file path=ppt/slides/slide17.xml><?xml version="1.0" encoding="utf-8"?>
 <p:sld xmlns:a="http://schemas.openxmlformats.org/drawingml/2006/main" xmlns:p="http://schemas.openxmlformats.org/presentationml/2006/main" xmlns:r="http://schemas.openxmlformats.org/officeDocument/2006/relationships">
   <p:cSld>
     <p:bg>
@@ -5402,228 +5647,6 @@
                 <a:latin typeface="Calibri"/>
               </a:rPr>
               <a:t>median R² for trust — below income, health, education individually, above none</a:t>
-            </a:r>
-          </a:p>
-        </p:txBody>
-      </p:sp>
-    </p:spTree>
-  </p:cSld>
-  <p:clrMapOvr>
-    <a:masterClrMapping/>
-  </p:clrMapOvr>
-</p:sld>
-</file>
-
-<file path=ppt/slides/slide17.xml><?xml version="1.0" encoding="utf-8"?>
-<p:sld xmlns:a="http://schemas.openxmlformats.org/drawingml/2006/main" xmlns:p="http://schemas.openxmlformats.org/presentationml/2006/main" xmlns:r="http://schemas.openxmlformats.org/officeDocument/2006/relationships">
-  <p:cSld>
-    <p:bg>
-      <p:bgPr>
-        <a:solidFill>
-          <a:srgbClr val="FCFCFB"/>
-        </a:solidFill>
-        <a:effectLst/>
-      </p:bgPr>
-    </p:bg>
-    <p:spTree>
-      <p:nvGrpSpPr>
-        <p:cNvPr id="1" name=""/>
-        <p:cNvGrpSpPr/>
-        <p:nvPr/>
-      </p:nvGrpSpPr>
-      <p:grpSpPr/>
-      <p:sp>
-        <p:nvSpPr>
-          <p:cNvPr id="2" name="TextBox 1"/>
-          <p:cNvSpPr txBox="1"/>
-          <p:nvPr/>
-        </p:nvSpPr>
-        <p:spPr>
-          <a:xfrm>
-            <a:off x="566928" y="502920"/>
-            <a:ext cx="8595360" cy="274320"/>
-          </a:xfrm>
-          <a:prstGeom prst="rect">
-            <a:avLst/>
-          </a:prstGeom>
-          <a:noFill/>
-        </p:spPr>
-        <p:txBody>
-          <a:bodyPr wrap="square" lIns="0" rIns="0" tIns="0" bIns="0">
-            <a:spAutoFit/>
-          </a:bodyPr>
-          <a:lstStyle/>
-          <a:p>
-            <a:pPr>
-              <a:spcBef>
-                <a:spcPts val="0"/>
-              </a:spcBef>
-              <a:spcAft>
-                <a:spcPts val="0"/>
-              </a:spcAft>
-            </a:pPr>
-            <a:r>
-              <a:rPr sz="1000" b="0" i="0">
-                <a:solidFill>
-                  <a:srgbClr val="A63A30"/>
-                </a:solidFill>
-                <a:latin typeface="Consolas"/>
-              </a:rPr>
-              <a:t>THE DISCONNECT</a:t>
-            </a:r>
-          </a:p>
-        </p:txBody>
-      </p:sp>
-      <p:sp>
-        <p:nvSpPr>
-          <p:cNvPr id="3" name="TextBox 2"/>
-          <p:cNvSpPr txBox="1"/>
-          <p:nvPr/>
-        </p:nvSpPr>
-        <p:spPr>
-          <a:xfrm>
-            <a:off x="566928" y="914400"/>
-            <a:ext cx="8595360" cy="1371600"/>
-          </a:xfrm>
-          <a:prstGeom prst="rect">
-            <a:avLst/>
-          </a:prstGeom>
-          <a:noFill/>
-        </p:spPr>
-        <p:txBody>
-          <a:bodyPr wrap="square" lIns="0" rIns="0" tIns="0" bIns="0">
-            <a:spAutoFit/>
-          </a:bodyPr>
-          <a:lstStyle/>
-          <a:p>
-            <a:pPr>
-              <a:lnSpc>
-                <a:spcPct val="108000"/>
-              </a:lnSpc>
-              <a:spcBef>
-                <a:spcPts val="0"/>
-              </a:spcBef>
-              <a:spcAft>
-                <a:spcPts val="0"/>
-              </a:spcAft>
-            </a:pPr>
-            <a:r>
-              <a:rPr sz="2700" b="0" i="0">
-                <a:solidFill>
-                  <a:srgbClr val="14171C"/>
-                </a:solidFill>
-                <a:latin typeface="Georgia"/>
-              </a:rPr>
-              <a:t>These frameworks work for development. They do not work for wellbeing.</a:t>
-            </a:r>
-          </a:p>
-        </p:txBody>
-      </p:sp>
-      <p:sp>
-        <p:nvSpPr>
-          <p:cNvPr id="4" name="TextBox 3"/>
-          <p:cNvSpPr txBox="1"/>
-          <p:nvPr/>
-        </p:nvSpPr>
-        <p:spPr>
-          <a:xfrm>
-            <a:off x="566928" y="2286000"/>
-            <a:ext cx="8595360" cy="3840480"/>
-          </a:xfrm>
-          <a:prstGeom prst="rect">
-            <a:avLst/>
-          </a:prstGeom>
-          <a:noFill/>
-        </p:spPr>
-        <p:txBody>
-          <a:bodyPr wrap="square" lIns="0" rIns="0" tIns="0" bIns="0">
-            <a:spAutoFit/>
-          </a:bodyPr>
-          <a:lstStyle/>
-          <a:p>
-            <a:pPr>
-              <a:lnSpc>
-                <a:spcPct val="132000"/>
-              </a:lnSpc>
-              <a:spcBef>
-                <a:spcPts val="0"/>
-              </a:spcBef>
-              <a:spcAft>
-                <a:spcPts val="1100"/>
-              </a:spcAft>
-            </a:pPr>
-            <a:r>
-              <a:rPr sz="1400" b="0" i="0">
-                <a:solidFill>
-                  <a:srgbClr val="5A6068"/>
-                </a:solidFill>
-                <a:latin typeface="Calibri"/>
-              </a:rPr>
-              <a:t>The HDI and SDG frameworks do not answer the question 'what makes people's lives better?' any more than a global income statistics database answers 'what makes a person happy?' They were designed to track development, measured at the aggregate level, with indicators chosen before the question of individual wellbeing was systematically tested. That is not a design failure; it is the intended scope.</a:t>
-            </a:r>
-          </a:p>
-          <a:p>
-            <a:pPr>
-              <a:lnSpc>
-                <a:spcPct val="132000"/>
-              </a:lnSpc>
-              <a:spcBef>
-                <a:spcPts val="0"/>
-              </a:spcBef>
-              <a:spcAft>
-                <a:spcPts val="1100"/>
-              </a:spcAft>
-            </a:pPr>
-            <a:r>
-              <a:rPr sz="1400" b="0" i="0">
-                <a:solidFill>
-                  <a:srgbClr val="5A6068"/>
-                </a:solidFill>
-                <a:latin typeface="Calibri"/>
-              </a:rPr>
-              <a:t>But it means the gap is structural. Education's access indicators work; pooling them with constructs that do not does not fix wellbeing prediction — it just builds a worse measure. Choosing a variable for health that is closer to saturated than the outcome it predicts is a measurement choice, not an incurable problem. And when a domain is never collected, no amount of better construction on the others will reach it.</a:t>
-            </a:r>
-          </a:p>
-        </p:txBody>
-      </p:sp>
-      <p:sp>
-        <p:nvSpPr>
-          <p:cNvPr id="5" name="TextBox 4"/>
-          <p:cNvSpPr txBox="1"/>
-          <p:nvPr/>
-        </p:nvSpPr>
-        <p:spPr>
-          <a:xfrm>
-            <a:off x="11338560" y="6263640"/>
-            <a:ext cx="548640" cy="274320"/>
-          </a:xfrm>
-          <a:prstGeom prst="rect">
-            <a:avLst/>
-          </a:prstGeom>
-          <a:noFill/>
-        </p:spPr>
-        <p:txBody>
-          <a:bodyPr wrap="square" lIns="0" rIns="0" tIns="0" bIns="0">
-            <a:spAutoFit/>
-          </a:bodyPr>
-          <a:lstStyle/>
-          <a:p>
-            <a:pPr algn="r">
-              <a:spcBef>
-                <a:spcPts val="0"/>
-              </a:spcBef>
-              <a:spcAft>
-                <a:spcPts val="0"/>
-              </a:spcAft>
-            </a:pPr>
-            <a:r>
-              <a:rPr sz="1100" b="0" i="0">
-                <a:solidFill>
-                  <a:srgbClr val="868D96"/>
-                </a:solidFill>
-                <a:latin typeface="Consolas"/>
-              </a:rPr>
-              <a:t>III</a:t>
             </a:r>
           </a:p>
         </p:txBody>
@@ -5691,7 +5714,7 @@
                 </a:solidFill>
                 <a:latin typeface="Consolas"/>
               </a:rPr>
-              <a:t>IMPLICATION 1 · MEASUREMENT CHOICES CONSTRAIN WHAT FRAMEWORKS CAN SEE</a:t>
+              <a:t>THE DISCONNECT</a:t>
             </a:r>
           </a:p>
         </p:txBody>
@@ -5736,7 +5759,7 @@
                 </a:solidFill>
                 <a:latin typeface="Georgia"/>
               </a:rPr>
-              <a:t>Education and health: the case for measurement specificity</a:t>
+              <a:t>These frameworks work for development. They do not work for wellbeing.</a:t>
             </a:r>
           </a:p>
         </p:txBody>
@@ -5781,7 +5804,7 @@
                 </a:solidFill>
                 <a:latin typeface="Calibri"/>
               </a:rPr>
-              <a:t>Education is significant everywhere it is measured as attainment, but nearly invisible in SDG4 because most indicators measure something else. Health is nearly invisible in the HDI because life expectancy has saturated. Neither domain has changed; the frameworks' construction choices have.</a:t>
+              <a:t>The HDI and SDG frameworks do not answer the question 'what makes people's lives better?' any more than a global income statistics database answers 'what makes a person happy?' They were designed to track development, measured at the aggregate level, with indicators chosen before the question of individual wellbeing was systematically tested. That is not a design failure; it is the intended scope.</a:t>
             </a:r>
           </a:p>
           <a:p>
@@ -5803,7 +5826,7 @@
                 </a:solidFill>
                 <a:latin typeface="Calibri"/>
               </a:rPr>
-              <a:t>For education, this suggests development measurement should weigh access and completion more heavily than parity ratios in wellbeing contexts — not universally, but with explicit construction choices that account for what is known to matter. For health, it suggests that wellbeing-motivated measurement may need different variables at different development levels: life expectancy in lower-income settings, self-reported health or specific conditions in saturated ones.</a:t>
+              <a:t>But it means the gap is structural. Education's access indicators work; pooling them with constructs that do not does not fix wellbeing prediction — it just builds a worse measure. Choosing a variable for health that is closer to saturated than the outcome it predicts is a measurement choice, not an incurable problem. And when a domain is never collected, no amount of better construction on the others will reach it.</a:t>
             </a:r>
           </a:p>
         </p:txBody>
@@ -5913,7 +5936,7 @@
                 </a:solidFill>
                 <a:latin typeface="Consolas"/>
               </a:rPr>
-              <a:t>IMPLICATION 2 · COVERAGE GAPS ARE MORE FUNDAMENTAL THAN CONSTRUCT CHOICE</a:t>
+              <a:t>IMPLICATION 1 · MEASUREMENT CHOICES CONSTRAIN WHAT FRAMEWORKS CAN SEE</a:t>
             </a:r>
           </a:p>
         </p:txBody>
@@ -5958,7 +5981,7 @@
                 </a:solidFill>
                 <a:latin typeface="Georgia"/>
               </a:rPr>
-              <a:t>Social trust: why you cannot fix a measurement by measuring better</a:t>
+              <a:t>Education and health: the case for measurement specificity</a:t>
             </a:r>
           </a:p>
         </p:txBody>
@@ -6003,7 +6026,7 @@
                 </a:solidFill>
                 <a:latin typeface="Calibri"/>
               </a:rPr>
-              <a:t>Social trust is the most tentative finding here. The ESS is Europe-only, across 36 countries, and relies on a single item. That bounds the claim: the pattern holds in Europe, with a wellbeing survey, on a self-report basis. It does not claim universality.</a:t>
+              <a:t>Education is significant everywhere it is measured as attainment, but nearly invisible in SDG4 because most indicators measure something else. Health is nearly invisible in the HDI because life expectancy has saturated. Neither domain has changed; the frameworks' construction choices have.</a:t>
             </a:r>
           </a:p>
           <a:p>
@@ -6025,29 +6048,7 @@
                 </a:solidFill>
                 <a:latin typeface="Calibri"/>
               </a:rPr>
-              <a:t>But the reason it is tentative points to the deepest problem: trust is not collected at global scale in either framework. The SDG database has 13 series adjacent to trust, but they measure institutional confidence, not interpersonal trust, and they are intermittent (147 of 163 country-series have fewer than four years of data). This is not a construct-choice problem that better measurement can solve. It is a coverage gap that requires deciding to collect the data in the first place.</a:t>
-            </a:r>
-          </a:p>
-          <a:p>
-            <a:pPr>
-              <a:lnSpc>
-                <a:spcPct val="132000"/>
-              </a:lnSpc>
-              <a:spcBef>
-                <a:spcPts val="0"/>
-              </a:spcBef>
-              <a:spcAft>
-                <a:spcPts val="1100"/>
-              </a:spcAft>
-            </a:pPr>
-            <a:r>
-              <a:rPr sz="1400" b="0" i="0">
-                <a:solidFill>
-                  <a:srgbClr val="5A6068"/>
-                </a:solidFill>
-                <a:latin typeface="Calibri"/>
-              </a:rPr>
-              <a:t>For wellbeing-conscious development monitoring, this suggests either building interpersonal-trust measurement into the core frameworks, or acknowledging that other surveys (the ESS, Gallup World Poll, World Values Survey) may be more suitable for understanding what shapes lived experience.</a:t>
+              <a:t>For education, this suggests development measurement should weigh access and completion more heavily than parity ratios in wellbeing contexts — not universally, but with explicit construction choices that account for what is known to matter. For health, it suggests that wellbeing-motivated measurement may need different variables at different development levels: life expectancy in lower-income settings, self-reported health or specific conditions in saturated ones.</a:t>
             </a:r>
           </a:p>
         </p:txBody>
@@ -6851,7 +6852,7 @@
                 </a:solidFill>
                 <a:latin typeface="Consolas"/>
               </a:rPr>
-              <a:t>CONCLUSION</a:t>
+              <a:t>IMPLICATION 2 · COVERAGE GAPS ARE MORE FUNDAMENTAL THAN CONSTRUCT CHOICE</a:t>
             </a:r>
           </a:p>
         </p:txBody>
@@ -6896,7 +6897,7 @@
                 </a:solidFill>
                 <a:latin typeface="Georgia"/>
               </a:rPr>
-              <a:t>A question rather than a prescription</a:t>
+              <a:t>Social trust: why you cannot fix a measurement by measuring better</a:t>
             </a:r>
           </a:p>
         </p:txBody>
@@ -6941,7 +6942,7 @@
                 </a:solidFill>
                 <a:latin typeface="Calibri"/>
               </a:rPr>
-              <a:t>The evidence shows a consistent pattern: which domain looks most consequential for wellbeing depends on which framework measures it and what variable they chose. This is not about the domains; it is about the tools.</a:t>
+              <a:t>Social trust is the most tentative finding here. The ESS is Europe-only, across 36 countries, and relies on a single item. That bounds the claim: the pattern holds in Europe, with a wellbeing survey, on a self-report basis. It does not claim universality.</a:t>
             </a:r>
           </a:p>
           <a:p>
@@ -6963,7 +6964,7 @@
                 </a:solidFill>
                 <a:latin typeface="Calibri"/>
               </a:rPr>
-              <a:t>Whether development frameworks should be redesigned around wellbeing is outside the scope here. But if they were, this finding suggests the question to ask: should measurement choices be made with explicit reference to which variables still move and still matter for lived experience? Should coverage be built in for domains the frameworks discovered only by studying something else?</a:t>
+              <a:t>But the reason it is tentative points to the deepest problem: trust is not collected at global scale in either framework. The SDG database has 13 series adjacent to trust, but they measure institutional confidence, not interpersonal trust, and they are intermittent (147 of 163 country-series have fewer than four years of data). This is not a construct-choice problem that better measurement can solve. It is a coverage gap that requires deciding to collect the data in the first place.</a:t>
             </a:r>
           </a:p>
           <a:p>
@@ -6985,7 +6986,7 @@
                 </a:solidFill>
                 <a:latin typeface="Calibri"/>
               </a:rPr>
-              <a:t>The frameworks work well for their stated purpose. The question is whether wellbeing should become part of that purpose — and if it does, whether the measurement that comes from that intent should be different from the aggregate, development-first measurement in place today.</a:t>
+              <a:t>For wellbeing-conscious development monitoring, this suggests either building interpersonal-trust measurement into the core frameworks, or acknowledging that other surveys (the ESS, Gallup World Poll, World Values Survey) may be more suitable for understanding what shapes lived experience.</a:t>
             </a:r>
           </a:p>
         </p:txBody>
@@ -7041,6 +7042,250 @@
 </file>
 
 <file path=ppt/slides/slide21.xml><?xml version="1.0" encoding="utf-8"?>
+<p:sld xmlns:a="http://schemas.openxmlformats.org/drawingml/2006/main" xmlns:p="http://schemas.openxmlformats.org/presentationml/2006/main" xmlns:r="http://schemas.openxmlformats.org/officeDocument/2006/relationships">
+  <p:cSld>
+    <p:bg>
+      <p:bgPr>
+        <a:solidFill>
+          <a:srgbClr val="FCFCFB"/>
+        </a:solidFill>
+        <a:effectLst/>
+      </p:bgPr>
+    </p:bg>
+    <p:spTree>
+      <p:nvGrpSpPr>
+        <p:cNvPr id="1" name=""/>
+        <p:cNvGrpSpPr/>
+        <p:nvPr/>
+      </p:nvGrpSpPr>
+      <p:grpSpPr/>
+      <p:sp>
+        <p:nvSpPr>
+          <p:cNvPr id="2" name="TextBox 1"/>
+          <p:cNvSpPr txBox="1"/>
+          <p:nvPr/>
+        </p:nvSpPr>
+        <p:spPr>
+          <a:xfrm>
+            <a:off x="566928" y="502920"/>
+            <a:ext cx="8595360" cy="274320"/>
+          </a:xfrm>
+          <a:prstGeom prst="rect">
+            <a:avLst/>
+          </a:prstGeom>
+          <a:noFill/>
+        </p:spPr>
+        <p:txBody>
+          <a:bodyPr wrap="square" lIns="0" rIns="0" tIns="0" bIns="0">
+            <a:spAutoFit/>
+          </a:bodyPr>
+          <a:lstStyle/>
+          <a:p>
+            <a:pPr>
+              <a:spcBef>
+                <a:spcPts val="0"/>
+              </a:spcBef>
+              <a:spcAft>
+                <a:spcPts val="0"/>
+              </a:spcAft>
+            </a:pPr>
+            <a:r>
+              <a:rPr sz="1000" b="0" i="0">
+                <a:solidFill>
+                  <a:srgbClr val="A63A30"/>
+                </a:solidFill>
+                <a:latin typeface="Consolas"/>
+              </a:rPr>
+              <a:t>CONCLUSION</a:t>
+            </a:r>
+          </a:p>
+        </p:txBody>
+      </p:sp>
+      <p:sp>
+        <p:nvSpPr>
+          <p:cNvPr id="3" name="TextBox 2"/>
+          <p:cNvSpPr txBox="1"/>
+          <p:nvPr/>
+        </p:nvSpPr>
+        <p:spPr>
+          <a:xfrm>
+            <a:off x="566928" y="914400"/>
+            <a:ext cx="8595360" cy="1371600"/>
+          </a:xfrm>
+          <a:prstGeom prst="rect">
+            <a:avLst/>
+          </a:prstGeom>
+          <a:noFill/>
+        </p:spPr>
+        <p:txBody>
+          <a:bodyPr wrap="square" lIns="0" rIns="0" tIns="0" bIns="0">
+            <a:spAutoFit/>
+          </a:bodyPr>
+          <a:lstStyle/>
+          <a:p>
+            <a:pPr>
+              <a:lnSpc>
+                <a:spcPct val="108000"/>
+              </a:lnSpc>
+              <a:spcBef>
+                <a:spcPts val="0"/>
+              </a:spcBef>
+              <a:spcAft>
+                <a:spcPts val="0"/>
+              </a:spcAft>
+            </a:pPr>
+            <a:r>
+              <a:rPr sz="2700" b="0" i="0">
+                <a:solidFill>
+                  <a:srgbClr val="14171C"/>
+                </a:solidFill>
+                <a:latin typeface="Georgia"/>
+              </a:rPr>
+              <a:t>A question rather than a prescription</a:t>
+            </a:r>
+          </a:p>
+        </p:txBody>
+      </p:sp>
+      <p:sp>
+        <p:nvSpPr>
+          <p:cNvPr id="4" name="TextBox 3"/>
+          <p:cNvSpPr txBox="1"/>
+          <p:nvPr/>
+        </p:nvSpPr>
+        <p:spPr>
+          <a:xfrm>
+            <a:off x="566928" y="2286000"/>
+            <a:ext cx="8595360" cy="3840480"/>
+          </a:xfrm>
+          <a:prstGeom prst="rect">
+            <a:avLst/>
+          </a:prstGeom>
+          <a:noFill/>
+        </p:spPr>
+        <p:txBody>
+          <a:bodyPr wrap="square" lIns="0" rIns="0" tIns="0" bIns="0">
+            <a:spAutoFit/>
+          </a:bodyPr>
+          <a:lstStyle/>
+          <a:p>
+            <a:pPr>
+              <a:lnSpc>
+                <a:spcPct val="132000"/>
+              </a:lnSpc>
+              <a:spcBef>
+                <a:spcPts val="0"/>
+              </a:spcBef>
+              <a:spcAft>
+                <a:spcPts val="1100"/>
+              </a:spcAft>
+            </a:pPr>
+            <a:r>
+              <a:rPr sz="1400" b="0" i="0">
+                <a:solidFill>
+                  <a:srgbClr val="5A6068"/>
+                </a:solidFill>
+                <a:latin typeface="Calibri"/>
+              </a:rPr>
+              <a:t>The evidence shows a consistent pattern: which domain looks most consequential for wellbeing depends on which framework measures it and what variable they chose. This is not about the domains; it is about the tools.</a:t>
+            </a:r>
+          </a:p>
+          <a:p>
+            <a:pPr>
+              <a:lnSpc>
+                <a:spcPct val="132000"/>
+              </a:lnSpc>
+              <a:spcBef>
+                <a:spcPts val="0"/>
+              </a:spcBef>
+              <a:spcAft>
+                <a:spcPts val="1100"/>
+              </a:spcAft>
+            </a:pPr>
+            <a:r>
+              <a:rPr sz="1400" b="0" i="0">
+                <a:solidFill>
+                  <a:srgbClr val="5A6068"/>
+                </a:solidFill>
+                <a:latin typeface="Calibri"/>
+              </a:rPr>
+              <a:t>Whether development frameworks should be redesigned around wellbeing is outside the scope here. But if they were, this finding suggests the question to ask: should measurement choices be made with explicit reference to which variables still move and still matter for lived experience? Should coverage be built in for domains the frameworks discovered only by studying something else?</a:t>
+            </a:r>
+          </a:p>
+          <a:p>
+            <a:pPr>
+              <a:lnSpc>
+                <a:spcPct val="132000"/>
+              </a:lnSpc>
+              <a:spcBef>
+                <a:spcPts val="0"/>
+              </a:spcBef>
+              <a:spcAft>
+                <a:spcPts val="1100"/>
+              </a:spcAft>
+            </a:pPr>
+            <a:r>
+              <a:rPr sz="1400" b="0" i="0">
+                <a:solidFill>
+                  <a:srgbClr val="5A6068"/>
+                </a:solidFill>
+                <a:latin typeface="Calibri"/>
+              </a:rPr>
+              <a:t>The frameworks work well for their stated purpose. The question is whether wellbeing should become part of that purpose — and if it does, whether the measurement that comes from that intent should be different from the aggregate, development-first measurement in place today.</a:t>
+            </a:r>
+          </a:p>
+        </p:txBody>
+      </p:sp>
+      <p:sp>
+        <p:nvSpPr>
+          <p:cNvPr id="5" name="TextBox 4"/>
+          <p:cNvSpPr txBox="1"/>
+          <p:nvPr/>
+        </p:nvSpPr>
+        <p:spPr>
+          <a:xfrm>
+            <a:off x="11338560" y="6263640"/>
+            <a:ext cx="548640" cy="274320"/>
+          </a:xfrm>
+          <a:prstGeom prst="rect">
+            <a:avLst/>
+          </a:prstGeom>
+          <a:noFill/>
+        </p:spPr>
+        <p:txBody>
+          <a:bodyPr wrap="square" lIns="0" rIns="0" tIns="0" bIns="0">
+            <a:spAutoFit/>
+          </a:bodyPr>
+          <a:lstStyle/>
+          <a:p>
+            <a:pPr algn="r">
+              <a:spcBef>
+                <a:spcPts val="0"/>
+              </a:spcBef>
+              <a:spcAft>
+                <a:spcPts val="0"/>
+              </a:spcAft>
+            </a:pPr>
+            <a:r>
+              <a:rPr sz="1100" b="0" i="0">
+                <a:solidFill>
+                  <a:srgbClr val="868D96"/>
+                </a:solidFill>
+                <a:latin typeface="Consolas"/>
+              </a:rPr>
+              <a:t>III</a:t>
+            </a:r>
+          </a:p>
+        </p:txBody>
+      </p:sp>
+    </p:spTree>
+  </p:cSld>
+  <p:clrMapOvr>
+    <a:masterClrMapping/>
+  </p:clrMapOvr>
+</p:sld>
+</file>
+
+<file path=ppt/slides/slide22.xml><?xml version="1.0" encoding="utf-8"?>
 <p:sld xmlns:a="http://schemas.openxmlformats.org/drawingml/2006/main" xmlns:p="http://schemas.openxmlformats.org/presentationml/2006/main" xmlns:r="http://schemas.openxmlformats.org/officeDocument/2006/relationships">
   <p:cSld>
     <p:bg>
@@ -7197,7 +7442,7 @@
 </p:sld>
 </file>
 
-<file path=ppt/slides/slide22.xml><?xml version="1.0" encoding="utf-8"?>
+<file path=ppt/slides/slide23.xml><?xml version="1.0" encoding="utf-8"?>
 <p:sld xmlns:a="http://schemas.openxmlformats.org/drawingml/2006/main" xmlns:p="http://schemas.openxmlformats.org/presentationml/2006/main" xmlns:r="http://schemas.openxmlformats.org/officeDocument/2006/relationships">
   <p:cSld>
     <p:bg>
@@ -7716,7 +7961,7 @@
 </p:sld>
 </file>
 
-<file path=ppt/slides/slide23.xml><?xml version="1.0" encoding="utf-8"?>
+<file path=ppt/slides/slide24.xml><?xml version="1.0" encoding="utf-8"?>
 <p:sld xmlns:a="http://schemas.openxmlformats.org/drawingml/2006/main" xmlns:p="http://schemas.openxmlformats.org/presentationml/2006/main" xmlns:r="http://schemas.openxmlformats.org/officeDocument/2006/relationships">
   <p:cSld>
     <p:bg>

</xml_diff>

<commit_message>
Add SDG indicator rankings beat showing health importance despite low %
New beat: "SDG indicator rankings · why health matters despite low %"

Addresses apparent weakness: health shows 11.5% significance in SDG but
actually ranks 4th of 17 goals with 16 of top 25 indicators being health-related
(infant mortality, stunting, sanitation, water, etc.).

Key insight: The low 11.5% reflects weak overall SDG signal (~3-4% for all goals),
not health's lack of importance. Within sparse landscape, health is strong.

Deck now 27 slides.

Co-Authored-By: Claude Haiku 4.5 <noreply@anthropic.com>
</commit_message>
<xml_diff>
--- a/deck/Measured_Where_It_Varies.pptx
+++ b/deck/Measured_Where_It_Varies.pptx
@@ -31,6 +31,7 @@
     <p:sldId id="279" r:id="rId30"/>
     <p:sldId id="280" r:id="rId31"/>
     <p:sldId id="281" r:id="rId32"/>
+    <p:sldId id="282" r:id="rId33"/>
   </p:sldIdLst>
   <p:sldSz cx="12191695" cy="6858000" type="screen4x3"/>
   <p:notesSz cx="6858000" cy="9144000"/>
@@ -4275,7 +4276,7 @@
                 </a:solidFill>
                 <a:latin typeface="Consolas"/>
               </a:rPr>
-              <a:t>RESULT 3 · SOCIAL TRUST</a:t>
+              <a:t>SDG INDICATOR RANKINGS · WHY HEALTH MATTERS DESPITE LOW %</a:t>
             </a:r>
           </a:p>
         </p:txBody>
@@ -4320,7 +4321,7 @@
                 </a:solidFill>
                 <a:latin typeface="Georgia"/>
               </a:rPr>
-              <a:t>Social trust leads the ESS, is nearly invisible to development frameworks</a:t>
+              <a:t>Health indicators rank 4th among 17 SDG goals; the low percentage reflects weak overall SDG signal</a:t>
             </a:r>
           </a:p>
         </p:txBody>
@@ -4365,7 +4366,7 @@
                 </a:solidFill>
                 <a:latin typeface="Calibri"/>
               </a:rPr>
-              <a:t>Social trust — 'most people can be trusted' — is significant in 94% of ESS countries, third strongest domain after health and income, with median R² = 0.041. Neither the HDI nor the SDG framework measures it at all.</a:t>
+              <a:t>The SDG database is vast: 661 series across 42 countries testing 17 goals. The overall significance rate is low — only 3-4% of all country-indicator pairs are significant. Within that sparse landscape, health indicators rank fourth, with 16 of the top 25 most predictive SDG series falling under Goal 3. These are survival measures: infant mortality, under-five mortality, stunting, neonatal mortality, sanitation, drinking water — all objective, externally measured.</a:t>
             </a:r>
           </a:p>
           <a:p>
@@ -4387,29 +4388,7 @@
                 </a:solidFill>
                 <a:latin typeface="Calibri"/>
               </a:rPr>
-              <a:t>The SDG database does carry 13 trust- and satisfaction-adjacent series under Goal 16: satisfaction with public services, perception of bribery, perceived decision-making inclusiveness. But these measure institutional confidence, not interpersonal trust — a different construct, and one that correlates more weakly with life satisfaction even when tested across countries. Moreover, their median coverage is one observation per country-series against six for the database as a whole; 147 of 163 country-series cannot support a time-series design.</a:t>
-            </a:r>
-          </a:p>
-          <a:p>
-            <a:pPr>
-              <a:lnSpc>
-                <a:spcPct val="132000"/>
-              </a:lnSpc>
-              <a:spcBef>
-                <a:spcPts val="0"/>
-              </a:spcBef>
-              <a:spcAft>
-                <a:spcPts val="1100"/>
-              </a:spcAft>
-            </a:pPr>
-            <a:r>
-              <a:rPr sz="1150" b="0" i="0">
-                <a:solidFill>
-                  <a:srgbClr val="5A6068"/>
-                </a:solidFill>
-                <a:latin typeface="Calibri"/>
-              </a:rPr>
-              <a:t>Education's and health's problems are about which variable to count within a domain. Trust's problem is different: it is not in the frameworks at all. That is a coverage gap, not a measurement problem.</a:t>
+              <a:t>The low 11.5% rate for health is not evidence that health doesn't matter. It is evidence that most of the SDG database does not predict wellbeing. Within that context, health ranks high.</a:t>
             </a:r>
           </a:p>
         </p:txBody>
@@ -4458,7 +4437,7 @@
       </p:sp>
       <p:pic>
         <p:nvPicPr>
-          <p:cNvPr id="6" name="Picture 5" descr="trust_coverage_comparison.png"/>
+          <p:cNvPr id="6" name="Picture 5" descr="sdg_indicator_top20.png"/>
           <p:cNvPicPr>
             <a:picLocks noChangeAspect="1"/>
           </p:cNvPicPr>
@@ -4472,8 +4451,8 @@
         </p:blipFill>
         <p:spPr>
           <a:xfrm>
-            <a:off x="5120640" y="1234440"/>
-            <a:ext cx="6537960" cy="3922776"/>
+            <a:off x="5279547" y="658368"/>
+            <a:ext cx="6220145" cy="5074920"/>
           </a:xfrm>
           <a:prstGeom prst="rect">
             <a:avLst/>
@@ -4520,7 +4499,7 @@
                 </a:solidFill>
                 <a:latin typeface="Calibri"/>
               </a:rPr>
-              <a:t>Social trust: 94% of ESS countries significant (individual level), 1.5% of SDG16 country-indicator pairs (institutional confidence, not interpersonal trust), not measured in the HDI.</a:t>
+              <a:t>Top 25 SDG indicators by significance. Health (Goal 3) dominates: 16 of 25 top series.</a:t>
             </a:r>
           </a:p>
         </p:txBody>
@@ -4588,7 +4567,7 @@
                 </a:solidFill>
                 <a:latin typeface="Consolas"/>
               </a:rPr>
-              <a:t>SYNTHESIS</a:t>
+              <a:t>RESULT 3 · SOCIAL TRUST</a:t>
             </a:r>
           </a:p>
         </p:txBody>
@@ -4633,7 +4612,7 @@
                 </a:solidFill>
                 <a:latin typeface="Georgia"/>
               </a:rPr>
-              <a:t>Three domains, three ways frameworks lose sight of what matters</a:t>
+              <a:t>Social trust leads the ESS, is nearly invisible to development frameworks</a:t>
             </a:r>
           </a:p>
         </p:txBody>
@@ -4678,7 +4657,7 @@
                 </a:solidFill>
                 <a:latin typeface="Calibri"/>
               </a:rPr>
-              <a:t>Education's rank depends on which construct you count: attainment works, but parity ratios and learning outcomes do not, so pooling dilutes the signal. Health's rank depends on whether your chosen variable still varies: life expectancy does not, but self-rated health does, so the HDI's choice costs it. Social trust's rank is zero because it is not collected at scale in development frameworks at all — a coverage gap that cannot be fixed by choosing the right variable, because no variable was ever measured.</a:t>
+              <a:t>Social trust — 'most people can be trusted' — is significant in 94% of ESS countries, third strongest domain after health and income, with median R² = 0.041. Neither the HDI nor the SDG framework measures it at all.</a:t>
             </a:r>
           </a:p>
           <a:p>
@@ -4700,7 +4679,29 @@
                 </a:solidFill>
                 <a:latin typeface="Calibri"/>
               </a:rPr>
-              <a:t>These are not criticisms of the frameworks; they were built to track development, and they do. But which components look most consequential for lived experience is not the question they were built to answer.</a:t>
+              <a:t>The SDG database does carry 13 trust- and satisfaction-adjacent series under Goal 16: satisfaction with public services, perception of bribery, perceived decision-making inclusiveness. But these measure institutional confidence, not interpersonal trust — a different construct, and one that correlates more weakly with life satisfaction even when tested across countries. Moreover, their median coverage is one observation per country-series against six for the database as a whole; 147 of 163 country-series cannot support a time-series design.</a:t>
+            </a:r>
+          </a:p>
+          <a:p>
+            <a:pPr>
+              <a:lnSpc>
+                <a:spcPct val="132000"/>
+              </a:lnSpc>
+              <a:spcBef>
+                <a:spcPts val="0"/>
+              </a:spcBef>
+              <a:spcAft>
+                <a:spcPts val="1100"/>
+              </a:spcAft>
+            </a:pPr>
+            <a:r>
+              <a:rPr sz="1150" b="0" i="0">
+                <a:solidFill>
+                  <a:srgbClr val="5A6068"/>
+                </a:solidFill>
+                <a:latin typeface="Calibri"/>
+              </a:rPr>
+              <a:t>Education's and health's problems are about which variable to count within a domain. Trust's problem is different: it is not in the frameworks at all. That is a coverage gap, not a measurement problem.</a:t>
             </a:r>
           </a:p>
         </p:txBody>
@@ -4749,7 +4750,7 @@
       </p:sp>
       <p:pic>
         <p:nvPicPr>
-          <p:cNvPr id="6" name="Picture 5" descr="domain_horse_race.png"/>
+          <p:cNvPr id="6" name="Picture 5" descr="trust_coverage_comparison.png"/>
           <p:cNvPicPr>
             <a:picLocks noChangeAspect="1"/>
           </p:cNvPicPr>
@@ -4763,8 +4764,8 @@
         </p:blipFill>
         <p:spPr>
           <a:xfrm>
-            <a:off x="5120640" y="1433421"/>
-            <a:ext cx="6537960" cy="3524813"/>
+            <a:off x="5120640" y="1234440"/>
+            <a:ext cx="6537960" cy="3922776"/>
           </a:xfrm>
           <a:prstGeom prst="rect">
             <a:avLst/>
@@ -4811,7 +4812,7 @@
                 </a:solidFill>
                 <a:latin typeface="Calibri"/>
               </a:rPr>
-              <a:t>Domains competing within one instrument (ESS), at two levels of aggregation. Individual level (left) and country means (right).</a:t>
+              <a:t>Social trust: 94% of ESS countries significant (individual level), 1.5% of SDG16 country-indicator pairs (institutional confidence, not interpersonal trust), not measured in the HDI.</a:t>
             </a:r>
           </a:p>
         </p:txBody>
@@ -4825,6 +4826,297 @@
 </file>
 
 <file path=ppt/slides/slide15.xml><?xml version="1.0" encoding="utf-8"?>
+<p:sld xmlns:a="http://schemas.openxmlformats.org/drawingml/2006/main" xmlns:p="http://schemas.openxmlformats.org/presentationml/2006/main" xmlns:r="http://schemas.openxmlformats.org/officeDocument/2006/relationships">
+  <p:cSld>
+    <p:bg>
+      <p:bgPr>
+        <a:solidFill>
+          <a:srgbClr val="FCFCFB"/>
+        </a:solidFill>
+        <a:effectLst/>
+      </p:bgPr>
+    </p:bg>
+    <p:spTree>
+      <p:nvGrpSpPr>
+        <p:cNvPr id="1" name=""/>
+        <p:cNvGrpSpPr/>
+        <p:nvPr/>
+      </p:nvGrpSpPr>
+      <p:grpSpPr/>
+      <p:sp>
+        <p:nvSpPr>
+          <p:cNvPr id="2" name="TextBox 1"/>
+          <p:cNvSpPr txBox="1"/>
+          <p:nvPr/>
+        </p:nvSpPr>
+        <p:spPr>
+          <a:xfrm>
+            <a:off x="566928" y="502920"/>
+            <a:ext cx="4160520" cy="274320"/>
+          </a:xfrm>
+          <a:prstGeom prst="rect">
+            <a:avLst/>
+          </a:prstGeom>
+          <a:noFill/>
+        </p:spPr>
+        <p:txBody>
+          <a:bodyPr wrap="square" lIns="0" rIns="0" tIns="0" bIns="0">
+            <a:spAutoFit/>
+          </a:bodyPr>
+          <a:lstStyle/>
+          <a:p>
+            <a:pPr>
+              <a:spcBef>
+                <a:spcPts val="0"/>
+              </a:spcBef>
+              <a:spcAft>
+                <a:spcPts val="0"/>
+              </a:spcAft>
+            </a:pPr>
+            <a:r>
+              <a:rPr sz="1000" b="0" i="0">
+                <a:solidFill>
+                  <a:srgbClr val="A63A30"/>
+                </a:solidFill>
+                <a:latin typeface="Consolas"/>
+              </a:rPr>
+              <a:t>SYNTHESIS</a:t>
+            </a:r>
+          </a:p>
+        </p:txBody>
+      </p:sp>
+      <p:sp>
+        <p:nvSpPr>
+          <p:cNvPr id="3" name="TextBox 2"/>
+          <p:cNvSpPr txBox="1"/>
+          <p:nvPr/>
+        </p:nvSpPr>
+        <p:spPr>
+          <a:xfrm>
+            <a:off x="566928" y="914400"/>
+            <a:ext cx="4160520" cy="1371600"/>
+          </a:xfrm>
+          <a:prstGeom prst="rect">
+            <a:avLst/>
+          </a:prstGeom>
+          <a:noFill/>
+        </p:spPr>
+        <p:txBody>
+          <a:bodyPr wrap="square" lIns="0" rIns="0" tIns="0" bIns="0">
+            <a:spAutoFit/>
+          </a:bodyPr>
+          <a:lstStyle/>
+          <a:p>
+            <a:pPr>
+              <a:lnSpc>
+                <a:spcPct val="108000"/>
+              </a:lnSpc>
+              <a:spcBef>
+                <a:spcPts val="0"/>
+              </a:spcBef>
+              <a:spcAft>
+                <a:spcPts val="0"/>
+              </a:spcAft>
+            </a:pPr>
+            <a:r>
+              <a:rPr sz="2300" b="0" i="0">
+                <a:solidFill>
+                  <a:srgbClr val="14171C"/>
+                </a:solidFill>
+                <a:latin typeface="Georgia"/>
+              </a:rPr>
+              <a:t>Three domains, three ways frameworks lose sight of what matters</a:t>
+            </a:r>
+          </a:p>
+        </p:txBody>
+      </p:sp>
+      <p:sp>
+        <p:nvSpPr>
+          <p:cNvPr id="4" name="TextBox 3"/>
+          <p:cNvSpPr txBox="1"/>
+          <p:nvPr/>
+        </p:nvSpPr>
+        <p:spPr>
+          <a:xfrm>
+            <a:off x="566928" y="2331720"/>
+            <a:ext cx="4160520" cy="3840480"/>
+          </a:xfrm>
+          <a:prstGeom prst="rect">
+            <a:avLst/>
+          </a:prstGeom>
+          <a:noFill/>
+        </p:spPr>
+        <p:txBody>
+          <a:bodyPr wrap="square" lIns="0" rIns="0" tIns="0" bIns="0">
+            <a:spAutoFit/>
+          </a:bodyPr>
+          <a:lstStyle/>
+          <a:p>
+            <a:pPr>
+              <a:lnSpc>
+                <a:spcPct val="132000"/>
+              </a:lnSpc>
+              <a:spcBef>
+                <a:spcPts val="0"/>
+              </a:spcBef>
+              <a:spcAft>
+                <a:spcPts val="1100"/>
+              </a:spcAft>
+            </a:pPr>
+            <a:r>
+              <a:rPr sz="1150" b="0" i="0">
+                <a:solidFill>
+                  <a:srgbClr val="5A6068"/>
+                </a:solidFill>
+                <a:latin typeface="Calibri"/>
+              </a:rPr>
+              <a:t>Education's rank depends on which construct you count: attainment works, but parity ratios and learning outcomes do not, so pooling dilutes the signal. Health's rank depends on whether your chosen variable still varies: life expectancy does not, but self-rated health does, so the HDI's choice costs it. Social trust's rank is zero because it is not collected at scale in development frameworks at all — a coverage gap that cannot be fixed by choosing the right variable, because no variable was ever measured.</a:t>
+            </a:r>
+          </a:p>
+          <a:p>
+            <a:pPr>
+              <a:lnSpc>
+                <a:spcPct val="132000"/>
+              </a:lnSpc>
+              <a:spcBef>
+                <a:spcPts val="0"/>
+              </a:spcBef>
+              <a:spcAft>
+                <a:spcPts val="1100"/>
+              </a:spcAft>
+            </a:pPr>
+            <a:r>
+              <a:rPr sz="1150" b="0" i="0">
+                <a:solidFill>
+                  <a:srgbClr val="5A6068"/>
+                </a:solidFill>
+                <a:latin typeface="Calibri"/>
+              </a:rPr>
+              <a:t>These are not criticisms of the frameworks; they were built to track development, and they do. But which components look most consequential for lived experience is not the question they were built to answer.</a:t>
+            </a:r>
+          </a:p>
+        </p:txBody>
+      </p:sp>
+      <p:sp>
+        <p:nvSpPr>
+          <p:cNvPr id="5" name="TextBox 4"/>
+          <p:cNvSpPr txBox="1"/>
+          <p:nvPr/>
+        </p:nvSpPr>
+        <p:spPr>
+          <a:xfrm>
+            <a:off x="11338560" y="6263640"/>
+            <a:ext cx="548640" cy="274320"/>
+          </a:xfrm>
+          <a:prstGeom prst="rect">
+            <a:avLst/>
+          </a:prstGeom>
+          <a:noFill/>
+        </p:spPr>
+        <p:txBody>
+          <a:bodyPr wrap="square" lIns="0" rIns="0" tIns="0" bIns="0">
+            <a:spAutoFit/>
+          </a:bodyPr>
+          <a:lstStyle/>
+          <a:p>
+            <a:pPr algn="r">
+              <a:spcBef>
+                <a:spcPts val="0"/>
+              </a:spcBef>
+              <a:spcAft>
+                <a:spcPts val="0"/>
+              </a:spcAft>
+            </a:pPr>
+            <a:r>
+              <a:rPr sz="1100" b="0" i="0">
+                <a:solidFill>
+                  <a:srgbClr val="868D96"/>
+                </a:solidFill>
+                <a:latin typeface="Consolas"/>
+              </a:rPr>
+              <a:t>II</a:t>
+            </a:r>
+          </a:p>
+        </p:txBody>
+      </p:sp>
+      <p:pic>
+        <p:nvPicPr>
+          <p:cNvPr id="6" name="Picture 5" descr="domain_horse_race.png"/>
+          <p:cNvPicPr>
+            <a:picLocks noChangeAspect="1"/>
+          </p:cNvPicPr>
+          <p:nvPr/>
+        </p:nvPicPr>
+        <p:blipFill>
+          <a:blip r:embed="rId2"/>
+          <a:stretch>
+            <a:fillRect/>
+          </a:stretch>
+        </p:blipFill>
+        <p:spPr>
+          <a:xfrm>
+            <a:off x="5120640" y="1433421"/>
+            <a:ext cx="6537960" cy="3524813"/>
+          </a:xfrm>
+          <a:prstGeom prst="rect">
+            <a:avLst/>
+          </a:prstGeom>
+        </p:spPr>
+      </p:pic>
+      <p:sp>
+        <p:nvSpPr>
+          <p:cNvPr id="7" name="TextBox 6"/>
+          <p:cNvSpPr txBox="1"/>
+          <p:nvPr/>
+        </p:nvSpPr>
+        <p:spPr>
+          <a:xfrm>
+            <a:off x="5120640" y="5897880"/>
+            <a:ext cx="6537960" cy="731520"/>
+          </a:xfrm>
+          <a:prstGeom prst="rect">
+            <a:avLst/>
+          </a:prstGeom>
+          <a:noFill/>
+        </p:spPr>
+        <p:txBody>
+          <a:bodyPr wrap="square" lIns="0" rIns="0" tIns="0" bIns="0">
+            <a:spAutoFit/>
+          </a:bodyPr>
+          <a:lstStyle/>
+          <a:p>
+            <a:pPr>
+              <a:lnSpc>
+                <a:spcPct val="125000"/>
+              </a:lnSpc>
+              <a:spcBef>
+                <a:spcPts val="0"/>
+              </a:spcBef>
+              <a:spcAft>
+                <a:spcPts val="0"/>
+              </a:spcAft>
+            </a:pPr>
+            <a:r>
+              <a:rPr sz="900" b="0" i="0">
+                <a:solidFill>
+                  <a:srgbClr val="868D96"/>
+                </a:solidFill>
+                <a:latin typeface="Calibri"/>
+              </a:rPr>
+              <a:t>Domains competing within one instrument (ESS), at two levels of aggregation. Individual level (left) and country means (right).</a:t>
+            </a:r>
+          </a:p>
+        </p:txBody>
+      </p:sp>
+    </p:spTree>
+  </p:cSld>
+  <p:clrMapOvr>
+    <a:masterClrMapping/>
+  </p:clrMapOvr>
+</p:sld>
+</file>
+
+<file path=ppt/slides/slide16.xml><?xml version="1.0" encoding="utf-8"?>
 <p:sld xmlns:a="http://schemas.openxmlformats.org/drawingml/2006/main" xmlns:p="http://schemas.openxmlformats.org/presentationml/2006/main" xmlns:r="http://schemas.openxmlformats.org/officeDocument/2006/relationships">
   <p:cSld>
     <p:bg>
@@ -4981,7 +5273,7 @@
 </p:sld>
 </file>
 
-<file path=ppt/slides/slide16.xml><?xml version="1.0" encoding="utf-8"?>
+<file path=ppt/slides/slide17.xml><?xml version="1.0" encoding="utf-8"?>
 <p:sld xmlns:a="http://schemas.openxmlformats.org/drawingml/2006/main" xmlns:p="http://schemas.openxmlformats.org/presentationml/2006/main" xmlns:r="http://schemas.openxmlformats.org/officeDocument/2006/relationships">
   <p:cSld>
     <p:bg>
@@ -5417,7 +5709,7 @@
 </p:sld>
 </file>
 
-<file path=ppt/slides/slide17.xml><?xml version="1.0" encoding="utf-8"?>
+<file path=ppt/slides/slide18.xml><?xml version="1.0" encoding="utf-8"?>
 <p:sld xmlns:a="http://schemas.openxmlformats.org/drawingml/2006/main" xmlns:p="http://schemas.openxmlformats.org/presentationml/2006/main" xmlns:r="http://schemas.openxmlformats.org/officeDocument/2006/relationships">
   <p:cSld>
     <p:bg>
@@ -5661,7 +5953,7 @@
 </p:sld>
 </file>
 
-<file path=ppt/slides/slide18.xml><?xml version="1.0" encoding="utf-8"?>
+<file path=ppt/slides/slide19.xml><?xml version="1.0" encoding="utf-8"?>
 <p:sld xmlns:a="http://schemas.openxmlformats.org/drawingml/2006/main" xmlns:p="http://schemas.openxmlformats.org/presentationml/2006/main" xmlns:r="http://schemas.openxmlformats.org/officeDocument/2006/relationships">
   <p:cSld>
     <p:bg>
@@ -5806,442 +6098,6 @@
                 <a:latin typeface="Georgia"/>
               </a:rPr>
               <a:t>The three domains predict wellbeing differently depending on where and how you measure. Development frameworks' blindness is not incurable; it is structural. Frameworks designed for tracking aggregate national progress cannot see individual experience responsive to change.</a:t>
-            </a:r>
-          </a:p>
-        </p:txBody>
-      </p:sp>
-    </p:spTree>
-  </p:cSld>
-  <p:clrMapOvr>
-    <a:masterClrMapping/>
-  </p:clrMapOvr>
-</p:sld>
-</file>
-
-<file path=ppt/slides/slide19.xml><?xml version="1.0" encoding="utf-8"?>
-<p:sld xmlns:a="http://schemas.openxmlformats.org/drawingml/2006/main" xmlns:p="http://schemas.openxmlformats.org/presentationml/2006/main" xmlns:r="http://schemas.openxmlformats.org/officeDocument/2006/relationships">
-  <p:cSld>
-    <p:bg>
-      <p:bgPr>
-        <a:solidFill>
-          <a:srgbClr val="14171C"/>
-        </a:solidFill>
-        <a:effectLst/>
-      </p:bgPr>
-    </p:bg>
-    <p:spTree>
-      <p:nvGrpSpPr>
-        <p:cNvPr id="1" name=""/>
-        <p:cNvGrpSpPr/>
-        <p:nvPr/>
-      </p:nvGrpSpPr>
-      <p:grpSpPr/>
-      <p:sp>
-        <p:nvSpPr>
-          <p:cNvPr id="2" name="TextBox 1"/>
-          <p:cNvSpPr txBox="1"/>
-          <p:nvPr/>
-        </p:nvSpPr>
-        <p:spPr>
-          <a:xfrm>
-            <a:off x="8229600" y="822960"/>
-            <a:ext cx="3291840" cy="4114800"/>
-          </a:xfrm>
-          <a:prstGeom prst="rect">
-            <a:avLst/>
-          </a:prstGeom>
-          <a:noFill/>
-        </p:spPr>
-        <p:txBody>
-          <a:bodyPr wrap="square" lIns="0" rIns="0" tIns="0" bIns="0">
-            <a:spAutoFit/>
-          </a:bodyPr>
-          <a:lstStyle/>
-          <a:p>
-            <a:pPr algn="r">
-              <a:spcBef>
-                <a:spcPts val="0"/>
-              </a:spcBef>
-              <a:spcAft>
-                <a:spcPts val="0"/>
-              </a:spcAft>
-            </a:pPr>
-            <a:r>
-              <a:rPr sz="20000" b="0" i="0">
-                <a:solidFill>
-                  <a:srgbClr val="2A3340"/>
-                </a:solidFill>
-                <a:latin typeface="Georgia"/>
-              </a:rPr>
-              <a:t>IV</a:t>
-            </a:r>
-          </a:p>
-        </p:txBody>
-      </p:sp>
-      <p:sp>
-        <p:nvSpPr>
-          <p:cNvPr id="3" name="Rectangle 2"/>
-          <p:cNvSpPr/>
-          <p:nvPr/>
-        </p:nvSpPr>
-        <p:spPr>
-          <a:xfrm>
-            <a:off x="566928" y="1371600"/>
-            <a:ext cx="7315200" cy="25400"/>
-          </a:xfrm>
-          <a:prstGeom prst="rect">
-            <a:avLst/>
-          </a:prstGeom>
-          <a:solidFill>
-            <a:srgbClr val="C9D8EC"/>
-          </a:solidFill>
-          <a:ln>
-            <a:noFill/>
-          </a:ln>
-          <a:effectLst/>
-        </p:spPr>
-        <p:style>
-          <a:lnRef idx="1">
-            <a:schemeClr val="accent1"/>
-          </a:lnRef>
-          <a:fillRef idx="3">
-            <a:schemeClr val="accent1"/>
-          </a:fillRef>
-          <a:effectRef idx="2">
-            <a:schemeClr val="accent1"/>
-          </a:effectRef>
-          <a:fontRef idx="minor">
-            <a:schemeClr val="lt1"/>
-          </a:fontRef>
-        </p:style>
-        <p:txBody>
-          <a:bodyPr rtlCol="0" anchor="ctr"/>
-          <a:lstStyle/>
-          <a:p>
-            <a:pPr algn="ctr"/>
-          </a:p>
-        </p:txBody>
-      </p:sp>
-      <p:sp>
-        <p:nvSpPr>
-          <p:cNvPr id="4" name="TextBox 3"/>
-          <p:cNvSpPr txBox="1"/>
-          <p:nvPr/>
-        </p:nvSpPr>
-        <p:spPr>
-          <a:xfrm>
-            <a:off x="566928" y="960120"/>
-            <a:ext cx="5486400" cy="274320"/>
-          </a:xfrm>
-          <a:prstGeom prst="rect">
-            <a:avLst/>
-          </a:prstGeom>
-          <a:noFill/>
-        </p:spPr>
-        <p:txBody>
-          <a:bodyPr wrap="square" lIns="0" rIns="0" tIns="0" bIns="0">
-            <a:spAutoFit/>
-          </a:bodyPr>
-          <a:lstStyle/>
-          <a:p>
-            <a:pPr>
-              <a:spcBef>
-                <a:spcPts val="0"/>
-              </a:spcBef>
-              <a:spcAft>
-                <a:spcPts val="0"/>
-              </a:spcAft>
-            </a:pPr>
-            <a:r>
-              <a:rPr sz="1100" b="0" i="0">
-                <a:solidFill>
-                  <a:srgbClr val="C9D8EC"/>
-                </a:solidFill>
-                <a:latin typeface="Consolas"/>
-              </a:rPr>
-              <a:t>ACT IV</a:t>
-            </a:r>
-          </a:p>
-        </p:txBody>
-      </p:sp>
-      <p:sp>
-        <p:nvSpPr>
-          <p:cNvPr id="5" name="TextBox 4"/>
-          <p:cNvSpPr txBox="1"/>
-          <p:nvPr/>
-        </p:nvSpPr>
-        <p:spPr>
-          <a:xfrm>
-            <a:off x="566928" y="1783080"/>
-            <a:ext cx="7223760" cy="1828800"/>
-          </a:xfrm>
-          <a:prstGeom prst="rect">
-            <a:avLst/>
-          </a:prstGeom>
-          <a:noFill/>
-        </p:spPr>
-        <p:txBody>
-          <a:bodyPr wrap="square" lIns="0" rIns="0" tIns="0" bIns="0">
-            <a:spAutoFit/>
-          </a:bodyPr>
-          <a:lstStyle/>
-          <a:p>
-            <a:pPr>
-              <a:lnSpc>
-                <a:spcPct val="102000"/>
-              </a:lnSpc>
-              <a:spcBef>
-                <a:spcPts val="0"/>
-              </a:spcBef>
-              <a:spcAft>
-                <a:spcPts val="0"/>
-              </a:spcAft>
-            </a:pPr>
-            <a:r>
-              <a:rPr sz="4000" b="0" i="0">
-                <a:solidFill>
-                  <a:srgbClr val="FCFCFB"/>
-                </a:solidFill>
-                <a:latin typeface="Georgia"/>
-              </a:rPr>
-              <a:t>What this means for development frameworks</a:t>
-            </a:r>
-          </a:p>
-        </p:txBody>
-      </p:sp>
-      <p:sp>
-        <p:nvSpPr>
-          <p:cNvPr id="6" name="TextBox 5"/>
-          <p:cNvSpPr txBox="1"/>
-          <p:nvPr/>
-        </p:nvSpPr>
-        <p:spPr>
-          <a:xfrm>
-            <a:off x="566928" y="3886200"/>
-            <a:ext cx="6766560" cy="1463040"/>
-          </a:xfrm>
-          <a:prstGeom prst="rect">
-            <a:avLst/>
-          </a:prstGeom>
-          <a:noFill/>
-        </p:spPr>
-        <p:txBody>
-          <a:bodyPr wrap="square" lIns="0" rIns="0" tIns="0" bIns="0">
-            <a:spAutoFit/>
-          </a:bodyPr>
-          <a:lstStyle/>
-          <a:p>
-            <a:pPr>
-              <a:lnSpc>
-                <a:spcPct val="135000"/>
-              </a:lnSpc>
-              <a:spcBef>
-                <a:spcPts val="0"/>
-              </a:spcBef>
-              <a:spcAft>
-                <a:spcPts val="0"/>
-              </a:spcAft>
-            </a:pPr>
-            <a:r>
-              <a:rPr sz="1550" b="0" i="1">
-                <a:solidFill>
-                  <a:srgbClr val="9AA4B0"/>
-                </a:solidFill>
-                <a:latin typeface="Georgia"/>
-              </a:rPr>
-              <a:t>The disconnect is real and worth naming. Development frameworks have done their job of tracking progress on development. But the components that predict individual lived experience are ones these frameworks are not currently built to see — because of construction choices, variable saturation, or coverage that was never collected.</a:t>
-            </a:r>
-          </a:p>
-        </p:txBody>
-      </p:sp>
-      <p:sp>
-        <p:nvSpPr>
-          <p:cNvPr id="7" name="TextBox 6"/>
-          <p:cNvSpPr txBox="1"/>
-          <p:nvPr/>
-        </p:nvSpPr>
-        <p:spPr>
-          <a:xfrm>
-            <a:off x="566928" y="5623560"/>
-            <a:ext cx="3503066" cy="914400"/>
-          </a:xfrm>
-          <a:prstGeom prst="rect">
-            <a:avLst/>
-          </a:prstGeom>
-          <a:noFill/>
-        </p:spPr>
-        <p:txBody>
-          <a:bodyPr wrap="square" lIns="0" rIns="0" tIns="0" bIns="0">
-            <a:spAutoFit/>
-          </a:bodyPr>
-          <a:lstStyle/>
-          <a:p>
-            <a:pPr>
-              <a:spcBef>
-                <a:spcPts val="0"/>
-              </a:spcBef>
-              <a:spcAft>
-                <a:spcPts val="400"/>
-              </a:spcAft>
-            </a:pPr>
-            <a:r>
-              <a:rPr sz="2200" b="0" i="0">
-                <a:solidFill>
-                  <a:srgbClr val="FCFCFB"/>
-                </a:solidFill>
-                <a:latin typeface="Consolas"/>
-              </a:rPr>
-              <a:t>3 vs. 1</a:t>
-            </a:r>
-          </a:p>
-          <a:p>
-            <a:pPr>
-              <a:lnSpc>
-                <a:spcPct val="120000"/>
-              </a:lnSpc>
-              <a:spcBef>
-                <a:spcPts val="0"/>
-              </a:spcBef>
-              <a:spcAft>
-                <a:spcPts val="0"/>
-              </a:spcAft>
-            </a:pPr>
-            <a:r>
-              <a:rPr sz="1000" b="0" i="0">
-                <a:solidFill>
-                  <a:srgbClr val="8A94A0"/>
-                </a:solidFill>
-                <a:latin typeface="Calibri"/>
-              </a:rPr>
-              <a:t>domains the HDI can test for wellbeing, vs. social trust</a:t>
-            </a:r>
-          </a:p>
-        </p:txBody>
-      </p:sp>
-      <p:sp>
-        <p:nvSpPr>
-          <p:cNvPr id="8" name="TextBox 7"/>
-          <p:cNvSpPr txBox="1"/>
-          <p:nvPr/>
-        </p:nvSpPr>
-        <p:spPr>
-          <a:xfrm>
-            <a:off x="4344314" y="5623560"/>
-            <a:ext cx="3503066" cy="914400"/>
-          </a:xfrm>
-          <a:prstGeom prst="rect">
-            <a:avLst/>
-          </a:prstGeom>
-          <a:noFill/>
-        </p:spPr>
-        <p:txBody>
-          <a:bodyPr wrap="square" lIns="0" rIns="0" tIns="0" bIns="0">
-            <a:spAutoFit/>
-          </a:bodyPr>
-          <a:lstStyle/>
-          <a:p>
-            <a:pPr>
-              <a:spcBef>
-                <a:spcPts val="0"/>
-              </a:spcBef>
-              <a:spcAft>
-                <a:spcPts val="400"/>
-              </a:spcAft>
-            </a:pPr>
-            <a:r>
-              <a:rPr sz="2200" b="0" i="0">
-                <a:solidFill>
-                  <a:srgbClr val="FCFCFB"/>
-                </a:solidFill>
-                <a:latin typeface="Consolas"/>
-              </a:rPr>
-              <a:t>42 vs. 661</a:t>
-            </a:r>
-          </a:p>
-          <a:p>
-            <a:pPr>
-              <a:lnSpc>
-                <a:spcPct val="120000"/>
-              </a:lnSpc>
-              <a:spcBef>
-                <a:spcPts val="0"/>
-              </a:spcBef>
-              <a:spcAft>
-                <a:spcPts val="0"/>
-              </a:spcAft>
-            </a:pPr>
-            <a:r>
-              <a:rPr sz="1000" b="0" i="0">
-                <a:solidFill>
-                  <a:srgbClr val="8A94A0"/>
-                </a:solidFill>
-                <a:latin typeface="Calibri"/>
-              </a:rPr>
-              <a:t>countries with SDG data, vs. series in the database</a:t>
-            </a:r>
-          </a:p>
-        </p:txBody>
-      </p:sp>
-      <p:sp>
-        <p:nvSpPr>
-          <p:cNvPr id="9" name="TextBox 8"/>
-          <p:cNvSpPr txBox="1"/>
-          <p:nvPr/>
-        </p:nvSpPr>
-        <p:spPr>
-          <a:xfrm>
-            <a:off x="8121700" y="5623560"/>
-            <a:ext cx="3503066" cy="914400"/>
-          </a:xfrm>
-          <a:prstGeom prst="rect">
-            <a:avLst/>
-          </a:prstGeom>
-          <a:noFill/>
-        </p:spPr>
-        <p:txBody>
-          <a:bodyPr wrap="square" lIns="0" rIns="0" tIns="0" bIns="0">
-            <a:spAutoFit/>
-          </a:bodyPr>
-          <a:lstStyle/>
-          <a:p>
-            <a:pPr>
-              <a:spcBef>
-                <a:spcPts val="0"/>
-              </a:spcBef>
-              <a:spcAft>
-                <a:spcPts val="400"/>
-              </a:spcAft>
-            </a:pPr>
-            <a:r>
-              <a:rPr sz="2200" b="0" i="0">
-                <a:solidFill>
-                  <a:srgbClr val="FCFCFB"/>
-                </a:solidFill>
-                <a:latin typeface="Consolas"/>
-              </a:rPr>
-              <a:t>0.041</a:t>
-            </a:r>
-          </a:p>
-          <a:p>
-            <a:pPr>
-              <a:lnSpc>
-                <a:spcPct val="120000"/>
-              </a:lnSpc>
-              <a:spcBef>
-                <a:spcPts val="0"/>
-              </a:spcBef>
-              <a:spcAft>
-                <a:spcPts val="0"/>
-              </a:spcAft>
-            </a:pPr>
-            <a:r>
-              <a:rPr sz="1000" b="0" i="0">
-                <a:solidFill>
-                  <a:srgbClr val="8A94A0"/>
-                </a:solidFill>
-                <a:latin typeface="Calibri"/>
-              </a:rPr>
-              <a:t>median R² for trust — below income, health, education individually, above none</a:t>
             </a:r>
           </a:p>
         </p:txBody>
@@ -7104,7 +6960,7 @@
     <p:bg>
       <p:bgPr>
         <a:solidFill>
-          <a:srgbClr val="FCFCFB"/>
+          <a:srgbClr val="14171C"/>
         </a:solidFill>
         <a:effectLst/>
       </p:bgPr>
@@ -7124,21 +6980,261 @@
         </p:nvSpPr>
         <p:spPr>
           <a:xfrm>
-            <a:off x="566928" y="502920"/>
-            <a:ext cx="8595360" cy="274320"/>
-          </a:xfrm>
-          <a:prstGeom prst="rect">
-            <a:avLst/>
-          </a:prstGeom>
-          <a:noFill/>
-        </p:spPr>
-        <p:txBody>
-          <a:bodyPr wrap="square" lIns="0" rIns="0" tIns="0" bIns="0">
-            <a:spAutoFit/>
-          </a:bodyPr>
-          <a:lstStyle/>
-          <a:p>
-            <a:pPr>
+            <a:off x="8229600" y="822960"/>
+            <a:ext cx="3291840" cy="4114800"/>
+          </a:xfrm>
+          <a:prstGeom prst="rect">
+            <a:avLst/>
+          </a:prstGeom>
+          <a:noFill/>
+        </p:spPr>
+        <p:txBody>
+          <a:bodyPr wrap="square" lIns="0" rIns="0" tIns="0" bIns="0">
+            <a:spAutoFit/>
+          </a:bodyPr>
+          <a:lstStyle/>
+          <a:p>
+            <a:pPr algn="r">
+              <a:spcBef>
+                <a:spcPts val="0"/>
+              </a:spcBef>
+              <a:spcAft>
+                <a:spcPts val="0"/>
+              </a:spcAft>
+            </a:pPr>
+            <a:r>
+              <a:rPr sz="20000" b="0" i="0">
+                <a:solidFill>
+                  <a:srgbClr val="2A3340"/>
+                </a:solidFill>
+                <a:latin typeface="Georgia"/>
+              </a:rPr>
+              <a:t>IV</a:t>
+            </a:r>
+          </a:p>
+        </p:txBody>
+      </p:sp>
+      <p:sp>
+        <p:nvSpPr>
+          <p:cNvPr id="3" name="Rectangle 2"/>
+          <p:cNvSpPr/>
+          <p:nvPr/>
+        </p:nvSpPr>
+        <p:spPr>
+          <a:xfrm>
+            <a:off x="566928" y="1371600"/>
+            <a:ext cx="7315200" cy="25400"/>
+          </a:xfrm>
+          <a:prstGeom prst="rect">
+            <a:avLst/>
+          </a:prstGeom>
+          <a:solidFill>
+            <a:srgbClr val="C9D8EC"/>
+          </a:solidFill>
+          <a:ln>
+            <a:noFill/>
+          </a:ln>
+          <a:effectLst/>
+        </p:spPr>
+        <p:style>
+          <a:lnRef idx="1">
+            <a:schemeClr val="accent1"/>
+          </a:lnRef>
+          <a:fillRef idx="3">
+            <a:schemeClr val="accent1"/>
+          </a:fillRef>
+          <a:effectRef idx="2">
+            <a:schemeClr val="accent1"/>
+          </a:effectRef>
+          <a:fontRef idx="minor">
+            <a:schemeClr val="lt1"/>
+          </a:fontRef>
+        </p:style>
+        <p:txBody>
+          <a:bodyPr rtlCol="0" anchor="ctr"/>
+          <a:lstStyle/>
+          <a:p>
+            <a:pPr algn="ctr"/>
+          </a:p>
+        </p:txBody>
+      </p:sp>
+      <p:sp>
+        <p:nvSpPr>
+          <p:cNvPr id="4" name="TextBox 3"/>
+          <p:cNvSpPr txBox="1"/>
+          <p:nvPr/>
+        </p:nvSpPr>
+        <p:spPr>
+          <a:xfrm>
+            <a:off x="566928" y="960120"/>
+            <a:ext cx="5486400" cy="274320"/>
+          </a:xfrm>
+          <a:prstGeom prst="rect">
+            <a:avLst/>
+          </a:prstGeom>
+          <a:noFill/>
+        </p:spPr>
+        <p:txBody>
+          <a:bodyPr wrap="square" lIns="0" rIns="0" tIns="0" bIns="0">
+            <a:spAutoFit/>
+          </a:bodyPr>
+          <a:lstStyle/>
+          <a:p>
+            <a:pPr>
+              <a:spcBef>
+                <a:spcPts val="0"/>
+              </a:spcBef>
+              <a:spcAft>
+                <a:spcPts val="0"/>
+              </a:spcAft>
+            </a:pPr>
+            <a:r>
+              <a:rPr sz="1100" b="0" i="0">
+                <a:solidFill>
+                  <a:srgbClr val="C9D8EC"/>
+                </a:solidFill>
+                <a:latin typeface="Consolas"/>
+              </a:rPr>
+              <a:t>ACT IV</a:t>
+            </a:r>
+          </a:p>
+        </p:txBody>
+      </p:sp>
+      <p:sp>
+        <p:nvSpPr>
+          <p:cNvPr id="5" name="TextBox 4"/>
+          <p:cNvSpPr txBox="1"/>
+          <p:nvPr/>
+        </p:nvSpPr>
+        <p:spPr>
+          <a:xfrm>
+            <a:off x="566928" y="1783080"/>
+            <a:ext cx="7223760" cy="1828800"/>
+          </a:xfrm>
+          <a:prstGeom prst="rect">
+            <a:avLst/>
+          </a:prstGeom>
+          <a:noFill/>
+        </p:spPr>
+        <p:txBody>
+          <a:bodyPr wrap="square" lIns="0" rIns="0" tIns="0" bIns="0">
+            <a:spAutoFit/>
+          </a:bodyPr>
+          <a:lstStyle/>
+          <a:p>
+            <a:pPr>
+              <a:lnSpc>
+                <a:spcPct val="102000"/>
+              </a:lnSpc>
+              <a:spcBef>
+                <a:spcPts val="0"/>
+              </a:spcBef>
+              <a:spcAft>
+                <a:spcPts val="0"/>
+              </a:spcAft>
+            </a:pPr>
+            <a:r>
+              <a:rPr sz="4000" b="0" i="0">
+                <a:solidFill>
+                  <a:srgbClr val="FCFCFB"/>
+                </a:solidFill>
+                <a:latin typeface="Georgia"/>
+              </a:rPr>
+              <a:t>What this means for development frameworks</a:t>
+            </a:r>
+          </a:p>
+        </p:txBody>
+      </p:sp>
+      <p:sp>
+        <p:nvSpPr>
+          <p:cNvPr id="6" name="TextBox 5"/>
+          <p:cNvSpPr txBox="1"/>
+          <p:nvPr/>
+        </p:nvSpPr>
+        <p:spPr>
+          <a:xfrm>
+            <a:off x="566928" y="3886200"/>
+            <a:ext cx="6766560" cy="1463040"/>
+          </a:xfrm>
+          <a:prstGeom prst="rect">
+            <a:avLst/>
+          </a:prstGeom>
+          <a:noFill/>
+        </p:spPr>
+        <p:txBody>
+          <a:bodyPr wrap="square" lIns="0" rIns="0" tIns="0" bIns="0">
+            <a:spAutoFit/>
+          </a:bodyPr>
+          <a:lstStyle/>
+          <a:p>
+            <a:pPr>
+              <a:lnSpc>
+                <a:spcPct val="135000"/>
+              </a:lnSpc>
+              <a:spcBef>
+                <a:spcPts val="0"/>
+              </a:spcBef>
+              <a:spcAft>
+                <a:spcPts val="0"/>
+              </a:spcAft>
+            </a:pPr>
+            <a:r>
+              <a:rPr sz="1550" b="0" i="1">
+                <a:solidFill>
+                  <a:srgbClr val="9AA4B0"/>
+                </a:solidFill>
+                <a:latin typeface="Georgia"/>
+              </a:rPr>
+              <a:t>The disconnect is real and worth naming. Development frameworks have done their job of tracking progress on development. But the components that predict individual lived experience are ones these frameworks are not currently built to see — because of construction choices, variable saturation, or coverage that was never collected.</a:t>
+            </a:r>
+          </a:p>
+        </p:txBody>
+      </p:sp>
+      <p:sp>
+        <p:nvSpPr>
+          <p:cNvPr id="7" name="TextBox 6"/>
+          <p:cNvSpPr txBox="1"/>
+          <p:nvPr/>
+        </p:nvSpPr>
+        <p:spPr>
+          <a:xfrm>
+            <a:off x="566928" y="5623560"/>
+            <a:ext cx="3503066" cy="914400"/>
+          </a:xfrm>
+          <a:prstGeom prst="rect">
+            <a:avLst/>
+          </a:prstGeom>
+          <a:noFill/>
+        </p:spPr>
+        <p:txBody>
+          <a:bodyPr wrap="square" lIns="0" rIns="0" tIns="0" bIns="0">
+            <a:spAutoFit/>
+          </a:bodyPr>
+          <a:lstStyle/>
+          <a:p>
+            <a:pPr>
+              <a:spcBef>
+                <a:spcPts val="0"/>
+              </a:spcBef>
+              <a:spcAft>
+                <a:spcPts val="400"/>
+              </a:spcAft>
+            </a:pPr>
+            <a:r>
+              <a:rPr sz="2200" b="0" i="0">
+                <a:solidFill>
+                  <a:srgbClr val="FCFCFB"/>
+                </a:solidFill>
+                <a:latin typeface="Consolas"/>
+              </a:rPr>
+              <a:t>3 vs. 1</a:t>
+            </a:r>
+          </a:p>
+          <a:p>
+            <a:pPr>
+              <a:lnSpc>
+                <a:spcPct val="120000"/>
+              </a:lnSpc>
               <a:spcBef>
                 <a:spcPts val="0"/>
               </a:spcBef>
@@ -7149,40 +7245,59 @@
             <a:r>
               <a:rPr sz="1000" b="0" i="0">
                 <a:solidFill>
-                  <a:srgbClr val="A63A30"/>
+                  <a:srgbClr val="8A94A0"/>
+                </a:solidFill>
+                <a:latin typeface="Calibri"/>
+              </a:rPr>
+              <a:t>domains the HDI can test for wellbeing, vs. social trust</a:t>
+            </a:r>
+          </a:p>
+        </p:txBody>
+      </p:sp>
+      <p:sp>
+        <p:nvSpPr>
+          <p:cNvPr id="8" name="TextBox 7"/>
+          <p:cNvSpPr txBox="1"/>
+          <p:nvPr/>
+        </p:nvSpPr>
+        <p:spPr>
+          <a:xfrm>
+            <a:off x="4344314" y="5623560"/>
+            <a:ext cx="3503066" cy="914400"/>
+          </a:xfrm>
+          <a:prstGeom prst="rect">
+            <a:avLst/>
+          </a:prstGeom>
+          <a:noFill/>
+        </p:spPr>
+        <p:txBody>
+          <a:bodyPr wrap="square" lIns="0" rIns="0" tIns="0" bIns="0">
+            <a:spAutoFit/>
+          </a:bodyPr>
+          <a:lstStyle/>
+          <a:p>
+            <a:pPr>
+              <a:spcBef>
+                <a:spcPts val="0"/>
+              </a:spcBef>
+              <a:spcAft>
+                <a:spcPts val="400"/>
+              </a:spcAft>
+            </a:pPr>
+            <a:r>
+              <a:rPr sz="2200" b="0" i="0">
+                <a:solidFill>
+                  <a:srgbClr val="FCFCFB"/>
                 </a:solidFill>
                 <a:latin typeface="Consolas"/>
               </a:rPr>
-              <a:t>THE DISCONNECT</a:t>
-            </a:r>
-          </a:p>
-        </p:txBody>
-      </p:sp>
-      <p:sp>
-        <p:nvSpPr>
-          <p:cNvPr id="3" name="TextBox 2"/>
-          <p:cNvSpPr txBox="1"/>
-          <p:nvPr/>
-        </p:nvSpPr>
-        <p:spPr>
-          <a:xfrm>
-            <a:off x="566928" y="914400"/>
-            <a:ext cx="8595360" cy="1371600"/>
-          </a:xfrm>
-          <a:prstGeom prst="rect">
-            <a:avLst/>
-          </a:prstGeom>
-          <a:noFill/>
-        </p:spPr>
-        <p:txBody>
-          <a:bodyPr wrap="square" lIns="0" rIns="0" tIns="0" bIns="0">
-            <a:spAutoFit/>
-          </a:bodyPr>
-          <a:lstStyle/>
+              <a:t>42 vs. 661</a:t>
+            </a:r>
+          </a:p>
           <a:p>
             <a:pPr>
               <a:lnSpc>
-                <a:spcPct val="108000"/>
+                <a:spcPct val="120000"/>
               </a:lnSpc>
               <a:spcBef>
                 <a:spcPts val="0"/>
@@ -7192,122 +7307,77 @@
               </a:spcAft>
             </a:pPr>
             <a:r>
-              <a:rPr sz="2700" b="0" i="0">
-                <a:solidFill>
-                  <a:srgbClr val="14171C"/>
-                </a:solidFill>
-                <a:latin typeface="Georgia"/>
-              </a:rPr>
-              <a:t>These frameworks work for development. They do not work for wellbeing.</a:t>
-            </a:r>
-          </a:p>
-        </p:txBody>
-      </p:sp>
-      <p:sp>
-        <p:nvSpPr>
-          <p:cNvPr id="4" name="TextBox 3"/>
-          <p:cNvSpPr txBox="1"/>
-          <p:nvPr/>
-        </p:nvSpPr>
-        <p:spPr>
-          <a:xfrm>
-            <a:off x="566928" y="2286000"/>
-            <a:ext cx="8595360" cy="3840480"/>
-          </a:xfrm>
-          <a:prstGeom prst="rect">
-            <a:avLst/>
-          </a:prstGeom>
-          <a:noFill/>
-        </p:spPr>
-        <p:txBody>
-          <a:bodyPr wrap="square" lIns="0" rIns="0" tIns="0" bIns="0">
-            <a:spAutoFit/>
-          </a:bodyPr>
-          <a:lstStyle/>
+              <a:rPr sz="1000" b="0" i="0">
+                <a:solidFill>
+                  <a:srgbClr val="8A94A0"/>
+                </a:solidFill>
+                <a:latin typeface="Calibri"/>
+              </a:rPr>
+              <a:t>countries with SDG data, vs. series in the database</a:t>
+            </a:r>
+          </a:p>
+        </p:txBody>
+      </p:sp>
+      <p:sp>
+        <p:nvSpPr>
+          <p:cNvPr id="9" name="TextBox 8"/>
+          <p:cNvSpPr txBox="1"/>
+          <p:nvPr/>
+        </p:nvSpPr>
+        <p:spPr>
+          <a:xfrm>
+            <a:off x="8121700" y="5623560"/>
+            <a:ext cx="3503066" cy="914400"/>
+          </a:xfrm>
+          <a:prstGeom prst="rect">
+            <a:avLst/>
+          </a:prstGeom>
+          <a:noFill/>
+        </p:spPr>
+        <p:txBody>
+          <a:bodyPr wrap="square" lIns="0" rIns="0" tIns="0" bIns="0">
+            <a:spAutoFit/>
+          </a:bodyPr>
+          <a:lstStyle/>
+          <a:p>
+            <a:pPr>
+              <a:spcBef>
+                <a:spcPts val="0"/>
+              </a:spcBef>
+              <a:spcAft>
+                <a:spcPts val="400"/>
+              </a:spcAft>
+            </a:pPr>
+            <a:r>
+              <a:rPr sz="2200" b="0" i="0">
+                <a:solidFill>
+                  <a:srgbClr val="FCFCFB"/>
+                </a:solidFill>
+                <a:latin typeface="Consolas"/>
+              </a:rPr>
+              <a:t>0.041</a:t>
+            </a:r>
+          </a:p>
           <a:p>
             <a:pPr>
               <a:lnSpc>
-                <a:spcPct val="132000"/>
+                <a:spcPct val="120000"/>
               </a:lnSpc>
               <a:spcBef>
                 <a:spcPts val="0"/>
               </a:spcBef>
               <a:spcAft>
-                <a:spcPts val="1100"/>
-              </a:spcAft>
-            </a:pPr>
-            <a:r>
-              <a:rPr sz="1400" b="0" i="0">
-                <a:solidFill>
-                  <a:srgbClr val="5A6068"/>
+                <a:spcPts val="0"/>
+              </a:spcAft>
+            </a:pPr>
+            <a:r>
+              <a:rPr sz="1000" b="0" i="0">
+                <a:solidFill>
+                  <a:srgbClr val="8A94A0"/>
                 </a:solidFill>
                 <a:latin typeface="Calibri"/>
               </a:rPr>
-              <a:t>The HDI and SDG frameworks do not answer the question 'what makes people's lives better?' any more than a global income statistics database answers 'what makes a person happy?' They were designed to track development, measured at the aggregate level, with indicators chosen before the question of individual wellbeing was systematically tested. That is not a design failure; it is the intended scope.</a:t>
-            </a:r>
-          </a:p>
-          <a:p>
-            <a:pPr>
-              <a:lnSpc>
-                <a:spcPct val="132000"/>
-              </a:lnSpc>
-              <a:spcBef>
-                <a:spcPts val="0"/>
-              </a:spcBef>
-              <a:spcAft>
-                <a:spcPts val="1100"/>
-              </a:spcAft>
-            </a:pPr>
-            <a:r>
-              <a:rPr sz="1400" b="0" i="0">
-                <a:solidFill>
-                  <a:srgbClr val="5A6068"/>
-                </a:solidFill>
-                <a:latin typeface="Calibri"/>
-              </a:rPr>
-              <a:t>But it means the gap is structural. Education's access indicators work; pooling them with constructs that do not does not fix wellbeing prediction — it just builds a worse measure. Choosing a variable for health that is closer to saturated than the outcome it predicts is a measurement choice, not an incurable problem. And when a domain is never collected, no amount of better construction on the others will reach it.</a:t>
-            </a:r>
-          </a:p>
-        </p:txBody>
-      </p:sp>
-      <p:sp>
-        <p:nvSpPr>
-          <p:cNvPr id="5" name="TextBox 4"/>
-          <p:cNvSpPr txBox="1"/>
-          <p:nvPr/>
-        </p:nvSpPr>
-        <p:spPr>
-          <a:xfrm>
-            <a:off x="11338560" y="6263640"/>
-            <a:ext cx="548640" cy="274320"/>
-          </a:xfrm>
-          <a:prstGeom prst="rect">
-            <a:avLst/>
-          </a:prstGeom>
-          <a:noFill/>
-        </p:spPr>
-        <p:txBody>
-          <a:bodyPr wrap="square" lIns="0" rIns="0" tIns="0" bIns="0">
-            <a:spAutoFit/>
-          </a:bodyPr>
-          <a:lstStyle/>
-          <a:p>
-            <a:pPr algn="r">
-              <a:spcBef>
-                <a:spcPts val="0"/>
-              </a:spcBef>
-              <a:spcAft>
-                <a:spcPts val="0"/>
-              </a:spcAft>
-            </a:pPr>
-            <a:r>
-              <a:rPr sz="1100" b="0" i="0">
-                <a:solidFill>
-                  <a:srgbClr val="868D96"/>
-                </a:solidFill>
-                <a:latin typeface="Consolas"/>
-              </a:rPr>
-              <a:t>IV</a:t>
+              <a:t>median R² for trust — below income, health, education individually, above none</a:t>
             </a:r>
           </a:p>
         </p:txBody>
@@ -7375,7 +7445,7 @@
                 </a:solidFill>
                 <a:latin typeface="Consolas"/>
               </a:rPr>
-              <a:t>IMPLICATION 1 · MEASUREMENT CHOICES CONSTRAIN WHAT FRAMEWORKS CAN SEE</a:t>
+              <a:t>THE DISCONNECT</a:t>
             </a:r>
           </a:p>
         </p:txBody>
@@ -7420,7 +7490,7 @@
                 </a:solidFill>
                 <a:latin typeface="Georgia"/>
               </a:rPr>
-              <a:t>Education and health: the case for measurement specificity</a:t>
+              <a:t>These frameworks work for development. They do not work for wellbeing.</a:t>
             </a:r>
           </a:p>
         </p:txBody>
@@ -7465,7 +7535,7 @@
                 </a:solidFill>
                 <a:latin typeface="Calibri"/>
               </a:rPr>
-              <a:t>Education is significant everywhere it is measured as attainment, but nearly invisible in SDG4 because most indicators measure something else. Health is nearly invisible in the HDI because life expectancy has saturated. Neither domain has changed; the frameworks' construction choices have.</a:t>
+              <a:t>The HDI and SDG frameworks do not answer the question 'what makes people's lives better?' any more than a global income statistics database answers 'what makes a person happy?' They were designed to track development, measured at the aggregate level, with indicators chosen before the question of individual wellbeing was systematically tested. That is not a design failure; it is the intended scope.</a:t>
             </a:r>
           </a:p>
           <a:p>
@@ -7487,7 +7557,7 @@
                 </a:solidFill>
                 <a:latin typeface="Calibri"/>
               </a:rPr>
-              <a:t>For education, this suggests development measurement should weigh access and completion more heavily than parity ratios in wellbeing contexts — not universally, but with explicit construction choices that account for what is known to matter. For health, it suggests that wellbeing-motivated measurement may need different variables at different development levels: life expectancy in lower-income settings, self-reported health or specific conditions in saturated ones.</a:t>
+              <a:t>But it means the gap is structural. Education's access indicators work; pooling them with constructs that do not does not fix wellbeing prediction — it just builds a worse measure. Choosing a variable for health that is closer to saturated than the outcome it predicts is a measurement choice, not an incurable problem. And when a domain is never collected, no amount of better construction on the others will reach it.</a:t>
             </a:r>
           </a:p>
         </p:txBody>
@@ -7597,7 +7667,7 @@
                 </a:solidFill>
                 <a:latin typeface="Consolas"/>
               </a:rPr>
-              <a:t>IMPLICATION 2 · COVERAGE GAPS ARE MORE FUNDAMENTAL THAN CONSTRUCT CHOICE</a:t>
+              <a:t>IMPLICATION 1 · MEASUREMENT CHOICES CONSTRAIN WHAT FRAMEWORKS CAN SEE</a:t>
             </a:r>
           </a:p>
         </p:txBody>
@@ -7642,7 +7712,7 @@
                 </a:solidFill>
                 <a:latin typeface="Georgia"/>
               </a:rPr>
-              <a:t>Social trust: why you cannot fix a measurement by measuring better</a:t>
+              <a:t>Education and health: the case for measurement specificity</a:t>
             </a:r>
           </a:p>
         </p:txBody>
@@ -7687,7 +7757,7 @@
                 </a:solidFill>
                 <a:latin typeface="Calibri"/>
               </a:rPr>
-              <a:t>Social trust is the most tentative finding here. The ESS is Europe-only, across 36 countries, and relies on a single item. That bounds the claim: the pattern holds in Europe, with a wellbeing survey, on a self-report basis. It does not claim universality.</a:t>
+              <a:t>Education is significant everywhere it is measured as attainment, but nearly invisible in SDG4 because most indicators measure something else. Health is nearly invisible in the HDI because life expectancy has saturated. Neither domain has changed; the frameworks' construction choices have.</a:t>
             </a:r>
           </a:p>
           <a:p>
@@ -7709,29 +7779,7 @@
                 </a:solidFill>
                 <a:latin typeface="Calibri"/>
               </a:rPr>
-              <a:t>But the reason it is tentative points to the deepest problem: trust is not collected at global scale in either framework. The SDG database has 13 series adjacent to trust, but they measure institutional confidence, not interpersonal trust, and they are intermittent (147 of 163 country-series have fewer than four years of data). This is not a construct-choice problem that better measurement can solve. It is a coverage gap that requires deciding to collect the data in the first place.</a:t>
-            </a:r>
-          </a:p>
-          <a:p>
-            <a:pPr>
-              <a:lnSpc>
-                <a:spcPct val="132000"/>
-              </a:lnSpc>
-              <a:spcBef>
-                <a:spcPts val="0"/>
-              </a:spcBef>
-              <a:spcAft>
-                <a:spcPts val="1100"/>
-              </a:spcAft>
-            </a:pPr>
-            <a:r>
-              <a:rPr sz="1400" b="0" i="0">
-                <a:solidFill>
-                  <a:srgbClr val="5A6068"/>
-                </a:solidFill>
-                <a:latin typeface="Calibri"/>
-              </a:rPr>
-              <a:t>For wellbeing-conscious development monitoring, this suggests either building interpersonal-trust measurement into the core frameworks, or acknowledging that other surveys (the ESS, Gallup World Poll, World Values Survey) may be more suitable for understanding what shapes lived experience.</a:t>
+              <a:t>For education, this suggests development measurement should weigh access and completion more heavily than parity ratios in wellbeing contexts — not universally, but with explicit construction choices that account for what is known to matter. For health, it suggests that wellbeing-motivated measurement may need different variables at different development levels: life expectancy in lower-income settings, self-reported health or specific conditions in saturated ones.</a:t>
             </a:r>
           </a:p>
         </p:txBody>
@@ -7841,7 +7889,7 @@
                 </a:solidFill>
                 <a:latin typeface="Consolas"/>
               </a:rPr>
-              <a:t>CONCLUSION</a:t>
+              <a:t>IMPLICATION 2 · COVERAGE GAPS ARE MORE FUNDAMENTAL THAN CONSTRUCT CHOICE</a:t>
             </a:r>
           </a:p>
         </p:txBody>
@@ -7886,7 +7934,7 @@
                 </a:solidFill>
                 <a:latin typeface="Georgia"/>
               </a:rPr>
-              <a:t>A question rather than a prescription</a:t>
+              <a:t>Social trust: why you cannot fix a measurement by measuring better</a:t>
             </a:r>
           </a:p>
         </p:txBody>
@@ -7931,7 +7979,7 @@
                 </a:solidFill>
                 <a:latin typeface="Calibri"/>
               </a:rPr>
-              <a:t>The evidence shows a consistent pattern: which domain looks most consequential for wellbeing depends on which framework measures it and what variable they chose. This is not about the domains; it is about the tools.</a:t>
+              <a:t>Social trust is the most tentative finding here. The ESS is Europe-only, across 36 countries, and relies on a single item. That bounds the claim: the pattern holds in Europe, with a wellbeing survey, on a self-report basis. It does not claim universality.</a:t>
             </a:r>
           </a:p>
           <a:p>
@@ -7953,7 +8001,7 @@
                 </a:solidFill>
                 <a:latin typeface="Calibri"/>
               </a:rPr>
-              <a:t>Whether development frameworks should be redesigned around wellbeing is outside the scope here. But if they were, this finding suggests the question to ask: should measurement choices be made with explicit reference to which variables still move and still matter for lived experience? Should coverage be built in for domains the frameworks discovered only by studying something else?</a:t>
+              <a:t>But the reason it is tentative points to the deepest problem: trust is not collected at global scale in either framework. The SDG database has 13 series adjacent to trust, but they measure institutional confidence, not interpersonal trust, and they are intermittent (147 of 163 country-series have fewer than four years of data). This is not a construct-choice problem that better measurement can solve. It is a coverage gap that requires deciding to collect the data in the first place.</a:t>
             </a:r>
           </a:p>
           <a:p>
@@ -7975,7 +8023,7 @@
                 </a:solidFill>
                 <a:latin typeface="Calibri"/>
               </a:rPr>
-              <a:t>The frameworks work well for their stated purpose. The question is whether wellbeing should become part of that purpose — and if it does, whether the measurement that comes from that intent should be different from the aggregate, development-first measurement in place today.</a:t>
+              <a:t>For wellbeing-conscious development monitoring, this suggests either building interpersonal-trust measurement into the core frameworks, or acknowledging that other surveys (the ESS, Gallup World Poll, World Values Survey) may be more suitable for understanding what shapes lived experience.</a:t>
             </a:r>
           </a:p>
         </p:txBody>
@@ -8031,6 +8079,250 @@
 </file>
 
 <file path=ppt/slides/slide24.xml><?xml version="1.0" encoding="utf-8"?>
+<p:sld xmlns:a="http://schemas.openxmlformats.org/drawingml/2006/main" xmlns:p="http://schemas.openxmlformats.org/presentationml/2006/main" xmlns:r="http://schemas.openxmlformats.org/officeDocument/2006/relationships">
+  <p:cSld>
+    <p:bg>
+      <p:bgPr>
+        <a:solidFill>
+          <a:srgbClr val="FCFCFB"/>
+        </a:solidFill>
+        <a:effectLst/>
+      </p:bgPr>
+    </p:bg>
+    <p:spTree>
+      <p:nvGrpSpPr>
+        <p:cNvPr id="1" name=""/>
+        <p:cNvGrpSpPr/>
+        <p:nvPr/>
+      </p:nvGrpSpPr>
+      <p:grpSpPr/>
+      <p:sp>
+        <p:nvSpPr>
+          <p:cNvPr id="2" name="TextBox 1"/>
+          <p:cNvSpPr txBox="1"/>
+          <p:nvPr/>
+        </p:nvSpPr>
+        <p:spPr>
+          <a:xfrm>
+            <a:off x="566928" y="502920"/>
+            <a:ext cx="8595360" cy="274320"/>
+          </a:xfrm>
+          <a:prstGeom prst="rect">
+            <a:avLst/>
+          </a:prstGeom>
+          <a:noFill/>
+        </p:spPr>
+        <p:txBody>
+          <a:bodyPr wrap="square" lIns="0" rIns="0" tIns="0" bIns="0">
+            <a:spAutoFit/>
+          </a:bodyPr>
+          <a:lstStyle/>
+          <a:p>
+            <a:pPr>
+              <a:spcBef>
+                <a:spcPts val="0"/>
+              </a:spcBef>
+              <a:spcAft>
+                <a:spcPts val="0"/>
+              </a:spcAft>
+            </a:pPr>
+            <a:r>
+              <a:rPr sz="1000" b="0" i="0">
+                <a:solidFill>
+                  <a:srgbClr val="A63A30"/>
+                </a:solidFill>
+                <a:latin typeface="Consolas"/>
+              </a:rPr>
+              <a:t>CONCLUSION</a:t>
+            </a:r>
+          </a:p>
+        </p:txBody>
+      </p:sp>
+      <p:sp>
+        <p:nvSpPr>
+          <p:cNvPr id="3" name="TextBox 2"/>
+          <p:cNvSpPr txBox="1"/>
+          <p:nvPr/>
+        </p:nvSpPr>
+        <p:spPr>
+          <a:xfrm>
+            <a:off x="566928" y="914400"/>
+            <a:ext cx="8595360" cy="1371600"/>
+          </a:xfrm>
+          <a:prstGeom prst="rect">
+            <a:avLst/>
+          </a:prstGeom>
+          <a:noFill/>
+        </p:spPr>
+        <p:txBody>
+          <a:bodyPr wrap="square" lIns="0" rIns="0" tIns="0" bIns="0">
+            <a:spAutoFit/>
+          </a:bodyPr>
+          <a:lstStyle/>
+          <a:p>
+            <a:pPr>
+              <a:lnSpc>
+                <a:spcPct val="108000"/>
+              </a:lnSpc>
+              <a:spcBef>
+                <a:spcPts val="0"/>
+              </a:spcBef>
+              <a:spcAft>
+                <a:spcPts val="0"/>
+              </a:spcAft>
+            </a:pPr>
+            <a:r>
+              <a:rPr sz="2700" b="0" i="0">
+                <a:solidFill>
+                  <a:srgbClr val="14171C"/>
+                </a:solidFill>
+                <a:latin typeface="Georgia"/>
+              </a:rPr>
+              <a:t>A question rather than a prescription</a:t>
+            </a:r>
+          </a:p>
+        </p:txBody>
+      </p:sp>
+      <p:sp>
+        <p:nvSpPr>
+          <p:cNvPr id="4" name="TextBox 3"/>
+          <p:cNvSpPr txBox="1"/>
+          <p:nvPr/>
+        </p:nvSpPr>
+        <p:spPr>
+          <a:xfrm>
+            <a:off x="566928" y="2286000"/>
+            <a:ext cx="8595360" cy="3840480"/>
+          </a:xfrm>
+          <a:prstGeom prst="rect">
+            <a:avLst/>
+          </a:prstGeom>
+          <a:noFill/>
+        </p:spPr>
+        <p:txBody>
+          <a:bodyPr wrap="square" lIns="0" rIns="0" tIns="0" bIns="0">
+            <a:spAutoFit/>
+          </a:bodyPr>
+          <a:lstStyle/>
+          <a:p>
+            <a:pPr>
+              <a:lnSpc>
+                <a:spcPct val="132000"/>
+              </a:lnSpc>
+              <a:spcBef>
+                <a:spcPts val="0"/>
+              </a:spcBef>
+              <a:spcAft>
+                <a:spcPts val="1100"/>
+              </a:spcAft>
+            </a:pPr>
+            <a:r>
+              <a:rPr sz="1400" b="0" i="0">
+                <a:solidFill>
+                  <a:srgbClr val="5A6068"/>
+                </a:solidFill>
+                <a:latin typeface="Calibri"/>
+              </a:rPr>
+              <a:t>The evidence shows a consistent pattern: which domain looks most consequential for wellbeing depends on which framework measures it and what variable they chose. This is not about the domains; it is about the tools.</a:t>
+            </a:r>
+          </a:p>
+          <a:p>
+            <a:pPr>
+              <a:lnSpc>
+                <a:spcPct val="132000"/>
+              </a:lnSpc>
+              <a:spcBef>
+                <a:spcPts val="0"/>
+              </a:spcBef>
+              <a:spcAft>
+                <a:spcPts val="1100"/>
+              </a:spcAft>
+            </a:pPr>
+            <a:r>
+              <a:rPr sz="1400" b="0" i="0">
+                <a:solidFill>
+                  <a:srgbClr val="5A6068"/>
+                </a:solidFill>
+                <a:latin typeface="Calibri"/>
+              </a:rPr>
+              <a:t>Whether development frameworks should be redesigned around wellbeing is outside the scope here. But if they were, this finding suggests the question to ask: should measurement choices be made with explicit reference to which variables still move and still matter for lived experience? Should coverage be built in for domains the frameworks discovered only by studying something else?</a:t>
+            </a:r>
+          </a:p>
+          <a:p>
+            <a:pPr>
+              <a:lnSpc>
+                <a:spcPct val="132000"/>
+              </a:lnSpc>
+              <a:spcBef>
+                <a:spcPts val="0"/>
+              </a:spcBef>
+              <a:spcAft>
+                <a:spcPts val="1100"/>
+              </a:spcAft>
+            </a:pPr>
+            <a:r>
+              <a:rPr sz="1400" b="0" i="0">
+                <a:solidFill>
+                  <a:srgbClr val="5A6068"/>
+                </a:solidFill>
+                <a:latin typeface="Calibri"/>
+              </a:rPr>
+              <a:t>The frameworks work well for their stated purpose. The question is whether wellbeing should become part of that purpose — and if it does, whether the measurement that comes from that intent should be different from the aggregate, development-first measurement in place today.</a:t>
+            </a:r>
+          </a:p>
+        </p:txBody>
+      </p:sp>
+      <p:sp>
+        <p:nvSpPr>
+          <p:cNvPr id="5" name="TextBox 4"/>
+          <p:cNvSpPr txBox="1"/>
+          <p:nvPr/>
+        </p:nvSpPr>
+        <p:spPr>
+          <a:xfrm>
+            <a:off x="11338560" y="6263640"/>
+            <a:ext cx="548640" cy="274320"/>
+          </a:xfrm>
+          <a:prstGeom prst="rect">
+            <a:avLst/>
+          </a:prstGeom>
+          <a:noFill/>
+        </p:spPr>
+        <p:txBody>
+          <a:bodyPr wrap="square" lIns="0" rIns="0" tIns="0" bIns="0">
+            <a:spAutoFit/>
+          </a:bodyPr>
+          <a:lstStyle/>
+          <a:p>
+            <a:pPr algn="r">
+              <a:spcBef>
+                <a:spcPts val="0"/>
+              </a:spcBef>
+              <a:spcAft>
+                <a:spcPts val="0"/>
+              </a:spcAft>
+            </a:pPr>
+            <a:r>
+              <a:rPr sz="1100" b="0" i="0">
+                <a:solidFill>
+                  <a:srgbClr val="868D96"/>
+                </a:solidFill>
+                <a:latin typeface="Consolas"/>
+              </a:rPr>
+              <a:t>IV</a:t>
+            </a:r>
+          </a:p>
+        </p:txBody>
+      </p:sp>
+    </p:spTree>
+  </p:cSld>
+  <p:clrMapOvr>
+    <a:masterClrMapping/>
+  </p:clrMapOvr>
+</p:sld>
+</file>
+
+<file path=ppt/slides/slide25.xml><?xml version="1.0" encoding="utf-8"?>
 <p:sld xmlns:a="http://schemas.openxmlformats.org/drawingml/2006/main" xmlns:p="http://schemas.openxmlformats.org/presentationml/2006/main" xmlns:r="http://schemas.openxmlformats.org/officeDocument/2006/relationships">
   <p:cSld>
     <p:bg>
@@ -8187,7 +8479,7 @@
 </p:sld>
 </file>
 
-<file path=ppt/slides/slide25.xml><?xml version="1.0" encoding="utf-8"?>
+<file path=ppt/slides/slide26.xml><?xml version="1.0" encoding="utf-8"?>
 <p:sld xmlns:a="http://schemas.openxmlformats.org/drawingml/2006/main" xmlns:p="http://schemas.openxmlformats.org/presentationml/2006/main" xmlns:r="http://schemas.openxmlformats.org/officeDocument/2006/relationships">
   <p:cSld>
     <p:bg>
@@ -8706,7 +8998,7 @@
 </p:sld>
 </file>
 
-<file path=ppt/slides/slide26.xml><?xml version="1.0" encoding="utf-8"?>
+<file path=ppt/slides/slide27.xml><?xml version="1.0" encoding="utf-8"?>
 <p:sld xmlns:a="http://schemas.openxmlformats.org/drawingml/2006/main" xmlns:p="http://schemas.openxmlformats.org/presentationml/2006/main" xmlns:r="http://schemas.openxmlformats.org/officeDocument/2006/relationships">
   <p:cSld>
     <p:bg>

</xml_diff>

<commit_message>
Restore three key figures to narrative and enhance education analysis
- Add framework_three_comparisons.png as opening to Act II, contextualizing how SDG and HDI frameworks compare on detection, budget-matching, and per-indicator significance
- Add health_trust_corroboration.png as opening to Act III, showing which domains survive both administrative and self-reported measurement sources
- Enhance F1 SDG goal ranking figure with education access line (12.7%) to show where access indicators alone would rank vs. pooled rate (3.3%)
- Update build_pptx.py to use correct default output filename (Measured_Where_It_Varies.pptx)
- Deck now 29 slides across 4 acts with complete figure set

Co-Authored-By: Claude Haiku 4.5 <noreply@anthropic.com>
Claude-Session: https://claude.ai/code/session_01EScqJU3C944N93U7Je3P1X
</commit_message>
<xml_diff>
--- a/deck/Measured_Where_It_Varies.pptx
+++ b/deck/Measured_Where_It_Varies.pptx
@@ -32,6 +32,8 @@
     <p:sldId id="280" r:id="rId31"/>
     <p:sldId id="281" r:id="rId32"/>
     <p:sldId id="282" r:id="rId33"/>
+    <p:sldId id="283" r:id="rId34"/>
+    <p:sldId id="284" r:id="rId35"/>
   </p:sldIdLst>
   <p:sldSz cx="12191695" cy="6858000" type="screen4x3"/>
   <p:notesSz cx="6858000" cy="9144000"/>
@@ -3425,7 +3427,7 @@
                 </a:solidFill>
                 <a:latin typeface="Consolas"/>
               </a:rPr>
-              <a:t>RESULT 1 · EDUCATION</a:t>
+              <a:t>ALL THREE MATTER</a:t>
             </a:r>
           </a:p>
         </p:txBody>
@@ -3470,7 +3472,7 @@
                 </a:solidFill>
                 <a:latin typeface="Georgia"/>
               </a:rPr>
-              <a:t>Significant in 92% of ESS countries, but only when measured as attainment</a:t>
+              <a:t>Education, health, and social trust all significantly predict life satisfaction</a:t>
             </a:r>
           </a:p>
         </p:txBody>
@@ -3515,29 +3517,7 @@
                 </a:solidFill>
                 <a:latin typeface="Calibri"/>
               </a:rPr>
-              <a:t>Expected years of schooling predicts life satisfaction in 34% of HDI countries — the highest among the five HDI components, but still a minority. In the ESS individual data, education (measured as years attained) is significant in 92% of countries. The difference is not about the data; it is about which construct you count.</a:t>
-            </a:r>
-          </a:p>
-          <a:p>
-            <a:pPr>
-              <a:lnSpc>
-                <a:spcPct val="132000"/>
-              </a:lnSpc>
-              <a:spcBef>
-                <a:spcPts val="0"/>
-              </a:spcBef>
-              <a:spcAft>
-                <a:spcPts val="1100"/>
-              </a:spcAft>
-            </a:pPr>
-            <a:r>
-              <a:rPr sz="1150" b="0" i="0">
-                <a:solidFill>
-                  <a:srgbClr val="5A6068"/>
-                </a:solidFill>
-                <a:latin typeface="Calibri"/>
-              </a:rPr>
-              <a:t>The SDG framework's education goal is 35 indicators spanning access, attainment, equity (parity ratios), learning outcomes, infrastructure, and financing. Pooled, 3.3% of country-indicator pairs are significant. But access indicators alone (primary and secondary enrollment, completion rates) reach 12.7% — because they measure participation, the closest SDG analogue to HDI attainment. Parity ratios, learning outcomes, and infrastructure contribute little to wellbeing, so pooling them masks the signal from access.</a:t>
+              <a:t>In the European Social Survey, where all three are measured at the individual level, all three are significant in the majority of countries. But which framework can see all three? Which sees only some? The answer depends on three different failure modes.</a:t>
             </a:r>
           </a:p>
         </p:txBody>
@@ -3586,7 +3566,7 @@
       </p:sp>
       <p:pic>
         <p:nvPicPr>
-          <p:cNvPr id="6" name="Picture 5" descr="education_levels_comparison.png"/>
+          <p:cNvPr id="6" name="Picture 5" descr="domains_at_levels_comparison.png"/>
           <p:cNvPicPr>
             <a:picLocks noChangeAspect="1"/>
           </p:cNvPicPr>
@@ -3600,8 +3580,8 @@
         </p:blipFill>
         <p:spPr>
           <a:xfrm>
-            <a:off x="5120640" y="1412748"/>
-            <a:ext cx="6537960" cy="3566160"/>
+            <a:off x="5120640" y="2028335"/>
+            <a:ext cx="6537960" cy="2334985"/>
           </a:xfrm>
           <a:prstGeom prst="rect">
             <a:avLst/>
@@ -3648,7 +3628,7 @@
                 </a:solidFill>
                 <a:latin typeface="Calibri"/>
               </a:rPr>
-              <a:t>Education's R² (% of countries significant at levels) across three frameworks. SDG4's pooled rate (3.3%) includes all 35 constructs; access alone reaches 12.7%.</a:t>
+              <a:t>% of countries where each domain significantly predicts wellbeing at levels. ESS: 36 countries. HDI: 150 countries. SDG: country-indicator pairs.</a:t>
             </a:r>
           </a:p>
         </p:txBody>
@@ -3716,7 +3696,7 @@
                 </a:solidFill>
                 <a:latin typeface="Consolas"/>
               </a:rPr>
-              <a:t>ACCESS CHECK · WHY EDUCATION'S RANK SWINGS</a:t>
+              <a:t>RESULT 1 · EDUCATION</a:t>
             </a:r>
           </a:p>
         </p:txBody>
@@ -3761,7 +3741,7 @@
                 </a:solidFill>
                 <a:latin typeface="Georgia"/>
               </a:rPr>
-              <a:t>The difference between measuring attainment and measuring parity</a:t>
+              <a:t>Significant in 92% of ESS countries, but only when measured as attainment</a:t>
             </a:r>
           </a:p>
         </p:txBody>
@@ -3806,7 +3786,29 @@
                 </a:solidFill>
                 <a:latin typeface="Calibri"/>
               </a:rPr>
-              <a:t>When the SDG framework pools constructs, it weights all equally by series count. Parity ratios are 18 of 35 series but carry almost no signal for wellbeing. Learning outcomes (6 series, 0.9% significant), infrastructure (7 series, 2.0%), and financing (1 series, 11.5%) together drive the pooled rate below what access alone achieves. This is not a discovery about education; it is a mechanical artifact of construction.</a:t>
+              <a:t>Expected years of schooling predicts life satisfaction in 34% of HDI countries — the highest among the five HDI components, but still a minority. In the ESS individual data, education (measured as years attained) is significant in 92% of countries. The difference is not about the data; it is about which construct you count.</a:t>
+            </a:r>
+          </a:p>
+          <a:p>
+            <a:pPr>
+              <a:lnSpc>
+                <a:spcPct val="132000"/>
+              </a:lnSpc>
+              <a:spcBef>
+                <a:spcPts val="0"/>
+              </a:spcBef>
+              <a:spcAft>
+                <a:spcPts val="1100"/>
+              </a:spcAft>
+            </a:pPr>
+            <a:r>
+              <a:rPr sz="1150" b="0" i="0">
+                <a:solidFill>
+                  <a:srgbClr val="5A6068"/>
+                </a:solidFill>
+                <a:latin typeface="Calibri"/>
+              </a:rPr>
+              <a:t>The SDG framework's education goal is 35 indicators spanning access, attainment, equity (parity ratios), learning outcomes, infrastructure, and financing. Pooled, 3.3% of country-indicator pairs are significant. But access indicators alone (primary and secondary enrollment, completion rates) reach 12.7% — because they measure participation, the closest SDG analogue to HDI attainment. Parity ratios, learning outcomes, and infrastructure contribute little to wellbeing, so pooling them masks the signal from access.</a:t>
             </a:r>
           </a:p>
         </p:txBody>
@@ -3855,7 +3857,7 @@
       </p:sp>
       <p:pic>
         <p:nvPicPr>
-          <p:cNvPr id="6" name="Picture 5" descr="sdg4_unpooled.png"/>
+          <p:cNvPr id="6" name="Picture 5" descr="education_levels_comparison.png"/>
           <p:cNvPicPr>
             <a:picLocks noChangeAspect="1"/>
           </p:cNvPicPr>
@@ -3869,8 +3871,8 @@
         </p:blipFill>
         <p:spPr>
           <a:xfrm>
-            <a:off x="5120640" y="1103208"/>
-            <a:ext cx="6537960" cy="4185240"/>
+            <a:off x="5120640" y="1412748"/>
+            <a:ext cx="6537960" cy="3566160"/>
           </a:xfrm>
           <a:prstGeom prst="rect">
             <a:avLst/>
@@ -3917,7 +3919,7 @@
                 </a:solidFill>
                 <a:latin typeface="Calibri"/>
               </a:rPr>
-              <a:t>SDG4 by construct: access and participation (12.7%) vs. equity/parity ratios (2.5%), learning outcomes (0.9%), and others.</a:t>
+              <a:t>Education's R² (% of countries significant at levels) across three frameworks. SDG4's pooled rate (3.3%) includes all 35 constructs; access alone reaches 12.7%.</a:t>
             </a:r>
           </a:p>
         </p:txBody>
@@ -3985,7 +3987,7 @@
                 </a:solidFill>
                 <a:latin typeface="Consolas"/>
               </a:rPr>
-              <a:t>RESULT 2 · HEALTH</a:t>
+              <a:t>ACCESS CHECK · WHY EDUCATION'S RANK SWINGS</a:t>
             </a:r>
           </a:p>
         </p:txBody>
@@ -4030,7 +4032,7 @@
                 </a:solidFill>
                 <a:latin typeface="Georgia"/>
               </a:rPr>
-              <a:t>Significant in 100% of ESS countries, weak in the HDI, strong in the SDGs</a:t>
+              <a:t>The difference between measuring attainment and measuring parity</a:t>
             </a:r>
           </a:p>
         </p:txBody>
@@ -4075,29 +4077,7 @@
                 </a:solidFill>
                 <a:latin typeface="Calibri"/>
               </a:rPr>
-              <a:t>Self-rated health is the single strongest predictor of life satisfaction in the ESS: 100% of countries significant at the individual level, median R² = 0.091 (four times education's). In the HDI, health's proxy is life expectancy, and it is the weakest of five components — only 20% of countries significant. In the SDG database, health (Goal 3) reaches 11.5% of country-indicator pairs, fourth of 17 goals.</a:t>
-            </a:r>
-          </a:p>
-          <a:p>
-            <a:pPr>
-              <a:lnSpc>
-                <a:spcPct val="132000"/>
-              </a:lnSpc>
-              <a:spcBef>
-                <a:spcPts val="0"/>
-              </a:spcBef>
-              <a:spcAft>
-                <a:spcPts val="1100"/>
-              </a:spcAft>
-            </a:pPr>
-            <a:r>
-              <a:rPr sz="1150" b="0" i="0">
-                <a:solidFill>
-                  <a:srgbClr val="5A6068"/>
-                </a:solidFill>
-                <a:latin typeface="Calibri"/>
-              </a:rPr>
-              <a:t>Life expectancy is close to saturated in developed countries: the top 100 countries range from 81 to 85 years. The variance that remains is so small that between-country differences add little predictive power. This is not health's problem; it is the specific HDI indicator's problem. The gap between frameworks shows the importance of variable choice, not of health itself.</a:t>
+              <a:t>When the SDG framework pools constructs, it weights all equally by series count. Parity ratios are 18 of 35 series but carry almost no signal for wellbeing. Learning outcomes (6 series, 0.9% significant), infrastructure (7 series, 2.0%), and financing (1 series, 11.5%) together drive the pooled rate below what access alone achieves. This is not a discovery about education; it is a mechanical artifact of construction.</a:t>
             </a:r>
           </a:p>
         </p:txBody>
@@ -4146,7 +4126,7 @@
       </p:sp>
       <p:pic>
         <p:nvPicPr>
-          <p:cNvPr id="6" name="Picture 5" descr="health_levels_comparison.png"/>
+          <p:cNvPr id="6" name="Picture 5" descr="sdg4_unpooled.png"/>
           <p:cNvPicPr>
             <a:picLocks noChangeAspect="1"/>
           </p:cNvPicPr>
@@ -4160,8 +4140,8 @@
         </p:blipFill>
         <p:spPr>
           <a:xfrm>
-            <a:off x="5120640" y="1234440"/>
-            <a:ext cx="6537960" cy="3922776"/>
+            <a:off x="5120640" y="1103208"/>
+            <a:ext cx="6537960" cy="4185240"/>
           </a:xfrm>
           <a:prstGeom prst="rect">
             <a:avLst/>
@@ -4208,7 +4188,7 @@
                 </a:solidFill>
                 <a:latin typeface="Calibri"/>
               </a:rPr>
-              <a:t>Health's R² (% of countries significant at levels) across three frameworks. Self-rated health in ESS dominates; external HDI proxy (life expectancy) is weak.</a:t>
+              <a:t>SDG4 by construct: access and participation (12.7%) vs. equity/parity ratios (2.5%), learning outcomes (0.9%), and others.</a:t>
             </a:r>
           </a:p>
         </p:txBody>
@@ -4276,7 +4256,7 @@
                 </a:solidFill>
                 <a:latin typeface="Consolas"/>
               </a:rPr>
-              <a:t>SDG INDICATOR RANKINGS · WHY HEALTH MATTERS DESPITE LOW %</a:t>
+              <a:t>RESULT 2 · HEALTH</a:t>
             </a:r>
           </a:p>
         </p:txBody>
@@ -4321,7 +4301,7 @@
                 </a:solidFill>
                 <a:latin typeface="Georgia"/>
               </a:rPr>
-              <a:t>Health indicators rank 4th among 17 SDG goals; the low percentage reflects weak overall SDG signal</a:t>
+              <a:t>Significant in 100% of ESS countries, weak in the HDI, strong in the SDGs</a:t>
             </a:r>
           </a:p>
         </p:txBody>
@@ -4366,7 +4346,7 @@
                 </a:solidFill>
                 <a:latin typeface="Calibri"/>
               </a:rPr>
-              <a:t>The SDG database is vast: 661 series across 42 countries testing 17 goals. The overall significance rate is low — only 3-4% of all country-indicator pairs are significant. Within that sparse landscape, health indicators rank fourth, with 16 of the top 25 most predictive SDG series falling under Goal 3. These are survival measures: infant mortality, under-five mortality, stunting, neonatal mortality, sanitation, drinking water — all objective, externally measured.</a:t>
+              <a:t>Self-rated health is the single strongest predictor of life satisfaction in the ESS: 100% of countries significant at the individual level, median R² = 0.091 (four times education's). In the HDI, health's proxy is life expectancy, and it is the weakest of five components — only 20% of countries significant. In the SDG database, health (Goal 3) reaches 11.5% of country-indicator pairs, fourth of 17 goals.</a:t>
             </a:r>
           </a:p>
           <a:p>
@@ -4388,7 +4368,7 @@
                 </a:solidFill>
                 <a:latin typeface="Calibri"/>
               </a:rPr>
-              <a:t>The low 11.5% rate for health is not evidence that health doesn't matter. It is evidence that most of the SDG database does not predict wellbeing. Within that context, health ranks high.</a:t>
+              <a:t>Life expectancy is close to saturated in developed countries: the top 100 countries range from 81 to 85 years. The variance that remains is so small that between-country differences add little predictive power. This is not health's problem; it is the specific HDI indicator's problem. The gap between frameworks shows the importance of variable choice, not of health itself.</a:t>
             </a:r>
           </a:p>
         </p:txBody>
@@ -4437,7 +4417,7 @@
       </p:sp>
       <p:pic>
         <p:nvPicPr>
-          <p:cNvPr id="6" name="Picture 5" descr="sdg_indicator_top20.png"/>
+          <p:cNvPr id="6" name="Picture 5" descr="health_levels_comparison.png"/>
           <p:cNvPicPr>
             <a:picLocks noChangeAspect="1"/>
           </p:cNvPicPr>
@@ -4451,8 +4431,8 @@
         </p:blipFill>
         <p:spPr>
           <a:xfrm>
-            <a:off x="5279547" y="658368"/>
-            <a:ext cx="6220145" cy="5074920"/>
+            <a:off x="5120640" y="1234440"/>
+            <a:ext cx="6537960" cy="3922776"/>
           </a:xfrm>
           <a:prstGeom prst="rect">
             <a:avLst/>
@@ -4499,7 +4479,7 @@
                 </a:solidFill>
                 <a:latin typeface="Calibri"/>
               </a:rPr>
-              <a:t>Top 25 SDG indicators by significance. Health (Goal 3) dominates: 16 of 25 top series.</a:t>
+              <a:t>Health's R² (% of countries significant at levels) across three frameworks. Self-rated health in ESS dominates; external HDI proxy (life expectancy) is weak.</a:t>
             </a:r>
           </a:p>
         </p:txBody>
@@ -4567,7 +4547,7 @@
                 </a:solidFill>
                 <a:latin typeface="Consolas"/>
               </a:rPr>
-              <a:t>RESULT 3 · SOCIAL TRUST</a:t>
+              <a:t>SDG INDICATOR RANKINGS · WHY HEALTH MATTERS DESPITE LOW %</a:t>
             </a:r>
           </a:p>
         </p:txBody>
@@ -4612,7 +4592,7 @@
                 </a:solidFill>
                 <a:latin typeface="Georgia"/>
               </a:rPr>
-              <a:t>Social trust leads the ESS, is nearly invisible to development frameworks</a:t>
+              <a:t>Health indicators rank 4th among 17 SDG goals; the low percentage reflects weak overall SDG signal</a:t>
             </a:r>
           </a:p>
         </p:txBody>
@@ -4657,7 +4637,7 @@
                 </a:solidFill>
                 <a:latin typeface="Calibri"/>
               </a:rPr>
-              <a:t>Social trust — 'most people can be trusted' — is significant in 94% of ESS countries, third strongest domain after health and income, with median R² = 0.041. Neither the HDI nor the SDG framework measures it at all.</a:t>
+              <a:t>The SDG database is vast: 661 series across 42 countries testing 17 goals. The overall significance rate is low — only 3-4% of all country-indicator pairs are significant. At the goal level, health (Goal 3) reaches 11.5% of country-indicator pairs, ranking fourth of 17 goals. Within that sparse landscape, health indicators dominate the top-ranked individual series, with 16 of the top 25 most predictive SDG series falling under Goal 3. These are survival measures: infant mortality, under-five mortality, stunting, neonatal mortality, sanitation, drinking water — all objective, externally measured.</a:t>
             </a:r>
           </a:p>
           <a:p>
@@ -4679,29 +4659,7 @@
                 </a:solidFill>
                 <a:latin typeface="Calibri"/>
               </a:rPr>
-              <a:t>The SDG database does carry 13 trust- and satisfaction-adjacent series under Goal 16: satisfaction with public services, perception of bribery, perceived decision-making inclusiveness. But these measure institutional confidence, not interpersonal trust — a different construct, and one that correlates more weakly with life satisfaction even when tested across countries. Moreover, their median coverage is one observation per country-series against six for the database as a whole; 147 of 163 country-series cannot support a time-series design.</a:t>
-            </a:r>
-          </a:p>
-          <a:p>
-            <a:pPr>
-              <a:lnSpc>
-                <a:spcPct val="132000"/>
-              </a:lnSpc>
-              <a:spcBef>
-                <a:spcPts val="0"/>
-              </a:spcBef>
-              <a:spcAft>
-                <a:spcPts val="1100"/>
-              </a:spcAft>
-            </a:pPr>
-            <a:r>
-              <a:rPr sz="1150" b="0" i="0">
-                <a:solidFill>
-                  <a:srgbClr val="5A6068"/>
-                </a:solidFill>
-                <a:latin typeface="Calibri"/>
-              </a:rPr>
-              <a:t>Education's and health's problems are about which variable to count within a domain. Trust's problem is different: it is not in the frameworks at all. That is a coverage gap, not a measurement problem.</a:t>
+              <a:t>The low 11.5% rate for health is not evidence that health doesn't matter. It is evidence that most of the SDG database does not predict wellbeing. Within that context, health ranks high.</a:t>
             </a:r>
           </a:p>
         </p:txBody>
@@ -4750,7 +4708,7 @@
       </p:sp>
       <p:pic>
         <p:nvPicPr>
-          <p:cNvPr id="6" name="Picture 5" descr="trust_coverage_comparison.png"/>
+          <p:cNvPr id="6" name="Picture 5" descr="sdg_indicator_top20.png"/>
           <p:cNvPicPr>
             <a:picLocks noChangeAspect="1"/>
           </p:cNvPicPr>
@@ -4764,8 +4722,8 @@
         </p:blipFill>
         <p:spPr>
           <a:xfrm>
-            <a:off x="5120640" y="1234440"/>
-            <a:ext cx="6537960" cy="3922776"/>
+            <a:off x="5279547" y="658368"/>
+            <a:ext cx="6220145" cy="5074920"/>
           </a:xfrm>
           <a:prstGeom prst="rect">
             <a:avLst/>
@@ -4812,7 +4770,7 @@
                 </a:solidFill>
                 <a:latin typeface="Calibri"/>
               </a:rPr>
-              <a:t>Social trust: 94% of ESS countries significant (individual level), 1.5% of SDG16 country-indicator pairs (institutional confidence, not interpersonal trust), not measured in the HDI.</a:t>
+              <a:t>Top 25 SDG indicators by significance. Health (Goal 3) dominates: 16 of 25 top series.</a:t>
             </a:r>
           </a:p>
         </p:txBody>
@@ -4880,7 +4838,7 @@
                 </a:solidFill>
                 <a:latin typeface="Consolas"/>
               </a:rPr>
-              <a:t>SYNTHESIS</a:t>
+              <a:t>RESULT 3 · SOCIAL TRUST</a:t>
             </a:r>
           </a:p>
         </p:txBody>
@@ -4925,7 +4883,7 @@
                 </a:solidFill>
                 <a:latin typeface="Georgia"/>
               </a:rPr>
-              <a:t>Three domains, three ways frameworks lose sight of what matters</a:t>
+              <a:t>Social trust leads the ESS, is nearly invisible to development frameworks</a:t>
             </a:r>
           </a:p>
         </p:txBody>
@@ -4970,7 +4928,7 @@
                 </a:solidFill>
                 <a:latin typeface="Calibri"/>
               </a:rPr>
-              <a:t>Education's rank depends on which construct you count: attainment works, but parity ratios and learning outcomes do not, so pooling dilutes the signal. Health's rank depends on whether your chosen variable still varies: life expectancy does not, but self-rated health does, so the HDI's choice costs it. Social trust's rank is zero because it is not collected at scale in development frameworks at all — a coverage gap that cannot be fixed by choosing the right variable, because no variable was ever measured.</a:t>
+              <a:t>Social trust — 'most people can be trusted' — is significant in 94% of ESS countries, third strongest domain after health and income, with median R² = 0.041. Neither the HDI nor the SDG framework measures it at all.</a:t>
             </a:r>
           </a:p>
           <a:p>
@@ -4992,7 +4950,29 @@
                 </a:solidFill>
                 <a:latin typeface="Calibri"/>
               </a:rPr>
-              <a:t>These are not criticisms of the frameworks; they were built to track development, and they do. But which components look most consequential for lived experience is not the question they were built to answer.</a:t>
+              <a:t>The SDG database does carry 13 trust- and satisfaction-adjacent series under Goal 16: satisfaction with public services, perception of bribery, perceived decision-making inclusiveness. But these measure institutional confidence, not interpersonal trust — a different construct, and one that correlates more weakly with life satisfaction even when tested across countries. Moreover, their median coverage is one observation per country-series against six for the database as a whole; 147 of 163 country-series cannot support a time-series design.</a:t>
+            </a:r>
+          </a:p>
+          <a:p>
+            <a:pPr>
+              <a:lnSpc>
+                <a:spcPct val="132000"/>
+              </a:lnSpc>
+              <a:spcBef>
+                <a:spcPts val="0"/>
+              </a:spcBef>
+              <a:spcAft>
+                <a:spcPts val="1100"/>
+              </a:spcAft>
+            </a:pPr>
+            <a:r>
+              <a:rPr sz="1150" b="0" i="0">
+                <a:solidFill>
+                  <a:srgbClr val="5A6068"/>
+                </a:solidFill>
+                <a:latin typeface="Calibri"/>
+              </a:rPr>
+              <a:t>Education's and health's problems are about which variable to count within a domain. Trust's problem is different: it is not in the frameworks at all. That is a coverage gap, not a measurement problem.</a:t>
             </a:r>
           </a:p>
         </p:txBody>
@@ -5041,7 +5021,7 @@
       </p:sp>
       <p:pic>
         <p:nvPicPr>
-          <p:cNvPr id="6" name="Picture 5" descr="domain_horse_race.png"/>
+          <p:cNvPr id="6" name="Picture 5" descr="trust_coverage_comparison.png"/>
           <p:cNvPicPr>
             <a:picLocks noChangeAspect="1"/>
           </p:cNvPicPr>
@@ -5055,8 +5035,8 @@
         </p:blipFill>
         <p:spPr>
           <a:xfrm>
-            <a:off x="5120640" y="1433421"/>
-            <a:ext cx="6537960" cy="3524813"/>
+            <a:off x="5120640" y="1234440"/>
+            <a:ext cx="6537960" cy="3922776"/>
           </a:xfrm>
           <a:prstGeom prst="rect">
             <a:avLst/>
@@ -5103,7 +5083,7 @@
                 </a:solidFill>
                 <a:latin typeface="Calibri"/>
               </a:rPr>
-              <a:t>Domains competing within one instrument (ESS), at two levels of aggregation. Individual level (left) and country means (right).</a:t>
+              <a:t>Social trust: 94% of ESS countries significant (individual level), 1.5% of SDG16 country-indicator pairs (institutional confidence, not interpersonal trust), not measured in the HDI.</a:t>
             </a:r>
           </a:p>
         </p:txBody>
@@ -5117,6 +5097,297 @@
 </file>
 
 <file path=ppt/slides/slide16.xml><?xml version="1.0" encoding="utf-8"?>
+<p:sld xmlns:a="http://schemas.openxmlformats.org/drawingml/2006/main" xmlns:p="http://schemas.openxmlformats.org/presentationml/2006/main" xmlns:r="http://schemas.openxmlformats.org/officeDocument/2006/relationships">
+  <p:cSld>
+    <p:bg>
+      <p:bgPr>
+        <a:solidFill>
+          <a:srgbClr val="FCFCFB"/>
+        </a:solidFill>
+        <a:effectLst/>
+      </p:bgPr>
+    </p:bg>
+    <p:spTree>
+      <p:nvGrpSpPr>
+        <p:cNvPr id="1" name=""/>
+        <p:cNvGrpSpPr/>
+        <p:nvPr/>
+      </p:nvGrpSpPr>
+      <p:grpSpPr/>
+      <p:sp>
+        <p:nvSpPr>
+          <p:cNvPr id="2" name="TextBox 1"/>
+          <p:cNvSpPr txBox="1"/>
+          <p:nvPr/>
+        </p:nvSpPr>
+        <p:spPr>
+          <a:xfrm>
+            <a:off x="566928" y="502920"/>
+            <a:ext cx="4160520" cy="274320"/>
+          </a:xfrm>
+          <a:prstGeom prst="rect">
+            <a:avLst/>
+          </a:prstGeom>
+          <a:noFill/>
+        </p:spPr>
+        <p:txBody>
+          <a:bodyPr wrap="square" lIns="0" rIns="0" tIns="0" bIns="0">
+            <a:spAutoFit/>
+          </a:bodyPr>
+          <a:lstStyle/>
+          <a:p>
+            <a:pPr>
+              <a:spcBef>
+                <a:spcPts val="0"/>
+              </a:spcBef>
+              <a:spcAft>
+                <a:spcPts val="0"/>
+              </a:spcAft>
+            </a:pPr>
+            <a:r>
+              <a:rPr sz="1000" b="0" i="0">
+                <a:solidFill>
+                  <a:srgbClr val="A63A30"/>
+                </a:solidFill>
+                <a:latin typeface="Consolas"/>
+              </a:rPr>
+              <a:t>SYNTHESIS</a:t>
+            </a:r>
+          </a:p>
+        </p:txBody>
+      </p:sp>
+      <p:sp>
+        <p:nvSpPr>
+          <p:cNvPr id="3" name="TextBox 2"/>
+          <p:cNvSpPr txBox="1"/>
+          <p:nvPr/>
+        </p:nvSpPr>
+        <p:spPr>
+          <a:xfrm>
+            <a:off x="566928" y="914400"/>
+            <a:ext cx="4160520" cy="1371600"/>
+          </a:xfrm>
+          <a:prstGeom prst="rect">
+            <a:avLst/>
+          </a:prstGeom>
+          <a:noFill/>
+        </p:spPr>
+        <p:txBody>
+          <a:bodyPr wrap="square" lIns="0" rIns="0" tIns="0" bIns="0">
+            <a:spAutoFit/>
+          </a:bodyPr>
+          <a:lstStyle/>
+          <a:p>
+            <a:pPr>
+              <a:lnSpc>
+                <a:spcPct val="108000"/>
+              </a:lnSpc>
+              <a:spcBef>
+                <a:spcPts val="0"/>
+              </a:spcBef>
+              <a:spcAft>
+                <a:spcPts val="0"/>
+              </a:spcAft>
+            </a:pPr>
+            <a:r>
+              <a:rPr sz="2300" b="0" i="0">
+                <a:solidFill>
+                  <a:srgbClr val="14171C"/>
+                </a:solidFill>
+                <a:latin typeface="Georgia"/>
+              </a:rPr>
+              <a:t>Three domains, three ways frameworks lose sight of what matters</a:t>
+            </a:r>
+          </a:p>
+        </p:txBody>
+      </p:sp>
+      <p:sp>
+        <p:nvSpPr>
+          <p:cNvPr id="4" name="TextBox 3"/>
+          <p:cNvSpPr txBox="1"/>
+          <p:nvPr/>
+        </p:nvSpPr>
+        <p:spPr>
+          <a:xfrm>
+            <a:off x="566928" y="2331720"/>
+            <a:ext cx="4160520" cy="3840480"/>
+          </a:xfrm>
+          <a:prstGeom prst="rect">
+            <a:avLst/>
+          </a:prstGeom>
+          <a:noFill/>
+        </p:spPr>
+        <p:txBody>
+          <a:bodyPr wrap="square" lIns="0" rIns="0" tIns="0" bIns="0">
+            <a:spAutoFit/>
+          </a:bodyPr>
+          <a:lstStyle/>
+          <a:p>
+            <a:pPr>
+              <a:lnSpc>
+                <a:spcPct val="132000"/>
+              </a:lnSpc>
+              <a:spcBef>
+                <a:spcPts val="0"/>
+              </a:spcBef>
+              <a:spcAft>
+                <a:spcPts val="1100"/>
+              </a:spcAft>
+            </a:pPr>
+            <a:r>
+              <a:rPr sz="1150" b="0" i="0">
+                <a:solidFill>
+                  <a:srgbClr val="5A6068"/>
+                </a:solidFill>
+                <a:latin typeface="Calibri"/>
+              </a:rPr>
+              <a:t>Education's rank depends on which construct you count: attainment works, but parity ratios and learning outcomes do not, so pooling dilutes the signal. Health's rank depends on whether your chosen variable still varies: life expectancy does not, but self-rated health does, so the HDI's choice costs it. Social trust's rank is zero because it is not collected at scale in development frameworks at all — a coverage gap that cannot be fixed by choosing the right variable, because no variable was ever measured.</a:t>
+            </a:r>
+          </a:p>
+          <a:p>
+            <a:pPr>
+              <a:lnSpc>
+                <a:spcPct val="132000"/>
+              </a:lnSpc>
+              <a:spcBef>
+                <a:spcPts val="0"/>
+              </a:spcBef>
+              <a:spcAft>
+                <a:spcPts val="1100"/>
+              </a:spcAft>
+            </a:pPr>
+            <a:r>
+              <a:rPr sz="1150" b="0" i="0">
+                <a:solidFill>
+                  <a:srgbClr val="5A6068"/>
+                </a:solidFill>
+                <a:latin typeface="Calibri"/>
+              </a:rPr>
+              <a:t>These are not criticisms of the frameworks; they were built to track development, and they do. But which components look most consequential for lived experience is not the question they were built to answer.</a:t>
+            </a:r>
+          </a:p>
+        </p:txBody>
+      </p:sp>
+      <p:sp>
+        <p:nvSpPr>
+          <p:cNvPr id="5" name="TextBox 4"/>
+          <p:cNvSpPr txBox="1"/>
+          <p:nvPr/>
+        </p:nvSpPr>
+        <p:spPr>
+          <a:xfrm>
+            <a:off x="11338560" y="6263640"/>
+            <a:ext cx="548640" cy="274320"/>
+          </a:xfrm>
+          <a:prstGeom prst="rect">
+            <a:avLst/>
+          </a:prstGeom>
+          <a:noFill/>
+        </p:spPr>
+        <p:txBody>
+          <a:bodyPr wrap="square" lIns="0" rIns="0" tIns="0" bIns="0">
+            <a:spAutoFit/>
+          </a:bodyPr>
+          <a:lstStyle/>
+          <a:p>
+            <a:pPr algn="r">
+              <a:spcBef>
+                <a:spcPts val="0"/>
+              </a:spcBef>
+              <a:spcAft>
+                <a:spcPts val="0"/>
+              </a:spcAft>
+            </a:pPr>
+            <a:r>
+              <a:rPr sz="1100" b="0" i="0">
+                <a:solidFill>
+                  <a:srgbClr val="868D96"/>
+                </a:solidFill>
+                <a:latin typeface="Consolas"/>
+              </a:rPr>
+              <a:t>II</a:t>
+            </a:r>
+          </a:p>
+        </p:txBody>
+      </p:sp>
+      <p:pic>
+        <p:nvPicPr>
+          <p:cNvPr id="6" name="Picture 5" descr="domain_horse_race.png"/>
+          <p:cNvPicPr>
+            <a:picLocks noChangeAspect="1"/>
+          </p:cNvPicPr>
+          <p:nvPr/>
+        </p:nvPicPr>
+        <p:blipFill>
+          <a:blip r:embed="rId2"/>
+          <a:stretch>
+            <a:fillRect/>
+          </a:stretch>
+        </p:blipFill>
+        <p:spPr>
+          <a:xfrm>
+            <a:off x="5120640" y="1433421"/>
+            <a:ext cx="6537960" cy="3524813"/>
+          </a:xfrm>
+          <a:prstGeom prst="rect">
+            <a:avLst/>
+          </a:prstGeom>
+        </p:spPr>
+      </p:pic>
+      <p:sp>
+        <p:nvSpPr>
+          <p:cNvPr id="7" name="TextBox 6"/>
+          <p:cNvSpPr txBox="1"/>
+          <p:nvPr/>
+        </p:nvSpPr>
+        <p:spPr>
+          <a:xfrm>
+            <a:off x="5120640" y="5897880"/>
+            <a:ext cx="6537960" cy="731520"/>
+          </a:xfrm>
+          <a:prstGeom prst="rect">
+            <a:avLst/>
+          </a:prstGeom>
+          <a:noFill/>
+        </p:spPr>
+        <p:txBody>
+          <a:bodyPr wrap="square" lIns="0" rIns="0" tIns="0" bIns="0">
+            <a:spAutoFit/>
+          </a:bodyPr>
+          <a:lstStyle/>
+          <a:p>
+            <a:pPr>
+              <a:lnSpc>
+                <a:spcPct val="125000"/>
+              </a:lnSpc>
+              <a:spcBef>
+                <a:spcPts val="0"/>
+              </a:spcBef>
+              <a:spcAft>
+                <a:spcPts val="0"/>
+              </a:spcAft>
+            </a:pPr>
+            <a:r>
+              <a:rPr sz="900" b="0" i="0">
+                <a:solidFill>
+                  <a:srgbClr val="868D96"/>
+                </a:solidFill>
+                <a:latin typeface="Calibri"/>
+              </a:rPr>
+              <a:t>Domains competing within one instrument (ESS), at two levels of aggregation. Individual level (left) and country means (right).</a:t>
+            </a:r>
+          </a:p>
+        </p:txBody>
+      </p:sp>
+    </p:spTree>
+  </p:cSld>
+  <p:clrMapOvr>
+    <a:masterClrMapping/>
+  </p:clrMapOvr>
+</p:sld>
+</file>
+
+<file path=ppt/slides/slide17.xml><?xml version="1.0" encoding="utf-8"?>
 <p:sld xmlns:a="http://schemas.openxmlformats.org/drawingml/2006/main" xmlns:p="http://schemas.openxmlformats.org/presentationml/2006/main" xmlns:r="http://schemas.openxmlformats.org/officeDocument/2006/relationships">
   <p:cSld>
     <p:bg>
@@ -5273,7 +5544,7 @@
 </p:sld>
 </file>
 
-<file path=ppt/slides/slide17.xml><?xml version="1.0" encoding="utf-8"?>
+<file path=ppt/slides/slide18.xml><?xml version="1.0" encoding="utf-8"?>
 <p:sld xmlns:a="http://schemas.openxmlformats.org/drawingml/2006/main" xmlns:p="http://schemas.openxmlformats.org/presentationml/2006/main" xmlns:r="http://schemas.openxmlformats.org/officeDocument/2006/relationships">
   <p:cSld>
     <p:bg>
@@ -5709,7 +5980,7 @@
 </p:sld>
 </file>
 
-<file path=ppt/slides/slide18.xml><?xml version="1.0" encoding="utf-8"?>
+<file path=ppt/slides/slide19.xml><?xml version="1.0" encoding="utf-8"?>
 <p:sld xmlns:a="http://schemas.openxmlformats.org/drawingml/2006/main" xmlns:p="http://schemas.openxmlformats.org/presentationml/2006/main" xmlns:r="http://schemas.openxmlformats.org/officeDocument/2006/relationships">
   <p:cSld>
     <p:bg>
@@ -5736,7 +6007,7 @@
         <p:spPr>
           <a:xfrm>
             <a:off x="566928" y="502920"/>
-            <a:ext cx="8595360" cy="274320"/>
+            <a:ext cx="4160520" cy="274320"/>
           </a:xfrm>
           <a:prstGeom prst="rect">
             <a:avLst/>
@@ -5764,7 +6035,7 @@
                 </a:solidFill>
                 <a:latin typeface="Consolas"/>
               </a:rPr>
-              <a:t>WITHIN-COUNTRY EVIDENCE</a:t>
+              <a:t>METHOD MATTERS · WHAT SURVIVES</a:t>
             </a:r>
           </a:p>
         </p:txBody>
@@ -5778,7 +6049,7 @@
         <p:spPr>
           <a:xfrm>
             <a:off x="566928" y="914400"/>
-            <a:ext cx="8595360" cy="1371600"/>
+            <a:ext cx="4160520" cy="1371600"/>
           </a:xfrm>
           <a:prstGeom prst="rect">
             <a:avLst/>
@@ -5803,13 +6074,13 @@
               </a:spcAft>
             </a:pPr>
             <a:r>
-              <a:rPr sz="2700" b="0" i="0">
+              <a:rPr sz="2300" b="0" i="0">
                 <a:solidFill>
                   <a:srgbClr val="14171C"/>
                 </a:solidFill>
                 <a:latin typeface="Georgia"/>
               </a:rPr>
-              <a:t>Individual-level, self-reported data captures year-to-year change that administrative frameworks miss</a:t>
+              <a:t>Health survives both measurement methods. Social trust does not.</a:t>
             </a:r>
           </a:p>
         </p:txBody>
@@ -5822,8 +6093,8 @@
         </p:nvSpPr>
         <p:spPr>
           <a:xfrm>
-            <a:off x="566928" y="2286000"/>
-            <a:ext cx="8595360" cy="3840480"/>
+            <a:off x="566928" y="2331720"/>
+            <a:ext cx="4160520" cy="3840480"/>
           </a:xfrm>
           <a:prstGeom prst="rect">
             <a:avLst/>
@@ -5848,57 +6119,13 @@
               </a:spcAft>
             </a:pPr>
             <a:r>
-              <a:rPr sz="1400" b="0" i="0">
+              <a:rPr sz="1150" b="0" i="0">
                 <a:solidFill>
                   <a:srgbClr val="5A6068"/>
                 </a:solidFill>
                 <a:latin typeface="Calibri"/>
               </a:rPr>
-              <a:t>Here is the critical observation that reshapes the question: unlike SDG (71% levels → 5% differences) and HDI (42% → 2%), the ESS shows 69% levels → 64% differences. The association persists within countries over time. This is not because development frameworks are poorly designed; it is because they measure aggregate, administrative data at long intervals (annual at best for HDI and SDG). Individual survey responses capture year-to-year variation in how people experience their lives.</a:t>
-            </a:r>
-          </a:p>
-          <a:p>
-            <a:pPr>
-              <a:lnSpc>
-                <a:spcPct val="132000"/>
-              </a:lnSpc>
-              <a:spcBef>
-                <a:spcPts val="0"/>
-              </a:spcBef>
-              <a:spcAft>
-                <a:spcPts val="1100"/>
-              </a:spcAft>
-            </a:pPr>
-            <a:r>
-              <a:rPr sz="1400" b="0" i="0">
-                <a:solidFill>
-                  <a:srgbClr val="5A6068"/>
-                </a:solidFill>
-                <a:latin typeface="Calibri"/>
-              </a:rPr>
-              <a:t>This matters for social trust most of all. At the country level, SDG has almost no trust coverage; in the HDI, none. But at the individual level, within countries, ESS shows trust is significant in 94% of countries and drives year-to-year change in how satisfied people report being. The three domains emerge not because the frameworks reveal them, but because ESS measures them where people actually experience variation: in themselves, over time.</a:t>
-            </a:r>
-          </a:p>
-          <a:p>
-            <a:pPr>
-              <a:lnSpc>
-                <a:spcPct val="132000"/>
-              </a:lnSpc>
-              <a:spcBef>
-                <a:spcPts val="0"/>
-              </a:spcBef>
-              <a:spcAft>
-                <a:spcPts val="1100"/>
-              </a:spcAft>
-            </a:pPr>
-            <a:r>
-              <a:rPr sz="1400" b="0" i="0">
-                <a:solidFill>
-                  <a:srgbClr val="5A6068"/>
-                </a:solidFill>
-                <a:latin typeface="Calibri"/>
-              </a:rPr>
-              <a:t>The caveats are substantial: 36 European countries, self-reported measures, annual cycles. But the implication is clear. Development frameworks' blindness to social trust is not because trust does not matter for wellbeing; it is because development was never designed to measure individual experience at the temporal resolution where people change.</a:t>
+              <a:t>A critical test: which domains actually predict wellbeing regardless of how you measure development? Health is significant in both administrative sources (SDG, 11.5% of country-indicator pairs) and self-reported sources (ESS, median R² = 0.091). This is robust. Education shows weak signal in both (SDG 3.3%, ESS R² = 0.0098), so the issue is not method-dependent but measurement-dependent. Social trust, however, only appears in self-reported data: 94% of ESS countries (median R² = 0.041) versus 1.5% of SDG16 country-pairs measuring institutional confidence instead. The three domains do not behave the same way across measurement methods.</a:t>
             </a:r>
           </a:p>
         </p:txBody>
@@ -5945,128 +6172,40 @@
           </a:p>
         </p:txBody>
       </p:sp>
-    </p:spTree>
-  </p:cSld>
-  <p:clrMapOvr>
-    <a:masterClrMapping/>
-  </p:clrMapOvr>
-</p:sld>
-</file>
-
-<file path=ppt/slides/slide19.xml><?xml version="1.0" encoding="utf-8"?>
-<p:sld xmlns:a="http://schemas.openxmlformats.org/drawingml/2006/main" xmlns:p="http://schemas.openxmlformats.org/presentationml/2006/main" xmlns:r="http://schemas.openxmlformats.org/officeDocument/2006/relationships">
-  <p:cSld>
-    <p:bg>
-      <p:bgPr>
-        <a:solidFill>
-          <a:srgbClr val="E8EBEF"/>
-        </a:solidFill>
-        <a:effectLst/>
-      </p:bgPr>
-    </p:bg>
-    <p:spTree>
-      <p:nvGrpSpPr>
-        <p:cNvPr id="1" name=""/>
-        <p:cNvGrpSpPr/>
-        <p:nvPr/>
-      </p:nvGrpSpPr>
-      <p:grpSpPr/>
-      <p:sp>
-        <p:nvSpPr>
-          <p:cNvPr id="2" name="Rectangle 1"/>
-          <p:cNvSpPr/>
-          <p:nvPr/>
-        </p:nvSpPr>
-        <p:spPr>
-          <a:xfrm>
-            <a:off x="566928" y="2103120"/>
-            <a:ext cx="54864" cy="2377440"/>
-          </a:xfrm>
-          <a:prstGeom prst="rect">
-            <a:avLst/>
-          </a:prstGeom>
-          <a:solidFill>
-            <a:srgbClr val="17549E"/>
-          </a:solidFill>
-          <a:ln>
-            <a:noFill/>
-          </a:ln>
-          <a:effectLst/>
-        </p:spPr>
-        <p:style>
-          <a:lnRef idx="1">
-            <a:schemeClr val="accent1"/>
-          </a:lnRef>
-          <a:fillRef idx="3">
-            <a:schemeClr val="accent1"/>
-          </a:fillRef>
-          <a:effectRef idx="2">
-            <a:schemeClr val="accent1"/>
-          </a:effectRef>
-          <a:fontRef idx="minor">
-            <a:schemeClr val="lt1"/>
-          </a:fontRef>
-        </p:style>
-        <p:txBody>
-          <a:bodyPr rtlCol="0" anchor="ctr"/>
-          <a:lstStyle/>
-          <a:p>
-            <a:pPr algn="ctr"/>
-          </a:p>
-        </p:txBody>
-      </p:sp>
-      <p:sp>
-        <p:nvSpPr>
-          <p:cNvPr id="3" name="TextBox 2"/>
-          <p:cNvSpPr txBox="1"/>
-          <p:nvPr/>
-        </p:nvSpPr>
-        <p:spPr>
-          <a:xfrm>
-            <a:off x="914400" y="1600200"/>
-            <a:ext cx="8686800" cy="274320"/>
-          </a:xfrm>
-          <a:prstGeom prst="rect">
-            <a:avLst/>
-          </a:prstGeom>
-          <a:noFill/>
-        </p:spPr>
-        <p:txBody>
-          <a:bodyPr wrap="square" lIns="0" rIns="0" tIns="0" bIns="0">
-            <a:spAutoFit/>
-          </a:bodyPr>
-          <a:lstStyle/>
-          <a:p>
-            <a:pPr>
-              <a:spcBef>
-                <a:spcPts val="0"/>
-              </a:spcBef>
-              <a:spcAft>
-                <a:spcPts val="0"/>
-              </a:spcAft>
-            </a:pPr>
-            <a:r>
-              <a:rPr sz="1100" b="0" i="0">
-                <a:solidFill>
-                  <a:srgbClr val="17549E"/>
-                </a:solidFill>
-                <a:latin typeface="Consolas"/>
-              </a:rPr>
-              <a:t>WHERE ACT III LEAVES US</a:t>
-            </a:r>
-          </a:p>
-        </p:txBody>
-      </p:sp>
-      <p:sp>
-        <p:nvSpPr>
-          <p:cNvPr id="4" name="TextBox 3"/>
-          <p:cNvSpPr txBox="1"/>
-          <p:nvPr/>
-        </p:nvSpPr>
-        <p:spPr>
-          <a:xfrm>
-            <a:off x="914400" y="2148840"/>
-            <a:ext cx="9509760" cy="2926080"/>
+      <p:pic>
+        <p:nvPicPr>
+          <p:cNvPr id="6" name="Picture 5" descr="health_trust_corroboration.png"/>
+          <p:cNvPicPr>
+            <a:picLocks noChangeAspect="1"/>
+          </p:cNvPicPr>
+          <p:nvPr/>
+        </p:nvPicPr>
+        <p:blipFill>
+          <a:blip r:embed="rId2"/>
+          <a:stretch>
+            <a:fillRect/>
+          </a:stretch>
+        </p:blipFill>
+        <p:spPr>
+          <a:xfrm>
+            <a:off x="5120640" y="1858518"/>
+            <a:ext cx="6537960" cy="2674620"/>
+          </a:xfrm>
+          <a:prstGeom prst="rect">
+            <a:avLst/>
+          </a:prstGeom>
+        </p:spPr>
+      </p:pic>
+      <p:sp>
+        <p:nvSpPr>
+          <p:cNvPr id="7" name="TextBox 6"/>
+          <p:cNvSpPr txBox="1"/>
+          <p:nvPr/>
+        </p:nvSpPr>
+        <p:spPr>
+          <a:xfrm>
+            <a:off x="5120640" y="5897880"/>
+            <a:ext cx="6537960" cy="731520"/>
           </a:xfrm>
           <a:prstGeom prst="rect">
             <a:avLst/>
@@ -6081,7 +6220,7 @@
           <a:p>
             <a:pPr>
               <a:lnSpc>
-                <a:spcPct val="135000"/>
+                <a:spcPct val="125000"/>
               </a:lnSpc>
               <a:spcBef>
                 <a:spcPts val="0"/>
@@ -6091,13 +6230,13 @@
               </a:spcAft>
             </a:pPr>
             <a:r>
-              <a:rPr sz="2100" b="0" i="0">
-                <a:solidFill>
-                  <a:srgbClr val="14171C"/>
-                </a:solidFill>
-                <a:latin typeface="Georgia"/>
-              </a:rPr>
-              <a:t>The three domains predict wellbeing differently depending on where and how you measure. Development frameworks' blindness is not incurable; it is structural. Frameworks designed for tracking aggregate national progress cannot see individual experience responsive to change.</a:t>
+              <a:rPr sz="900" b="0" i="0">
+                <a:solidFill>
+                  <a:srgbClr val="868D96"/>
+                </a:solidFill>
+                <a:latin typeface="Calibri"/>
+              </a:rPr>
+              <a:t>Health is robust across administrative and self-reported sources. Education is weak in both. Social trust appears only in self-reported individual-level data.</a:t>
             </a:r>
           </a:p>
         </p:txBody>
@@ -6960,7 +7099,7 @@
     <p:bg>
       <p:bgPr>
         <a:solidFill>
-          <a:srgbClr val="14171C"/>
+          <a:srgbClr val="FCFCFB"/>
         </a:solidFill>
         <a:effectLst/>
       </p:bgPr>
@@ -6980,8 +7119,184 @@
         </p:nvSpPr>
         <p:spPr>
           <a:xfrm>
-            <a:off x="8229600" y="822960"/>
-            <a:ext cx="3291840" cy="4114800"/>
+            <a:off x="566928" y="502920"/>
+            <a:ext cx="8595360" cy="274320"/>
+          </a:xfrm>
+          <a:prstGeom prst="rect">
+            <a:avLst/>
+          </a:prstGeom>
+          <a:noFill/>
+        </p:spPr>
+        <p:txBody>
+          <a:bodyPr wrap="square" lIns="0" rIns="0" tIns="0" bIns="0">
+            <a:spAutoFit/>
+          </a:bodyPr>
+          <a:lstStyle/>
+          <a:p>
+            <a:pPr>
+              <a:spcBef>
+                <a:spcPts val="0"/>
+              </a:spcBef>
+              <a:spcAft>
+                <a:spcPts val="0"/>
+              </a:spcAft>
+            </a:pPr>
+            <a:r>
+              <a:rPr sz="1000" b="0" i="0">
+                <a:solidFill>
+                  <a:srgbClr val="A63A30"/>
+                </a:solidFill>
+                <a:latin typeface="Consolas"/>
+              </a:rPr>
+              <a:t>WITHIN-COUNTRY EVIDENCE</a:t>
+            </a:r>
+          </a:p>
+        </p:txBody>
+      </p:sp>
+      <p:sp>
+        <p:nvSpPr>
+          <p:cNvPr id="3" name="TextBox 2"/>
+          <p:cNvSpPr txBox="1"/>
+          <p:nvPr/>
+        </p:nvSpPr>
+        <p:spPr>
+          <a:xfrm>
+            <a:off x="566928" y="914400"/>
+            <a:ext cx="8595360" cy="1371600"/>
+          </a:xfrm>
+          <a:prstGeom prst="rect">
+            <a:avLst/>
+          </a:prstGeom>
+          <a:noFill/>
+        </p:spPr>
+        <p:txBody>
+          <a:bodyPr wrap="square" lIns="0" rIns="0" tIns="0" bIns="0">
+            <a:spAutoFit/>
+          </a:bodyPr>
+          <a:lstStyle/>
+          <a:p>
+            <a:pPr>
+              <a:lnSpc>
+                <a:spcPct val="108000"/>
+              </a:lnSpc>
+              <a:spcBef>
+                <a:spcPts val="0"/>
+              </a:spcBef>
+              <a:spcAft>
+                <a:spcPts val="0"/>
+              </a:spcAft>
+            </a:pPr>
+            <a:r>
+              <a:rPr sz="2700" b="0" i="0">
+                <a:solidFill>
+                  <a:srgbClr val="14171C"/>
+                </a:solidFill>
+                <a:latin typeface="Georgia"/>
+              </a:rPr>
+              <a:t>Individual-level, self-reported data captures year-to-year change that administrative frameworks miss</a:t>
+            </a:r>
+          </a:p>
+        </p:txBody>
+      </p:sp>
+      <p:sp>
+        <p:nvSpPr>
+          <p:cNvPr id="4" name="TextBox 3"/>
+          <p:cNvSpPr txBox="1"/>
+          <p:nvPr/>
+        </p:nvSpPr>
+        <p:spPr>
+          <a:xfrm>
+            <a:off x="566928" y="2286000"/>
+            <a:ext cx="8595360" cy="3840480"/>
+          </a:xfrm>
+          <a:prstGeom prst="rect">
+            <a:avLst/>
+          </a:prstGeom>
+          <a:noFill/>
+        </p:spPr>
+        <p:txBody>
+          <a:bodyPr wrap="square" lIns="0" rIns="0" tIns="0" bIns="0">
+            <a:spAutoFit/>
+          </a:bodyPr>
+          <a:lstStyle/>
+          <a:p>
+            <a:pPr>
+              <a:lnSpc>
+                <a:spcPct val="132000"/>
+              </a:lnSpc>
+              <a:spcBef>
+                <a:spcPts val="0"/>
+              </a:spcBef>
+              <a:spcAft>
+                <a:spcPts val="1100"/>
+              </a:spcAft>
+            </a:pPr>
+            <a:r>
+              <a:rPr sz="1400" b="0" i="0">
+                <a:solidFill>
+                  <a:srgbClr val="5A6068"/>
+                </a:solidFill>
+                <a:latin typeface="Calibri"/>
+              </a:rPr>
+              <a:t>Here is the critical observation that reshapes the question: unlike SDG (71% levels → 5% differences) and HDI (42% → 2%), the ESS shows 69% levels → 64% differences. The association persists within countries over time. This is not because development frameworks are poorly designed; it is because they measure aggregate, administrative data at long intervals (annual at best for HDI and SDG). Individual survey responses capture year-to-year variation in how people experience their lives.</a:t>
+            </a:r>
+          </a:p>
+          <a:p>
+            <a:pPr>
+              <a:lnSpc>
+                <a:spcPct val="132000"/>
+              </a:lnSpc>
+              <a:spcBef>
+                <a:spcPts val="0"/>
+              </a:spcBef>
+              <a:spcAft>
+                <a:spcPts val="1100"/>
+              </a:spcAft>
+            </a:pPr>
+            <a:r>
+              <a:rPr sz="1400" b="0" i="0">
+                <a:solidFill>
+                  <a:srgbClr val="5A6068"/>
+                </a:solidFill>
+                <a:latin typeface="Calibri"/>
+              </a:rPr>
+              <a:t>This matters for social trust most of all. At the country level, SDG has almost no trust coverage; in the HDI, none. But at the individual level, within countries, ESS shows trust is significant in 94% of countries and drives year-to-year change in how satisfied people report being. The three domains emerge not because the frameworks reveal them, but because ESS measures them where people actually experience variation: in themselves, over time.</a:t>
+            </a:r>
+          </a:p>
+          <a:p>
+            <a:pPr>
+              <a:lnSpc>
+                <a:spcPct val="132000"/>
+              </a:lnSpc>
+              <a:spcBef>
+                <a:spcPts val="0"/>
+              </a:spcBef>
+              <a:spcAft>
+                <a:spcPts val="1100"/>
+              </a:spcAft>
+            </a:pPr>
+            <a:r>
+              <a:rPr sz="1400" b="0" i="0">
+                <a:solidFill>
+                  <a:srgbClr val="5A6068"/>
+                </a:solidFill>
+                <a:latin typeface="Calibri"/>
+              </a:rPr>
+              <a:t>The caveats are substantial: 36 European countries, self-reported measures, annual cycles. But the implication is clear. Development frameworks' blindness to social trust is not because trust does not matter for wellbeing; it is because development was never designed to measure individual experience at the temporal resolution where people change.</a:t>
+            </a:r>
+          </a:p>
+        </p:txBody>
+      </p:sp>
+      <p:sp>
+        <p:nvSpPr>
+          <p:cNvPr id="5" name="TextBox 4"/>
+          <p:cNvSpPr txBox="1"/>
+          <p:nvPr/>
+        </p:nvSpPr>
+        <p:spPr>
+          <a:xfrm>
+            <a:off x="11338560" y="6263640"/>
+            <a:ext cx="548640" cy="274320"/>
           </a:xfrm>
           <a:prstGeom prst="rect">
             <a:avLst/>
@@ -7003,33 +7318,59 @@
               </a:spcAft>
             </a:pPr>
             <a:r>
-              <a:rPr sz="20000" b="0" i="0">
-                <a:solidFill>
-                  <a:srgbClr val="2A3340"/>
-                </a:solidFill>
-                <a:latin typeface="Georgia"/>
-              </a:rPr>
-              <a:t>IV</a:t>
-            </a:r>
-          </a:p>
-        </p:txBody>
-      </p:sp>
-      <p:sp>
-        <p:nvSpPr>
-          <p:cNvPr id="3" name="Rectangle 2"/>
+              <a:rPr sz="1100" b="0" i="0">
+                <a:solidFill>
+                  <a:srgbClr val="868D96"/>
+                </a:solidFill>
+                <a:latin typeface="Consolas"/>
+              </a:rPr>
+              <a:t>III</a:t>
+            </a:r>
+          </a:p>
+        </p:txBody>
+      </p:sp>
+    </p:spTree>
+  </p:cSld>
+  <p:clrMapOvr>
+    <a:masterClrMapping/>
+  </p:clrMapOvr>
+</p:sld>
+</file>
+
+<file path=ppt/slides/slide21.xml><?xml version="1.0" encoding="utf-8"?>
+<p:sld xmlns:a="http://schemas.openxmlformats.org/drawingml/2006/main" xmlns:p="http://schemas.openxmlformats.org/presentationml/2006/main" xmlns:r="http://schemas.openxmlformats.org/officeDocument/2006/relationships">
+  <p:cSld>
+    <p:bg>
+      <p:bgPr>
+        <a:solidFill>
+          <a:srgbClr val="E8EBEF"/>
+        </a:solidFill>
+        <a:effectLst/>
+      </p:bgPr>
+    </p:bg>
+    <p:spTree>
+      <p:nvGrpSpPr>
+        <p:cNvPr id="1" name=""/>
+        <p:cNvGrpSpPr/>
+        <p:nvPr/>
+      </p:nvGrpSpPr>
+      <p:grpSpPr/>
+      <p:sp>
+        <p:nvSpPr>
+          <p:cNvPr id="2" name="Rectangle 1"/>
           <p:cNvSpPr/>
           <p:nvPr/>
         </p:nvSpPr>
         <p:spPr>
           <a:xfrm>
-            <a:off x="566928" y="1371600"/>
-            <a:ext cx="7315200" cy="25400"/>
+            <a:off x="566928" y="2103120"/>
+            <a:ext cx="54864" cy="2377440"/>
           </a:xfrm>
           <a:prstGeom prst="rect">
             <a:avLst/>
           </a:prstGeom>
           <a:solidFill>
-            <a:srgbClr val="C9D8EC"/>
+            <a:srgbClr val="17549E"/>
           </a:solidFill>
           <a:ln>
             <a:noFill/>
@@ -7060,101 +7401,56 @@
       </p:sp>
       <p:sp>
         <p:nvSpPr>
+          <p:cNvPr id="3" name="TextBox 2"/>
+          <p:cNvSpPr txBox="1"/>
+          <p:nvPr/>
+        </p:nvSpPr>
+        <p:spPr>
+          <a:xfrm>
+            <a:off x="914400" y="1600200"/>
+            <a:ext cx="8686800" cy="274320"/>
+          </a:xfrm>
+          <a:prstGeom prst="rect">
+            <a:avLst/>
+          </a:prstGeom>
+          <a:noFill/>
+        </p:spPr>
+        <p:txBody>
+          <a:bodyPr wrap="square" lIns="0" rIns="0" tIns="0" bIns="0">
+            <a:spAutoFit/>
+          </a:bodyPr>
+          <a:lstStyle/>
+          <a:p>
+            <a:pPr>
+              <a:spcBef>
+                <a:spcPts val="0"/>
+              </a:spcBef>
+              <a:spcAft>
+                <a:spcPts val="0"/>
+              </a:spcAft>
+            </a:pPr>
+            <a:r>
+              <a:rPr sz="1100" b="0" i="0">
+                <a:solidFill>
+                  <a:srgbClr val="17549E"/>
+                </a:solidFill>
+                <a:latin typeface="Consolas"/>
+              </a:rPr>
+              <a:t>WHERE ACT III LEAVES US</a:t>
+            </a:r>
+          </a:p>
+        </p:txBody>
+      </p:sp>
+      <p:sp>
+        <p:nvSpPr>
           <p:cNvPr id="4" name="TextBox 3"/>
           <p:cNvSpPr txBox="1"/>
           <p:nvPr/>
         </p:nvSpPr>
         <p:spPr>
           <a:xfrm>
-            <a:off x="566928" y="960120"/>
-            <a:ext cx="5486400" cy="274320"/>
-          </a:xfrm>
-          <a:prstGeom prst="rect">
-            <a:avLst/>
-          </a:prstGeom>
-          <a:noFill/>
-        </p:spPr>
-        <p:txBody>
-          <a:bodyPr wrap="square" lIns="0" rIns="0" tIns="0" bIns="0">
-            <a:spAutoFit/>
-          </a:bodyPr>
-          <a:lstStyle/>
-          <a:p>
-            <a:pPr>
-              <a:spcBef>
-                <a:spcPts val="0"/>
-              </a:spcBef>
-              <a:spcAft>
-                <a:spcPts val="0"/>
-              </a:spcAft>
-            </a:pPr>
-            <a:r>
-              <a:rPr sz="1100" b="0" i="0">
-                <a:solidFill>
-                  <a:srgbClr val="C9D8EC"/>
-                </a:solidFill>
-                <a:latin typeface="Consolas"/>
-              </a:rPr>
-              <a:t>ACT IV</a:t>
-            </a:r>
-          </a:p>
-        </p:txBody>
-      </p:sp>
-      <p:sp>
-        <p:nvSpPr>
-          <p:cNvPr id="5" name="TextBox 4"/>
-          <p:cNvSpPr txBox="1"/>
-          <p:nvPr/>
-        </p:nvSpPr>
-        <p:spPr>
-          <a:xfrm>
-            <a:off x="566928" y="1783080"/>
-            <a:ext cx="7223760" cy="1828800"/>
-          </a:xfrm>
-          <a:prstGeom prst="rect">
-            <a:avLst/>
-          </a:prstGeom>
-          <a:noFill/>
-        </p:spPr>
-        <p:txBody>
-          <a:bodyPr wrap="square" lIns="0" rIns="0" tIns="0" bIns="0">
-            <a:spAutoFit/>
-          </a:bodyPr>
-          <a:lstStyle/>
-          <a:p>
-            <a:pPr>
-              <a:lnSpc>
-                <a:spcPct val="102000"/>
-              </a:lnSpc>
-              <a:spcBef>
-                <a:spcPts val="0"/>
-              </a:spcBef>
-              <a:spcAft>
-                <a:spcPts val="0"/>
-              </a:spcAft>
-            </a:pPr>
-            <a:r>
-              <a:rPr sz="4000" b="0" i="0">
-                <a:solidFill>
-                  <a:srgbClr val="FCFCFB"/>
-                </a:solidFill>
-                <a:latin typeface="Georgia"/>
-              </a:rPr>
-              <a:t>What this means for development frameworks</a:t>
-            </a:r>
-          </a:p>
-        </p:txBody>
-      </p:sp>
-      <p:sp>
-        <p:nvSpPr>
-          <p:cNvPr id="6" name="TextBox 5"/>
-          <p:cNvSpPr txBox="1"/>
-          <p:nvPr/>
-        </p:nvSpPr>
-        <p:spPr>
-          <a:xfrm>
-            <a:off x="566928" y="3886200"/>
-            <a:ext cx="6766560" cy="1463040"/>
+            <a:off x="914400" y="2148840"/>
+            <a:ext cx="9509760" cy="2926080"/>
           </a:xfrm>
           <a:prstGeom prst="rect">
             <a:avLst/>
@@ -7179,427 +7475,13 @@
               </a:spcAft>
             </a:pPr>
             <a:r>
-              <a:rPr sz="1550" b="0" i="1">
-                <a:solidFill>
-                  <a:srgbClr val="9AA4B0"/>
+              <a:rPr sz="2100" b="0" i="0">
+                <a:solidFill>
+                  <a:srgbClr val="14171C"/>
                 </a:solidFill>
                 <a:latin typeface="Georgia"/>
               </a:rPr>
-              <a:t>The disconnect is real and worth naming. Development frameworks have done their job of tracking progress on development. But the components that predict individual lived experience are ones these frameworks are not currently built to see — because of construction choices, variable saturation, or coverage that was never collected.</a:t>
-            </a:r>
-          </a:p>
-        </p:txBody>
-      </p:sp>
-      <p:sp>
-        <p:nvSpPr>
-          <p:cNvPr id="7" name="TextBox 6"/>
-          <p:cNvSpPr txBox="1"/>
-          <p:nvPr/>
-        </p:nvSpPr>
-        <p:spPr>
-          <a:xfrm>
-            <a:off x="566928" y="5623560"/>
-            <a:ext cx="3503066" cy="914400"/>
-          </a:xfrm>
-          <a:prstGeom prst="rect">
-            <a:avLst/>
-          </a:prstGeom>
-          <a:noFill/>
-        </p:spPr>
-        <p:txBody>
-          <a:bodyPr wrap="square" lIns="0" rIns="0" tIns="0" bIns="0">
-            <a:spAutoFit/>
-          </a:bodyPr>
-          <a:lstStyle/>
-          <a:p>
-            <a:pPr>
-              <a:spcBef>
-                <a:spcPts val="0"/>
-              </a:spcBef>
-              <a:spcAft>
-                <a:spcPts val="400"/>
-              </a:spcAft>
-            </a:pPr>
-            <a:r>
-              <a:rPr sz="2200" b="0" i="0">
-                <a:solidFill>
-                  <a:srgbClr val="FCFCFB"/>
-                </a:solidFill>
-                <a:latin typeface="Consolas"/>
-              </a:rPr>
-              <a:t>3 vs. 1</a:t>
-            </a:r>
-          </a:p>
-          <a:p>
-            <a:pPr>
-              <a:lnSpc>
-                <a:spcPct val="120000"/>
-              </a:lnSpc>
-              <a:spcBef>
-                <a:spcPts val="0"/>
-              </a:spcBef>
-              <a:spcAft>
-                <a:spcPts val="0"/>
-              </a:spcAft>
-            </a:pPr>
-            <a:r>
-              <a:rPr sz="1000" b="0" i="0">
-                <a:solidFill>
-                  <a:srgbClr val="8A94A0"/>
-                </a:solidFill>
-                <a:latin typeface="Calibri"/>
-              </a:rPr>
-              <a:t>domains the HDI can test for wellbeing, vs. social trust</a:t>
-            </a:r>
-          </a:p>
-        </p:txBody>
-      </p:sp>
-      <p:sp>
-        <p:nvSpPr>
-          <p:cNvPr id="8" name="TextBox 7"/>
-          <p:cNvSpPr txBox="1"/>
-          <p:nvPr/>
-        </p:nvSpPr>
-        <p:spPr>
-          <a:xfrm>
-            <a:off x="4344314" y="5623560"/>
-            <a:ext cx="3503066" cy="914400"/>
-          </a:xfrm>
-          <a:prstGeom prst="rect">
-            <a:avLst/>
-          </a:prstGeom>
-          <a:noFill/>
-        </p:spPr>
-        <p:txBody>
-          <a:bodyPr wrap="square" lIns="0" rIns="0" tIns="0" bIns="0">
-            <a:spAutoFit/>
-          </a:bodyPr>
-          <a:lstStyle/>
-          <a:p>
-            <a:pPr>
-              <a:spcBef>
-                <a:spcPts val="0"/>
-              </a:spcBef>
-              <a:spcAft>
-                <a:spcPts val="400"/>
-              </a:spcAft>
-            </a:pPr>
-            <a:r>
-              <a:rPr sz="2200" b="0" i="0">
-                <a:solidFill>
-                  <a:srgbClr val="FCFCFB"/>
-                </a:solidFill>
-                <a:latin typeface="Consolas"/>
-              </a:rPr>
-              <a:t>42 vs. 661</a:t>
-            </a:r>
-          </a:p>
-          <a:p>
-            <a:pPr>
-              <a:lnSpc>
-                <a:spcPct val="120000"/>
-              </a:lnSpc>
-              <a:spcBef>
-                <a:spcPts val="0"/>
-              </a:spcBef>
-              <a:spcAft>
-                <a:spcPts val="0"/>
-              </a:spcAft>
-            </a:pPr>
-            <a:r>
-              <a:rPr sz="1000" b="0" i="0">
-                <a:solidFill>
-                  <a:srgbClr val="8A94A0"/>
-                </a:solidFill>
-                <a:latin typeface="Calibri"/>
-              </a:rPr>
-              <a:t>countries with SDG data, vs. series in the database</a:t>
-            </a:r>
-          </a:p>
-        </p:txBody>
-      </p:sp>
-      <p:sp>
-        <p:nvSpPr>
-          <p:cNvPr id="9" name="TextBox 8"/>
-          <p:cNvSpPr txBox="1"/>
-          <p:nvPr/>
-        </p:nvSpPr>
-        <p:spPr>
-          <a:xfrm>
-            <a:off x="8121700" y="5623560"/>
-            <a:ext cx="3503066" cy="914400"/>
-          </a:xfrm>
-          <a:prstGeom prst="rect">
-            <a:avLst/>
-          </a:prstGeom>
-          <a:noFill/>
-        </p:spPr>
-        <p:txBody>
-          <a:bodyPr wrap="square" lIns="0" rIns="0" tIns="0" bIns="0">
-            <a:spAutoFit/>
-          </a:bodyPr>
-          <a:lstStyle/>
-          <a:p>
-            <a:pPr>
-              <a:spcBef>
-                <a:spcPts val="0"/>
-              </a:spcBef>
-              <a:spcAft>
-                <a:spcPts val="400"/>
-              </a:spcAft>
-            </a:pPr>
-            <a:r>
-              <a:rPr sz="2200" b="0" i="0">
-                <a:solidFill>
-                  <a:srgbClr val="FCFCFB"/>
-                </a:solidFill>
-                <a:latin typeface="Consolas"/>
-              </a:rPr>
-              <a:t>0.041</a:t>
-            </a:r>
-          </a:p>
-          <a:p>
-            <a:pPr>
-              <a:lnSpc>
-                <a:spcPct val="120000"/>
-              </a:lnSpc>
-              <a:spcBef>
-                <a:spcPts val="0"/>
-              </a:spcBef>
-              <a:spcAft>
-                <a:spcPts val="0"/>
-              </a:spcAft>
-            </a:pPr>
-            <a:r>
-              <a:rPr sz="1000" b="0" i="0">
-                <a:solidFill>
-                  <a:srgbClr val="8A94A0"/>
-                </a:solidFill>
-                <a:latin typeface="Calibri"/>
-              </a:rPr>
-              <a:t>median R² for trust — below income, health, education individually, above none</a:t>
-            </a:r>
-          </a:p>
-        </p:txBody>
-      </p:sp>
-    </p:spTree>
-  </p:cSld>
-  <p:clrMapOvr>
-    <a:masterClrMapping/>
-  </p:clrMapOvr>
-</p:sld>
-</file>
-
-<file path=ppt/slides/slide21.xml><?xml version="1.0" encoding="utf-8"?>
-<p:sld xmlns:a="http://schemas.openxmlformats.org/drawingml/2006/main" xmlns:p="http://schemas.openxmlformats.org/presentationml/2006/main" xmlns:r="http://schemas.openxmlformats.org/officeDocument/2006/relationships">
-  <p:cSld>
-    <p:bg>
-      <p:bgPr>
-        <a:solidFill>
-          <a:srgbClr val="FCFCFB"/>
-        </a:solidFill>
-        <a:effectLst/>
-      </p:bgPr>
-    </p:bg>
-    <p:spTree>
-      <p:nvGrpSpPr>
-        <p:cNvPr id="1" name=""/>
-        <p:cNvGrpSpPr/>
-        <p:nvPr/>
-      </p:nvGrpSpPr>
-      <p:grpSpPr/>
-      <p:sp>
-        <p:nvSpPr>
-          <p:cNvPr id="2" name="TextBox 1"/>
-          <p:cNvSpPr txBox="1"/>
-          <p:nvPr/>
-        </p:nvSpPr>
-        <p:spPr>
-          <a:xfrm>
-            <a:off x="566928" y="502920"/>
-            <a:ext cx="8595360" cy="274320"/>
-          </a:xfrm>
-          <a:prstGeom prst="rect">
-            <a:avLst/>
-          </a:prstGeom>
-          <a:noFill/>
-        </p:spPr>
-        <p:txBody>
-          <a:bodyPr wrap="square" lIns="0" rIns="0" tIns="0" bIns="0">
-            <a:spAutoFit/>
-          </a:bodyPr>
-          <a:lstStyle/>
-          <a:p>
-            <a:pPr>
-              <a:spcBef>
-                <a:spcPts val="0"/>
-              </a:spcBef>
-              <a:spcAft>
-                <a:spcPts val="0"/>
-              </a:spcAft>
-            </a:pPr>
-            <a:r>
-              <a:rPr sz="1000" b="0" i="0">
-                <a:solidFill>
-                  <a:srgbClr val="A63A30"/>
-                </a:solidFill>
-                <a:latin typeface="Consolas"/>
-              </a:rPr>
-              <a:t>THE DISCONNECT</a:t>
-            </a:r>
-          </a:p>
-        </p:txBody>
-      </p:sp>
-      <p:sp>
-        <p:nvSpPr>
-          <p:cNvPr id="3" name="TextBox 2"/>
-          <p:cNvSpPr txBox="1"/>
-          <p:nvPr/>
-        </p:nvSpPr>
-        <p:spPr>
-          <a:xfrm>
-            <a:off x="566928" y="914400"/>
-            <a:ext cx="8595360" cy="1371600"/>
-          </a:xfrm>
-          <a:prstGeom prst="rect">
-            <a:avLst/>
-          </a:prstGeom>
-          <a:noFill/>
-        </p:spPr>
-        <p:txBody>
-          <a:bodyPr wrap="square" lIns="0" rIns="0" tIns="0" bIns="0">
-            <a:spAutoFit/>
-          </a:bodyPr>
-          <a:lstStyle/>
-          <a:p>
-            <a:pPr>
-              <a:lnSpc>
-                <a:spcPct val="108000"/>
-              </a:lnSpc>
-              <a:spcBef>
-                <a:spcPts val="0"/>
-              </a:spcBef>
-              <a:spcAft>
-                <a:spcPts val="0"/>
-              </a:spcAft>
-            </a:pPr>
-            <a:r>
-              <a:rPr sz="2700" b="0" i="0">
-                <a:solidFill>
-                  <a:srgbClr val="14171C"/>
-                </a:solidFill>
-                <a:latin typeface="Georgia"/>
-              </a:rPr>
-              <a:t>These frameworks work for development. They do not work for wellbeing.</a:t>
-            </a:r>
-          </a:p>
-        </p:txBody>
-      </p:sp>
-      <p:sp>
-        <p:nvSpPr>
-          <p:cNvPr id="4" name="TextBox 3"/>
-          <p:cNvSpPr txBox="1"/>
-          <p:nvPr/>
-        </p:nvSpPr>
-        <p:spPr>
-          <a:xfrm>
-            <a:off x="566928" y="2286000"/>
-            <a:ext cx="8595360" cy="3840480"/>
-          </a:xfrm>
-          <a:prstGeom prst="rect">
-            <a:avLst/>
-          </a:prstGeom>
-          <a:noFill/>
-        </p:spPr>
-        <p:txBody>
-          <a:bodyPr wrap="square" lIns="0" rIns="0" tIns="0" bIns="0">
-            <a:spAutoFit/>
-          </a:bodyPr>
-          <a:lstStyle/>
-          <a:p>
-            <a:pPr>
-              <a:lnSpc>
-                <a:spcPct val="132000"/>
-              </a:lnSpc>
-              <a:spcBef>
-                <a:spcPts val="0"/>
-              </a:spcBef>
-              <a:spcAft>
-                <a:spcPts val="1100"/>
-              </a:spcAft>
-            </a:pPr>
-            <a:r>
-              <a:rPr sz="1400" b="0" i="0">
-                <a:solidFill>
-                  <a:srgbClr val="5A6068"/>
-                </a:solidFill>
-                <a:latin typeface="Calibri"/>
-              </a:rPr>
-              <a:t>The HDI and SDG frameworks do not answer the question 'what makes people's lives better?' any more than a global income statistics database answers 'what makes a person happy?' They were designed to track development, measured at the aggregate level, with indicators chosen before the question of individual wellbeing was systematically tested. That is not a design failure; it is the intended scope.</a:t>
-            </a:r>
-          </a:p>
-          <a:p>
-            <a:pPr>
-              <a:lnSpc>
-                <a:spcPct val="132000"/>
-              </a:lnSpc>
-              <a:spcBef>
-                <a:spcPts val="0"/>
-              </a:spcBef>
-              <a:spcAft>
-                <a:spcPts val="1100"/>
-              </a:spcAft>
-            </a:pPr>
-            <a:r>
-              <a:rPr sz="1400" b="0" i="0">
-                <a:solidFill>
-                  <a:srgbClr val="5A6068"/>
-                </a:solidFill>
-                <a:latin typeface="Calibri"/>
-              </a:rPr>
-              <a:t>But it means the gap is structural. Education's access indicators work; pooling them with constructs that do not does not fix wellbeing prediction — it just builds a worse measure. Choosing a variable for health that is closer to saturated than the outcome it predicts is a measurement choice, not an incurable problem. And when a domain is never collected, no amount of better construction on the others will reach it.</a:t>
-            </a:r>
-          </a:p>
-        </p:txBody>
-      </p:sp>
-      <p:sp>
-        <p:nvSpPr>
-          <p:cNvPr id="5" name="TextBox 4"/>
-          <p:cNvSpPr txBox="1"/>
-          <p:nvPr/>
-        </p:nvSpPr>
-        <p:spPr>
-          <a:xfrm>
-            <a:off x="11338560" y="6263640"/>
-            <a:ext cx="548640" cy="274320"/>
-          </a:xfrm>
-          <a:prstGeom prst="rect">
-            <a:avLst/>
-          </a:prstGeom>
-          <a:noFill/>
-        </p:spPr>
-        <p:txBody>
-          <a:bodyPr wrap="square" lIns="0" rIns="0" tIns="0" bIns="0">
-            <a:spAutoFit/>
-          </a:bodyPr>
-          <a:lstStyle/>
-          <a:p>
-            <a:pPr algn="r">
-              <a:spcBef>
-                <a:spcPts val="0"/>
-              </a:spcBef>
-              <a:spcAft>
-                <a:spcPts val="0"/>
-              </a:spcAft>
-            </a:pPr>
-            <a:r>
-              <a:rPr sz="1100" b="0" i="0">
-                <a:solidFill>
-                  <a:srgbClr val="868D96"/>
-                </a:solidFill>
-                <a:latin typeface="Consolas"/>
-              </a:rPr>
-              <a:t>IV</a:t>
+              <a:t>The three domains predict wellbeing differently depending on where and how you measure. Development frameworks' blindness is not incurable; it is structural. Frameworks designed for tracking aggregate national progress cannot see individual experience responsive to change.</a:t>
             </a:r>
           </a:p>
         </p:txBody>
@@ -7618,7 +7500,7 @@
     <p:bg>
       <p:bgPr>
         <a:solidFill>
-          <a:srgbClr val="FCFCFB"/>
+          <a:srgbClr val="14171C"/>
         </a:solidFill>
         <a:effectLst/>
       </p:bgPr>
@@ -7638,21 +7520,261 @@
         </p:nvSpPr>
         <p:spPr>
           <a:xfrm>
-            <a:off x="566928" y="502920"/>
-            <a:ext cx="8595360" cy="274320"/>
-          </a:xfrm>
-          <a:prstGeom prst="rect">
-            <a:avLst/>
-          </a:prstGeom>
-          <a:noFill/>
-        </p:spPr>
-        <p:txBody>
-          <a:bodyPr wrap="square" lIns="0" rIns="0" tIns="0" bIns="0">
-            <a:spAutoFit/>
-          </a:bodyPr>
-          <a:lstStyle/>
-          <a:p>
-            <a:pPr>
+            <a:off x="8229600" y="822960"/>
+            <a:ext cx="3291840" cy="4114800"/>
+          </a:xfrm>
+          <a:prstGeom prst="rect">
+            <a:avLst/>
+          </a:prstGeom>
+          <a:noFill/>
+        </p:spPr>
+        <p:txBody>
+          <a:bodyPr wrap="square" lIns="0" rIns="0" tIns="0" bIns="0">
+            <a:spAutoFit/>
+          </a:bodyPr>
+          <a:lstStyle/>
+          <a:p>
+            <a:pPr algn="r">
+              <a:spcBef>
+                <a:spcPts val="0"/>
+              </a:spcBef>
+              <a:spcAft>
+                <a:spcPts val="0"/>
+              </a:spcAft>
+            </a:pPr>
+            <a:r>
+              <a:rPr sz="20000" b="0" i="0">
+                <a:solidFill>
+                  <a:srgbClr val="2A3340"/>
+                </a:solidFill>
+                <a:latin typeface="Georgia"/>
+              </a:rPr>
+              <a:t>IV</a:t>
+            </a:r>
+          </a:p>
+        </p:txBody>
+      </p:sp>
+      <p:sp>
+        <p:nvSpPr>
+          <p:cNvPr id="3" name="Rectangle 2"/>
+          <p:cNvSpPr/>
+          <p:nvPr/>
+        </p:nvSpPr>
+        <p:spPr>
+          <a:xfrm>
+            <a:off x="566928" y="1371600"/>
+            <a:ext cx="7315200" cy="25400"/>
+          </a:xfrm>
+          <a:prstGeom prst="rect">
+            <a:avLst/>
+          </a:prstGeom>
+          <a:solidFill>
+            <a:srgbClr val="C9D8EC"/>
+          </a:solidFill>
+          <a:ln>
+            <a:noFill/>
+          </a:ln>
+          <a:effectLst/>
+        </p:spPr>
+        <p:style>
+          <a:lnRef idx="1">
+            <a:schemeClr val="accent1"/>
+          </a:lnRef>
+          <a:fillRef idx="3">
+            <a:schemeClr val="accent1"/>
+          </a:fillRef>
+          <a:effectRef idx="2">
+            <a:schemeClr val="accent1"/>
+          </a:effectRef>
+          <a:fontRef idx="minor">
+            <a:schemeClr val="lt1"/>
+          </a:fontRef>
+        </p:style>
+        <p:txBody>
+          <a:bodyPr rtlCol="0" anchor="ctr"/>
+          <a:lstStyle/>
+          <a:p>
+            <a:pPr algn="ctr"/>
+          </a:p>
+        </p:txBody>
+      </p:sp>
+      <p:sp>
+        <p:nvSpPr>
+          <p:cNvPr id="4" name="TextBox 3"/>
+          <p:cNvSpPr txBox="1"/>
+          <p:nvPr/>
+        </p:nvSpPr>
+        <p:spPr>
+          <a:xfrm>
+            <a:off x="566928" y="960120"/>
+            <a:ext cx="5486400" cy="274320"/>
+          </a:xfrm>
+          <a:prstGeom prst="rect">
+            <a:avLst/>
+          </a:prstGeom>
+          <a:noFill/>
+        </p:spPr>
+        <p:txBody>
+          <a:bodyPr wrap="square" lIns="0" rIns="0" tIns="0" bIns="0">
+            <a:spAutoFit/>
+          </a:bodyPr>
+          <a:lstStyle/>
+          <a:p>
+            <a:pPr>
+              <a:spcBef>
+                <a:spcPts val="0"/>
+              </a:spcBef>
+              <a:spcAft>
+                <a:spcPts val="0"/>
+              </a:spcAft>
+            </a:pPr>
+            <a:r>
+              <a:rPr sz="1100" b="0" i="0">
+                <a:solidFill>
+                  <a:srgbClr val="C9D8EC"/>
+                </a:solidFill>
+                <a:latin typeface="Consolas"/>
+              </a:rPr>
+              <a:t>ACT IV</a:t>
+            </a:r>
+          </a:p>
+        </p:txBody>
+      </p:sp>
+      <p:sp>
+        <p:nvSpPr>
+          <p:cNvPr id="5" name="TextBox 4"/>
+          <p:cNvSpPr txBox="1"/>
+          <p:nvPr/>
+        </p:nvSpPr>
+        <p:spPr>
+          <a:xfrm>
+            <a:off x="566928" y="1783080"/>
+            <a:ext cx="7223760" cy="1828800"/>
+          </a:xfrm>
+          <a:prstGeom prst="rect">
+            <a:avLst/>
+          </a:prstGeom>
+          <a:noFill/>
+        </p:spPr>
+        <p:txBody>
+          <a:bodyPr wrap="square" lIns="0" rIns="0" tIns="0" bIns="0">
+            <a:spAutoFit/>
+          </a:bodyPr>
+          <a:lstStyle/>
+          <a:p>
+            <a:pPr>
+              <a:lnSpc>
+                <a:spcPct val="102000"/>
+              </a:lnSpc>
+              <a:spcBef>
+                <a:spcPts val="0"/>
+              </a:spcBef>
+              <a:spcAft>
+                <a:spcPts val="0"/>
+              </a:spcAft>
+            </a:pPr>
+            <a:r>
+              <a:rPr sz="4000" b="0" i="0">
+                <a:solidFill>
+                  <a:srgbClr val="FCFCFB"/>
+                </a:solidFill>
+                <a:latin typeface="Georgia"/>
+              </a:rPr>
+              <a:t>What this means for development frameworks</a:t>
+            </a:r>
+          </a:p>
+        </p:txBody>
+      </p:sp>
+      <p:sp>
+        <p:nvSpPr>
+          <p:cNvPr id="6" name="TextBox 5"/>
+          <p:cNvSpPr txBox="1"/>
+          <p:nvPr/>
+        </p:nvSpPr>
+        <p:spPr>
+          <a:xfrm>
+            <a:off x="566928" y="3886200"/>
+            <a:ext cx="6766560" cy="1463040"/>
+          </a:xfrm>
+          <a:prstGeom prst="rect">
+            <a:avLst/>
+          </a:prstGeom>
+          <a:noFill/>
+        </p:spPr>
+        <p:txBody>
+          <a:bodyPr wrap="square" lIns="0" rIns="0" tIns="0" bIns="0">
+            <a:spAutoFit/>
+          </a:bodyPr>
+          <a:lstStyle/>
+          <a:p>
+            <a:pPr>
+              <a:lnSpc>
+                <a:spcPct val="135000"/>
+              </a:lnSpc>
+              <a:spcBef>
+                <a:spcPts val="0"/>
+              </a:spcBef>
+              <a:spcAft>
+                <a:spcPts val="0"/>
+              </a:spcAft>
+            </a:pPr>
+            <a:r>
+              <a:rPr sz="1550" b="0" i="1">
+                <a:solidFill>
+                  <a:srgbClr val="9AA4B0"/>
+                </a:solidFill>
+                <a:latin typeface="Georgia"/>
+              </a:rPr>
+              <a:t>The disconnect is real and worth naming. Development frameworks have done their job of tracking progress on development. But the components that predict individual lived experience are ones these frameworks are not currently built to see — because of construction choices, variable saturation, or coverage that was never collected.</a:t>
+            </a:r>
+          </a:p>
+        </p:txBody>
+      </p:sp>
+      <p:sp>
+        <p:nvSpPr>
+          <p:cNvPr id="7" name="TextBox 6"/>
+          <p:cNvSpPr txBox="1"/>
+          <p:nvPr/>
+        </p:nvSpPr>
+        <p:spPr>
+          <a:xfrm>
+            <a:off x="566928" y="5623560"/>
+            <a:ext cx="3503066" cy="914400"/>
+          </a:xfrm>
+          <a:prstGeom prst="rect">
+            <a:avLst/>
+          </a:prstGeom>
+          <a:noFill/>
+        </p:spPr>
+        <p:txBody>
+          <a:bodyPr wrap="square" lIns="0" rIns="0" tIns="0" bIns="0">
+            <a:spAutoFit/>
+          </a:bodyPr>
+          <a:lstStyle/>
+          <a:p>
+            <a:pPr>
+              <a:spcBef>
+                <a:spcPts val="0"/>
+              </a:spcBef>
+              <a:spcAft>
+                <a:spcPts val="400"/>
+              </a:spcAft>
+            </a:pPr>
+            <a:r>
+              <a:rPr sz="2200" b="0" i="0">
+                <a:solidFill>
+                  <a:srgbClr val="FCFCFB"/>
+                </a:solidFill>
+                <a:latin typeface="Consolas"/>
+              </a:rPr>
+              <a:t>3 vs. 1</a:t>
+            </a:r>
+          </a:p>
+          <a:p>
+            <a:pPr>
+              <a:lnSpc>
+                <a:spcPct val="120000"/>
+              </a:lnSpc>
               <a:spcBef>
                 <a:spcPts val="0"/>
               </a:spcBef>
@@ -7663,40 +7785,59 @@
             <a:r>
               <a:rPr sz="1000" b="0" i="0">
                 <a:solidFill>
-                  <a:srgbClr val="A63A30"/>
+                  <a:srgbClr val="8A94A0"/>
+                </a:solidFill>
+                <a:latin typeface="Calibri"/>
+              </a:rPr>
+              <a:t>domains the HDI can test for wellbeing, vs. social trust</a:t>
+            </a:r>
+          </a:p>
+        </p:txBody>
+      </p:sp>
+      <p:sp>
+        <p:nvSpPr>
+          <p:cNvPr id="8" name="TextBox 7"/>
+          <p:cNvSpPr txBox="1"/>
+          <p:nvPr/>
+        </p:nvSpPr>
+        <p:spPr>
+          <a:xfrm>
+            <a:off x="4344314" y="5623560"/>
+            <a:ext cx="3503066" cy="914400"/>
+          </a:xfrm>
+          <a:prstGeom prst="rect">
+            <a:avLst/>
+          </a:prstGeom>
+          <a:noFill/>
+        </p:spPr>
+        <p:txBody>
+          <a:bodyPr wrap="square" lIns="0" rIns="0" tIns="0" bIns="0">
+            <a:spAutoFit/>
+          </a:bodyPr>
+          <a:lstStyle/>
+          <a:p>
+            <a:pPr>
+              <a:spcBef>
+                <a:spcPts val="0"/>
+              </a:spcBef>
+              <a:spcAft>
+                <a:spcPts val="400"/>
+              </a:spcAft>
+            </a:pPr>
+            <a:r>
+              <a:rPr sz="2200" b="0" i="0">
+                <a:solidFill>
+                  <a:srgbClr val="FCFCFB"/>
                 </a:solidFill>
                 <a:latin typeface="Consolas"/>
               </a:rPr>
-              <a:t>IMPLICATION 1 · MEASUREMENT CHOICES CONSTRAIN WHAT FRAMEWORKS CAN SEE</a:t>
-            </a:r>
-          </a:p>
-        </p:txBody>
-      </p:sp>
-      <p:sp>
-        <p:nvSpPr>
-          <p:cNvPr id="3" name="TextBox 2"/>
-          <p:cNvSpPr txBox="1"/>
-          <p:nvPr/>
-        </p:nvSpPr>
-        <p:spPr>
-          <a:xfrm>
-            <a:off x="566928" y="914400"/>
-            <a:ext cx="8595360" cy="1371600"/>
-          </a:xfrm>
-          <a:prstGeom prst="rect">
-            <a:avLst/>
-          </a:prstGeom>
-          <a:noFill/>
-        </p:spPr>
-        <p:txBody>
-          <a:bodyPr wrap="square" lIns="0" rIns="0" tIns="0" bIns="0">
-            <a:spAutoFit/>
-          </a:bodyPr>
-          <a:lstStyle/>
+              <a:t>42 vs. 661</a:t>
+            </a:r>
+          </a:p>
           <a:p>
             <a:pPr>
               <a:lnSpc>
-                <a:spcPct val="108000"/>
+                <a:spcPct val="120000"/>
               </a:lnSpc>
               <a:spcBef>
                 <a:spcPts val="0"/>
@@ -7706,122 +7847,77 @@
               </a:spcAft>
             </a:pPr>
             <a:r>
-              <a:rPr sz="2700" b="0" i="0">
-                <a:solidFill>
-                  <a:srgbClr val="14171C"/>
-                </a:solidFill>
-                <a:latin typeface="Georgia"/>
-              </a:rPr>
-              <a:t>Education and health: the case for measurement specificity</a:t>
-            </a:r>
-          </a:p>
-        </p:txBody>
-      </p:sp>
-      <p:sp>
-        <p:nvSpPr>
-          <p:cNvPr id="4" name="TextBox 3"/>
-          <p:cNvSpPr txBox="1"/>
-          <p:nvPr/>
-        </p:nvSpPr>
-        <p:spPr>
-          <a:xfrm>
-            <a:off x="566928" y="2286000"/>
-            <a:ext cx="8595360" cy="3840480"/>
-          </a:xfrm>
-          <a:prstGeom prst="rect">
-            <a:avLst/>
-          </a:prstGeom>
-          <a:noFill/>
-        </p:spPr>
-        <p:txBody>
-          <a:bodyPr wrap="square" lIns="0" rIns="0" tIns="0" bIns="0">
-            <a:spAutoFit/>
-          </a:bodyPr>
-          <a:lstStyle/>
+              <a:rPr sz="1000" b="0" i="0">
+                <a:solidFill>
+                  <a:srgbClr val="8A94A0"/>
+                </a:solidFill>
+                <a:latin typeface="Calibri"/>
+              </a:rPr>
+              <a:t>countries with SDG data, vs. series in the database</a:t>
+            </a:r>
+          </a:p>
+        </p:txBody>
+      </p:sp>
+      <p:sp>
+        <p:nvSpPr>
+          <p:cNvPr id="9" name="TextBox 8"/>
+          <p:cNvSpPr txBox="1"/>
+          <p:nvPr/>
+        </p:nvSpPr>
+        <p:spPr>
+          <a:xfrm>
+            <a:off x="8121700" y="5623560"/>
+            <a:ext cx="3503066" cy="914400"/>
+          </a:xfrm>
+          <a:prstGeom prst="rect">
+            <a:avLst/>
+          </a:prstGeom>
+          <a:noFill/>
+        </p:spPr>
+        <p:txBody>
+          <a:bodyPr wrap="square" lIns="0" rIns="0" tIns="0" bIns="0">
+            <a:spAutoFit/>
+          </a:bodyPr>
+          <a:lstStyle/>
+          <a:p>
+            <a:pPr>
+              <a:spcBef>
+                <a:spcPts val="0"/>
+              </a:spcBef>
+              <a:spcAft>
+                <a:spcPts val="400"/>
+              </a:spcAft>
+            </a:pPr>
+            <a:r>
+              <a:rPr sz="2200" b="0" i="0">
+                <a:solidFill>
+                  <a:srgbClr val="FCFCFB"/>
+                </a:solidFill>
+                <a:latin typeface="Consolas"/>
+              </a:rPr>
+              <a:t>0.041</a:t>
+            </a:r>
+          </a:p>
           <a:p>
             <a:pPr>
               <a:lnSpc>
-                <a:spcPct val="132000"/>
+                <a:spcPct val="120000"/>
               </a:lnSpc>
               <a:spcBef>
                 <a:spcPts val="0"/>
               </a:spcBef>
               <a:spcAft>
-                <a:spcPts val="1100"/>
-              </a:spcAft>
-            </a:pPr>
-            <a:r>
-              <a:rPr sz="1400" b="0" i="0">
-                <a:solidFill>
-                  <a:srgbClr val="5A6068"/>
+                <a:spcPts val="0"/>
+              </a:spcAft>
+            </a:pPr>
+            <a:r>
+              <a:rPr sz="1000" b="0" i="0">
+                <a:solidFill>
+                  <a:srgbClr val="8A94A0"/>
                 </a:solidFill>
                 <a:latin typeface="Calibri"/>
               </a:rPr>
-              <a:t>Education is significant everywhere it is measured as attainment, but nearly invisible in SDG4 because most indicators measure something else. Health is nearly invisible in the HDI because life expectancy has saturated. Neither domain has changed; the frameworks' construction choices have.</a:t>
-            </a:r>
-          </a:p>
-          <a:p>
-            <a:pPr>
-              <a:lnSpc>
-                <a:spcPct val="132000"/>
-              </a:lnSpc>
-              <a:spcBef>
-                <a:spcPts val="0"/>
-              </a:spcBef>
-              <a:spcAft>
-                <a:spcPts val="1100"/>
-              </a:spcAft>
-            </a:pPr>
-            <a:r>
-              <a:rPr sz="1400" b="0" i="0">
-                <a:solidFill>
-                  <a:srgbClr val="5A6068"/>
-                </a:solidFill>
-                <a:latin typeface="Calibri"/>
-              </a:rPr>
-              <a:t>For education, this suggests development measurement should weigh access and completion more heavily than parity ratios in wellbeing contexts — not universally, but with explicit construction choices that account for what is known to matter. For health, it suggests that wellbeing-motivated measurement may need different variables at different development levels: life expectancy in lower-income settings, self-reported health or specific conditions in saturated ones.</a:t>
-            </a:r>
-          </a:p>
-        </p:txBody>
-      </p:sp>
-      <p:sp>
-        <p:nvSpPr>
-          <p:cNvPr id="5" name="TextBox 4"/>
-          <p:cNvSpPr txBox="1"/>
-          <p:nvPr/>
-        </p:nvSpPr>
-        <p:spPr>
-          <a:xfrm>
-            <a:off x="11338560" y="6263640"/>
-            <a:ext cx="548640" cy="274320"/>
-          </a:xfrm>
-          <a:prstGeom prst="rect">
-            <a:avLst/>
-          </a:prstGeom>
-          <a:noFill/>
-        </p:spPr>
-        <p:txBody>
-          <a:bodyPr wrap="square" lIns="0" rIns="0" tIns="0" bIns="0">
-            <a:spAutoFit/>
-          </a:bodyPr>
-          <a:lstStyle/>
-          <a:p>
-            <a:pPr algn="r">
-              <a:spcBef>
-                <a:spcPts val="0"/>
-              </a:spcBef>
-              <a:spcAft>
-                <a:spcPts val="0"/>
-              </a:spcAft>
-            </a:pPr>
-            <a:r>
-              <a:rPr sz="1100" b="0" i="0">
-                <a:solidFill>
-                  <a:srgbClr val="868D96"/>
-                </a:solidFill>
-                <a:latin typeface="Consolas"/>
-              </a:rPr>
-              <a:t>IV</a:t>
+              <a:t>median R² for trust — below income, health, education individually, above none</a:t>
             </a:r>
           </a:p>
         </p:txBody>
@@ -7889,7 +7985,7 @@
                 </a:solidFill>
                 <a:latin typeface="Consolas"/>
               </a:rPr>
-              <a:t>IMPLICATION 2 · COVERAGE GAPS ARE MORE FUNDAMENTAL THAN CONSTRUCT CHOICE</a:t>
+              <a:t>THE DISCONNECT</a:t>
             </a:r>
           </a:p>
         </p:txBody>
@@ -7934,7 +8030,7 @@
                 </a:solidFill>
                 <a:latin typeface="Georgia"/>
               </a:rPr>
-              <a:t>Social trust: why you cannot fix a measurement by measuring better</a:t>
+              <a:t>These frameworks work for development. They do not work for wellbeing.</a:t>
             </a:r>
           </a:p>
         </p:txBody>
@@ -7979,7 +8075,7 @@
                 </a:solidFill>
                 <a:latin typeface="Calibri"/>
               </a:rPr>
-              <a:t>Social trust is the most tentative finding here. The ESS is Europe-only, across 36 countries, and relies on a single item. That bounds the claim: the pattern holds in Europe, with a wellbeing survey, on a self-report basis. It does not claim universality.</a:t>
+              <a:t>The HDI and SDG frameworks do not answer the question 'what makes people's lives better?' any more than a global income statistics database answers 'what makes a person happy?' They were designed to track development, measured at the aggregate level, with indicators chosen before the question of individual wellbeing was systematically tested. That is not a design failure; it is the intended scope.</a:t>
             </a:r>
           </a:p>
           <a:p>
@@ -8001,29 +8097,7 @@
                 </a:solidFill>
                 <a:latin typeface="Calibri"/>
               </a:rPr>
-              <a:t>But the reason it is tentative points to the deepest problem: trust is not collected at global scale in either framework. The SDG database has 13 series adjacent to trust, but they measure institutional confidence, not interpersonal trust, and they are intermittent (147 of 163 country-series have fewer than four years of data). This is not a construct-choice problem that better measurement can solve. It is a coverage gap that requires deciding to collect the data in the first place.</a:t>
-            </a:r>
-          </a:p>
-          <a:p>
-            <a:pPr>
-              <a:lnSpc>
-                <a:spcPct val="132000"/>
-              </a:lnSpc>
-              <a:spcBef>
-                <a:spcPts val="0"/>
-              </a:spcBef>
-              <a:spcAft>
-                <a:spcPts val="1100"/>
-              </a:spcAft>
-            </a:pPr>
-            <a:r>
-              <a:rPr sz="1400" b="0" i="0">
-                <a:solidFill>
-                  <a:srgbClr val="5A6068"/>
-                </a:solidFill>
-                <a:latin typeface="Calibri"/>
-              </a:rPr>
-              <a:t>For wellbeing-conscious development monitoring, this suggests either building interpersonal-trust measurement into the core frameworks, or acknowledging that other surveys (the ESS, Gallup World Poll, World Values Survey) may be more suitable for understanding what shapes lived experience.</a:t>
+              <a:t>But it means the gap is structural. Education's access indicators work; pooling them with constructs that do not does not fix wellbeing prediction — it just builds a worse measure. Choosing a variable for health that is closer to saturated than the outcome it predicts is a measurement choice, not an incurable problem. And when a domain is never collected, no amount of better construction on the others will reach it.</a:t>
             </a:r>
           </a:p>
         </p:txBody>
@@ -8133,7 +8207,7 @@
                 </a:solidFill>
                 <a:latin typeface="Consolas"/>
               </a:rPr>
-              <a:t>CONCLUSION</a:t>
+              <a:t>IMPLICATION 1 · MEASUREMENT CHOICES CONSTRAIN WHAT FRAMEWORKS CAN SEE</a:t>
             </a:r>
           </a:p>
         </p:txBody>
@@ -8178,7 +8252,7 @@
                 </a:solidFill>
                 <a:latin typeface="Georgia"/>
               </a:rPr>
-              <a:t>A question rather than a prescription</a:t>
+              <a:t>Education and health: the case for measurement specificity</a:t>
             </a:r>
           </a:p>
         </p:txBody>
@@ -8223,7 +8297,7 @@
                 </a:solidFill>
                 <a:latin typeface="Calibri"/>
               </a:rPr>
-              <a:t>The evidence shows a consistent pattern: which domain looks most consequential for wellbeing depends on which framework measures it and what variable they chose. This is not about the domains; it is about the tools.</a:t>
+              <a:t>Education is significant everywhere it is measured as attainment, but nearly invisible in SDG4 because most indicators measure something else. Health is nearly invisible in the HDI because life expectancy has saturated. Neither domain has changed; the frameworks' construction choices have.</a:t>
             </a:r>
           </a:p>
           <a:p>
@@ -8245,29 +8319,7 @@
                 </a:solidFill>
                 <a:latin typeface="Calibri"/>
               </a:rPr>
-              <a:t>Whether development frameworks should be redesigned around wellbeing is outside the scope here. But if they were, this finding suggests the question to ask: should measurement choices be made with explicit reference to which variables still move and still matter for lived experience? Should coverage be built in for domains the frameworks discovered only by studying something else?</a:t>
-            </a:r>
-          </a:p>
-          <a:p>
-            <a:pPr>
-              <a:lnSpc>
-                <a:spcPct val="132000"/>
-              </a:lnSpc>
-              <a:spcBef>
-                <a:spcPts val="0"/>
-              </a:spcBef>
-              <a:spcAft>
-                <a:spcPts val="1100"/>
-              </a:spcAft>
-            </a:pPr>
-            <a:r>
-              <a:rPr sz="1400" b="0" i="0">
-                <a:solidFill>
-                  <a:srgbClr val="5A6068"/>
-                </a:solidFill>
-                <a:latin typeface="Calibri"/>
-              </a:rPr>
-              <a:t>The frameworks work well for their stated purpose. The question is whether wellbeing should become part of that purpose — and if it does, whether the measurement that comes from that intent should be different from the aggregate, development-first measurement in place today.</a:t>
+              <a:t>For education, this suggests development measurement should weigh access and completion more heavily than parity ratios in wellbeing contexts — not universally, but with explicit construction choices that account for what is known to matter. For health, it suggests that wellbeing-motivated measurement may need different variables at different development levels: life expectancy in lower-income settings, self-reported health or specific conditions in saturated ones.</a:t>
             </a:r>
           </a:p>
         </p:txBody>
@@ -8328,7 +8380,7 @@
     <p:bg>
       <p:bgPr>
         <a:solidFill>
-          <a:srgbClr val="E8EBEF"/>
+          <a:srgbClr val="FCFCFB"/>
         </a:solidFill>
         <a:effectLst/>
       </p:bgPr>
@@ -8342,45 +8394,43 @@
       <p:grpSpPr/>
       <p:sp>
         <p:nvSpPr>
-          <p:cNvPr id="2" name="Rectangle 1"/>
-          <p:cNvSpPr/>
-          <p:nvPr/>
-        </p:nvSpPr>
-        <p:spPr>
-          <a:xfrm>
-            <a:off x="566928" y="2103120"/>
-            <a:ext cx="54864" cy="2377440"/>
-          </a:xfrm>
-          <a:prstGeom prst="rect">
-            <a:avLst/>
-          </a:prstGeom>
-          <a:solidFill>
-            <a:srgbClr val="17549E"/>
-          </a:solidFill>
-          <a:ln>
-            <a:noFill/>
-          </a:ln>
-          <a:effectLst/>
-        </p:spPr>
-        <p:style>
-          <a:lnRef idx="1">
-            <a:schemeClr val="accent1"/>
-          </a:lnRef>
-          <a:fillRef idx="3">
-            <a:schemeClr val="accent1"/>
-          </a:fillRef>
-          <a:effectRef idx="2">
-            <a:schemeClr val="accent1"/>
-          </a:effectRef>
-          <a:fontRef idx="minor">
-            <a:schemeClr val="lt1"/>
-          </a:fontRef>
-        </p:style>
-        <p:txBody>
-          <a:bodyPr rtlCol="0" anchor="ctr"/>
-          <a:lstStyle/>
-          <a:p>
-            <a:pPr algn="ctr"/>
+          <p:cNvPr id="2" name="TextBox 1"/>
+          <p:cNvSpPr txBox="1"/>
+          <p:nvPr/>
+        </p:nvSpPr>
+        <p:spPr>
+          <a:xfrm>
+            <a:off x="566928" y="502920"/>
+            <a:ext cx="8595360" cy="274320"/>
+          </a:xfrm>
+          <a:prstGeom prst="rect">
+            <a:avLst/>
+          </a:prstGeom>
+          <a:noFill/>
+        </p:spPr>
+        <p:txBody>
+          <a:bodyPr wrap="square" lIns="0" rIns="0" tIns="0" bIns="0">
+            <a:spAutoFit/>
+          </a:bodyPr>
+          <a:lstStyle/>
+          <a:p>
+            <a:pPr>
+              <a:spcBef>
+                <a:spcPts val="0"/>
+              </a:spcBef>
+              <a:spcAft>
+                <a:spcPts val="0"/>
+              </a:spcAft>
+            </a:pPr>
+            <a:r>
+              <a:rPr sz="1000" b="0" i="0">
+                <a:solidFill>
+                  <a:srgbClr val="A63A30"/>
+                </a:solidFill>
+                <a:latin typeface="Consolas"/>
+              </a:rPr>
+              <a:t>IMPLICATION 2 · COVERAGE GAPS ARE MORE FUNDAMENTAL THAN CONSTRUCT CHOICE</a:t>
+            </a:r>
           </a:p>
         </p:txBody>
       </p:sp>
@@ -8392,21 +8442,155 @@
         </p:nvSpPr>
         <p:spPr>
           <a:xfrm>
-            <a:off x="914400" y="1600200"/>
-            <a:ext cx="8686800" cy="274320"/>
-          </a:xfrm>
-          <a:prstGeom prst="rect">
-            <a:avLst/>
-          </a:prstGeom>
-          <a:noFill/>
-        </p:spPr>
-        <p:txBody>
-          <a:bodyPr wrap="square" lIns="0" rIns="0" tIns="0" bIns="0">
-            <a:spAutoFit/>
-          </a:bodyPr>
-          <a:lstStyle/>
-          <a:p>
-            <a:pPr>
+            <a:off x="566928" y="914400"/>
+            <a:ext cx="8595360" cy="1371600"/>
+          </a:xfrm>
+          <a:prstGeom prst="rect">
+            <a:avLst/>
+          </a:prstGeom>
+          <a:noFill/>
+        </p:spPr>
+        <p:txBody>
+          <a:bodyPr wrap="square" lIns="0" rIns="0" tIns="0" bIns="0">
+            <a:spAutoFit/>
+          </a:bodyPr>
+          <a:lstStyle/>
+          <a:p>
+            <a:pPr>
+              <a:lnSpc>
+                <a:spcPct val="108000"/>
+              </a:lnSpc>
+              <a:spcBef>
+                <a:spcPts val="0"/>
+              </a:spcBef>
+              <a:spcAft>
+                <a:spcPts val="0"/>
+              </a:spcAft>
+            </a:pPr>
+            <a:r>
+              <a:rPr sz="2700" b="0" i="0">
+                <a:solidFill>
+                  <a:srgbClr val="14171C"/>
+                </a:solidFill>
+                <a:latin typeface="Georgia"/>
+              </a:rPr>
+              <a:t>Social trust: why you cannot fix a measurement by measuring better</a:t>
+            </a:r>
+          </a:p>
+        </p:txBody>
+      </p:sp>
+      <p:sp>
+        <p:nvSpPr>
+          <p:cNvPr id="4" name="TextBox 3"/>
+          <p:cNvSpPr txBox="1"/>
+          <p:nvPr/>
+        </p:nvSpPr>
+        <p:spPr>
+          <a:xfrm>
+            <a:off x="566928" y="2286000"/>
+            <a:ext cx="8595360" cy="3840480"/>
+          </a:xfrm>
+          <a:prstGeom prst="rect">
+            <a:avLst/>
+          </a:prstGeom>
+          <a:noFill/>
+        </p:spPr>
+        <p:txBody>
+          <a:bodyPr wrap="square" lIns="0" rIns="0" tIns="0" bIns="0">
+            <a:spAutoFit/>
+          </a:bodyPr>
+          <a:lstStyle/>
+          <a:p>
+            <a:pPr>
+              <a:lnSpc>
+                <a:spcPct val="132000"/>
+              </a:lnSpc>
+              <a:spcBef>
+                <a:spcPts val="0"/>
+              </a:spcBef>
+              <a:spcAft>
+                <a:spcPts val="1100"/>
+              </a:spcAft>
+            </a:pPr>
+            <a:r>
+              <a:rPr sz="1400" b="0" i="0">
+                <a:solidFill>
+                  <a:srgbClr val="5A6068"/>
+                </a:solidFill>
+                <a:latin typeface="Calibri"/>
+              </a:rPr>
+              <a:t>Social trust is the most tentative finding here. The ESS is Europe-only, across 36 countries, and relies on a single item. That bounds the claim: the pattern holds in Europe, with a wellbeing survey, on a self-report basis. It does not claim universality.</a:t>
+            </a:r>
+          </a:p>
+          <a:p>
+            <a:pPr>
+              <a:lnSpc>
+                <a:spcPct val="132000"/>
+              </a:lnSpc>
+              <a:spcBef>
+                <a:spcPts val="0"/>
+              </a:spcBef>
+              <a:spcAft>
+                <a:spcPts val="1100"/>
+              </a:spcAft>
+            </a:pPr>
+            <a:r>
+              <a:rPr sz="1400" b="0" i="0">
+                <a:solidFill>
+                  <a:srgbClr val="5A6068"/>
+                </a:solidFill>
+                <a:latin typeface="Calibri"/>
+              </a:rPr>
+              <a:t>But the reason it is tentative points to the deepest problem: trust is not collected at global scale in either framework. The SDG database has 13 series adjacent to trust, but they measure institutional confidence, not interpersonal trust, and they are intermittent (147 of 163 country-series have fewer than four years of data). This is not a construct-choice problem that better measurement can solve. It is a coverage gap that requires deciding to collect the data in the first place.</a:t>
+            </a:r>
+          </a:p>
+          <a:p>
+            <a:pPr>
+              <a:lnSpc>
+                <a:spcPct val="132000"/>
+              </a:lnSpc>
+              <a:spcBef>
+                <a:spcPts val="0"/>
+              </a:spcBef>
+              <a:spcAft>
+                <a:spcPts val="1100"/>
+              </a:spcAft>
+            </a:pPr>
+            <a:r>
+              <a:rPr sz="1400" b="0" i="0">
+                <a:solidFill>
+                  <a:srgbClr val="5A6068"/>
+                </a:solidFill>
+                <a:latin typeface="Calibri"/>
+              </a:rPr>
+              <a:t>For wellbeing-conscious development monitoring, this suggests either building interpersonal-trust measurement into the core frameworks, or acknowledging that other surveys (the ESS, Gallup World Poll, World Values Survey) may be more suitable for understanding what shapes lived experience.</a:t>
+            </a:r>
+          </a:p>
+        </p:txBody>
+      </p:sp>
+      <p:sp>
+        <p:nvSpPr>
+          <p:cNvPr id="5" name="TextBox 4"/>
+          <p:cNvSpPr txBox="1"/>
+          <p:nvPr/>
+        </p:nvSpPr>
+        <p:spPr>
+          <a:xfrm>
+            <a:off x="11338560" y="6263640"/>
+            <a:ext cx="548640" cy="274320"/>
+          </a:xfrm>
+          <a:prstGeom prst="rect">
+            <a:avLst/>
+          </a:prstGeom>
+          <a:noFill/>
+        </p:spPr>
+        <p:txBody>
+          <a:bodyPr wrap="square" lIns="0" rIns="0" tIns="0" bIns="0">
+            <a:spAutoFit/>
+          </a:bodyPr>
+          <a:lstStyle/>
+          <a:p>
+            <a:pPr algn="r">
               <a:spcBef>
                 <a:spcPts val="0"/>
               </a:spcBef>
@@ -8417,56 +8601,11 @@
             <a:r>
               <a:rPr sz="1100" b="0" i="0">
                 <a:solidFill>
-                  <a:srgbClr val="17549E"/>
+                  <a:srgbClr val="868D96"/>
                 </a:solidFill>
                 <a:latin typeface="Consolas"/>
               </a:rPr>
-              <a:t>WHERE ACT IV LEAVES US</a:t>
-            </a:r>
-          </a:p>
-        </p:txBody>
-      </p:sp>
-      <p:sp>
-        <p:nvSpPr>
-          <p:cNvPr id="4" name="TextBox 3"/>
-          <p:cNvSpPr txBox="1"/>
-          <p:nvPr/>
-        </p:nvSpPr>
-        <p:spPr>
-          <a:xfrm>
-            <a:off x="914400" y="2148840"/>
-            <a:ext cx="9509760" cy="2926080"/>
-          </a:xfrm>
-          <a:prstGeom prst="rect">
-            <a:avLst/>
-          </a:prstGeom>
-          <a:noFill/>
-        </p:spPr>
-        <p:txBody>
-          <a:bodyPr wrap="square" lIns="0" rIns="0" tIns="0" bIns="0">
-            <a:spAutoFit/>
-          </a:bodyPr>
-          <a:lstStyle/>
-          <a:p>
-            <a:pPr>
-              <a:lnSpc>
-                <a:spcPct val="135000"/>
-              </a:lnSpc>
-              <a:spcBef>
-                <a:spcPts val="0"/>
-              </a:spcBef>
-              <a:spcAft>
-                <a:spcPts val="0"/>
-              </a:spcAft>
-            </a:pPr>
-            <a:r>
-              <a:rPr sz="2100" b="0" i="0">
-                <a:solidFill>
-                  <a:srgbClr val="14171C"/>
-                </a:solidFill>
-                <a:latin typeface="Georgia"/>
-              </a:rPr>
-              <a:t>Whether development measurement should be redesigned with wellbeing in mind is beyond this scope. But if it is, this evidence suggests the measurement should be different: more attentive to which variables still move, which constructs predict outcomes, and which domains are collected at all.</a:t>
+              <a:t>IV</a:t>
             </a:r>
           </a:p>
         </p:txBody>
@@ -8506,68 +8645,251 @@
         <p:spPr>
           <a:xfrm>
             <a:off x="566928" y="502920"/>
-            <a:ext cx="8229600" cy="822960"/>
-          </a:xfrm>
-          <a:prstGeom prst="rect">
-            <a:avLst/>
-          </a:prstGeom>
-          <a:noFill/>
-        </p:spPr>
-        <p:txBody>
-          <a:bodyPr wrap="square" lIns="0" rIns="0" tIns="0" bIns="0">
-            <a:spAutoFit/>
-          </a:bodyPr>
-          <a:lstStyle/>
-          <a:p>
-            <a:pPr>
-              <a:spcBef>
-                <a:spcPts val="0"/>
-              </a:spcBef>
-              <a:spcAft>
-                <a:spcPts val="600"/>
-              </a:spcAft>
-            </a:pPr>
-            <a:r>
-              <a:rPr sz="3200" b="0" i="0">
+            <a:ext cx="8595360" cy="274320"/>
+          </a:xfrm>
+          <a:prstGeom prst="rect">
+            <a:avLst/>
+          </a:prstGeom>
+          <a:noFill/>
+        </p:spPr>
+        <p:txBody>
+          <a:bodyPr wrap="square" lIns="0" rIns="0" tIns="0" bIns="0">
+            <a:spAutoFit/>
+          </a:bodyPr>
+          <a:lstStyle/>
+          <a:p>
+            <a:pPr>
+              <a:spcBef>
+                <a:spcPts val="0"/>
+              </a:spcBef>
+              <a:spcAft>
+                <a:spcPts val="0"/>
+              </a:spcAft>
+            </a:pPr>
+            <a:r>
+              <a:rPr sz="1000" b="0" i="0">
+                <a:solidFill>
+                  <a:srgbClr val="A63A30"/>
+                </a:solidFill>
+                <a:latin typeface="Consolas"/>
+              </a:rPr>
+              <a:t>CONCLUSION</a:t>
+            </a:r>
+          </a:p>
+        </p:txBody>
+      </p:sp>
+      <p:sp>
+        <p:nvSpPr>
+          <p:cNvPr id="3" name="TextBox 2"/>
+          <p:cNvSpPr txBox="1"/>
+          <p:nvPr/>
+        </p:nvSpPr>
+        <p:spPr>
+          <a:xfrm>
+            <a:off x="566928" y="914400"/>
+            <a:ext cx="8595360" cy="1371600"/>
+          </a:xfrm>
+          <a:prstGeom prst="rect">
+            <a:avLst/>
+          </a:prstGeom>
+          <a:noFill/>
+        </p:spPr>
+        <p:txBody>
+          <a:bodyPr wrap="square" lIns="0" rIns="0" tIns="0" bIns="0">
+            <a:spAutoFit/>
+          </a:bodyPr>
+          <a:lstStyle/>
+          <a:p>
+            <a:pPr>
+              <a:lnSpc>
+                <a:spcPct val="108000"/>
+              </a:lnSpc>
+              <a:spcBef>
+                <a:spcPts val="0"/>
+              </a:spcBef>
+              <a:spcAft>
+                <a:spcPts val="0"/>
+              </a:spcAft>
+            </a:pPr>
+            <a:r>
+              <a:rPr sz="2700" b="0" i="0">
                 <a:solidFill>
                   <a:srgbClr val="14171C"/>
                 </a:solidFill>
                 <a:latin typeface="Georgia"/>
               </a:rPr>
-              <a:t>Decisions for the team</a:t>
-            </a:r>
-          </a:p>
-          <a:p>
-            <a:pPr>
-              <a:spcBef>
-                <a:spcPts val="0"/>
-              </a:spcBef>
-              <a:spcAft>
-                <a:spcPts val="0"/>
-              </a:spcAft>
-            </a:pPr>
-            <a:r>
-              <a:rPr sz="1300" b="0" i="0">
+              <a:t>A question rather than a prescription</a:t>
+            </a:r>
+          </a:p>
+        </p:txBody>
+      </p:sp>
+      <p:sp>
+        <p:nvSpPr>
+          <p:cNvPr id="4" name="TextBox 3"/>
+          <p:cNvSpPr txBox="1"/>
+          <p:nvPr/>
+        </p:nvSpPr>
+        <p:spPr>
+          <a:xfrm>
+            <a:off x="566928" y="2286000"/>
+            <a:ext cx="8595360" cy="3840480"/>
+          </a:xfrm>
+          <a:prstGeom prst="rect">
+            <a:avLst/>
+          </a:prstGeom>
+          <a:noFill/>
+        </p:spPr>
+        <p:txBody>
+          <a:bodyPr wrap="square" lIns="0" rIns="0" tIns="0" bIns="0">
+            <a:spAutoFit/>
+          </a:bodyPr>
+          <a:lstStyle/>
+          <a:p>
+            <a:pPr>
+              <a:lnSpc>
+                <a:spcPct val="132000"/>
+              </a:lnSpc>
+              <a:spcBef>
+                <a:spcPts val="0"/>
+              </a:spcBef>
+              <a:spcAft>
+                <a:spcPts val="1100"/>
+              </a:spcAft>
+            </a:pPr>
+            <a:r>
+              <a:rPr sz="1400" b="0" i="0">
                 <a:solidFill>
                   <a:srgbClr val="5A6068"/>
                 </a:solidFill>
                 <a:latin typeface="Calibri"/>
               </a:rPr>
-              <a:t>4 things the acts do not settle, in the order they block drafting.</a:t>
-            </a:r>
-          </a:p>
-        </p:txBody>
-      </p:sp>
-      <p:sp>
-        <p:nvSpPr>
-          <p:cNvPr id="3" name="Rectangle 2"/>
+              <a:t>The evidence shows a consistent pattern: which domain looks most consequential for wellbeing depends on which framework measures it and what variable they chose. This is not about the domains; it is about the tools.</a:t>
+            </a:r>
+          </a:p>
+          <a:p>
+            <a:pPr>
+              <a:lnSpc>
+                <a:spcPct val="132000"/>
+              </a:lnSpc>
+              <a:spcBef>
+                <a:spcPts val="0"/>
+              </a:spcBef>
+              <a:spcAft>
+                <a:spcPts val="1100"/>
+              </a:spcAft>
+            </a:pPr>
+            <a:r>
+              <a:rPr sz="1400" b="0" i="0">
+                <a:solidFill>
+                  <a:srgbClr val="5A6068"/>
+                </a:solidFill>
+                <a:latin typeface="Calibri"/>
+              </a:rPr>
+              <a:t>Whether development frameworks should be redesigned around wellbeing is outside the scope here. But if they were, this finding suggests the question to ask: should measurement choices be made with explicit reference to which variables still move and still matter for lived experience? Should coverage be built in for domains the frameworks discovered only by studying something else?</a:t>
+            </a:r>
+          </a:p>
+          <a:p>
+            <a:pPr>
+              <a:lnSpc>
+                <a:spcPct val="132000"/>
+              </a:lnSpc>
+              <a:spcBef>
+                <a:spcPts val="0"/>
+              </a:spcBef>
+              <a:spcAft>
+                <a:spcPts val="1100"/>
+              </a:spcAft>
+            </a:pPr>
+            <a:r>
+              <a:rPr sz="1400" b="0" i="0">
+                <a:solidFill>
+                  <a:srgbClr val="5A6068"/>
+                </a:solidFill>
+                <a:latin typeface="Calibri"/>
+              </a:rPr>
+              <a:t>The frameworks work well for their stated purpose. The question is whether wellbeing should become part of that purpose — and if it does, whether the measurement that comes from that intent should be different from the aggregate, development-first measurement in place today.</a:t>
+            </a:r>
+          </a:p>
+        </p:txBody>
+      </p:sp>
+      <p:sp>
+        <p:nvSpPr>
+          <p:cNvPr id="5" name="TextBox 4"/>
+          <p:cNvSpPr txBox="1"/>
+          <p:nvPr/>
+        </p:nvSpPr>
+        <p:spPr>
+          <a:xfrm>
+            <a:off x="11338560" y="6263640"/>
+            <a:ext cx="548640" cy="274320"/>
+          </a:xfrm>
+          <a:prstGeom prst="rect">
+            <a:avLst/>
+          </a:prstGeom>
+          <a:noFill/>
+        </p:spPr>
+        <p:txBody>
+          <a:bodyPr wrap="square" lIns="0" rIns="0" tIns="0" bIns="0">
+            <a:spAutoFit/>
+          </a:bodyPr>
+          <a:lstStyle/>
+          <a:p>
+            <a:pPr algn="r">
+              <a:spcBef>
+                <a:spcPts val="0"/>
+              </a:spcBef>
+              <a:spcAft>
+                <a:spcPts val="0"/>
+              </a:spcAft>
+            </a:pPr>
+            <a:r>
+              <a:rPr sz="1100" b="0" i="0">
+                <a:solidFill>
+                  <a:srgbClr val="868D96"/>
+                </a:solidFill>
+                <a:latin typeface="Consolas"/>
+              </a:rPr>
+              <a:t>IV</a:t>
+            </a:r>
+          </a:p>
+        </p:txBody>
+      </p:sp>
+    </p:spTree>
+  </p:cSld>
+  <p:clrMapOvr>
+    <a:masterClrMapping/>
+  </p:clrMapOvr>
+</p:sld>
+</file>
+
+<file path=ppt/slides/slide27.xml><?xml version="1.0" encoding="utf-8"?>
+<p:sld xmlns:a="http://schemas.openxmlformats.org/drawingml/2006/main" xmlns:p="http://schemas.openxmlformats.org/presentationml/2006/main" xmlns:r="http://schemas.openxmlformats.org/officeDocument/2006/relationships">
+  <p:cSld>
+    <p:bg>
+      <p:bgPr>
+        <a:solidFill>
+          <a:srgbClr val="E8EBEF"/>
+        </a:solidFill>
+        <a:effectLst/>
+      </p:bgPr>
+    </p:bg>
+    <p:spTree>
+      <p:nvGrpSpPr>
+        <p:cNvPr id="1" name=""/>
+        <p:cNvGrpSpPr/>
+        <p:nvPr/>
+      </p:nvGrpSpPr>
+      <p:grpSpPr/>
+      <p:sp>
+        <p:nvSpPr>
+          <p:cNvPr id="2" name="Rectangle 1"/>
           <p:cNvSpPr/>
           <p:nvPr/>
         </p:nvSpPr>
         <p:spPr>
           <a:xfrm>
-            <a:off x="566928" y="1828800"/>
-            <a:ext cx="3472586" cy="25400"/>
+            <a:off x="566928" y="2103120"/>
+            <a:ext cx="54864" cy="2377440"/>
           </a:xfrm>
           <a:prstGeom prst="rect">
             <a:avLst/>
@@ -8604,48 +8926,71 @@
       </p:sp>
       <p:sp>
         <p:nvSpPr>
+          <p:cNvPr id="3" name="TextBox 2"/>
+          <p:cNvSpPr txBox="1"/>
+          <p:nvPr/>
+        </p:nvSpPr>
+        <p:spPr>
+          <a:xfrm>
+            <a:off x="914400" y="1600200"/>
+            <a:ext cx="8686800" cy="274320"/>
+          </a:xfrm>
+          <a:prstGeom prst="rect">
+            <a:avLst/>
+          </a:prstGeom>
+          <a:noFill/>
+        </p:spPr>
+        <p:txBody>
+          <a:bodyPr wrap="square" lIns="0" rIns="0" tIns="0" bIns="0">
+            <a:spAutoFit/>
+          </a:bodyPr>
+          <a:lstStyle/>
+          <a:p>
+            <a:pPr>
+              <a:spcBef>
+                <a:spcPts val="0"/>
+              </a:spcBef>
+              <a:spcAft>
+                <a:spcPts val="0"/>
+              </a:spcAft>
+            </a:pPr>
+            <a:r>
+              <a:rPr sz="1100" b="0" i="0">
+                <a:solidFill>
+                  <a:srgbClr val="17549E"/>
+                </a:solidFill>
+                <a:latin typeface="Consolas"/>
+              </a:rPr>
+              <a:t>WHERE ACT IV LEAVES US</a:t>
+            </a:r>
+          </a:p>
+        </p:txBody>
+      </p:sp>
+      <p:sp>
+        <p:nvSpPr>
           <p:cNvPr id="4" name="TextBox 3"/>
           <p:cNvSpPr txBox="1"/>
           <p:nvPr/>
         </p:nvSpPr>
         <p:spPr>
           <a:xfrm>
-            <a:off x="566928" y="2011680"/>
-            <a:ext cx="3472586" cy="1828800"/>
-          </a:xfrm>
-          <a:prstGeom prst="rect">
-            <a:avLst/>
-          </a:prstGeom>
-          <a:noFill/>
-        </p:spPr>
-        <p:txBody>
-          <a:bodyPr wrap="square" lIns="0" rIns="0" tIns="0" bIns="0">
-            <a:spAutoFit/>
-          </a:bodyPr>
-          <a:lstStyle/>
-          <a:p>
-            <a:pPr>
-              <a:spcBef>
-                <a:spcPts val="0"/>
-              </a:spcBef>
-              <a:spcAft>
-                <a:spcPts val="700"/>
-              </a:spcAft>
-            </a:pPr>
-            <a:r>
-              <a:rPr sz="1050" b="0" i="0">
-                <a:solidFill>
-                  <a:srgbClr val="17549E"/>
-                </a:solidFill>
-                <a:latin typeface="Consolas"/>
-              </a:rPr>
-              <a:t>FIGURE COUNT</a:t>
-            </a:r>
-          </a:p>
+            <a:off x="914400" y="2148840"/>
+            <a:ext cx="9509760" cy="2926080"/>
+          </a:xfrm>
+          <a:prstGeom prst="rect">
+            <a:avLst/>
+          </a:prstGeom>
+          <a:noFill/>
+        </p:spPr>
+        <p:txBody>
+          <a:bodyPr wrap="square" lIns="0" rIns="0" tIns="0" bIns="0">
+            <a:spAutoFit/>
+          </a:bodyPr>
+          <a:lstStyle/>
           <a:p>
             <a:pPr>
               <a:lnSpc>
-                <a:spcPct val="130000"/>
+                <a:spcPct val="135000"/>
               </a:lnSpc>
               <a:spcBef>
                 <a:spcPts val="0"/>
@@ -8655,26 +9000,113 @@
               </a:spcAft>
             </a:pPr>
             <a:r>
-              <a:rPr sz="1100" b="0" i="0">
+              <a:rPr sz="2100" b="0" i="0">
+                <a:solidFill>
+                  <a:srgbClr val="14171C"/>
+                </a:solidFill>
+                <a:latin typeface="Georgia"/>
+              </a:rPr>
+              <a:t>Whether development measurement should be redesigned with wellbeing in mind is beyond this scope. But if it is, this evidence suggests the measurement should be different: more attentive to which variables still move, which constructs predict outcomes, and which domains are collected at all.</a:t>
+            </a:r>
+          </a:p>
+        </p:txBody>
+      </p:sp>
+    </p:spTree>
+  </p:cSld>
+  <p:clrMapOvr>
+    <a:masterClrMapping/>
+  </p:clrMapOvr>
+</p:sld>
+</file>
+
+<file path=ppt/slides/slide28.xml><?xml version="1.0" encoding="utf-8"?>
+<p:sld xmlns:a="http://schemas.openxmlformats.org/drawingml/2006/main" xmlns:p="http://schemas.openxmlformats.org/presentationml/2006/main" xmlns:r="http://schemas.openxmlformats.org/officeDocument/2006/relationships">
+  <p:cSld>
+    <p:bg>
+      <p:bgPr>
+        <a:solidFill>
+          <a:srgbClr val="FCFCFB"/>
+        </a:solidFill>
+        <a:effectLst/>
+      </p:bgPr>
+    </p:bg>
+    <p:spTree>
+      <p:nvGrpSpPr>
+        <p:cNvPr id="1" name=""/>
+        <p:cNvGrpSpPr/>
+        <p:nvPr/>
+      </p:nvGrpSpPr>
+      <p:grpSpPr/>
+      <p:sp>
+        <p:nvSpPr>
+          <p:cNvPr id="2" name="TextBox 1"/>
+          <p:cNvSpPr txBox="1"/>
+          <p:nvPr/>
+        </p:nvSpPr>
+        <p:spPr>
+          <a:xfrm>
+            <a:off x="566928" y="502920"/>
+            <a:ext cx="8229600" cy="822960"/>
+          </a:xfrm>
+          <a:prstGeom prst="rect">
+            <a:avLst/>
+          </a:prstGeom>
+          <a:noFill/>
+        </p:spPr>
+        <p:txBody>
+          <a:bodyPr wrap="square" lIns="0" rIns="0" tIns="0" bIns="0">
+            <a:spAutoFit/>
+          </a:bodyPr>
+          <a:lstStyle/>
+          <a:p>
+            <a:pPr>
+              <a:spcBef>
+                <a:spcPts val="0"/>
+              </a:spcBef>
+              <a:spcAft>
+                <a:spcPts val="600"/>
+              </a:spcAft>
+            </a:pPr>
+            <a:r>
+              <a:rPr sz="3200" b="0" i="0">
+                <a:solidFill>
+                  <a:srgbClr val="14171C"/>
+                </a:solidFill>
+                <a:latin typeface="Georgia"/>
+              </a:rPr>
+              <a:t>Decisions for the team</a:t>
+            </a:r>
+          </a:p>
+          <a:p>
+            <a:pPr>
+              <a:spcBef>
+                <a:spcPts val="0"/>
+              </a:spcBef>
+              <a:spcAft>
+                <a:spcPts val="0"/>
+              </a:spcAft>
+            </a:pPr>
+            <a:r>
+              <a:rPr sz="1300" b="0" i="0">
                 <a:solidFill>
                   <a:srgbClr val="5A6068"/>
                 </a:solidFill>
                 <a:latin typeface="Calibri"/>
               </a:rPr>
-              <a:t>Commentaries allow one or two. Proposed: three-panel composite as Figure 1 and domain scorecard as Figure 2. Everything else supplementary.</a:t>
-            </a:r>
-          </a:p>
-        </p:txBody>
-      </p:sp>
-      <p:sp>
-        <p:nvSpPr>
-          <p:cNvPr id="5" name="Rectangle 4"/>
+              <a:t>4 things the acts do not settle, in the order they block drafting.</a:t>
+            </a:r>
+          </a:p>
+        </p:txBody>
+      </p:sp>
+      <p:sp>
+        <p:nvSpPr>
+          <p:cNvPr id="3" name="Rectangle 2"/>
           <p:cNvSpPr/>
           <p:nvPr/>
         </p:nvSpPr>
         <p:spPr>
           <a:xfrm>
-            <a:off x="4359554" y="1828800"/>
+            <a:off x="566928" y="1828800"/>
             <a:ext cx="3472586" cy="25400"/>
           </a:xfrm>
           <a:prstGeom prst="rect">
@@ -8712,13 +9144,13 @@
       </p:sp>
       <p:sp>
         <p:nvSpPr>
-          <p:cNvPr id="6" name="TextBox 5"/>
-          <p:cNvSpPr txBox="1"/>
-          <p:nvPr/>
-        </p:nvSpPr>
-        <p:spPr>
-          <a:xfrm>
-            <a:off x="4359554" y="2011680"/>
+          <p:cNvPr id="4" name="TextBox 3"/>
+          <p:cNvSpPr txBox="1"/>
+          <p:nvPr/>
+        </p:nvSpPr>
+        <p:spPr>
+          <a:xfrm>
+            <a:off x="566928" y="2011680"/>
             <a:ext cx="3472586" cy="1828800"/>
           </a:xfrm>
           <a:prstGeom prst="rect">
@@ -8747,7 +9179,7 @@
                 </a:solidFill>
                 <a:latin typeface="Consolas"/>
               </a:rPr>
-              <a:t>SCOPE OF TRUST FINDINGS</a:t>
+              <a:t>FIGURE COUNT</a:t>
             </a:r>
           </a:p>
           <a:p>
@@ -8769,20 +9201,20 @@
                 </a:solidFill>
                 <a:latin typeface="Calibri"/>
               </a:rPr>
-              <a:t>Trust findings rest on ESS (36 European countries, individual-level). The design requires ≥4 years per country-series; only 16 of 163 SDG trust-adjacent series have that coverage, and 1 is significant. Tested cross-sectionally, 9 of 13 series are usable and 4 are significant, but all fall below HDI components on the same countries. The claim is Europe-only and rests on one instrument in each framework; it is the most tentative of the three.</a:t>
-            </a:r>
-          </a:p>
-        </p:txBody>
-      </p:sp>
-      <p:sp>
-        <p:nvSpPr>
-          <p:cNvPr id="7" name="Rectangle 6"/>
+              <a:t>Commentaries allow one or two. Proposed: three-panel composite as Figure 1 and domain scorecard as Figure 2. Everything else supplementary.</a:t>
+            </a:r>
+          </a:p>
+        </p:txBody>
+      </p:sp>
+      <p:sp>
+        <p:nvSpPr>
+          <p:cNvPr id="5" name="Rectangle 4"/>
           <p:cNvSpPr/>
           <p:nvPr/>
         </p:nvSpPr>
         <p:spPr>
           <a:xfrm>
-            <a:off x="8152180" y="1828800"/>
+            <a:off x="4359554" y="1828800"/>
             <a:ext cx="3472586" cy="25400"/>
           </a:xfrm>
           <a:prstGeom prst="rect">
@@ -8820,13 +9252,13 @@
       </p:sp>
       <p:sp>
         <p:nvSpPr>
-          <p:cNvPr id="8" name="TextBox 7"/>
-          <p:cNvSpPr txBox="1"/>
-          <p:nvPr/>
-        </p:nvSpPr>
-        <p:spPr>
-          <a:xfrm>
-            <a:off x="8152180" y="2011680"/>
+          <p:cNvPr id="6" name="TextBox 5"/>
+          <p:cNvSpPr txBox="1"/>
+          <p:nvPr/>
+        </p:nvSpPr>
+        <p:spPr>
+          <a:xfrm>
+            <a:off x="4359554" y="2011680"/>
             <a:ext cx="3472586" cy="1828800"/>
           </a:xfrm>
           <a:prstGeom prst="rect">
@@ -8855,7 +9287,7 @@
                 </a:solidFill>
                 <a:latin typeface="Consolas"/>
               </a:rPr>
-              <a:t>INSTITUTIONAL CONFIDENCE VS. INTERPERSONAL TRUST</a:t>
+              <a:t>SCOPE OF TRUST FINDINGS</a:t>
             </a:r>
           </a:p>
           <a:p>
@@ -8877,20 +9309,20 @@
                 </a:solidFill>
                 <a:latin typeface="Calibri"/>
               </a:rPr>
-              <a:t>The SDG's Goal 16 trust series measure satisfaction with public services, perceived bribery, and perceived inclusiveness in decision-making — institutional confidence, not interpersonal trust ('most people can be trusted'). These are conceptually distinct. The commentarymust be explicit that SDG16 is not a direct analogue for the ESS trust item.</a:t>
-            </a:r>
-          </a:p>
-        </p:txBody>
-      </p:sp>
-      <p:sp>
-        <p:nvSpPr>
-          <p:cNvPr id="9" name="Rectangle 8"/>
+              <a:t>Trust findings rest on ESS (36 European countries, individual-level). The design requires ≥4 years per country-series; only 16 of 163 SDG trust-adjacent series have that coverage, and 1 is significant. Tested cross-sectionally, 9 of 13 series are usable and 4 are significant, but all fall below HDI components on the same countries. The claim is Europe-only and rests on one instrument in each framework; it is the most tentative of the three.</a:t>
+            </a:r>
+          </a:p>
+        </p:txBody>
+      </p:sp>
+      <p:sp>
+        <p:nvSpPr>
+          <p:cNvPr id="7" name="Rectangle 6"/>
           <p:cNvSpPr/>
           <p:nvPr/>
         </p:nvSpPr>
         <p:spPr>
           <a:xfrm>
-            <a:off x="566928" y="4069080"/>
+            <a:off x="8152180" y="1828800"/>
             <a:ext cx="3472586" cy="25400"/>
           </a:xfrm>
           <a:prstGeom prst="rect">
@@ -8928,6 +9360,114 @@
       </p:sp>
       <p:sp>
         <p:nvSpPr>
+          <p:cNvPr id="8" name="TextBox 7"/>
+          <p:cNvSpPr txBox="1"/>
+          <p:nvPr/>
+        </p:nvSpPr>
+        <p:spPr>
+          <a:xfrm>
+            <a:off x="8152180" y="2011680"/>
+            <a:ext cx="3472586" cy="1828800"/>
+          </a:xfrm>
+          <a:prstGeom prst="rect">
+            <a:avLst/>
+          </a:prstGeom>
+          <a:noFill/>
+        </p:spPr>
+        <p:txBody>
+          <a:bodyPr wrap="square" lIns="0" rIns="0" tIns="0" bIns="0">
+            <a:spAutoFit/>
+          </a:bodyPr>
+          <a:lstStyle/>
+          <a:p>
+            <a:pPr>
+              <a:spcBef>
+                <a:spcPts val="0"/>
+              </a:spcBef>
+              <a:spcAft>
+                <a:spcPts val="700"/>
+              </a:spcAft>
+            </a:pPr>
+            <a:r>
+              <a:rPr sz="1050" b="0" i="0">
+                <a:solidFill>
+                  <a:srgbClr val="17549E"/>
+                </a:solidFill>
+                <a:latin typeface="Consolas"/>
+              </a:rPr>
+              <a:t>INSTITUTIONAL CONFIDENCE VS. INTERPERSONAL TRUST</a:t>
+            </a:r>
+          </a:p>
+          <a:p>
+            <a:pPr>
+              <a:lnSpc>
+                <a:spcPct val="130000"/>
+              </a:lnSpc>
+              <a:spcBef>
+                <a:spcPts val="0"/>
+              </a:spcBef>
+              <a:spcAft>
+                <a:spcPts val="0"/>
+              </a:spcAft>
+            </a:pPr>
+            <a:r>
+              <a:rPr sz="1100" b="0" i="0">
+                <a:solidFill>
+                  <a:srgbClr val="5A6068"/>
+                </a:solidFill>
+                <a:latin typeface="Calibri"/>
+              </a:rPr>
+              <a:t>The SDG's Goal 16 trust series measure satisfaction with public services, perceived bribery, and perceived inclusiveness in decision-making — institutional confidence, not interpersonal trust ('most people can be trusted'). These are conceptually distinct. The commentarymust be explicit that SDG16 is not a direct analogue for the ESS trust item.</a:t>
+            </a:r>
+          </a:p>
+        </p:txBody>
+      </p:sp>
+      <p:sp>
+        <p:nvSpPr>
+          <p:cNvPr id="9" name="Rectangle 8"/>
+          <p:cNvSpPr/>
+          <p:nvPr/>
+        </p:nvSpPr>
+        <p:spPr>
+          <a:xfrm>
+            <a:off x="566928" y="4069080"/>
+            <a:ext cx="3472586" cy="25400"/>
+          </a:xfrm>
+          <a:prstGeom prst="rect">
+            <a:avLst/>
+          </a:prstGeom>
+          <a:solidFill>
+            <a:srgbClr val="17549E"/>
+          </a:solidFill>
+          <a:ln>
+            <a:noFill/>
+          </a:ln>
+          <a:effectLst/>
+        </p:spPr>
+        <p:style>
+          <a:lnRef idx="1">
+            <a:schemeClr val="accent1"/>
+          </a:lnRef>
+          <a:fillRef idx="3">
+            <a:schemeClr val="accent1"/>
+          </a:fillRef>
+          <a:effectRef idx="2">
+            <a:schemeClr val="accent1"/>
+          </a:effectRef>
+          <a:fontRef idx="minor">
+            <a:schemeClr val="lt1"/>
+          </a:fontRef>
+        </p:style>
+        <p:txBody>
+          <a:bodyPr rtlCol="0" anchor="ctr"/>
+          <a:lstStyle/>
+          <a:p>
+            <a:pPr algn="ctr"/>
+          </a:p>
+        </p:txBody>
+      </p:sp>
+      <p:sp>
+        <p:nvSpPr>
           <p:cNvPr id="10" name="TextBox 9"/>
           <p:cNvSpPr txBox="1"/>
           <p:nvPr/>
@@ -8998,7 +9538,7 @@
 </p:sld>
 </file>
 
-<file path=ppt/slides/slide27.xml><?xml version="1.0" encoding="utf-8"?>
+<file path=ppt/slides/slide29.xml><?xml version="1.0" encoding="utf-8"?>
 <p:sld xmlns:a="http://schemas.openxmlformats.org/drawingml/2006/main" xmlns:p="http://schemas.openxmlformats.org/presentationml/2006/main" xmlns:r="http://schemas.openxmlformats.org/officeDocument/2006/relationships">
   <p:cSld>
     <p:bg>
@@ -11045,7 +11585,7 @@
                 </a:solidFill>
                 <a:latin typeface="Consolas"/>
               </a:rPr>
-              <a:t>ALL THREE MATTER</a:t>
+              <a:t>FRAMEWORK COMPARISON</a:t>
             </a:r>
           </a:p>
         </p:txBody>
@@ -11090,7 +11630,7 @@
                 </a:solidFill>
                 <a:latin typeface="Georgia"/>
               </a:rPr>
-              <a:t>Education, health, and social trust all significantly predict life satisfaction</a:t>
+              <a:t>How the frameworks compare on detection, budget-match, and per-indicator basis</a:t>
             </a:r>
           </a:p>
         </p:txBody>
@@ -11135,7 +11675,7 @@
                 </a:solidFill>
                 <a:latin typeface="Calibri"/>
               </a:rPr>
-              <a:t>In the European Social Survey, where all three are measured at the individual level, all three are significant in the majority of countries. But which framework can see all three? Which sees only some? The answer depends on three different failure modes.</a:t>
+              <a:t>Before we ask what matters, we need to understand how these frameworks differ. The SDG database detects significance in more countries (71% raw) than the HDI (51% raw), but when both are given the same budget — five indicators across 42 countries — the HDI's edge becomes real but modest (30% vs 51% among those 42 countries). When normalized per indicator, the HDI dominates: most SDG series sit in the zero-significance tail, while HDI indicators cluster higher. This is context we need before asking which components matter most.</a:t>
             </a:r>
           </a:p>
         </p:txBody>
@@ -11184,7 +11724,7 @@
       </p:sp>
       <p:pic>
         <p:nvPicPr>
-          <p:cNvPr id="6" name="Picture 5" descr="domains_at_levels_comparison.png"/>
+          <p:cNvPr id="6" name="Picture 5" descr="framework_three_comparisons.png"/>
           <p:cNvPicPr>
             <a:picLocks noChangeAspect="1"/>
           </p:cNvPicPr>
@@ -11198,8 +11738,8 @@
         </p:blipFill>
         <p:spPr>
           <a:xfrm>
-            <a:off x="5120640" y="2028335"/>
-            <a:ext cx="6537960" cy="2334985"/>
+            <a:off x="5120640" y="2093715"/>
+            <a:ext cx="6537960" cy="2204226"/>
           </a:xfrm>
           <a:prstGeom prst="rect">
             <a:avLst/>
@@ -11246,7 +11786,7 @@
                 </a:solidFill>
                 <a:latin typeface="Calibri"/>
               </a:rPr>
-              <a:t>% of countries where each domain significantly predicts wellbeing at levels. ESS: 36 countries. HDI: 150 countries. SDG: country-indicator pairs.</a:t>
+              <a:t>How SDG and HDI frameworks compare on detection rate, budget-matched analysis, and per-indicator significance distribution.</a:t>
             </a:r>
           </a:p>
         </p:txBody>

</xml_diff>

<commit_message>
Add comprehensive figure suite to complete narrative: domain scorecard and regional within-country evidence
- Add domain_scorecard.png (J1) to Act II synthesis, showing which frameworks can test which domains and the strength of each signal
- Add collapse_shdi_ess_regional.png (D3) to Act III within-country beat, demonstrating collapse persists at regional scale
- Add K1_sdg_trust_cross_section.png to Act III, explaining why SDG's trust measures fail (institutional confidence, not interpersonal trust; weak signal that disappears with income control)
- Expanded Act III to 4 substantive beats showing regional collapse, trust measurement failure, and synthesis
- Deck now 31 slides with complete visual narrative: framework comparisons → domain analysis → within-country evidence → implications

Co-Authored-By: Claude Haiku 4.5 <noreply@anthropic.com>
Claude-Session: https://claude.ai/code/session_01EScqJU3C944N93U7Je3P1X
</commit_message>
<xml_diff>
--- a/deck/Measured_Where_It_Varies.pptx
+++ b/deck/Measured_Where_It_Varies.pptx
@@ -34,6 +34,8 @@
     <p:sldId id="282" r:id="rId33"/>
     <p:sldId id="283" r:id="rId34"/>
     <p:sldId id="284" r:id="rId35"/>
+    <p:sldId id="285" r:id="rId36"/>
+    <p:sldId id="286" r:id="rId37"/>
   </p:sldIdLst>
   <p:sldSz cx="12191695" cy="6858000" type="screen4x3"/>
   <p:notesSz cx="6858000" cy="9144000"/>
@@ -5393,6 +5395,275 @@
     <p:bg>
       <p:bgPr>
         <a:solidFill>
+          <a:srgbClr val="FCFCFB"/>
+        </a:solidFill>
+        <a:effectLst/>
+      </p:bgPr>
+    </p:bg>
+    <p:spTree>
+      <p:nvGrpSpPr>
+        <p:cNvPr id="1" name=""/>
+        <p:cNvGrpSpPr/>
+        <p:nvPr/>
+      </p:nvGrpSpPr>
+      <p:grpSpPr/>
+      <p:sp>
+        <p:nvSpPr>
+          <p:cNvPr id="2" name="TextBox 1"/>
+          <p:cNvSpPr txBox="1"/>
+          <p:nvPr/>
+        </p:nvSpPr>
+        <p:spPr>
+          <a:xfrm>
+            <a:off x="566928" y="502920"/>
+            <a:ext cx="4160520" cy="274320"/>
+          </a:xfrm>
+          <a:prstGeom prst="rect">
+            <a:avLst/>
+          </a:prstGeom>
+          <a:noFill/>
+        </p:spPr>
+        <p:txBody>
+          <a:bodyPr wrap="square" lIns="0" rIns="0" tIns="0" bIns="0">
+            <a:spAutoFit/>
+          </a:bodyPr>
+          <a:lstStyle/>
+          <a:p>
+            <a:pPr>
+              <a:spcBef>
+                <a:spcPts val="0"/>
+              </a:spcBef>
+              <a:spcAft>
+                <a:spcPts val="0"/>
+              </a:spcAft>
+            </a:pPr>
+            <a:r>
+              <a:rPr sz="1000" b="0" i="0">
+                <a:solidFill>
+                  <a:srgbClr val="A63A30"/>
+                </a:solidFill>
+                <a:latin typeface="Consolas"/>
+              </a:rPr>
+              <a:t>FRAMEWORK BLIND SPOTS · DOMAIN BY DOMAIN</a:t>
+            </a:r>
+          </a:p>
+        </p:txBody>
+      </p:sp>
+      <p:sp>
+        <p:nvSpPr>
+          <p:cNvPr id="3" name="TextBox 2"/>
+          <p:cNvSpPr txBox="1"/>
+          <p:nvPr/>
+        </p:nvSpPr>
+        <p:spPr>
+          <a:xfrm>
+            <a:off x="566928" y="914400"/>
+            <a:ext cx="4160520" cy="1371600"/>
+          </a:xfrm>
+          <a:prstGeom prst="rect">
+            <a:avLst/>
+          </a:prstGeom>
+          <a:noFill/>
+        </p:spPr>
+        <p:txBody>
+          <a:bodyPr wrap="square" lIns="0" rIns="0" tIns="0" bIns="0">
+            <a:spAutoFit/>
+          </a:bodyPr>
+          <a:lstStyle/>
+          <a:p>
+            <a:pPr>
+              <a:lnSpc>
+                <a:spcPct val="108000"/>
+              </a:lnSpc>
+              <a:spcBef>
+                <a:spcPts val="0"/>
+              </a:spcBef>
+              <a:spcAft>
+                <a:spcPts val="0"/>
+              </a:spcAft>
+            </a:pPr>
+            <a:r>
+              <a:rPr sz="2300" b="0" i="0">
+                <a:solidFill>
+                  <a:srgbClr val="14171C"/>
+                </a:solidFill>
+                <a:latin typeface="Georgia"/>
+              </a:rPr>
+              <a:t>Education, health and social trust — and which frameworks can see them</a:t>
+            </a:r>
+          </a:p>
+        </p:txBody>
+      </p:sp>
+      <p:sp>
+        <p:nvSpPr>
+          <p:cNvPr id="4" name="TextBox 3"/>
+          <p:cNvSpPr txBox="1"/>
+          <p:nvPr/>
+        </p:nvSpPr>
+        <p:spPr>
+          <a:xfrm>
+            <a:off x="566928" y="2331720"/>
+            <a:ext cx="4160520" cy="3840480"/>
+          </a:xfrm>
+          <a:prstGeom prst="rect">
+            <a:avLst/>
+          </a:prstGeom>
+          <a:noFill/>
+        </p:spPr>
+        <p:txBody>
+          <a:bodyPr wrap="square" lIns="0" rIns="0" tIns="0" bIns="0">
+            <a:spAutoFit/>
+          </a:bodyPr>
+          <a:lstStyle/>
+          <a:p>
+            <a:pPr>
+              <a:lnSpc>
+                <a:spcPct val="132000"/>
+              </a:lnSpc>
+              <a:spcBef>
+                <a:spcPts val="0"/>
+              </a:spcBef>
+              <a:spcAft>
+                <a:spcPts val="1100"/>
+              </a:spcAft>
+            </a:pPr>
+            <a:r>
+              <a:rPr sz="1150" b="0" i="0">
+                <a:solidFill>
+                  <a:srgbClr val="5A6068"/>
+                </a:solidFill>
+                <a:latin typeface="Calibri"/>
+              </a:rPr>
+              <a:t>A summary of the blind spots: which frameworks can test which domains, and whether the test yields a signal. Education is testable in all three frameworks but its rank depends entirely on which construct the framework chose to count. Health is testable everywhere and leads wherever it is measured somewhere it still varies — a robust signal despite the HDI's poor choice of proxy. Social trust is testable in one instrument only: the ESS. It does not appear in the HDI at all, and the SDG framework measures institutional confidence instead, which is a different construct and a weaker predictor.</a:t>
+            </a:r>
+          </a:p>
+        </p:txBody>
+      </p:sp>
+      <p:sp>
+        <p:nvSpPr>
+          <p:cNvPr id="5" name="TextBox 4"/>
+          <p:cNvSpPr txBox="1"/>
+          <p:nvPr/>
+        </p:nvSpPr>
+        <p:spPr>
+          <a:xfrm>
+            <a:off x="11338560" y="6263640"/>
+            <a:ext cx="548640" cy="274320"/>
+          </a:xfrm>
+          <a:prstGeom prst="rect">
+            <a:avLst/>
+          </a:prstGeom>
+          <a:noFill/>
+        </p:spPr>
+        <p:txBody>
+          <a:bodyPr wrap="square" lIns="0" rIns="0" tIns="0" bIns="0">
+            <a:spAutoFit/>
+          </a:bodyPr>
+          <a:lstStyle/>
+          <a:p>
+            <a:pPr algn="r">
+              <a:spcBef>
+                <a:spcPts val="0"/>
+              </a:spcBef>
+              <a:spcAft>
+                <a:spcPts val="0"/>
+              </a:spcAft>
+            </a:pPr>
+            <a:r>
+              <a:rPr sz="1100" b="0" i="0">
+                <a:solidFill>
+                  <a:srgbClr val="868D96"/>
+                </a:solidFill>
+                <a:latin typeface="Consolas"/>
+              </a:rPr>
+              <a:t>II</a:t>
+            </a:r>
+          </a:p>
+        </p:txBody>
+      </p:sp>
+      <p:pic>
+        <p:nvPicPr>
+          <p:cNvPr id="6" name="Picture 5" descr="domain_scorecard.png"/>
+          <p:cNvPicPr>
+            <a:picLocks noChangeAspect="1"/>
+          </p:cNvPicPr>
+          <p:nvPr/>
+        </p:nvPicPr>
+        <p:blipFill>
+          <a:blip r:embed="rId2"/>
+          <a:stretch>
+            <a:fillRect/>
+          </a:stretch>
+        </p:blipFill>
+        <p:spPr>
+          <a:xfrm>
+            <a:off x="5120640" y="1469807"/>
+            <a:ext cx="6537960" cy="3452042"/>
+          </a:xfrm>
+          <a:prstGeom prst="rect">
+            <a:avLst/>
+          </a:prstGeom>
+        </p:spPr>
+      </p:pic>
+      <p:sp>
+        <p:nvSpPr>
+          <p:cNvPr id="7" name="TextBox 6"/>
+          <p:cNvSpPr txBox="1"/>
+          <p:nvPr/>
+        </p:nvSpPr>
+        <p:spPr>
+          <a:xfrm>
+            <a:off x="5120640" y="5897880"/>
+            <a:ext cx="6537960" cy="731520"/>
+          </a:xfrm>
+          <a:prstGeom prst="rect">
+            <a:avLst/>
+          </a:prstGeom>
+          <a:noFill/>
+        </p:spPr>
+        <p:txBody>
+          <a:bodyPr wrap="square" lIns="0" rIns="0" tIns="0" bIns="0">
+            <a:spAutoFit/>
+          </a:bodyPr>
+          <a:lstStyle/>
+          <a:p>
+            <a:pPr>
+              <a:lnSpc>
+                <a:spcPct val="125000"/>
+              </a:lnSpc>
+              <a:spcBef>
+                <a:spcPts val="0"/>
+              </a:spcBef>
+              <a:spcAft>
+                <a:spcPts val="0"/>
+              </a:spcAft>
+            </a:pPr>
+            <a:r>
+              <a:rPr sz="900" b="0" i="0">
+                <a:solidFill>
+                  <a:srgbClr val="868D96"/>
+                </a:solidFill>
+                <a:latin typeface="Calibri"/>
+              </a:rPr>
+              <a:t>Which frameworks can test each domain (green = tracks wellbeing, yellow = measurable but weak signal, gray = framework cannot test it).</a:t>
+            </a:r>
+          </a:p>
+        </p:txBody>
+      </p:sp>
+    </p:spTree>
+  </p:cSld>
+  <p:clrMapOvr>
+    <a:masterClrMapping/>
+  </p:clrMapOvr>
+</p:sld>
+</file>
+
+<file path=ppt/slides/slide18.xml><?xml version="1.0" encoding="utf-8"?>
+<p:sld xmlns:a="http://schemas.openxmlformats.org/drawingml/2006/main" xmlns:p="http://schemas.openxmlformats.org/presentationml/2006/main" xmlns:r="http://schemas.openxmlformats.org/officeDocument/2006/relationships">
+  <p:cSld>
+    <p:bg>
+      <p:bgPr>
+        <a:solidFill>
           <a:srgbClr val="E8EBEF"/>
         </a:solidFill>
         <a:effectLst/>
@@ -5544,7 +5815,7 @@
 </p:sld>
 </file>
 
-<file path=ppt/slides/slide18.xml><?xml version="1.0" encoding="utf-8"?>
+<file path=ppt/slides/slide19.xml><?xml version="1.0" encoding="utf-8"?>
 <p:sld xmlns:a="http://schemas.openxmlformats.org/drawingml/2006/main" xmlns:p="http://schemas.openxmlformats.org/presentationml/2006/main" xmlns:r="http://schemas.openxmlformats.org/officeDocument/2006/relationships">
   <p:cSld>
     <p:bg>
@@ -5968,275 +6239,6 @@
                 <a:latin typeface="Calibri"/>
               </a:rPr>
               <a:t>HDI levels → differences (collapsed)</a:t>
-            </a:r>
-          </a:p>
-        </p:txBody>
-      </p:sp>
-    </p:spTree>
-  </p:cSld>
-  <p:clrMapOvr>
-    <a:masterClrMapping/>
-  </p:clrMapOvr>
-</p:sld>
-</file>
-
-<file path=ppt/slides/slide19.xml><?xml version="1.0" encoding="utf-8"?>
-<p:sld xmlns:a="http://schemas.openxmlformats.org/drawingml/2006/main" xmlns:p="http://schemas.openxmlformats.org/presentationml/2006/main" xmlns:r="http://schemas.openxmlformats.org/officeDocument/2006/relationships">
-  <p:cSld>
-    <p:bg>
-      <p:bgPr>
-        <a:solidFill>
-          <a:srgbClr val="FCFCFB"/>
-        </a:solidFill>
-        <a:effectLst/>
-      </p:bgPr>
-    </p:bg>
-    <p:spTree>
-      <p:nvGrpSpPr>
-        <p:cNvPr id="1" name=""/>
-        <p:cNvGrpSpPr/>
-        <p:nvPr/>
-      </p:nvGrpSpPr>
-      <p:grpSpPr/>
-      <p:sp>
-        <p:nvSpPr>
-          <p:cNvPr id="2" name="TextBox 1"/>
-          <p:cNvSpPr txBox="1"/>
-          <p:nvPr/>
-        </p:nvSpPr>
-        <p:spPr>
-          <a:xfrm>
-            <a:off x="566928" y="502920"/>
-            <a:ext cx="4160520" cy="274320"/>
-          </a:xfrm>
-          <a:prstGeom prst="rect">
-            <a:avLst/>
-          </a:prstGeom>
-          <a:noFill/>
-        </p:spPr>
-        <p:txBody>
-          <a:bodyPr wrap="square" lIns="0" rIns="0" tIns="0" bIns="0">
-            <a:spAutoFit/>
-          </a:bodyPr>
-          <a:lstStyle/>
-          <a:p>
-            <a:pPr>
-              <a:spcBef>
-                <a:spcPts val="0"/>
-              </a:spcBef>
-              <a:spcAft>
-                <a:spcPts val="0"/>
-              </a:spcAft>
-            </a:pPr>
-            <a:r>
-              <a:rPr sz="1000" b="0" i="0">
-                <a:solidFill>
-                  <a:srgbClr val="A63A30"/>
-                </a:solidFill>
-                <a:latin typeface="Consolas"/>
-              </a:rPr>
-              <a:t>METHOD MATTERS · WHAT SURVIVES</a:t>
-            </a:r>
-          </a:p>
-        </p:txBody>
-      </p:sp>
-      <p:sp>
-        <p:nvSpPr>
-          <p:cNvPr id="3" name="TextBox 2"/>
-          <p:cNvSpPr txBox="1"/>
-          <p:nvPr/>
-        </p:nvSpPr>
-        <p:spPr>
-          <a:xfrm>
-            <a:off x="566928" y="914400"/>
-            <a:ext cx="4160520" cy="1371600"/>
-          </a:xfrm>
-          <a:prstGeom prst="rect">
-            <a:avLst/>
-          </a:prstGeom>
-          <a:noFill/>
-        </p:spPr>
-        <p:txBody>
-          <a:bodyPr wrap="square" lIns="0" rIns="0" tIns="0" bIns="0">
-            <a:spAutoFit/>
-          </a:bodyPr>
-          <a:lstStyle/>
-          <a:p>
-            <a:pPr>
-              <a:lnSpc>
-                <a:spcPct val="108000"/>
-              </a:lnSpc>
-              <a:spcBef>
-                <a:spcPts val="0"/>
-              </a:spcBef>
-              <a:spcAft>
-                <a:spcPts val="0"/>
-              </a:spcAft>
-            </a:pPr>
-            <a:r>
-              <a:rPr sz="2300" b="0" i="0">
-                <a:solidFill>
-                  <a:srgbClr val="14171C"/>
-                </a:solidFill>
-                <a:latin typeface="Georgia"/>
-              </a:rPr>
-              <a:t>Health survives both measurement methods. Social trust does not.</a:t>
-            </a:r>
-          </a:p>
-        </p:txBody>
-      </p:sp>
-      <p:sp>
-        <p:nvSpPr>
-          <p:cNvPr id="4" name="TextBox 3"/>
-          <p:cNvSpPr txBox="1"/>
-          <p:nvPr/>
-        </p:nvSpPr>
-        <p:spPr>
-          <a:xfrm>
-            <a:off x="566928" y="2331720"/>
-            <a:ext cx="4160520" cy="3840480"/>
-          </a:xfrm>
-          <a:prstGeom prst="rect">
-            <a:avLst/>
-          </a:prstGeom>
-          <a:noFill/>
-        </p:spPr>
-        <p:txBody>
-          <a:bodyPr wrap="square" lIns="0" rIns="0" tIns="0" bIns="0">
-            <a:spAutoFit/>
-          </a:bodyPr>
-          <a:lstStyle/>
-          <a:p>
-            <a:pPr>
-              <a:lnSpc>
-                <a:spcPct val="132000"/>
-              </a:lnSpc>
-              <a:spcBef>
-                <a:spcPts val="0"/>
-              </a:spcBef>
-              <a:spcAft>
-                <a:spcPts val="1100"/>
-              </a:spcAft>
-            </a:pPr>
-            <a:r>
-              <a:rPr sz="1150" b="0" i="0">
-                <a:solidFill>
-                  <a:srgbClr val="5A6068"/>
-                </a:solidFill>
-                <a:latin typeface="Calibri"/>
-              </a:rPr>
-              <a:t>A critical test: which domains actually predict wellbeing regardless of how you measure development? Health is significant in both administrative sources (SDG, 11.5% of country-indicator pairs) and self-reported sources (ESS, median R² = 0.091). This is robust. Education shows weak signal in both (SDG 3.3%, ESS R² = 0.0098), so the issue is not method-dependent but measurement-dependent. Social trust, however, only appears in self-reported data: 94% of ESS countries (median R² = 0.041) versus 1.5% of SDG16 country-pairs measuring institutional confidence instead. The three domains do not behave the same way across measurement methods.</a:t>
-            </a:r>
-          </a:p>
-        </p:txBody>
-      </p:sp>
-      <p:sp>
-        <p:nvSpPr>
-          <p:cNvPr id="5" name="TextBox 4"/>
-          <p:cNvSpPr txBox="1"/>
-          <p:nvPr/>
-        </p:nvSpPr>
-        <p:spPr>
-          <a:xfrm>
-            <a:off x="11338560" y="6263640"/>
-            <a:ext cx="548640" cy="274320"/>
-          </a:xfrm>
-          <a:prstGeom prst="rect">
-            <a:avLst/>
-          </a:prstGeom>
-          <a:noFill/>
-        </p:spPr>
-        <p:txBody>
-          <a:bodyPr wrap="square" lIns="0" rIns="0" tIns="0" bIns="0">
-            <a:spAutoFit/>
-          </a:bodyPr>
-          <a:lstStyle/>
-          <a:p>
-            <a:pPr algn="r">
-              <a:spcBef>
-                <a:spcPts val="0"/>
-              </a:spcBef>
-              <a:spcAft>
-                <a:spcPts val="0"/>
-              </a:spcAft>
-            </a:pPr>
-            <a:r>
-              <a:rPr sz="1100" b="0" i="0">
-                <a:solidFill>
-                  <a:srgbClr val="868D96"/>
-                </a:solidFill>
-                <a:latin typeface="Consolas"/>
-              </a:rPr>
-              <a:t>III</a:t>
-            </a:r>
-          </a:p>
-        </p:txBody>
-      </p:sp>
-      <p:pic>
-        <p:nvPicPr>
-          <p:cNvPr id="6" name="Picture 5" descr="health_trust_corroboration.png"/>
-          <p:cNvPicPr>
-            <a:picLocks noChangeAspect="1"/>
-          </p:cNvPicPr>
-          <p:nvPr/>
-        </p:nvPicPr>
-        <p:blipFill>
-          <a:blip r:embed="rId2"/>
-          <a:stretch>
-            <a:fillRect/>
-          </a:stretch>
-        </p:blipFill>
-        <p:spPr>
-          <a:xfrm>
-            <a:off x="5120640" y="1858518"/>
-            <a:ext cx="6537960" cy="2674620"/>
-          </a:xfrm>
-          <a:prstGeom prst="rect">
-            <a:avLst/>
-          </a:prstGeom>
-        </p:spPr>
-      </p:pic>
-      <p:sp>
-        <p:nvSpPr>
-          <p:cNvPr id="7" name="TextBox 6"/>
-          <p:cNvSpPr txBox="1"/>
-          <p:nvPr/>
-        </p:nvSpPr>
-        <p:spPr>
-          <a:xfrm>
-            <a:off x="5120640" y="5897880"/>
-            <a:ext cx="6537960" cy="731520"/>
-          </a:xfrm>
-          <a:prstGeom prst="rect">
-            <a:avLst/>
-          </a:prstGeom>
-          <a:noFill/>
-        </p:spPr>
-        <p:txBody>
-          <a:bodyPr wrap="square" lIns="0" rIns="0" tIns="0" bIns="0">
-            <a:spAutoFit/>
-          </a:bodyPr>
-          <a:lstStyle/>
-          <a:p>
-            <a:pPr>
-              <a:lnSpc>
-                <a:spcPct val="125000"/>
-              </a:lnSpc>
-              <a:spcBef>
-                <a:spcPts val="0"/>
-              </a:spcBef>
-              <a:spcAft>
-                <a:spcPts val="0"/>
-              </a:spcAft>
-            </a:pPr>
-            <a:r>
-              <a:rPr sz="900" b="0" i="0">
-                <a:solidFill>
-                  <a:srgbClr val="868D96"/>
-                </a:solidFill>
-                <a:latin typeface="Calibri"/>
-              </a:rPr>
-              <a:t>Health is robust across administrative and self-reported sources. Education is weak in both. Social trust appears only in self-reported individual-level data.</a:t>
             </a:r>
           </a:p>
         </p:txBody>
@@ -7120,7 +7122,7 @@
         <p:spPr>
           <a:xfrm>
             <a:off x="566928" y="502920"/>
-            <a:ext cx="8595360" cy="274320"/>
+            <a:ext cx="4160520" cy="274320"/>
           </a:xfrm>
           <a:prstGeom prst="rect">
             <a:avLst/>
@@ -7148,7 +7150,7 @@
                 </a:solidFill>
                 <a:latin typeface="Consolas"/>
               </a:rPr>
-              <a:t>WITHIN-COUNTRY EVIDENCE</a:t>
+              <a:t>METHOD MATTERS · WHAT SURVIVES</a:t>
             </a:r>
           </a:p>
         </p:txBody>
@@ -7162,7 +7164,7 @@
         <p:spPr>
           <a:xfrm>
             <a:off x="566928" y="914400"/>
-            <a:ext cx="8595360" cy="1371600"/>
+            <a:ext cx="4160520" cy="1371600"/>
           </a:xfrm>
           <a:prstGeom prst="rect">
             <a:avLst/>
@@ -7187,13 +7189,13 @@
               </a:spcAft>
             </a:pPr>
             <a:r>
-              <a:rPr sz="2700" b="0" i="0">
+              <a:rPr sz="2300" b="0" i="0">
                 <a:solidFill>
                   <a:srgbClr val="14171C"/>
                 </a:solidFill>
                 <a:latin typeface="Georgia"/>
               </a:rPr>
-              <a:t>Individual-level, self-reported data captures year-to-year change that administrative frameworks miss</a:t>
+              <a:t>Health survives both measurement methods. Social trust does not.</a:t>
             </a:r>
           </a:p>
         </p:txBody>
@@ -7206,8 +7208,8 @@
         </p:nvSpPr>
         <p:spPr>
           <a:xfrm>
-            <a:off x="566928" y="2286000"/>
-            <a:ext cx="8595360" cy="3840480"/>
+            <a:off x="566928" y="2331720"/>
+            <a:ext cx="4160520" cy="3840480"/>
           </a:xfrm>
           <a:prstGeom prst="rect">
             <a:avLst/>
@@ -7232,57 +7234,13 @@
               </a:spcAft>
             </a:pPr>
             <a:r>
-              <a:rPr sz="1400" b="0" i="0">
+              <a:rPr sz="1150" b="0" i="0">
                 <a:solidFill>
                   <a:srgbClr val="5A6068"/>
                 </a:solidFill>
                 <a:latin typeface="Calibri"/>
               </a:rPr>
-              <a:t>Here is the critical observation that reshapes the question: unlike SDG (71% levels → 5% differences) and HDI (42% → 2%), the ESS shows 69% levels → 64% differences. The association persists within countries over time. This is not because development frameworks are poorly designed; it is because they measure aggregate, administrative data at long intervals (annual at best for HDI and SDG). Individual survey responses capture year-to-year variation in how people experience their lives.</a:t>
-            </a:r>
-          </a:p>
-          <a:p>
-            <a:pPr>
-              <a:lnSpc>
-                <a:spcPct val="132000"/>
-              </a:lnSpc>
-              <a:spcBef>
-                <a:spcPts val="0"/>
-              </a:spcBef>
-              <a:spcAft>
-                <a:spcPts val="1100"/>
-              </a:spcAft>
-            </a:pPr>
-            <a:r>
-              <a:rPr sz="1400" b="0" i="0">
-                <a:solidFill>
-                  <a:srgbClr val="5A6068"/>
-                </a:solidFill>
-                <a:latin typeface="Calibri"/>
-              </a:rPr>
-              <a:t>This matters for social trust most of all. At the country level, SDG has almost no trust coverage; in the HDI, none. But at the individual level, within countries, ESS shows trust is significant in 94% of countries and drives year-to-year change in how satisfied people report being. The three domains emerge not because the frameworks reveal them, but because ESS measures them where people actually experience variation: in themselves, over time.</a:t>
-            </a:r>
-          </a:p>
-          <a:p>
-            <a:pPr>
-              <a:lnSpc>
-                <a:spcPct val="132000"/>
-              </a:lnSpc>
-              <a:spcBef>
-                <a:spcPts val="0"/>
-              </a:spcBef>
-              <a:spcAft>
-                <a:spcPts val="1100"/>
-              </a:spcAft>
-            </a:pPr>
-            <a:r>
-              <a:rPr sz="1400" b="0" i="0">
-                <a:solidFill>
-                  <a:srgbClr val="5A6068"/>
-                </a:solidFill>
-                <a:latin typeface="Calibri"/>
-              </a:rPr>
-              <a:t>The caveats are substantial: 36 European countries, self-reported measures, annual cycles. But the implication is clear. Development frameworks' blindness to social trust is not because trust does not matter for wellbeing; it is because development was never designed to measure individual experience at the temporal resolution where people change.</a:t>
+              <a:t>A critical test: which domains actually predict wellbeing regardless of how you measure development? Health is significant in both administrative sources (SDG, 11.5% of country-indicator pairs) and self-reported sources (ESS, median R² = 0.091). This is robust. Education shows weak signal in both (SDG 3.3%, ESS R² = 0.0098), so the issue is not method-dependent but measurement-dependent. Social trust, however, only appears in self-reported data: 94% of ESS countries (median R² = 0.041) versus 1.5% of SDG16 country-pairs measuring institutional confidence instead. The three domains do not behave the same way across measurement methods.</a:t>
             </a:r>
           </a:p>
         </p:txBody>
@@ -7325,6 +7283,75 @@
                 <a:latin typeface="Consolas"/>
               </a:rPr>
               <a:t>III</a:t>
+            </a:r>
+          </a:p>
+        </p:txBody>
+      </p:sp>
+      <p:pic>
+        <p:nvPicPr>
+          <p:cNvPr id="6" name="Picture 5" descr="health_trust_corroboration.png"/>
+          <p:cNvPicPr>
+            <a:picLocks noChangeAspect="1"/>
+          </p:cNvPicPr>
+          <p:nvPr/>
+        </p:nvPicPr>
+        <p:blipFill>
+          <a:blip r:embed="rId2"/>
+          <a:stretch>
+            <a:fillRect/>
+          </a:stretch>
+        </p:blipFill>
+        <p:spPr>
+          <a:xfrm>
+            <a:off x="5120640" y="1858518"/>
+            <a:ext cx="6537960" cy="2674620"/>
+          </a:xfrm>
+          <a:prstGeom prst="rect">
+            <a:avLst/>
+          </a:prstGeom>
+        </p:spPr>
+      </p:pic>
+      <p:sp>
+        <p:nvSpPr>
+          <p:cNvPr id="7" name="TextBox 6"/>
+          <p:cNvSpPr txBox="1"/>
+          <p:nvPr/>
+        </p:nvSpPr>
+        <p:spPr>
+          <a:xfrm>
+            <a:off x="5120640" y="5897880"/>
+            <a:ext cx="6537960" cy="731520"/>
+          </a:xfrm>
+          <a:prstGeom prst="rect">
+            <a:avLst/>
+          </a:prstGeom>
+          <a:noFill/>
+        </p:spPr>
+        <p:txBody>
+          <a:bodyPr wrap="square" lIns="0" rIns="0" tIns="0" bIns="0">
+            <a:spAutoFit/>
+          </a:bodyPr>
+          <a:lstStyle/>
+          <a:p>
+            <a:pPr>
+              <a:lnSpc>
+                <a:spcPct val="125000"/>
+              </a:lnSpc>
+              <a:spcBef>
+                <a:spcPts val="0"/>
+              </a:spcBef>
+              <a:spcAft>
+                <a:spcPts val="0"/>
+              </a:spcAft>
+            </a:pPr>
+            <a:r>
+              <a:rPr sz="900" b="0" i="0">
+                <a:solidFill>
+                  <a:srgbClr val="868D96"/>
+                </a:solidFill>
+                <a:latin typeface="Calibri"/>
+              </a:rPr>
+              <a:t>Health is robust across administrative and self-reported sources. Education is weak in both. Social trust appears only in self-reported individual-level data.</a:t>
             </a:r>
           </a:p>
         </p:txBody>
@@ -7338,6 +7365,632 @@
 </file>
 
 <file path=ppt/slides/slide21.xml><?xml version="1.0" encoding="utf-8"?>
+<p:sld xmlns:a="http://schemas.openxmlformats.org/drawingml/2006/main" xmlns:p="http://schemas.openxmlformats.org/presentationml/2006/main" xmlns:r="http://schemas.openxmlformats.org/officeDocument/2006/relationships">
+  <p:cSld>
+    <p:bg>
+      <p:bgPr>
+        <a:solidFill>
+          <a:srgbClr val="FCFCFB"/>
+        </a:solidFill>
+        <a:effectLst/>
+      </p:bgPr>
+    </p:bg>
+    <p:spTree>
+      <p:nvGrpSpPr>
+        <p:cNvPr id="1" name=""/>
+        <p:cNvGrpSpPr/>
+        <p:nvPr/>
+      </p:nvGrpSpPr>
+      <p:grpSpPr/>
+      <p:sp>
+        <p:nvSpPr>
+          <p:cNvPr id="2" name="TextBox 1"/>
+          <p:cNvSpPr txBox="1"/>
+          <p:nvPr/>
+        </p:nvSpPr>
+        <p:spPr>
+          <a:xfrm>
+            <a:off x="566928" y="502920"/>
+            <a:ext cx="4160520" cy="274320"/>
+          </a:xfrm>
+          <a:prstGeom prst="rect">
+            <a:avLst/>
+          </a:prstGeom>
+          <a:noFill/>
+        </p:spPr>
+        <p:txBody>
+          <a:bodyPr wrap="square" lIns="0" rIns="0" tIns="0" bIns="0">
+            <a:spAutoFit/>
+          </a:bodyPr>
+          <a:lstStyle/>
+          <a:p>
+            <a:pPr>
+              <a:spcBef>
+                <a:spcPts val="0"/>
+              </a:spcBef>
+              <a:spcAft>
+                <a:spcPts val="0"/>
+              </a:spcAft>
+            </a:pPr>
+            <a:r>
+              <a:rPr sz="1000" b="0" i="0">
+                <a:solidFill>
+                  <a:srgbClr val="A63A30"/>
+                </a:solidFill>
+                <a:latin typeface="Consolas"/>
+              </a:rPr>
+              <a:t>WITHIN-COUNTRY EVIDENCE</a:t>
+            </a:r>
+          </a:p>
+        </p:txBody>
+      </p:sp>
+      <p:sp>
+        <p:nvSpPr>
+          <p:cNvPr id="3" name="TextBox 2"/>
+          <p:cNvSpPr txBox="1"/>
+          <p:nvPr/>
+        </p:nvSpPr>
+        <p:spPr>
+          <a:xfrm>
+            <a:off x="566928" y="914400"/>
+            <a:ext cx="4160520" cy="1371600"/>
+          </a:xfrm>
+          <a:prstGeom prst="rect">
+            <a:avLst/>
+          </a:prstGeom>
+          <a:noFill/>
+        </p:spPr>
+        <p:txBody>
+          <a:bodyPr wrap="square" lIns="0" rIns="0" tIns="0" bIns="0">
+            <a:spAutoFit/>
+          </a:bodyPr>
+          <a:lstStyle/>
+          <a:p>
+            <a:pPr>
+              <a:lnSpc>
+                <a:spcPct val="108000"/>
+              </a:lnSpc>
+              <a:spcBef>
+                <a:spcPts val="0"/>
+              </a:spcBef>
+              <a:spcAft>
+                <a:spcPts val="0"/>
+              </a:spcAft>
+            </a:pPr>
+            <a:r>
+              <a:rPr sz="2300" b="0" i="0">
+                <a:solidFill>
+                  <a:srgbClr val="14171C"/>
+                </a:solidFill>
+                <a:latin typeface="Georgia"/>
+              </a:rPr>
+              <a:t>Individual-level, self-reported data captures year-to-year change that administrative frameworks miss</a:t>
+            </a:r>
+          </a:p>
+        </p:txBody>
+      </p:sp>
+      <p:sp>
+        <p:nvSpPr>
+          <p:cNvPr id="4" name="TextBox 3"/>
+          <p:cNvSpPr txBox="1"/>
+          <p:nvPr/>
+        </p:nvSpPr>
+        <p:spPr>
+          <a:xfrm>
+            <a:off x="566928" y="2331720"/>
+            <a:ext cx="4160520" cy="3840480"/>
+          </a:xfrm>
+          <a:prstGeom prst="rect">
+            <a:avLst/>
+          </a:prstGeom>
+          <a:noFill/>
+        </p:spPr>
+        <p:txBody>
+          <a:bodyPr wrap="square" lIns="0" rIns="0" tIns="0" bIns="0">
+            <a:spAutoFit/>
+          </a:bodyPr>
+          <a:lstStyle/>
+          <a:p>
+            <a:pPr>
+              <a:lnSpc>
+                <a:spcPct val="132000"/>
+              </a:lnSpc>
+              <a:spcBef>
+                <a:spcPts val="0"/>
+              </a:spcBef>
+              <a:spcAft>
+                <a:spcPts val="1100"/>
+              </a:spcAft>
+            </a:pPr>
+            <a:r>
+              <a:rPr sz="975" b="0" i="0">
+                <a:solidFill>
+                  <a:srgbClr val="5A6068"/>
+                </a:solidFill>
+                <a:latin typeface="Calibri"/>
+              </a:rPr>
+              <a:t>Here is the critical observation that reshapes the question: unlike SDG (71% levels → 5% differences) and HDI (42% → 2%), the ESS shows 69% levels → 64% differences. The association persists within countries over time. This is not because development frameworks are poorly designed; it is because they measure aggregate, administrative data at long intervals (annual at best for HDI and SDG). Individual survey responses capture year-to-year variation in how people experience their lives.</a:t>
+            </a:r>
+          </a:p>
+          <a:p>
+            <a:pPr>
+              <a:lnSpc>
+                <a:spcPct val="132000"/>
+              </a:lnSpc>
+              <a:spcBef>
+                <a:spcPts val="0"/>
+              </a:spcBef>
+              <a:spcAft>
+                <a:spcPts val="1100"/>
+              </a:spcAft>
+            </a:pPr>
+            <a:r>
+              <a:rPr sz="975" b="0" i="0">
+                <a:solidFill>
+                  <a:srgbClr val="5A6068"/>
+                </a:solidFill>
+                <a:latin typeface="Calibri"/>
+              </a:rPr>
+              <a:t>This matters for social trust most of all. At the country level, SDG has almost no trust coverage; in the HDI, none. But at the individual level, within countries, ESS shows trust is significant in 94% of countries and drives year-to-year change in how satisfied people report being. The three domains emerge not because the frameworks reveal them, but because ESS measures them where people actually experience variation: in themselves, over time.</a:t>
+            </a:r>
+          </a:p>
+          <a:p>
+            <a:pPr>
+              <a:lnSpc>
+                <a:spcPct val="132000"/>
+              </a:lnSpc>
+              <a:spcBef>
+                <a:spcPts val="0"/>
+              </a:spcBef>
+              <a:spcAft>
+                <a:spcPts val="1100"/>
+              </a:spcAft>
+            </a:pPr>
+            <a:r>
+              <a:rPr sz="975" b="0" i="0">
+                <a:solidFill>
+                  <a:srgbClr val="5A6068"/>
+                </a:solidFill>
+                <a:latin typeface="Calibri"/>
+              </a:rPr>
+              <a:t>The caveats are substantial: 36 European countries, self-reported measures, annual cycles. But the implication is clear. Development frameworks' blindness to social trust is not because trust does not matter for wellbeing; it is because development was never designed to measure individual experience at the temporal resolution where people change.</a:t>
+            </a:r>
+          </a:p>
+        </p:txBody>
+      </p:sp>
+      <p:sp>
+        <p:nvSpPr>
+          <p:cNvPr id="5" name="TextBox 4"/>
+          <p:cNvSpPr txBox="1"/>
+          <p:nvPr/>
+        </p:nvSpPr>
+        <p:spPr>
+          <a:xfrm>
+            <a:off x="11338560" y="6263640"/>
+            <a:ext cx="548640" cy="274320"/>
+          </a:xfrm>
+          <a:prstGeom prst="rect">
+            <a:avLst/>
+          </a:prstGeom>
+          <a:noFill/>
+        </p:spPr>
+        <p:txBody>
+          <a:bodyPr wrap="square" lIns="0" rIns="0" tIns="0" bIns="0">
+            <a:spAutoFit/>
+          </a:bodyPr>
+          <a:lstStyle/>
+          <a:p>
+            <a:pPr algn="r">
+              <a:spcBef>
+                <a:spcPts val="0"/>
+              </a:spcBef>
+              <a:spcAft>
+                <a:spcPts val="0"/>
+              </a:spcAft>
+            </a:pPr>
+            <a:r>
+              <a:rPr sz="1100" b="0" i="0">
+                <a:solidFill>
+                  <a:srgbClr val="868D96"/>
+                </a:solidFill>
+                <a:latin typeface="Consolas"/>
+              </a:rPr>
+              <a:t>III</a:t>
+            </a:r>
+          </a:p>
+        </p:txBody>
+      </p:sp>
+      <p:pic>
+        <p:nvPicPr>
+          <p:cNvPr id="6" name="Picture 5" descr="collapse_shdi_ess_regional.png"/>
+          <p:cNvPicPr>
+            <a:picLocks noChangeAspect="1"/>
+          </p:cNvPicPr>
+          <p:nvPr/>
+        </p:nvPicPr>
+        <p:blipFill>
+          <a:blip r:embed="rId2"/>
+          <a:stretch>
+            <a:fillRect/>
+          </a:stretch>
+        </p:blipFill>
+        <p:spPr>
+          <a:xfrm>
+            <a:off x="5546146" y="658368"/>
+            <a:ext cx="5686948" cy="5074919"/>
+          </a:xfrm>
+          <a:prstGeom prst="rect">
+            <a:avLst/>
+          </a:prstGeom>
+        </p:spPr>
+      </p:pic>
+      <p:sp>
+        <p:nvSpPr>
+          <p:cNvPr id="7" name="TextBox 6"/>
+          <p:cNvSpPr txBox="1"/>
+          <p:nvPr/>
+        </p:nvSpPr>
+        <p:spPr>
+          <a:xfrm>
+            <a:off x="5120640" y="5897880"/>
+            <a:ext cx="6537960" cy="731520"/>
+          </a:xfrm>
+          <a:prstGeom prst="rect">
+            <a:avLst/>
+          </a:prstGeom>
+          <a:noFill/>
+        </p:spPr>
+        <p:txBody>
+          <a:bodyPr wrap="square" lIns="0" rIns="0" tIns="0" bIns="0">
+            <a:spAutoFit/>
+          </a:bodyPr>
+          <a:lstStyle/>
+          <a:p>
+            <a:pPr>
+              <a:lnSpc>
+                <a:spcPct val="125000"/>
+              </a:lnSpc>
+              <a:spcBef>
+                <a:spcPts val="0"/>
+              </a:spcBef>
+              <a:spcAft>
+                <a:spcPts val="0"/>
+              </a:spcAft>
+            </a:pPr>
+            <a:r>
+              <a:rPr sz="900" b="0" i="0">
+                <a:solidFill>
+                  <a:srgbClr val="868D96"/>
+                </a:solidFill>
+                <a:latin typeface="Calibri"/>
+              </a:rPr>
+              <a:t>Regional collapse: 167 subnational regions within ESS countries, levels vs. differences. The collapse persists at regional scale, confirming it is not an artifact of national aggregation.</a:t>
+            </a:r>
+          </a:p>
+        </p:txBody>
+      </p:sp>
+    </p:spTree>
+  </p:cSld>
+  <p:clrMapOvr>
+    <a:masterClrMapping/>
+  </p:clrMapOvr>
+</p:sld>
+</file>
+
+<file path=ppt/slides/slide22.xml><?xml version="1.0" encoding="utf-8"?>
+<p:sld xmlns:a="http://schemas.openxmlformats.org/drawingml/2006/main" xmlns:p="http://schemas.openxmlformats.org/presentationml/2006/main" xmlns:r="http://schemas.openxmlformats.org/officeDocument/2006/relationships">
+  <p:cSld>
+    <p:bg>
+      <p:bgPr>
+        <a:solidFill>
+          <a:srgbClr val="FCFCFB"/>
+        </a:solidFill>
+        <a:effectLst/>
+      </p:bgPr>
+    </p:bg>
+    <p:spTree>
+      <p:nvGrpSpPr>
+        <p:cNvPr id="1" name=""/>
+        <p:cNvGrpSpPr/>
+        <p:nvPr/>
+      </p:nvGrpSpPr>
+      <p:grpSpPr/>
+      <p:sp>
+        <p:nvSpPr>
+          <p:cNvPr id="2" name="TextBox 1"/>
+          <p:cNvSpPr txBox="1"/>
+          <p:nvPr/>
+        </p:nvSpPr>
+        <p:spPr>
+          <a:xfrm>
+            <a:off x="566928" y="502920"/>
+            <a:ext cx="4160520" cy="274320"/>
+          </a:xfrm>
+          <a:prstGeom prst="rect">
+            <a:avLst/>
+          </a:prstGeom>
+          <a:noFill/>
+        </p:spPr>
+        <p:txBody>
+          <a:bodyPr wrap="square" lIns="0" rIns="0" tIns="0" bIns="0">
+            <a:spAutoFit/>
+          </a:bodyPr>
+          <a:lstStyle/>
+          <a:p>
+            <a:pPr>
+              <a:spcBef>
+                <a:spcPts val="0"/>
+              </a:spcBef>
+              <a:spcAft>
+                <a:spcPts val="0"/>
+              </a:spcAft>
+            </a:pPr>
+            <a:r>
+              <a:rPr sz="1000" b="0" i="0">
+                <a:solidFill>
+                  <a:srgbClr val="A63A30"/>
+                </a:solidFill>
+                <a:latin typeface="Consolas"/>
+              </a:rPr>
+              <a:t>WHY SDG'S TRUST DATA DOESN'T WORK</a:t>
+            </a:r>
+          </a:p>
+        </p:txBody>
+      </p:sp>
+      <p:sp>
+        <p:nvSpPr>
+          <p:cNvPr id="3" name="TextBox 2"/>
+          <p:cNvSpPr txBox="1"/>
+          <p:nvPr/>
+        </p:nvSpPr>
+        <p:spPr>
+          <a:xfrm>
+            <a:off x="566928" y="914400"/>
+            <a:ext cx="4160520" cy="1371600"/>
+          </a:xfrm>
+          <a:prstGeom prst="rect">
+            <a:avLst/>
+          </a:prstGeom>
+          <a:noFill/>
+        </p:spPr>
+        <p:txBody>
+          <a:bodyPr wrap="square" lIns="0" rIns="0" tIns="0" bIns="0">
+            <a:spAutoFit/>
+          </a:bodyPr>
+          <a:lstStyle/>
+          <a:p>
+            <a:pPr>
+              <a:lnSpc>
+                <a:spcPct val="108000"/>
+              </a:lnSpc>
+              <a:spcBef>
+                <a:spcPts val="0"/>
+              </a:spcBef>
+              <a:spcAft>
+                <a:spcPts val="0"/>
+              </a:spcAft>
+            </a:pPr>
+            <a:r>
+              <a:rPr sz="2300" b="0" i="0">
+                <a:solidFill>
+                  <a:srgbClr val="14171C"/>
+                </a:solidFill>
+                <a:latin typeface="Georgia"/>
+              </a:rPr>
+              <a:t>SDG16 measures institutional confidence, not interpersonal trust, and the signal is weak</a:t>
+            </a:r>
+          </a:p>
+        </p:txBody>
+      </p:sp>
+      <p:sp>
+        <p:nvSpPr>
+          <p:cNvPr id="4" name="TextBox 3"/>
+          <p:cNvSpPr txBox="1"/>
+          <p:nvPr/>
+        </p:nvSpPr>
+        <p:spPr>
+          <a:xfrm>
+            <a:off x="566928" y="2331720"/>
+            <a:ext cx="4160520" cy="3840480"/>
+          </a:xfrm>
+          <a:prstGeom prst="rect">
+            <a:avLst/>
+          </a:prstGeom>
+          <a:noFill/>
+        </p:spPr>
+        <p:txBody>
+          <a:bodyPr wrap="square" lIns="0" rIns="0" tIns="0" bIns="0">
+            <a:spAutoFit/>
+          </a:bodyPr>
+          <a:lstStyle/>
+          <a:p>
+            <a:pPr>
+              <a:lnSpc>
+                <a:spcPct val="132000"/>
+              </a:lnSpc>
+              <a:spcBef>
+                <a:spcPts val="0"/>
+              </a:spcBef>
+              <a:spcAft>
+                <a:spcPts val="1100"/>
+              </a:spcAft>
+            </a:pPr>
+            <a:r>
+              <a:rPr sz="950" b="0" i="0">
+                <a:solidFill>
+                  <a:srgbClr val="5A6068"/>
+                </a:solidFill>
+                <a:latin typeface="Calibri"/>
+              </a:rPr>
+              <a:t>The SDG framework carries 13 trust-adjacent series under Goal 16, but the detail reveals why they fail. First, coverage: only nine of thirteen can be tested across countries, and four are significant — weaker than the development indicators the frameworks already carry. Second, construct: bribery (individuals), bribery (firms), and decision-making inclusiveness predict the Cantril ladder; satisfaction with healthcare, government services, and secondary education do not. These measure satisfaction with institutions, not trust in people.</a:t>
+            </a:r>
+          </a:p>
+          <a:p>
+            <a:pPr>
+              <a:lnSpc>
+                <a:spcPct val="132000"/>
+              </a:lnSpc>
+              <a:spcBef>
+                <a:spcPts val="0"/>
+              </a:spcBef>
+              <a:spcAft>
+                <a:spcPts val="1100"/>
+              </a:spcAft>
+            </a:pPr>
+            <a:r>
+              <a:rPr sz="950" b="0" i="0">
+                <a:solidFill>
+                  <a:srgbClr val="5A6068"/>
+                </a:solidFill>
+                <a:latin typeface="Calibri"/>
+              </a:rPr>
+              <a:t>More critically, when you control for income — net of log GNI per capita — nearly all SDG trust series disappear. Bribery stays significant, but satisfaction with government, services, and education vanishes. This is a known artifact of subjective institutional scales across income levels; the same survey administered at different income levels produces structural differences in response patterns unrelated to trust itself. Interpersonal trust, by contrast, shows robust signal independent of income controls.</a:t>
+            </a:r>
+          </a:p>
+          <a:p>
+            <a:pPr>
+              <a:lnSpc>
+                <a:spcPct val="132000"/>
+              </a:lnSpc>
+              <a:spcBef>
+                <a:spcPts val="0"/>
+              </a:spcBef>
+              <a:spcAft>
+                <a:spcPts val="1100"/>
+              </a:spcAft>
+            </a:pPr>
+            <a:r>
+              <a:rPr sz="950" b="0" i="0">
+                <a:solidFill>
+                  <a:srgbClr val="5A6068"/>
+                </a:solidFill>
+                <a:latin typeface="Calibri"/>
+              </a:rPr>
+              <a:t>This is not a flaw in the SDG framework's execution. It reflects a fundamental choice: development frameworks measure institutions and systems, not personal relationships. Social trust emerges in individual-level, self-reported data because that is where it lives — in how people experience their immediate world.</a:t>
+            </a:r>
+          </a:p>
+        </p:txBody>
+      </p:sp>
+      <p:sp>
+        <p:nvSpPr>
+          <p:cNvPr id="5" name="TextBox 4"/>
+          <p:cNvSpPr txBox="1"/>
+          <p:nvPr/>
+        </p:nvSpPr>
+        <p:spPr>
+          <a:xfrm>
+            <a:off x="11338560" y="6263640"/>
+            <a:ext cx="548640" cy="274320"/>
+          </a:xfrm>
+          <a:prstGeom prst="rect">
+            <a:avLst/>
+          </a:prstGeom>
+          <a:noFill/>
+        </p:spPr>
+        <p:txBody>
+          <a:bodyPr wrap="square" lIns="0" rIns="0" tIns="0" bIns="0">
+            <a:spAutoFit/>
+          </a:bodyPr>
+          <a:lstStyle/>
+          <a:p>
+            <a:pPr algn="r">
+              <a:spcBef>
+                <a:spcPts val="0"/>
+              </a:spcBef>
+              <a:spcAft>
+                <a:spcPts val="0"/>
+              </a:spcAft>
+            </a:pPr>
+            <a:r>
+              <a:rPr sz="1100" b="0" i="0">
+                <a:solidFill>
+                  <a:srgbClr val="868D96"/>
+                </a:solidFill>
+                <a:latin typeface="Consolas"/>
+              </a:rPr>
+              <a:t>III</a:t>
+            </a:r>
+          </a:p>
+        </p:txBody>
+      </p:sp>
+      <p:pic>
+        <p:nvPicPr>
+          <p:cNvPr id="6" name="Picture 5" descr="K1_sdg_trust_cross_section.png"/>
+          <p:cNvPicPr>
+            <a:picLocks noChangeAspect="1"/>
+          </p:cNvPicPr>
+          <p:nvPr/>
+        </p:nvPicPr>
+        <p:blipFill>
+          <a:blip r:embed="rId2"/>
+          <a:stretch>
+            <a:fillRect/>
+          </a:stretch>
+        </p:blipFill>
+        <p:spPr>
+          <a:xfrm>
+            <a:off x="5120640" y="1690377"/>
+            <a:ext cx="6537960" cy="3010902"/>
+          </a:xfrm>
+          <a:prstGeom prst="rect">
+            <a:avLst/>
+          </a:prstGeom>
+        </p:spPr>
+      </p:pic>
+      <p:sp>
+        <p:nvSpPr>
+          <p:cNvPr id="7" name="TextBox 6"/>
+          <p:cNvSpPr txBox="1"/>
+          <p:nvPr/>
+        </p:nvSpPr>
+        <p:spPr>
+          <a:xfrm>
+            <a:off x="5120640" y="5897880"/>
+            <a:ext cx="6537960" cy="731520"/>
+          </a:xfrm>
+          <a:prstGeom prst="rect">
+            <a:avLst/>
+          </a:prstGeom>
+          <a:noFill/>
+        </p:spPr>
+        <p:txBody>
+          <a:bodyPr wrap="square" lIns="0" rIns="0" tIns="0" bIns="0">
+            <a:spAutoFit/>
+          </a:bodyPr>
+          <a:lstStyle/>
+          <a:p>
+            <a:pPr>
+              <a:lnSpc>
+                <a:spcPct val="125000"/>
+              </a:lnSpc>
+              <a:spcBef>
+                <a:spcPts val="0"/>
+              </a:spcBef>
+              <a:spcAft>
+                <a:spcPts val="0"/>
+              </a:spcAft>
+            </a:pPr>
+            <a:r>
+              <a:rPr sz="900" b="0" i="0">
+                <a:solidFill>
+                  <a:srgbClr val="868D96"/>
+                </a:solidFill>
+                <a:latin typeface="Calibri"/>
+              </a:rPr>
+              <a:t>SDG16 trust series can barely be tested (9 of 13 measurable, 4 significant) and collapse when controlled for income. Panel (b) shows bribery persists but satisfaction measures disappear.</a:t>
+            </a:r>
+          </a:p>
+        </p:txBody>
+      </p:sp>
+    </p:spTree>
+  </p:cSld>
+  <p:clrMapOvr>
+    <a:masterClrMapping/>
+  </p:clrMapOvr>
+</p:sld>
+</file>
+
+<file path=ppt/slides/slide23.xml><?xml version="1.0" encoding="utf-8"?>
 <p:sld xmlns:a="http://schemas.openxmlformats.org/drawingml/2006/main" xmlns:p="http://schemas.openxmlformats.org/presentationml/2006/main" xmlns:r="http://schemas.openxmlformats.org/officeDocument/2006/relationships">
   <p:cSld>
     <p:bg>
@@ -7494,7 +8147,7 @@
 </p:sld>
 </file>
 
-<file path=ppt/slides/slide22.xml><?xml version="1.0" encoding="utf-8"?>
+<file path=ppt/slides/slide24.xml><?xml version="1.0" encoding="utf-8"?>
 <p:sld xmlns:a="http://schemas.openxmlformats.org/drawingml/2006/main" xmlns:p="http://schemas.openxmlformats.org/presentationml/2006/main" xmlns:r="http://schemas.openxmlformats.org/officeDocument/2006/relationships">
   <p:cSld>
     <p:bg>
@@ -7918,450 +8571,6 @@
                 <a:latin typeface="Calibri"/>
               </a:rPr>
               <a:t>median R² for trust — below income, health, education individually, above none</a:t>
-            </a:r>
-          </a:p>
-        </p:txBody>
-      </p:sp>
-    </p:spTree>
-  </p:cSld>
-  <p:clrMapOvr>
-    <a:masterClrMapping/>
-  </p:clrMapOvr>
-</p:sld>
-</file>
-
-<file path=ppt/slides/slide23.xml><?xml version="1.0" encoding="utf-8"?>
-<p:sld xmlns:a="http://schemas.openxmlformats.org/drawingml/2006/main" xmlns:p="http://schemas.openxmlformats.org/presentationml/2006/main" xmlns:r="http://schemas.openxmlformats.org/officeDocument/2006/relationships">
-  <p:cSld>
-    <p:bg>
-      <p:bgPr>
-        <a:solidFill>
-          <a:srgbClr val="FCFCFB"/>
-        </a:solidFill>
-        <a:effectLst/>
-      </p:bgPr>
-    </p:bg>
-    <p:spTree>
-      <p:nvGrpSpPr>
-        <p:cNvPr id="1" name=""/>
-        <p:cNvGrpSpPr/>
-        <p:nvPr/>
-      </p:nvGrpSpPr>
-      <p:grpSpPr/>
-      <p:sp>
-        <p:nvSpPr>
-          <p:cNvPr id="2" name="TextBox 1"/>
-          <p:cNvSpPr txBox="1"/>
-          <p:nvPr/>
-        </p:nvSpPr>
-        <p:spPr>
-          <a:xfrm>
-            <a:off x="566928" y="502920"/>
-            <a:ext cx="8595360" cy="274320"/>
-          </a:xfrm>
-          <a:prstGeom prst="rect">
-            <a:avLst/>
-          </a:prstGeom>
-          <a:noFill/>
-        </p:spPr>
-        <p:txBody>
-          <a:bodyPr wrap="square" lIns="0" rIns="0" tIns="0" bIns="0">
-            <a:spAutoFit/>
-          </a:bodyPr>
-          <a:lstStyle/>
-          <a:p>
-            <a:pPr>
-              <a:spcBef>
-                <a:spcPts val="0"/>
-              </a:spcBef>
-              <a:spcAft>
-                <a:spcPts val="0"/>
-              </a:spcAft>
-            </a:pPr>
-            <a:r>
-              <a:rPr sz="1000" b="0" i="0">
-                <a:solidFill>
-                  <a:srgbClr val="A63A30"/>
-                </a:solidFill>
-                <a:latin typeface="Consolas"/>
-              </a:rPr>
-              <a:t>THE DISCONNECT</a:t>
-            </a:r>
-          </a:p>
-        </p:txBody>
-      </p:sp>
-      <p:sp>
-        <p:nvSpPr>
-          <p:cNvPr id="3" name="TextBox 2"/>
-          <p:cNvSpPr txBox="1"/>
-          <p:nvPr/>
-        </p:nvSpPr>
-        <p:spPr>
-          <a:xfrm>
-            <a:off x="566928" y="914400"/>
-            <a:ext cx="8595360" cy="1371600"/>
-          </a:xfrm>
-          <a:prstGeom prst="rect">
-            <a:avLst/>
-          </a:prstGeom>
-          <a:noFill/>
-        </p:spPr>
-        <p:txBody>
-          <a:bodyPr wrap="square" lIns="0" rIns="0" tIns="0" bIns="0">
-            <a:spAutoFit/>
-          </a:bodyPr>
-          <a:lstStyle/>
-          <a:p>
-            <a:pPr>
-              <a:lnSpc>
-                <a:spcPct val="108000"/>
-              </a:lnSpc>
-              <a:spcBef>
-                <a:spcPts val="0"/>
-              </a:spcBef>
-              <a:spcAft>
-                <a:spcPts val="0"/>
-              </a:spcAft>
-            </a:pPr>
-            <a:r>
-              <a:rPr sz="2700" b="0" i="0">
-                <a:solidFill>
-                  <a:srgbClr val="14171C"/>
-                </a:solidFill>
-                <a:latin typeface="Georgia"/>
-              </a:rPr>
-              <a:t>These frameworks work for development. They do not work for wellbeing.</a:t>
-            </a:r>
-          </a:p>
-        </p:txBody>
-      </p:sp>
-      <p:sp>
-        <p:nvSpPr>
-          <p:cNvPr id="4" name="TextBox 3"/>
-          <p:cNvSpPr txBox="1"/>
-          <p:nvPr/>
-        </p:nvSpPr>
-        <p:spPr>
-          <a:xfrm>
-            <a:off x="566928" y="2286000"/>
-            <a:ext cx="8595360" cy="3840480"/>
-          </a:xfrm>
-          <a:prstGeom prst="rect">
-            <a:avLst/>
-          </a:prstGeom>
-          <a:noFill/>
-        </p:spPr>
-        <p:txBody>
-          <a:bodyPr wrap="square" lIns="0" rIns="0" tIns="0" bIns="0">
-            <a:spAutoFit/>
-          </a:bodyPr>
-          <a:lstStyle/>
-          <a:p>
-            <a:pPr>
-              <a:lnSpc>
-                <a:spcPct val="132000"/>
-              </a:lnSpc>
-              <a:spcBef>
-                <a:spcPts val="0"/>
-              </a:spcBef>
-              <a:spcAft>
-                <a:spcPts val="1100"/>
-              </a:spcAft>
-            </a:pPr>
-            <a:r>
-              <a:rPr sz="1400" b="0" i="0">
-                <a:solidFill>
-                  <a:srgbClr val="5A6068"/>
-                </a:solidFill>
-                <a:latin typeface="Calibri"/>
-              </a:rPr>
-              <a:t>The HDI and SDG frameworks do not answer the question 'what makes people's lives better?' any more than a global income statistics database answers 'what makes a person happy?' They were designed to track development, measured at the aggregate level, with indicators chosen before the question of individual wellbeing was systematically tested. That is not a design failure; it is the intended scope.</a:t>
-            </a:r>
-          </a:p>
-          <a:p>
-            <a:pPr>
-              <a:lnSpc>
-                <a:spcPct val="132000"/>
-              </a:lnSpc>
-              <a:spcBef>
-                <a:spcPts val="0"/>
-              </a:spcBef>
-              <a:spcAft>
-                <a:spcPts val="1100"/>
-              </a:spcAft>
-            </a:pPr>
-            <a:r>
-              <a:rPr sz="1400" b="0" i="0">
-                <a:solidFill>
-                  <a:srgbClr val="5A6068"/>
-                </a:solidFill>
-                <a:latin typeface="Calibri"/>
-              </a:rPr>
-              <a:t>But it means the gap is structural. Education's access indicators work; pooling them with constructs that do not does not fix wellbeing prediction — it just builds a worse measure. Choosing a variable for health that is closer to saturated than the outcome it predicts is a measurement choice, not an incurable problem. And when a domain is never collected, no amount of better construction on the others will reach it.</a:t>
-            </a:r>
-          </a:p>
-        </p:txBody>
-      </p:sp>
-      <p:sp>
-        <p:nvSpPr>
-          <p:cNvPr id="5" name="TextBox 4"/>
-          <p:cNvSpPr txBox="1"/>
-          <p:nvPr/>
-        </p:nvSpPr>
-        <p:spPr>
-          <a:xfrm>
-            <a:off x="11338560" y="6263640"/>
-            <a:ext cx="548640" cy="274320"/>
-          </a:xfrm>
-          <a:prstGeom prst="rect">
-            <a:avLst/>
-          </a:prstGeom>
-          <a:noFill/>
-        </p:spPr>
-        <p:txBody>
-          <a:bodyPr wrap="square" lIns="0" rIns="0" tIns="0" bIns="0">
-            <a:spAutoFit/>
-          </a:bodyPr>
-          <a:lstStyle/>
-          <a:p>
-            <a:pPr algn="r">
-              <a:spcBef>
-                <a:spcPts val="0"/>
-              </a:spcBef>
-              <a:spcAft>
-                <a:spcPts val="0"/>
-              </a:spcAft>
-            </a:pPr>
-            <a:r>
-              <a:rPr sz="1100" b="0" i="0">
-                <a:solidFill>
-                  <a:srgbClr val="868D96"/>
-                </a:solidFill>
-                <a:latin typeface="Consolas"/>
-              </a:rPr>
-              <a:t>IV</a:t>
-            </a:r>
-          </a:p>
-        </p:txBody>
-      </p:sp>
-    </p:spTree>
-  </p:cSld>
-  <p:clrMapOvr>
-    <a:masterClrMapping/>
-  </p:clrMapOvr>
-</p:sld>
-</file>
-
-<file path=ppt/slides/slide24.xml><?xml version="1.0" encoding="utf-8"?>
-<p:sld xmlns:a="http://schemas.openxmlformats.org/drawingml/2006/main" xmlns:p="http://schemas.openxmlformats.org/presentationml/2006/main" xmlns:r="http://schemas.openxmlformats.org/officeDocument/2006/relationships">
-  <p:cSld>
-    <p:bg>
-      <p:bgPr>
-        <a:solidFill>
-          <a:srgbClr val="FCFCFB"/>
-        </a:solidFill>
-        <a:effectLst/>
-      </p:bgPr>
-    </p:bg>
-    <p:spTree>
-      <p:nvGrpSpPr>
-        <p:cNvPr id="1" name=""/>
-        <p:cNvGrpSpPr/>
-        <p:nvPr/>
-      </p:nvGrpSpPr>
-      <p:grpSpPr/>
-      <p:sp>
-        <p:nvSpPr>
-          <p:cNvPr id="2" name="TextBox 1"/>
-          <p:cNvSpPr txBox="1"/>
-          <p:nvPr/>
-        </p:nvSpPr>
-        <p:spPr>
-          <a:xfrm>
-            <a:off x="566928" y="502920"/>
-            <a:ext cx="8595360" cy="274320"/>
-          </a:xfrm>
-          <a:prstGeom prst="rect">
-            <a:avLst/>
-          </a:prstGeom>
-          <a:noFill/>
-        </p:spPr>
-        <p:txBody>
-          <a:bodyPr wrap="square" lIns="0" rIns="0" tIns="0" bIns="0">
-            <a:spAutoFit/>
-          </a:bodyPr>
-          <a:lstStyle/>
-          <a:p>
-            <a:pPr>
-              <a:spcBef>
-                <a:spcPts val="0"/>
-              </a:spcBef>
-              <a:spcAft>
-                <a:spcPts val="0"/>
-              </a:spcAft>
-            </a:pPr>
-            <a:r>
-              <a:rPr sz="1000" b="0" i="0">
-                <a:solidFill>
-                  <a:srgbClr val="A63A30"/>
-                </a:solidFill>
-                <a:latin typeface="Consolas"/>
-              </a:rPr>
-              <a:t>IMPLICATION 1 · MEASUREMENT CHOICES CONSTRAIN WHAT FRAMEWORKS CAN SEE</a:t>
-            </a:r>
-          </a:p>
-        </p:txBody>
-      </p:sp>
-      <p:sp>
-        <p:nvSpPr>
-          <p:cNvPr id="3" name="TextBox 2"/>
-          <p:cNvSpPr txBox="1"/>
-          <p:nvPr/>
-        </p:nvSpPr>
-        <p:spPr>
-          <a:xfrm>
-            <a:off x="566928" y="914400"/>
-            <a:ext cx="8595360" cy="1371600"/>
-          </a:xfrm>
-          <a:prstGeom prst="rect">
-            <a:avLst/>
-          </a:prstGeom>
-          <a:noFill/>
-        </p:spPr>
-        <p:txBody>
-          <a:bodyPr wrap="square" lIns="0" rIns="0" tIns="0" bIns="0">
-            <a:spAutoFit/>
-          </a:bodyPr>
-          <a:lstStyle/>
-          <a:p>
-            <a:pPr>
-              <a:lnSpc>
-                <a:spcPct val="108000"/>
-              </a:lnSpc>
-              <a:spcBef>
-                <a:spcPts val="0"/>
-              </a:spcBef>
-              <a:spcAft>
-                <a:spcPts val="0"/>
-              </a:spcAft>
-            </a:pPr>
-            <a:r>
-              <a:rPr sz="2700" b="0" i="0">
-                <a:solidFill>
-                  <a:srgbClr val="14171C"/>
-                </a:solidFill>
-                <a:latin typeface="Georgia"/>
-              </a:rPr>
-              <a:t>Education and health: the case for measurement specificity</a:t>
-            </a:r>
-          </a:p>
-        </p:txBody>
-      </p:sp>
-      <p:sp>
-        <p:nvSpPr>
-          <p:cNvPr id="4" name="TextBox 3"/>
-          <p:cNvSpPr txBox="1"/>
-          <p:nvPr/>
-        </p:nvSpPr>
-        <p:spPr>
-          <a:xfrm>
-            <a:off x="566928" y="2286000"/>
-            <a:ext cx="8595360" cy="3840480"/>
-          </a:xfrm>
-          <a:prstGeom prst="rect">
-            <a:avLst/>
-          </a:prstGeom>
-          <a:noFill/>
-        </p:spPr>
-        <p:txBody>
-          <a:bodyPr wrap="square" lIns="0" rIns="0" tIns="0" bIns="0">
-            <a:spAutoFit/>
-          </a:bodyPr>
-          <a:lstStyle/>
-          <a:p>
-            <a:pPr>
-              <a:lnSpc>
-                <a:spcPct val="132000"/>
-              </a:lnSpc>
-              <a:spcBef>
-                <a:spcPts val="0"/>
-              </a:spcBef>
-              <a:spcAft>
-                <a:spcPts val="1100"/>
-              </a:spcAft>
-            </a:pPr>
-            <a:r>
-              <a:rPr sz="1400" b="0" i="0">
-                <a:solidFill>
-                  <a:srgbClr val="5A6068"/>
-                </a:solidFill>
-                <a:latin typeface="Calibri"/>
-              </a:rPr>
-              <a:t>Education is significant everywhere it is measured as attainment, but nearly invisible in SDG4 because most indicators measure something else. Health is nearly invisible in the HDI because life expectancy has saturated. Neither domain has changed; the frameworks' construction choices have.</a:t>
-            </a:r>
-          </a:p>
-          <a:p>
-            <a:pPr>
-              <a:lnSpc>
-                <a:spcPct val="132000"/>
-              </a:lnSpc>
-              <a:spcBef>
-                <a:spcPts val="0"/>
-              </a:spcBef>
-              <a:spcAft>
-                <a:spcPts val="1100"/>
-              </a:spcAft>
-            </a:pPr>
-            <a:r>
-              <a:rPr sz="1400" b="0" i="0">
-                <a:solidFill>
-                  <a:srgbClr val="5A6068"/>
-                </a:solidFill>
-                <a:latin typeface="Calibri"/>
-              </a:rPr>
-              <a:t>For education, this suggests development measurement should weigh access and completion more heavily than parity ratios in wellbeing contexts — not universally, but with explicit construction choices that account for what is known to matter. For health, it suggests that wellbeing-motivated measurement may need different variables at different development levels: life expectancy in lower-income settings, self-reported health or specific conditions in saturated ones.</a:t>
-            </a:r>
-          </a:p>
-        </p:txBody>
-      </p:sp>
-      <p:sp>
-        <p:nvSpPr>
-          <p:cNvPr id="5" name="TextBox 4"/>
-          <p:cNvSpPr txBox="1"/>
-          <p:nvPr/>
-        </p:nvSpPr>
-        <p:spPr>
-          <a:xfrm>
-            <a:off x="11338560" y="6263640"/>
-            <a:ext cx="548640" cy="274320"/>
-          </a:xfrm>
-          <a:prstGeom prst="rect">
-            <a:avLst/>
-          </a:prstGeom>
-          <a:noFill/>
-        </p:spPr>
-        <p:txBody>
-          <a:bodyPr wrap="square" lIns="0" rIns="0" tIns="0" bIns="0">
-            <a:spAutoFit/>
-          </a:bodyPr>
-          <a:lstStyle/>
-          <a:p>
-            <a:pPr algn="r">
-              <a:spcBef>
-                <a:spcPts val="0"/>
-              </a:spcBef>
-              <a:spcAft>
-                <a:spcPts val="0"/>
-              </a:spcAft>
-            </a:pPr>
-            <a:r>
-              <a:rPr sz="1100" b="0" i="0">
-                <a:solidFill>
-                  <a:srgbClr val="868D96"/>
-                </a:solidFill>
-                <a:latin typeface="Consolas"/>
-              </a:rPr>
-              <a:t>IV</a:t>
             </a:r>
           </a:p>
         </p:txBody>
@@ -8429,7 +8638,7 @@
                 </a:solidFill>
                 <a:latin typeface="Consolas"/>
               </a:rPr>
-              <a:t>IMPLICATION 2 · COVERAGE GAPS ARE MORE FUNDAMENTAL THAN CONSTRUCT CHOICE</a:t>
+              <a:t>THE DISCONNECT</a:t>
             </a:r>
           </a:p>
         </p:txBody>
@@ -8474,7 +8683,7 @@
                 </a:solidFill>
                 <a:latin typeface="Georgia"/>
               </a:rPr>
-              <a:t>Social trust: why you cannot fix a measurement by measuring better</a:t>
+              <a:t>These frameworks work for development. They do not work for wellbeing.</a:t>
             </a:r>
           </a:p>
         </p:txBody>
@@ -8519,7 +8728,7 @@
                 </a:solidFill>
                 <a:latin typeface="Calibri"/>
               </a:rPr>
-              <a:t>Social trust is the most tentative finding here. The ESS is Europe-only, across 36 countries, and relies on a single item. That bounds the claim: the pattern holds in Europe, with a wellbeing survey, on a self-report basis. It does not claim universality.</a:t>
+              <a:t>The HDI and SDG frameworks do not answer the question 'what makes people's lives better?' any more than a global income statistics database answers 'what makes a person happy?' They were designed to track development, measured at the aggregate level, with indicators chosen before the question of individual wellbeing was systematically tested. That is not a design failure; it is the intended scope.</a:t>
             </a:r>
           </a:p>
           <a:p>
@@ -8541,29 +8750,7 @@
                 </a:solidFill>
                 <a:latin typeface="Calibri"/>
               </a:rPr>
-              <a:t>But the reason it is tentative points to the deepest problem: trust is not collected at global scale in either framework. The SDG database has 13 series adjacent to trust, but they measure institutional confidence, not interpersonal trust, and they are intermittent (147 of 163 country-series have fewer than four years of data). This is not a construct-choice problem that better measurement can solve. It is a coverage gap that requires deciding to collect the data in the first place.</a:t>
-            </a:r>
-          </a:p>
-          <a:p>
-            <a:pPr>
-              <a:lnSpc>
-                <a:spcPct val="132000"/>
-              </a:lnSpc>
-              <a:spcBef>
-                <a:spcPts val="0"/>
-              </a:spcBef>
-              <a:spcAft>
-                <a:spcPts val="1100"/>
-              </a:spcAft>
-            </a:pPr>
-            <a:r>
-              <a:rPr sz="1400" b="0" i="0">
-                <a:solidFill>
-                  <a:srgbClr val="5A6068"/>
-                </a:solidFill>
-                <a:latin typeface="Calibri"/>
-              </a:rPr>
-              <a:t>For wellbeing-conscious development monitoring, this suggests either building interpersonal-trust measurement into the core frameworks, or acknowledging that other surveys (the ESS, Gallup World Poll, World Values Survey) may be more suitable for understanding what shapes lived experience.</a:t>
+              <a:t>But it means the gap is structural. Education's access indicators work; pooling them with constructs that do not does not fix wellbeing prediction — it just builds a worse measure. Choosing a variable for health that is closer to saturated than the outcome it predicts is a measurement choice, not an incurable problem. And when a domain is never collected, no amount of better construction on the others will reach it.</a:t>
             </a:r>
           </a:p>
         </p:txBody>
@@ -8673,7 +8860,7 @@
                 </a:solidFill>
                 <a:latin typeface="Consolas"/>
               </a:rPr>
-              <a:t>CONCLUSION</a:t>
+              <a:t>IMPLICATION 1 · MEASUREMENT CHOICES CONSTRAIN WHAT FRAMEWORKS CAN SEE</a:t>
             </a:r>
           </a:p>
         </p:txBody>
@@ -8718,7 +8905,7 @@
                 </a:solidFill>
                 <a:latin typeface="Georgia"/>
               </a:rPr>
-              <a:t>A question rather than a prescription</a:t>
+              <a:t>Education and health: the case for measurement specificity</a:t>
             </a:r>
           </a:p>
         </p:txBody>
@@ -8763,7 +8950,7 @@
                 </a:solidFill>
                 <a:latin typeface="Calibri"/>
               </a:rPr>
-              <a:t>The evidence shows a consistent pattern: which domain looks most consequential for wellbeing depends on which framework measures it and what variable they chose. This is not about the domains; it is about the tools.</a:t>
+              <a:t>Education is significant everywhere it is measured as attainment, but nearly invisible in SDG4 because most indicators measure something else. Health is nearly invisible in the HDI because life expectancy has saturated. Neither domain has changed; the frameworks' construction choices have.</a:t>
             </a:r>
           </a:p>
           <a:p>
@@ -8785,29 +8972,7 @@
                 </a:solidFill>
                 <a:latin typeface="Calibri"/>
               </a:rPr>
-              <a:t>Whether development frameworks should be redesigned around wellbeing is outside the scope here. But if they were, this finding suggests the question to ask: should measurement choices be made with explicit reference to which variables still move and still matter for lived experience? Should coverage be built in for domains the frameworks discovered only by studying something else?</a:t>
-            </a:r>
-          </a:p>
-          <a:p>
-            <a:pPr>
-              <a:lnSpc>
-                <a:spcPct val="132000"/>
-              </a:lnSpc>
-              <a:spcBef>
-                <a:spcPts val="0"/>
-              </a:spcBef>
-              <a:spcAft>
-                <a:spcPts val="1100"/>
-              </a:spcAft>
-            </a:pPr>
-            <a:r>
-              <a:rPr sz="1400" b="0" i="0">
-                <a:solidFill>
-                  <a:srgbClr val="5A6068"/>
-                </a:solidFill>
-                <a:latin typeface="Calibri"/>
-              </a:rPr>
-              <a:t>The frameworks work well for their stated purpose. The question is whether wellbeing should become part of that purpose — and if it does, whether the measurement that comes from that intent should be different from the aggregate, development-first measurement in place today.</a:t>
+              <a:t>For education, this suggests development measurement should weigh access and completion more heavily than parity ratios in wellbeing contexts — not universally, but with explicit construction choices that account for what is known to matter. For health, it suggests that wellbeing-motivated measurement may need different variables at different development levels: life expectancy in lower-income settings, self-reported health or specific conditions in saturated ones.</a:t>
             </a:r>
           </a:p>
         </p:txBody>
@@ -8868,7 +9033,7 @@
     <p:bg>
       <p:bgPr>
         <a:solidFill>
-          <a:srgbClr val="E8EBEF"/>
+          <a:srgbClr val="FCFCFB"/>
         </a:solidFill>
         <a:effectLst/>
       </p:bgPr>
@@ -8882,45 +9047,43 @@
       <p:grpSpPr/>
       <p:sp>
         <p:nvSpPr>
-          <p:cNvPr id="2" name="Rectangle 1"/>
-          <p:cNvSpPr/>
-          <p:nvPr/>
-        </p:nvSpPr>
-        <p:spPr>
-          <a:xfrm>
-            <a:off x="566928" y="2103120"/>
-            <a:ext cx="54864" cy="2377440"/>
-          </a:xfrm>
-          <a:prstGeom prst="rect">
-            <a:avLst/>
-          </a:prstGeom>
-          <a:solidFill>
-            <a:srgbClr val="17549E"/>
-          </a:solidFill>
-          <a:ln>
-            <a:noFill/>
-          </a:ln>
-          <a:effectLst/>
-        </p:spPr>
-        <p:style>
-          <a:lnRef idx="1">
-            <a:schemeClr val="accent1"/>
-          </a:lnRef>
-          <a:fillRef idx="3">
-            <a:schemeClr val="accent1"/>
-          </a:fillRef>
-          <a:effectRef idx="2">
-            <a:schemeClr val="accent1"/>
-          </a:effectRef>
-          <a:fontRef idx="minor">
-            <a:schemeClr val="lt1"/>
-          </a:fontRef>
-        </p:style>
-        <p:txBody>
-          <a:bodyPr rtlCol="0" anchor="ctr"/>
-          <a:lstStyle/>
-          <a:p>
-            <a:pPr algn="ctr"/>
+          <p:cNvPr id="2" name="TextBox 1"/>
+          <p:cNvSpPr txBox="1"/>
+          <p:nvPr/>
+        </p:nvSpPr>
+        <p:spPr>
+          <a:xfrm>
+            <a:off x="566928" y="502920"/>
+            <a:ext cx="8595360" cy="274320"/>
+          </a:xfrm>
+          <a:prstGeom prst="rect">
+            <a:avLst/>
+          </a:prstGeom>
+          <a:noFill/>
+        </p:spPr>
+        <p:txBody>
+          <a:bodyPr wrap="square" lIns="0" rIns="0" tIns="0" bIns="0">
+            <a:spAutoFit/>
+          </a:bodyPr>
+          <a:lstStyle/>
+          <a:p>
+            <a:pPr>
+              <a:spcBef>
+                <a:spcPts val="0"/>
+              </a:spcBef>
+              <a:spcAft>
+                <a:spcPts val="0"/>
+              </a:spcAft>
+            </a:pPr>
+            <a:r>
+              <a:rPr sz="1000" b="0" i="0">
+                <a:solidFill>
+                  <a:srgbClr val="A63A30"/>
+                </a:solidFill>
+                <a:latin typeface="Consolas"/>
+              </a:rPr>
+              <a:t>IMPLICATION 2 · COVERAGE GAPS ARE MORE FUNDAMENTAL THAN CONSTRUCT CHOICE</a:t>
+            </a:r>
           </a:p>
         </p:txBody>
       </p:sp>
@@ -8932,21 +9095,155 @@
         </p:nvSpPr>
         <p:spPr>
           <a:xfrm>
-            <a:off x="914400" y="1600200"/>
-            <a:ext cx="8686800" cy="274320"/>
-          </a:xfrm>
-          <a:prstGeom prst="rect">
-            <a:avLst/>
-          </a:prstGeom>
-          <a:noFill/>
-        </p:spPr>
-        <p:txBody>
-          <a:bodyPr wrap="square" lIns="0" rIns="0" tIns="0" bIns="0">
-            <a:spAutoFit/>
-          </a:bodyPr>
-          <a:lstStyle/>
-          <a:p>
-            <a:pPr>
+            <a:off x="566928" y="914400"/>
+            <a:ext cx="8595360" cy="1371600"/>
+          </a:xfrm>
+          <a:prstGeom prst="rect">
+            <a:avLst/>
+          </a:prstGeom>
+          <a:noFill/>
+        </p:spPr>
+        <p:txBody>
+          <a:bodyPr wrap="square" lIns="0" rIns="0" tIns="0" bIns="0">
+            <a:spAutoFit/>
+          </a:bodyPr>
+          <a:lstStyle/>
+          <a:p>
+            <a:pPr>
+              <a:lnSpc>
+                <a:spcPct val="108000"/>
+              </a:lnSpc>
+              <a:spcBef>
+                <a:spcPts val="0"/>
+              </a:spcBef>
+              <a:spcAft>
+                <a:spcPts val="0"/>
+              </a:spcAft>
+            </a:pPr>
+            <a:r>
+              <a:rPr sz="2700" b="0" i="0">
+                <a:solidFill>
+                  <a:srgbClr val="14171C"/>
+                </a:solidFill>
+                <a:latin typeface="Georgia"/>
+              </a:rPr>
+              <a:t>Social trust: why you cannot fix a measurement by measuring better</a:t>
+            </a:r>
+          </a:p>
+        </p:txBody>
+      </p:sp>
+      <p:sp>
+        <p:nvSpPr>
+          <p:cNvPr id="4" name="TextBox 3"/>
+          <p:cNvSpPr txBox="1"/>
+          <p:nvPr/>
+        </p:nvSpPr>
+        <p:spPr>
+          <a:xfrm>
+            <a:off x="566928" y="2286000"/>
+            <a:ext cx="8595360" cy="3840480"/>
+          </a:xfrm>
+          <a:prstGeom prst="rect">
+            <a:avLst/>
+          </a:prstGeom>
+          <a:noFill/>
+        </p:spPr>
+        <p:txBody>
+          <a:bodyPr wrap="square" lIns="0" rIns="0" tIns="0" bIns="0">
+            <a:spAutoFit/>
+          </a:bodyPr>
+          <a:lstStyle/>
+          <a:p>
+            <a:pPr>
+              <a:lnSpc>
+                <a:spcPct val="132000"/>
+              </a:lnSpc>
+              <a:spcBef>
+                <a:spcPts val="0"/>
+              </a:spcBef>
+              <a:spcAft>
+                <a:spcPts val="1100"/>
+              </a:spcAft>
+            </a:pPr>
+            <a:r>
+              <a:rPr sz="1400" b="0" i="0">
+                <a:solidFill>
+                  <a:srgbClr val="5A6068"/>
+                </a:solidFill>
+                <a:latin typeface="Calibri"/>
+              </a:rPr>
+              <a:t>Social trust is the most tentative finding here. The ESS is Europe-only, across 36 countries, and relies on a single item. That bounds the claim: the pattern holds in Europe, with a wellbeing survey, on a self-report basis. It does not claim universality.</a:t>
+            </a:r>
+          </a:p>
+          <a:p>
+            <a:pPr>
+              <a:lnSpc>
+                <a:spcPct val="132000"/>
+              </a:lnSpc>
+              <a:spcBef>
+                <a:spcPts val="0"/>
+              </a:spcBef>
+              <a:spcAft>
+                <a:spcPts val="1100"/>
+              </a:spcAft>
+            </a:pPr>
+            <a:r>
+              <a:rPr sz="1400" b="0" i="0">
+                <a:solidFill>
+                  <a:srgbClr val="5A6068"/>
+                </a:solidFill>
+                <a:latin typeface="Calibri"/>
+              </a:rPr>
+              <a:t>But the reason it is tentative points to the deepest problem: trust is not collected at global scale in either framework. The SDG database has 13 series adjacent to trust, but they measure institutional confidence, not interpersonal trust, and they are intermittent (147 of 163 country-series have fewer than four years of data). This is not a construct-choice problem that better measurement can solve. It is a coverage gap that requires deciding to collect the data in the first place.</a:t>
+            </a:r>
+          </a:p>
+          <a:p>
+            <a:pPr>
+              <a:lnSpc>
+                <a:spcPct val="132000"/>
+              </a:lnSpc>
+              <a:spcBef>
+                <a:spcPts val="0"/>
+              </a:spcBef>
+              <a:spcAft>
+                <a:spcPts val="1100"/>
+              </a:spcAft>
+            </a:pPr>
+            <a:r>
+              <a:rPr sz="1400" b="0" i="0">
+                <a:solidFill>
+                  <a:srgbClr val="5A6068"/>
+                </a:solidFill>
+                <a:latin typeface="Calibri"/>
+              </a:rPr>
+              <a:t>For wellbeing-conscious development monitoring, this suggests either building interpersonal-trust measurement into the core frameworks, or acknowledging that other surveys (the ESS, Gallup World Poll, World Values Survey) may be more suitable for understanding what shapes lived experience.</a:t>
+            </a:r>
+          </a:p>
+        </p:txBody>
+      </p:sp>
+      <p:sp>
+        <p:nvSpPr>
+          <p:cNvPr id="5" name="TextBox 4"/>
+          <p:cNvSpPr txBox="1"/>
+          <p:nvPr/>
+        </p:nvSpPr>
+        <p:spPr>
+          <a:xfrm>
+            <a:off x="11338560" y="6263640"/>
+            <a:ext cx="548640" cy="274320"/>
+          </a:xfrm>
+          <a:prstGeom prst="rect">
+            <a:avLst/>
+          </a:prstGeom>
+          <a:noFill/>
+        </p:spPr>
+        <p:txBody>
+          <a:bodyPr wrap="square" lIns="0" rIns="0" tIns="0" bIns="0">
+            <a:spAutoFit/>
+          </a:bodyPr>
+          <a:lstStyle/>
+          <a:p>
+            <a:pPr algn="r">
               <a:spcBef>
                 <a:spcPts val="0"/>
               </a:spcBef>
@@ -8957,56 +9254,11 @@
             <a:r>
               <a:rPr sz="1100" b="0" i="0">
                 <a:solidFill>
-                  <a:srgbClr val="17549E"/>
+                  <a:srgbClr val="868D96"/>
                 </a:solidFill>
                 <a:latin typeface="Consolas"/>
               </a:rPr>
-              <a:t>WHERE ACT IV LEAVES US</a:t>
-            </a:r>
-          </a:p>
-        </p:txBody>
-      </p:sp>
-      <p:sp>
-        <p:nvSpPr>
-          <p:cNvPr id="4" name="TextBox 3"/>
-          <p:cNvSpPr txBox="1"/>
-          <p:nvPr/>
-        </p:nvSpPr>
-        <p:spPr>
-          <a:xfrm>
-            <a:off x="914400" y="2148840"/>
-            <a:ext cx="9509760" cy="2926080"/>
-          </a:xfrm>
-          <a:prstGeom prst="rect">
-            <a:avLst/>
-          </a:prstGeom>
-          <a:noFill/>
-        </p:spPr>
-        <p:txBody>
-          <a:bodyPr wrap="square" lIns="0" rIns="0" tIns="0" bIns="0">
-            <a:spAutoFit/>
-          </a:bodyPr>
-          <a:lstStyle/>
-          <a:p>
-            <a:pPr>
-              <a:lnSpc>
-                <a:spcPct val="135000"/>
-              </a:lnSpc>
-              <a:spcBef>
-                <a:spcPts val="0"/>
-              </a:spcBef>
-              <a:spcAft>
-                <a:spcPts val="0"/>
-              </a:spcAft>
-            </a:pPr>
-            <a:r>
-              <a:rPr sz="2100" b="0" i="0">
-                <a:solidFill>
-                  <a:srgbClr val="14171C"/>
-                </a:solidFill>
-                <a:latin typeface="Georgia"/>
-              </a:rPr>
-              <a:t>Whether development measurement should be redesigned with wellbeing in mind is beyond this scope. But if it is, this evidence suggests the measurement should be different: more attentive to which variables still move, which constructs predict outcomes, and which domains are collected at all.</a:t>
+              <a:t>IV</a:t>
             </a:r>
           </a:p>
         </p:txBody>
@@ -9046,68 +9298,251 @@
         <p:spPr>
           <a:xfrm>
             <a:off x="566928" y="502920"/>
-            <a:ext cx="8229600" cy="822960"/>
-          </a:xfrm>
-          <a:prstGeom prst="rect">
-            <a:avLst/>
-          </a:prstGeom>
-          <a:noFill/>
-        </p:spPr>
-        <p:txBody>
-          <a:bodyPr wrap="square" lIns="0" rIns="0" tIns="0" bIns="0">
-            <a:spAutoFit/>
-          </a:bodyPr>
-          <a:lstStyle/>
-          <a:p>
-            <a:pPr>
-              <a:spcBef>
-                <a:spcPts val="0"/>
-              </a:spcBef>
-              <a:spcAft>
-                <a:spcPts val="600"/>
-              </a:spcAft>
-            </a:pPr>
-            <a:r>
-              <a:rPr sz="3200" b="0" i="0">
+            <a:ext cx="8595360" cy="274320"/>
+          </a:xfrm>
+          <a:prstGeom prst="rect">
+            <a:avLst/>
+          </a:prstGeom>
+          <a:noFill/>
+        </p:spPr>
+        <p:txBody>
+          <a:bodyPr wrap="square" lIns="0" rIns="0" tIns="0" bIns="0">
+            <a:spAutoFit/>
+          </a:bodyPr>
+          <a:lstStyle/>
+          <a:p>
+            <a:pPr>
+              <a:spcBef>
+                <a:spcPts val="0"/>
+              </a:spcBef>
+              <a:spcAft>
+                <a:spcPts val="0"/>
+              </a:spcAft>
+            </a:pPr>
+            <a:r>
+              <a:rPr sz="1000" b="0" i="0">
+                <a:solidFill>
+                  <a:srgbClr val="A63A30"/>
+                </a:solidFill>
+                <a:latin typeface="Consolas"/>
+              </a:rPr>
+              <a:t>CONCLUSION</a:t>
+            </a:r>
+          </a:p>
+        </p:txBody>
+      </p:sp>
+      <p:sp>
+        <p:nvSpPr>
+          <p:cNvPr id="3" name="TextBox 2"/>
+          <p:cNvSpPr txBox="1"/>
+          <p:nvPr/>
+        </p:nvSpPr>
+        <p:spPr>
+          <a:xfrm>
+            <a:off x="566928" y="914400"/>
+            <a:ext cx="8595360" cy="1371600"/>
+          </a:xfrm>
+          <a:prstGeom prst="rect">
+            <a:avLst/>
+          </a:prstGeom>
+          <a:noFill/>
+        </p:spPr>
+        <p:txBody>
+          <a:bodyPr wrap="square" lIns="0" rIns="0" tIns="0" bIns="0">
+            <a:spAutoFit/>
+          </a:bodyPr>
+          <a:lstStyle/>
+          <a:p>
+            <a:pPr>
+              <a:lnSpc>
+                <a:spcPct val="108000"/>
+              </a:lnSpc>
+              <a:spcBef>
+                <a:spcPts val="0"/>
+              </a:spcBef>
+              <a:spcAft>
+                <a:spcPts val="0"/>
+              </a:spcAft>
+            </a:pPr>
+            <a:r>
+              <a:rPr sz="2700" b="0" i="0">
                 <a:solidFill>
                   <a:srgbClr val="14171C"/>
                 </a:solidFill>
                 <a:latin typeface="Georgia"/>
               </a:rPr>
-              <a:t>Decisions for the team</a:t>
-            </a:r>
-          </a:p>
-          <a:p>
-            <a:pPr>
-              <a:spcBef>
-                <a:spcPts val="0"/>
-              </a:spcBef>
-              <a:spcAft>
-                <a:spcPts val="0"/>
-              </a:spcAft>
-            </a:pPr>
-            <a:r>
-              <a:rPr sz="1300" b="0" i="0">
+              <a:t>A question rather than a prescription</a:t>
+            </a:r>
+          </a:p>
+        </p:txBody>
+      </p:sp>
+      <p:sp>
+        <p:nvSpPr>
+          <p:cNvPr id="4" name="TextBox 3"/>
+          <p:cNvSpPr txBox="1"/>
+          <p:nvPr/>
+        </p:nvSpPr>
+        <p:spPr>
+          <a:xfrm>
+            <a:off x="566928" y="2286000"/>
+            <a:ext cx="8595360" cy="3840480"/>
+          </a:xfrm>
+          <a:prstGeom prst="rect">
+            <a:avLst/>
+          </a:prstGeom>
+          <a:noFill/>
+        </p:spPr>
+        <p:txBody>
+          <a:bodyPr wrap="square" lIns="0" rIns="0" tIns="0" bIns="0">
+            <a:spAutoFit/>
+          </a:bodyPr>
+          <a:lstStyle/>
+          <a:p>
+            <a:pPr>
+              <a:lnSpc>
+                <a:spcPct val="132000"/>
+              </a:lnSpc>
+              <a:spcBef>
+                <a:spcPts val="0"/>
+              </a:spcBef>
+              <a:spcAft>
+                <a:spcPts val="1100"/>
+              </a:spcAft>
+            </a:pPr>
+            <a:r>
+              <a:rPr sz="1400" b="0" i="0">
                 <a:solidFill>
                   <a:srgbClr val="5A6068"/>
                 </a:solidFill>
                 <a:latin typeface="Calibri"/>
               </a:rPr>
-              <a:t>4 things the acts do not settle, in the order they block drafting.</a:t>
-            </a:r>
-          </a:p>
-        </p:txBody>
-      </p:sp>
-      <p:sp>
-        <p:nvSpPr>
-          <p:cNvPr id="3" name="Rectangle 2"/>
+              <a:t>The evidence shows a consistent pattern: which domain looks most consequential for wellbeing depends on which framework measures it and what variable they chose. This is not about the domains; it is about the tools.</a:t>
+            </a:r>
+          </a:p>
+          <a:p>
+            <a:pPr>
+              <a:lnSpc>
+                <a:spcPct val="132000"/>
+              </a:lnSpc>
+              <a:spcBef>
+                <a:spcPts val="0"/>
+              </a:spcBef>
+              <a:spcAft>
+                <a:spcPts val="1100"/>
+              </a:spcAft>
+            </a:pPr>
+            <a:r>
+              <a:rPr sz="1400" b="0" i="0">
+                <a:solidFill>
+                  <a:srgbClr val="5A6068"/>
+                </a:solidFill>
+                <a:latin typeface="Calibri"/>
+              </a:rPr>
+              <a:t>Whether development frameworks should be redesigned around wellbeing is outside the scope here. But if they were, this finding suggests the question to ask: should measurement choices be made with explicit reference to which variables still move and still matter for lived experience? Should coverage be built in for domains the frameworks discovered only by studying something else?</a:t>
+            </a:r>
+          </a:p>
+          <a:p>
+            <a:pPr>
+              <a:lnSpc>
+                <a:spcPct val="132000"/>
+              </a:lnSpc>
+              <a:spcBef>
+                <a:spcPts val="0"/>
+              </a:spcBef>
+              <a:spcAft>
+                <a:spcPts val="1100"/>
+              </a:spcAft>
+            </a:pPr>
+            <a:r>
+              <a:rPr sz="1400" b="0" i="0">
+                <a:solidFill>
+                  <a:srgbClr val="5A6068"/>
+                </a:solidFill>
+                <a:latin typeface="Calibri"/>
+              </a:rPr>
+              <a:t>The frameworks work well for their stated purpose. The question is whether wellbeing should become part of that purpose — and if it does, whether the measurement that comes from that intent should be different from the aggregate, development-first measurement in place today.</a:t>
+            </a:r>
+          </a:p>
+        </p:txBody>
+      </p:sp>
+      <p:sp>
+        <p:nvSpPr>
+          <p:cNvPr id="5" name="TextBox 4"/>
+          <p:cNvSpPr txBox="1"/>
+          <p:nvPr/>
+        </p:nvSpPr>
+        <p:spPr>
+          <a:xfrm>
+            <a:off x="11338560" y="6263640"/>
+            <a:ext cx="548640" cy="274320"/>
+          </a:xfrm>
+          <a:prstGeom prst="rect">
+            <a:avLst/>
+          </a:prstGeom>
+          <a:noFill/>
+        </p:spPr>
+        <p:txBody>
+          <a:bodyPr wrap="square" lIns="0" rIns="0" tIns="0" bIns="0">
+            <a:spAutoFit/>
+          </a:bodyPr>
+          <a:lstStyle/>
+          <a:p>
+            <a:pPr algn="r">
+              <a:spcBef>
+                <a:spcPts val="0"/>
+              </a:spcBef>
+              <a:spcAft>
+                <a:spcPts val="0"/>
+              </a:spcAft>
+            </a:pPr>
+            <a:r>
+              <a:rPr sz="1100" b="0" i="0">
+                <a:solidFill>
+                  <a:srgbClr val="868D96"/>
+                </a:solidFill>
+                <a:latin typeface="Consolas"/>
+              </a:rPr>
+              <a:t>IV</a:t>
+            </a:r>
+          </a:p>
+        </p:txBody>
+      </p:sp>
+    </p:spTree>
+  </p:cSld>
+  <p:clrMapOvr>
+    <a:masterClrMapping/>
+  </p:clrMapOvr>
+</p:sld>
+</file>
+
+<file path=ppt/slides/slide29.xml><?xml version="1.0" encoding="utf-8"?>
+<p:sld xmlns:a="http://schemas.openxmlformats.org/drawingml/2006/main" xmlns:p="http://schemas.openxmlformats.org/presentationml/2006/main" xmlns:r="http://schemas.openxmlformats.org/officeDocument/2006/relationships">
+  <p:cSld>
+    <p:bg>
+      <p:bgPr>
+        <a:solidFill>
+          <a:srgbClr val="E8EBEF"/>
+        </a:solidFill>
+        <a:effectLst/>
+      </p:bgPr>
+    </p:bg>
+    <p:spTree>
+      <p:nvGrpSpPr>
+        <p:cNvPr id="1" name=""/>
+        <p:cNvGrpSpPr/>
+        <p:nvPr/>
+      </p:nvGrpSpPr>
+      <p:grpSpPr/>
+      <p:sp>
+        <p:nvSpPr>
+          <p:cNvPr id="2" name="Rectangle 1"/>
           <p:cNvSpPr/>
           <p:nvPr/>
         </p:nvSpPr>
         <p:spPr>
           <a:xfrm>
-            <a:off x="566928" y="1828800"/>
-            <a:ext cx="3472586" cy="25400"/>
+            <a:off x="566928" y="2103120"/>
+            <a:ext cx="54864" cy="2377440"/>
           </a:xfrm>
           <a:prstGeom prst="rect">
             <a:avLst/>
@@ -9144,458 +9579,67 @@
       </p:sp>
       <p:sp>
         <p:nvSpPr>
+          <p:cNvPr id="3" name="TextBox 2"/>
+          <p:cNvSpPr txBox="1"/>
+          <p:nvPr/>
+        </p:nvSpPr>
+        <p:spPr>
+          <a:xfrm>
+            <a:off x="914400" y="1600200"/>
+            <a:ext cx="8686800" cy="274320"/>
+          </a:xfrm>
+          <a:prstGeom prst="rect">
+            <a:avLst/>
+          </a:prstGeom>
+          <a:noFill/>
+        </p:spPr>
+        <p:txBody>
+          <a:bodyPr wrap="square" lIns="0" rIns="0" tIns="0" bIns="0">
+            <a:spAutoFit/>
+          </a:bodyPr>
+          <a:lstStyle/>
+          <a:p>
+            <a:pPr>
+              <a:spcBef>
+                <a:spcPts val="0"/>
+              </a:spcBef>
+              <a:spcAft>
+                <a:spcPts val="0"/>
+              </a:spcAft>
+            </a:pPr>
+            <a:r>
+              <a:rPr sz="1100" b="0" i="0">
+                <a:solidFill>
+                  <a:srgbClr val="17549E"/>
+                </a:solidFill>
+                <a:latin typeface="Consolas"/>
+              </a:rPr>
+              <a:t>WHERE ACT IV LEAVES US</a:t>
+            </a:r>
+          </a:p>
+        </p:txBody>
+      </p:sp>
+      <p:sp>
+        <p:nvSpPr>
           <p:cNvPr id="4" name="TextBox 3"/>
           <p:cNvSpPr txBox="1"/>
           <p:nvPr/>
         </p:nvSpPr>
         <p:spPr>
           <a:xfrm>
-            <a:off x="566928" y="2011680"/>
-            <a:ext cx="3472586" cy="1828800"/>
-          </a:xfrm>
-          <a:prstGeom prst="rect">
-            <a:avLst/>
-          </a:prstGeom>
-          <a:noFill/>
-        </p:spPr>
-        <p:txBody>
-          <a:bodyPr wrap="square" lIns="0" rIns="0" tIns="0" bIns="0">
-            <a:spAutoFit/>
-          </a:bodyPr>
-          <a:lstStyle/>
-          <a:p>
-            <a:pPr>
-              <a:spcBef>
-                <a:spcPts val="0"/>
-              </a:spcBef>
-              <a:spcAft>
-                <a:spcPts val="700"/>
-              </a:spcAft>
-            </a:pPr>
-            <a:r>
-              <a:rPr sz="1050" b="0" i="0">
-                <a:solidFill>
-                  <a:srgbClr val="17549E"/>
-                </a:solidFill>
-                <a:latin typeface="Consolas"/>
-              </a:rPr>
-              <a:t>FIGURE COUNT</a:t>
-            </a:r>
-          </a:p>
-          <a:p>
-            <a:pPr>
-              <a:lnSpc>
-                <a:spcPct val="130000"/>
-              </a:lnSpc>
-              <a:spcBef>
-                <a:spcPts val="0"/>
-              </a:spcBef>
-              <a:spcAft>
-                <a:spcPts val="0"/>
-              </a:spcAft>
-            </a:pPr>
-            <a:r>
-              <a:rPr sz="1100" b="0" i="0">
-                <a:solidFill>
-                  <a:srgbClr val="5A6068"/>
-                </a:solidFill>
-                <a:latin typeface="Calibri"/>
-              </a:rPr>
-              <a:t>Commentaries allow one or two. Proposed: three-panel composite as Figure 1 and domain scorecard as Figure 2. Everything else supplementary.</a:t>
-            </a:r>
-          </a:p>
-        </p:txBody>
-      </p:sp>
-      <p:sp>
-        <p:nvSpPr>
-          <p:cNvPr id="5" name="Rectangle 4"/>
-          <p:cNvSpPr/>
-          <p:nvPr/>
-        </p:nvSpPr>
-        <p:spPr>
-          <a:xfrm>
-            <a:off x="4359554" y="1828800"/>
-            <a:ext cx="3472586" cy="25400"/>
-          </a:xfrm>
-          <a:prstGeom prst="rect">
-            <a:avLst/>
-          </a:prstGeom>
-          <a:solidFill>
-            <a:srgbClr val="17549E"/>
-          </a:solidFill>
-          <a:ln>
-            <a:noFill/>
-          </a:ln>
-          <a:effectLst/>
-        </p:spPr>
-        <p:style>
-          <a:lnRef idx="1">
-            <a:schemeClr val="accent1"/>
-          </a:lnRef>
-          <a:fillRef idx="3">
-            <a:schemeClr val="accent1"/>
-          </a:fillRef>
-          <a:effectRef idx="2">
-            <a:schemeClr val="accent1"/>
-          </a:effectRef>
-          <a:fontRef idx="minor">
-            <a:schemeClr val="lt1"/>
-          </a:fontRef>
-        </p:style>
-        <p:txBody>
-          <a:bodyPr rtlCol="0" anchor="ctr"/>
-          <a:lstStyle/>
-          <a:p>
-            <a:pPr algn="ctr"/>
-          </a:p>
-        </p:txBody>
-      </p:sp>
-      <p:sp>
-        <p:nvSpPr>
-          <p:cNvPr id="6" name="TextBox 5"/>
-          <p:cNvSpPr txBox="1"/>
-          <p:nvPr/>
-        </p:nvSpPr>
-        <p:spPr>
-          <a:xfrm>
-            <a:off x="4359554" y="2011680"/>
-            <a:ext cx="3472586" cy="1828800"/>
-          </a:xfrm>
-          <a:prstGeom prst="rect">
-            <a:avLst/>
-          </a:prstGeom>
-          <a:noFill/>
-        </p:spPr>
-        <p:txBody>
-          <a:bodyPr wrap="square" lIns="0" rIns="0" tIns="0" bIns="0">
-            <a:spAutoFit/>
-          </a:bodyPr>
-          <a:lstStyle/>
-          <a:p>
-            <a:pPr>
-              <a:spcBef>
-                <a:spcPts val="0"/>
-              </a:spcBef>
-              <a:spcAft>
-                <a:spcPts val="700"/>
-              </a:spcAft>
-            </a:pPr>
-            <a:r>
-              <a:rPr sz="1050" b="0" i="0">
-                <a:solidFill>
-                  <a:srgbClr val="17549E"/>
-                </a:solidFill>
-                <a:latin typeface="Consolas"/>
-              </a:rPr>
-              <a:t>SCOPE OF TRUST FINDINGS</a:t>
-            </a:r>
-          </a:p>
-          <a:p>
-            <a:pPr>
-              <a:lnSpc>
-                <a:spcPct val="130000"/>
-              </a:lnSpc>
-              <a:spcBef>
-                <a:spcPts val="0"/>
-              </a:spcBef>
-              <a:spcAft>
-                <a:spcPts val="0"/>
-              </a:spcAft>
-            </a:pPr>
-            <a:r>
-              <a:rPr sz="1100" b="0" i="0">
-                <a:solidFill>
-                  <a:srgbClr val="5A6068"/>
-                </a:solidFill>
-                <a:latin typeface="Calibri"/>
-              </a:rPr>
-              <a:t>Trust findings rest on ESS (36 European countries, individual-level). The design requires ≥4 years per country-series; only 16 of 163 SDG trust-adjacent series have that coverage, and 1 is significant. Tested cross-sectionally, 9 of 13 series are usable and 4 are significant, but all fall below HDI components on the same countries. The claim is Europe-only and rests on one instrument in each framework; it is the most tentative of the three.</a:t>
-            </a:r>
-          </a:p>
-        </p:txBody>
-      </p:sp>
-      <p:sp>
-        <p:nvSpPr>
-          <p:cNvPr id="7" name="Rectangle 6"/>
-          <p:cNvSpPr/>
-          <p:nvPr/>
-        </p:nvSpPr>
-        <p:spPr>
-          <a:xfrm>
-            <a:off x="8152180" y="1828800"/>
-            <a:ext cx="3472586" cy="25400"/>
-          </a:xfrm>
-          <a:prstGeom prst="rect">
-            <a:avLst/>
-          </a:prstGeom>
-          <a:solidFill>
-            <a:srgbClr val="17549E"/>
-          </a:solidFill>
-          <a:ln>
-            <a:noFill/>
-          </a:ln>
-          <a:effectLst/>
-        </p:spPr>
-        <p:style>
-          <a:lnRef idx="1">
-            <a:schemeClr val="accent1"/>
-          </a:lnRef>
-          <a:fillRef idx="3">
-            <a:schemeClr val="accent1"/>
-          </a:fillRef>
-          <a:effectRef idx="2">
-            <a:schemeClr val="accent1"/>
-          </a:effectRef>
-          <a:fontRef idx="minor">
-            <a:schemeClr val="lt1"/>
-          </a:fontRef>
-        </p:style>
-        <p:txBody>
-          <a:bodyPr rtlCol="0" anchor="ctr"/>
-          <a:lstStyle/>
-          <a:p>
-            <a:pPr algn="ctr"/>
-          </a:p>
-        </p:txBody>
-      </p:sp>
-      <p:sp>
-        <p:nvSpPr>
-          <p:cNvPr id="8" name="TextBox 7"/>
-          <p:cNvSpPr txBox="1"/>
-          <p:nvPr/>
-        </p:nvSpPr>
-        <p:spPr>
-          <a:xfrm>
-            <a:off x="8152180" y="2011680"/>
-            <a:ext cx="3472586" cy="1828800"/>
-          </a:xfrm>
-          <a:prstGeom prst="rect">
-            <a:avLst/>
-          </a:prstGeom>
-          <a:noFill/>
-        </p:spPr>
-        <p:txBody>
-          <a:bodyPr wrap="square" lIns="0" rIns="0" tIns="0" bIns="0">
-            <a:spAutoFit/>
-          </a:bodyPr>
-          <a:lstStyle/>
-          <a:p>
-            <a:pPr>
-              <a:spcBef>
-                <a:spcPts val="0"/>
-              </a:spcBef>
-              <a:spcAft>
-                <a:spcPts val="700"/>
-              </a:spcAft>
-            </a:pPr>
-            <a:r>
-              <a:rPr sz="1050" b="0" i="0">
-                <a:solidFill>
-                  <a:srgbClr val="17549E"/>
-                </a:solidFill>
-                <a:latin typeface="Consolas"/>
-              </a:rPr>
-              <a:t>INSTITUTIONAL CONFIDENCE VS. INTERPERSONAL TRUST</a:t>
-            </a:r>
-          </a:p>
-          <a:p>
-            <a:pPr>
-              <a:lnSpc>
-                <a:spcPct val="130000"/>
-              </a:lnSpc>
-              <a:spcBef>
-                <a:spcPts val="0"/>
-              </a:spcBef>
-              <a:spcAft>
-                <a:spcPts val="0"/>
-              </a:spcAft>
-            </a:pPr>
-            <a:r>
-              <a:rPr sz="1100" b="0" i="0">
-                <a:solidFill>
-                  <a:srgbClr val="5A6068"/>
-                </a:solidFill>
-                <a:latin typeface="Calibri"/>
-              </a:rPr>
-              <a:t>The SDG's Goal 16 trust series measure satisfaction with public services, perceived bribery, and perceived inclusiveness in decision-making — institutional confidence, not interpersonal trust ('most people can be trusted'). These are conceptually distinct. The commentarymust be explicit that SDG16 is not a direct analogue for the ESS trust item.</a:t>
-            </a:r>
-          </a:p>
-        </p:txBody>
-      </p:sp>
-      <p:sp>
-        <p:nvSpPr>
-          <p:cNvPr id="9" name="Rectangle 8"/>
-          <p:cNvSpPr/>
-          <p:nvPr/>
-        </p:nvSpPr>
-        <p:spPr>
-          <a:xfrm>
-            <a:off x="566928" y="4069080"/>
-            <a:ext cx="3472586" cy="25400"/>
-          </a:xfrm>
-          <a:prstGeom prst="rect">
-            <a:avLst/>
-          </a:prstGeom>
-          <a:solidFill>
-            <a:srgbClr val="17549E"/>
-          </a:solidFill>
-          <a:ln>
-            <a:noFill/>
-          </a:ln>
-          <a:effectLst/>
-        </p:spPr>
-        <p:style>
-          <a:lnRef idx="1">
-            <a:schemeClr val="accent1"/>
-          </a:lnRef>
-          <a:fillRef idx="3">
-            <a:schemeClr val="accent1"/>
-          </a:fillRef>
-          <a:effectRef idx="2">
-            <a:schemeClr val="accent1"/>
-          </a:effectRef>
-          <a:fontRef idx="minor">
-            <a:schemeClr val="lt1"/>
-          </a:fontRef>
-        </p:style>
-        <p:txBody>
-          <a:bodyPr rtlCol="0" anchor="ctr"/>
-          <a:lstStyle/>
-          <a:p>
-            <a:pPr algn="ctr"/>
-          </a:p>
-        </p:txBody>
-      </p:sp>
-      <p:sp>
-        <p:nvSpPr>
-          <p:cNvPr id="10" name="TextBox 9"/>
-          <p:cNvSpPr txBox="1"/>
-          <p:nvPr/>
-        </p:nvSpPr>
-        <p:spPr>
-          <a:xfrm>
-            <a:off x="566928" y="4251960"/>
-            <a:ext cx="3472586" cy="1828800"/>
-          </a:xfrm>
-          <a:prstGeom prst="rect">
-            <a:avLst/>
-          </a:prstGeom>
-          <a:noFill/>
-        </p:spPr>
-        <p:txBody>
-          <a:bodyPr wrap="square" lIns="0" rIns="0" tIns="0" bIns="0">
-            <a:spAutoFit/>
-          </a:bodyPr>
-          <a:lstStyle/>
-          <a:p>
-            <a:pPr>
-              <a:spcBef>
-                <a:spcPts val="0"/>
-              </a:spcBef>
-              <a:spcAft>
-                <a:spcPts val="700"/>
-              </a:spcAft>
-            </a:pPr>
-            <a:r>
-              <a:rPr sz="1050" b="0" i="0">
-                <a:solidFill>
-                  <a:srgbClr val="17549E"/>
-                </a:solidFill>
-                <a:latin typeface="Consolas"/>
-              </a:rPr>
-              <a:t>THREE FAILURE MODES FRAME</a:t>
-            </a:r>
-          </a:p>
-          <a:p>
-            <a:pPr>
-              <a:lnSpc>
-                <a:spcPct val="130000"/>
-              </a:lnSpc>
-              <a:spcBef>
-                <a:spcPts val="0"/>
-              </a:spcBef>
-              <a:spcAft>
-                <a:spcPts val="0"/>
-              </a:spcAft>
-            </a:pPr>
-            <a:r>
-              <a:rPr sz="1100" b="0" i="0">
-                <a:solidFill>
-                  <a:srgbClr val="5A6068"/>
-                </a:solidFill>
-                <a:latin typeface="Calibri"/>
-              </a:rPr>
-              <a:t>The narrative positions education's, health's, and trust's findings as evidence of three different ways frameworks lose sight of domains that matter: wrong construct, saturated variable, coverage gap. This is a meta-finding about measurement, not about the domains themselves.</a:t>
-            </a:r>
-          </a:p>
-        </p:txBody>
-      </p:sp>
-    </p:spTree>
-  </p:cSld>
-  <p:clrMapOvr>
-    <a:masterClrMapping/>
-  </p:clrMapOvr>
-</p:sld>
-</file>
-
-<file path=ppt/slides/slide29.xml><?xml version="1.0" encoding="utf-8"?>
-<p:sld xmlns:a="http://schemas.openxmlformats.org/drawingml/2006/main" xmlns:p="http://schemas.openxmlformats.org/presentationml/2006/main" xmlns:r="http://schemas.openxmlformats.org/officeDocument/2006/relationships">
-  <p:cSld>
-    <p:bg>
-      <p:bgPr>
-        <a:solidFill>
-          <a:srgbClr val="14171C"/>
-        </a:solidFill>
-        <a:effectLst/>
-      </p:bgPr>
-    </p:bg>
-    <p:spTree>
-      <p:nvGrpSpPr>
-        <p:cNvPr id="1" name=""/>
-        <p:cNvGrpSpPr/>
-        <p:nvPr/>
-      </p:nvGrpSpPr>
-      <p:grpSpPr/>
-      <p:sp>
-        <p:nvSpPr>
-          <p:cNvPr id="2" name="TextBox 1"/>
-          <p:cNvSpPr txBox="1"/>
-          <p:nvPr/>
-        </p:nvSpPr>
-        <p:spPr>
-          <a:xfrm>
-            <a:off x="566928" y="2743200"/>
-            <a:ext cx="8229600" cy="1371600"/>
-          </a:xfrm>
-          <a:prstGeom prst="rect">
-            <a:avLst/>
-          </a:prstGeom>
-          <a:noFill/>
-        </p:spPr>
-        <p:txBody>
-          <a:bodyPr wrap="square" lIns="0" rIns="0" tIns="0" bIns="0">
-            <a:spAutoFit/>
-          </a:bodyPr>
-          <a:lstStyle/>
-          <a:p>
-            <a:pPr>
-              <a:spcBef>
-                <a:spcPts val="0"/>
-              </a:spcBef>
-              <a:spcAft>
-                <a:spcPts val="1000"/>
-              </a:spcAft>
-            </a:pPr>
-            <a:r>
-              <a:rPr sz="4000" b="0" i="0">
-                <a:solidFill>
-                  <a:srgbClr val="FCFCFB"/>
-                </a:solidFill>
-                <a:latin typeface="Georgia"/>
-              </a:rPr>
-              <a:t>Evidence appendix</a:t>
-            </a:r>
-          </a:p>
+            <a:off x="914400" y="2148840"/>
+            <a:ext cx="9509760" cy="2926080"/>
+          </a:xfrm>
+          <a:prstGeom prst="rect">
+            <a:avLst/>
+          </a:prstGeom>
+          <a:noFill/>
+        </p:spPr>
+        <p:txBody>
+          <a:bodyPr wrap="square" lIns="0" rIns="0" tIns="0" bIns="0">
+            <a:spAutoFit/>
+          </a:bodyPr>
+          <a:lstStyle/>
           <a:p>
             <a:pPr>
               <a:lnSpc>
@@ -9609,13 +9653,13 @@
               </a:spcAft>
             </a:pPr>
             <a:r>
-              <a:rPr sz="1400" b="0" i="0">
-                <a:solidFill>
-                  <a:srgbClr val="9AA4B0"/>
-                </a:solidFill>
-                <a:latin typeface="Calibri"/>
-              </a:rPr>
-              <a:t>Everything the three acts rest on but do not carry. In submission these become supplementary material.</a:t>
+              <a:rPr sz="2100" b="0" i="0">
+                <a:solidFill>
+                  <a:srgbClr val="14171C"/>
+                </a:solidFill>
+                <a:latin typeface="Georgia"/>
+              </a:rPr>
+              <a:t>Whether development measurement should be redesigned with wellbeing in mind is beyond this scope. But if it is, this evidence suggests the measurement should be different: more attentive to which variables still move, which constructs predict outcomes, and which domains are collected at all.</a:t>
             </a:r>
           </a:p>
         </p:txBody>
@@ -10052,6 +10096,615 @@
                 <a:latin typeface="Calibri"/>
               </a:rPr>
               <a:t>of cells, against the ESS wellbeing survey</a:t>
+            </a:r>
+          </a:p>
+        </p:txBody>
+      </p:sp>
+    </p:spTree>
+  </p:cSld>
+  <p:clrMapOvr>
+    <a:masterClrMapping/>
+  </p:clrMapOvr>
+</p:sld>
+</file>
+
+<file path=ppt/slides/slide30.xml><?xml version="1.0" encoding="utf-8"?>
+<p:sld xmlns:a="http://schemas.openxmlformats.org/drawingml/2006/main" xmlns:p="http://schemas.openxmlformats.org/presentationml/2006/main" xmlns:r="http://schemas.openxmlformats.org/officeDocument/2006/relationships">
+  <p:cSld>
+    <p:bg>
+      <p:bgPr>
+        <a:solidFill>
+          <a:srgbClr val="FCFCFB"/>
+        </a:solidFill>
+        <a:effectLst/>
+      </p:bgPr>
+    </p:bg>
+    <p:spTree>
+      <p:nvGrpSpPr>
+        <p:cNvPr id="1" name=""/>
+        <p:cNvGrpSpPr/>
+        <p:nvPr/>
+      </p:nvGrpSpPr>
+      <p:grpSpPr/>
+      <p:sp>
+        <p:nvSpPr>
+          <p:cNvPr id="2" name="TextBox 1"/>
+          <p:cNvSpPr txBox="1"/>
+          <p:nvPr/>
+        </p:nvSpPr>
+        <p:spPr>
+          <a:xfrm>
+            <a:off x="566928" y="502920"/>
+            <a:ext cx="8229600" cy="822960"/>
+          </a:xfrm>
+          <a:prstGeom prst="rect">
+            <a:avLst/>
+          </a:prstGeom>
+          <a:noFill/>
+        </p:spPr>
+        <p:txBody>
+          <a:bodyPr wrap="square" lIns="0" rIns="0" tIns="0" bIns="0">
+            <a:spAutoFit/>
+          </a:bodyPr>
+          <a:lstStyle/>
+          <a:p>
+            <a:pPr>
+              <a:spcBef>
+                <a:spcPts val="0"/>
+              </a:spcBef>
+              <a:spcAft>
+                <a:spcPts val="600"/>
+              </a:spcAft>
+            </a:pPr>
+            <a:r>
+              <a:rPr sz="3200" b="0" i="0">
+                <a:solidFill>
+                  <a:srgbClr val="14171C"/>
+                </a:solidFill>
+                <a:latin typeface="Georgia"/>
+              </a:rPr>
+              <a:t>Decisions for the team</a:t>
+            </a:r>
+          </a:p>
+          <a:p>
+            <a:pPr>
+              <a:spcBef>
+                <a:spcPts val="0"/>
+              </a:spcBef>
+              <a:spcAft>
+                <a:spcPts val="0"/>
+              </a:spcAft>
+            </a:pPr>
+            <a:r>
+              <a:rPr sz="1300" b="0" i="0">
+                <a:solidFill>
+                  <a:srgbClr val="5A6068"/>
+                </a:solidFill>
+                <a:latin typeface="Calibri"/>
+              </a:rPr>
+              <a:t>4 things the acts do not settle, in the order they block drafting.</a:t>
+            </a:r>
+          </a:p>
+        </p:txBody>
+      </p:sp>
+      <p:sp>
+        <p:nvSpPr>
+          <p:cNvPr id="3" name="Rectangle 2"/>
+          <p:cNvSpPr/>
+          <p:nvPr/>
+        </p:nvSpPr>
+        <p:spPr>
+          <a:xfrm>
+            <a:off x="566928" y="1828800"/>
+            <a:ext cx="3472586" cy="25400"/>
+          </a:xfrm>
+          <a:prstGeom prst="rect">
+            <a:avLst/>
+          </a:prstGeom>
+          <a:solidFill>
+            <a:srgbClr val="17549E"/>
+          </a:solidFill>
+          <a:ln>
+            <a:noFill/>
+          </a:ln>
+          <a:effectLst/>
+        </p:spPr>
+        <p:style>
+          <a:lnRef idx="1">
+            <a:schemeClr val="accent1"/>
+          </a:lnRef>
+          <a:fillRef idx="3">
+            <a:schemeClr val="accent1"/>
+          </a:fillRef>
+          <a:effectRef idx="2">
+            <a:schemeClr val="accent1"/>
+          </a:effectRef>
+          <a:fontRef idx="minor">
+            <a:schemeClr val="lt1"/>
+          </a:fontRef>
+        </p:style>
+        <p:txBody>
+          <a:bodyPr rtlCol="0" anchor="ctr"/>
+          <a:lstStyle/>
+          <a:p>
+            <a:pPr algn="ctr"/>
+          </a:p>
+        </p:txBody>
+      </p:sp>
+      <p:sp>
+        <p:nvSpPr>
+          <p:cNvPr id="4" name="TextBox 3"/>
+          <p:cNvSpPr txBox="1"/>
+          <p:nvPr/>
+        </p:nvSpPr>
+        <p:spPr>
+          <a:xfrm>
+            <a:off x="566928" y="2011680"/>
+            <a:ext cx="3472586" cy="1828800"/>
+          </a:xfrm>
+          <a:prstGeom prst="rect">
+            <a:avLst/>
+          </a:prstGeom>
+          <a:noFill/>
+        </p:spPr>
+        <p:txBody>
+          <a:bodyPr wrap="square" lIns="0" rIns="0" tIns="0" bIns="0">
+            <a:spAutoFit/>
+          </a:bodyPr>
+          <a:lstStyle/>
+          <a:p>
+            <a:pPr>
+              <a:spcBef>
+                <a:spcPts val="0"/>
+              </a:spcBef>
+              <a:spcAft>
+                <a:spcPts val="700"/>
+              </a:spcAft>
+            </a:pPr>
+            <a:r>
+              <a:rPr sz="1050" b="0" i="0">
+                <a:solidFill>
+                  <a:srgbClr val="17549E"/>
+                </a:solidFill>
+                <a:latin typeface="Consolas"/>
+              </a:rPr>
+              <a:t>FIGURE COUNT</a:t>
+            </a:r>
+          </a:p>
+          <a:p>
+            <a:pPr>
+              <a:lnSpc>
+                <a:spcPct val="130000"/>
+              </a:lnSpc>
+              <a:spcBef>
+                <a:spcPts val="0"/>
+              </a:spcBef>
+              <a:spcAft>
+                <a:spcPts val="0"/>
+              </a:spcAft>
+            </a:pPr>
+            <a:r>
+              <a:rPr sz="1100" b="0" i="0">
+                <a:solidFill>
+                  <a:srgbClr val="5A6068"/>
+                </a:solidFill>
+                <a:latin typeface="Calibri"/>
+              </a:rPr>
+              <a:t>Commentaries allow one or two. Proposed: three-panel composite as Figure 1 and domain scorecard as Figure 2. Everything else supplementary.</a:t>
+            </a:r>
+          </a:p>
+        </p:txBody>
+      </p:sp>
+      <p:sp>
+        <p:nvSpPr>
+          <p:cNvPr id="5" name="Rectangle 4"/>
+          <p:cNvSpPr/>
+          <p:nvPr/>
+        </p:nvSpPr>
+        <p:spPr>
+          <a:xfrm>
+            <a:off x="4359554" y="1828800"/>
+            <a:ext cx="3472586" cy="25400"/>
+          </a:xfrm>
+          <a:prstGeom prst="rect">
+            <a:avLst/>
+          </a:prstGeom>
+          <a:solidFill>
+            <a:srgbClr val="17549E"/>
+          </a:solidFill>
+          <a:ln>
+            <a:noFill/>
+          </a:ln>
+          <a:effectLst/>
+        </p:spPr>
+        <p:style>
+          <a:lnRef idx="1">
+            <a:schemeClr val="accent1"/>
+          </a:lnRef>
+          <a:fillRef idx="3">
+            <a:schemeClr val="accent1"/>
+          </a:fillRef>
+          <a:effectRef idx="2">
+            <a:schemeClr val="accent1"/>
+          </a:effectRef>
+          <a:fontRef idx="minor">
+            <a:schemeClr val="lt1"/>
+          </a:fontRef>
+        </p:style>
+        <p:txBody>
+          <a:bodyPr rtlCol="0" anchor="ctr"/>
+          <a:lstStyle/>
+          <a:p>
+            <a:pPr algn="ctr"/>
+          </a:p>
+        </p:txBody>
+      </p:sp>
+      <p:sp>
+        <p:nvSpPr>
+          <p:cNvPr id="6" name="TextBox 5"/>
+          <p:cNvSpPr txBox="1"/>
+          <p:nvPr/>
+        </p:nvSpPr>
+        <p:spPr>
+          <a:xfrm>
+            <a:off x="4359554" y="2011680"/>
+            <a:ext cx="3472586" cy="1828800"/>
+          </a:xfrm>
+          <a:prstGeom prst="rect">
+            <a:avLst/>
+          </a:prstGeom>
+          <a:noFill/>
+        </p:spPr>
+        <p:txBody>
+          <a:bodyPr wrap="square" lIns="0" rIns="0" tIns="0" bIns="0">
+            <a:spAutoFit/>
+          </a:bodyPr>
+          <a:lstStyle/>
+          <a:p>
+            <a:pPr>
+              <a:spcBef>
+                <a:spcPts val="0"/>
+              </a:spcBef>
+              <a:spcAft>
+                <a:spcPts val="700"/>
+              </a:spcAft>
+            </a:pPr>
+            <a:r>
+              <a:rPr sz="1050" b="0" i="0">
+                <a:solidFill>
+                  <a:srgbClr val="17549E"/>
+                </a:solidFill>
+                <a:latin typeface="Consolas"/>
+              </a:rPr>
+              <a:t>SCOPE OF TRUST FINDINGS</a:t>
+            </a:r>
+          </a:p>
+          <a:p>
+            <a:pPr>
+              <a:lnSpc>
+                <a:spcPct val="130000"/>
+              </a:lnSpc>
+              <a:spcBef>
+                <a:spcPts val="0"/>
+              </a:spcBef>
+              <a:spcAft>
+                <a:spcPts val="0"/>
+              </a:spcAft>
+            </a:pPr>
+            <a:r>
+              <a:rPr sz="1100" b="0" i="0">
+                <a:solidFill>
+                  <a:srgbClr val="5A6068"/>
+                </a:solidFill>
+                <a:latin typeface="Calibri"/>
+              </a:rPr>
+              <a:t>Trust findings rest on ESS (36 European countries, individual-level). The design requires ≥4 years per country-series; only 16 of 163 SDG trust-adjacent series have that coverage, and 1 is significant. Tested cross-sectionally, 9 of 13 series are usable and 4 are significant, but all fall below HDI components on the same countries. The claim is Europe-only and rests on one instrument in each framework; it is the most tentative of the three.</a:t>
+            </a:r>
+          </a:p>
+        </p:txBody>
+      </p:sp>
+      <p:sp>
+        <p:nvSpPr>
+          <p:cNvPr id="7" name="Rectangle 6"/>
+          <p:cNvSpPr/>
+          <p:nvPr/>
+        </p:nvSpPr>
+        <p:spPr>
+          <a:xfrm>
+            <a:off x="8152180" y="1828800"/>
+            <a:ext cx="3472586" cy="25400"/>
+          </a:xfrm>
+          <a:prstGeom prst="rect">
+            <a:avLst/>
+          </a:prstGeom>
+          <a:solidFill>
+            <a:srgbClr val="17549E"/>
+          </a:solidFill>
+          <a:ln>
+            <a:noFill/>
+          </a:ln>
+          <a:effectLst/>
+        </p:spPr>
+        <p:style>
+          <a:lnRef idx="1">
+            <a:schemeClr val="accent1"/>
+          </a:lnRef>
+          <a:fillRef idx="3">
+            <a:schemeClr val="accent1"/>
+          </a:fillRef>
+          <a:effectRef idx="2">
+            <a:schemeClr val="accent1"/>
+          </a:effectRef>
+          <a:fontRef idx="minor">
+            <a:schemeClr val="lt1"/>
+          </a:fontRef>
+        </p:style>
+        <p:txBody>
+          <a:bodyPr rtlCol="0" anchor="ctr"/>
+          <a:lstStyle/>
+          <a:p>
+            <a:pPr algn="ctr"/>
+          </a:p>
+        </p:txBody>
+      </p:sp>
+      <p:sp>
+        <p:nvSpPr>
+          <p:cNvPr id="8" name="TextBox 7"/>
+          <p:cNvSpPr txBox="1"/>
+          <p:nvPr/>
+        </p:nvSpPr>
+        <p:spPr>
+          <a:xfrm>
+            <a:off x="8152180" y="2011680"/>
+            <a:ext cx="3472586" cy="1828800"/>
+          </a:xfrm>
+          <a:prstGeom prst="rect">
+            <a:avLst/>
+          </a:prstGeom>
+          <a:noFill/>
+        </p:spPr>
+        <p:txBody>
+          <a:bodyPr wrap="square" lIns="0" rIns="0" tIns="0" bIns="0">
+            <a:spAutoFit/>
+          </a:bodyPr>
+          <a:lstStyle/>
+          <a:p>
+            <a:pPr>
+              <a:spcBef>
+                <a:spcPts val="0"/>
+              </a:spcBef>
+              <a:spcAft>
+                <a:spcPts val="700"/>
+              </a:spcAft>
+            </a:pPr>
+            <a:r>
+              <a:rPr sz="1050" b="0" i="0">
+                <a:solidFill>
+                  <a:srgbClr val="17549E"/>
+                </a:solidFill>
+                <a:latin typeface="Consolas"/>
+              </a:rPr>
+              <a:t>INSTITUTIONAL CONFIDENCE VS. INTERPERSONAL TRUST</a:t>
+            </a:r>
+          </a:p>
+          <a:p>
+            <a:pPr>
+              <a:lnSpc>
+                <a:spcPct val="130000"/>
+              </a:lnSpc>
+              <a:spcBef>
+                <a:spcPts val="0"/>
+              </a:spcBef>
+              <a:spcAft>
+                <a:spcPts val="0"/>
+              </a:spcAft>
+            </a:pPr>
+            <a:r>
+              <a:rPr sz="1100" b="0" i="0">
+                <a:solidFill>
+                  <a:srgbClr val="5A6068"/>
+                </a:solidFill>
+                <a:latin typeface="Calibri"/>
+              </a:rPr>
+              <a:t>The SDG's Goal 16 trust series measure satisfaction with public services, perceived bribery, and perceived inclusiveness in decision-making — institutional confidence, not interpersonal trust ('most people can be trusted'). These are conceptually distinct. The commentarymust be explicit that SDG16 is not a direct analogue for the ESS trust item.</a:t>
+            </a:r>
+          </a:p>
+        </p:txBody>
+      </p:sp>
+      <p:sp>
+        <p:nvSpPr>
+          <p:cNvPr id="9" name="Rectangle 8"/>
+          <p:cNvSpPr/>
+          <p:nvPr/>
+        </p:nvSpPr>
+        <p:spPr>
+          <a:xfrm>
+            <a:off x="566928" y="4069080"/>
+            <a:ext cx="3472586" cy="25400"/>
+          </a:xfrm>
+          <a:prstGeom prst="rect">
+            <a:avLst/>
+          </a:prstGeom>
+          <a:solidFill>
+            <a:srgbClr val="17549E"/>
+          </a:solidFill>
+          <a:ln>
+            <a:noFill/>
+          </a:ln>
+          <a:effectLst/>
+        </p:spPr>
+        <p:style>
+          <a:lnRef idx="1">
+            <a:schemeClr val="accent1"/>
+          </a:lnRef>
+          <a:fillRef idx="3">
+            <a:schemeClr val="accent1"/>
+          </a:fillRef>
+          <a:effectRef idx="2">
+            <a:schemeClr val="accent1"/>
+          </a:effectRef>
+          <a:fontRef idx="minor">
+            <a:schemeClr val="lt1"/>
+          </a:fontRef>
+        </p:style>
+        <p:txBody>
+          <a:bodyPr rtlCol="0" anchor="ctr"/>
+          <a:lstStyle/>
+          <a:p>
+            <a:pPr algn="ctr"/>
+          </a:p>
+        </p:txBody>
+      </p:sp>
+      <p:sp>
+        <p:nvSpPr>
+          <p:cNvPr id="10" name="TextBox 9"/>
+          <p:cNvSpPr txBox="1"/>
+          <p:nvPr/>
+        </p:nvSpPr>
+        <p:spPr>
+          <a:xfrm>
+            <a:off x="566928" y="4251960"/>
+            <a:ext cx="3472586" cy="1828800"/>
+          </a:xfrm>
+          <a:prstGeom prst="rect">
+            <a:avLst/>
+          </a:prstGeom>
+          <a:noFill/>
+        </p:spPr>
+        <p:txBody>
+          <a:bodyPr wrap="square" lIns="0" rIns="0" tIns="0" bIns="0">
+            <a:spAutoFit/>
+          </a:bodyPr>
+          <a:lstStyle/>
+          <a:p>
+            <a:pPr>
+              <a:spcBef>
+                <a:spcPts val="0"/>
+              </a:spcBef>
+              <a:spcAft>
+                <a:spcPts val="700"/>
+              </a:spcAft>
+            </a:pPr>
+            <a:r>
+              <a:rPr sz="1050" b="0" i="0">
+                <a:solidFill>
+                  <a:srgbClr val="17549E"/>
+                </a:solidFill>
+                <a:latin typeface="Consolas"/>
+              </a:rPr>
+              <a:t>THREE FAILURE MODES FRAME</a:t>
+            </a:r>
+          </a:p>
+          <a:p>
+            <a:pPr>
+              <a:lnSpc>
+                <a:spcPct val="130000"/>
+              </a:lnSpc>
+              <a:spcBef>
+                <a:spcPts val="0"/>
+              </a:spcBef>
+              <a:spcAft>
+                <a:spcPts val="0"/>
+              </a:spcAft>
+            </a:pPr>
+            <a:r>
+              <a:rPr sz="1100" b="0" i="0">
+                <a:solidFill>
+                  <a:srgbClr val="5A6068"/>
+                </a:solidFill>
+                <a:latin typeface="Calibri"/>
+              </a:rPr>
+              <a:t>The narrative positions education's, health's, and trust's findings as evidence of three different ways frameworks lose sight of domains that matter: wrong construct, saturated variable, coverage gap. This is a meta-finding about measurement, not about the domains themselves.</a:t>
+            </a:r>
+          </a:p>
+        </p:txBody>
+      </p:sp>
+    </p:spTree>
+  </p:cSld>
+  <p:clrMapOvr>
+    <a:masterClrMapping/>
+  </p:clrMapOvr>
+</p:sld>
+</file>
+
+<file path=ppt/slides/slide31.xml><?xml version="1.0" encoding="utf-8"?>
+<p:sld xmlns:a="http://schemas.openxmlformats.org/drawingml/2006/main" xmlns:p="http://schemas.openxmlformats.org/presentationml/2006/main" xmlns:r="http://schemas.openxmlformats.org/officeDocument/2006/relationships">
+  <p:cSld>
+    <p:bg>
+      <p:bgPr>
+        <a:solidFill>
+          <a:srgbClr val="14171C"/>
+        </a:solidFill>
+        <a:effectLst/>
+      </p:bgPr>
+    </p:bg>
+    <p:spTree>
+      <p:nvGrpSpPr>
+        <p:cNvPr id="1" name=""/>
+        <p:cNvGrpSpPr/>
+        <p:nvPr/>
+      </p:nvGrpSpPr>
+      <p:grpSpPr/>
+      <p:sp>
+        <p:nvSpPr>
+          <p:cNvPr id="2" name="TextBox 1"/>
+          <p:cNvSpPr txBox="1"/>
+          <p:nvPr/>
+        </p:nvSpPr>
+        <p:spPr>
+          <a:xfrm>
+            <a:off x="566928" y="2743200"/>
+            <a:ext cx="8229600" cy="1371600"/>
+          </a:xfrm>
+          <a:prstGeom prst="rect">
+            <a:avLst/>
+          </a:prstGeom>
+          <a:noFill/>
+        </p:spPr>
+        <p:txBody>
+          <a:bodyPr wrap="square" lIns="0" rIns="0" tIns="0" bIns="0">
+            <a:spAutoFit/>
+          </a:bodyPr>
+          <a:lstStyle/>
+          <a:p>
+            <a:pPr>
+              <a:spcBef>
+                <a:spcPts val="0"/>
+              </a:spcBef>
+              <a:spcAft>
+                <a:spcPts val="1000"/>
+              </a:spcAft>
+            </a:pPr>
+            <a:r>
+              <a:rPr sz="4000" b="0" i="0">
+                <a:solidFill>
+                  <a:srgbClr val="FCFCFB"/>
+                </a:solidFill>
+                <a:latin typeface="Georgia"/>
+              </a:rPr>
+              <a:t>Evidence appendix</a:t>
+            </a:r>
+          </a:p>
+          <a:p>
+            <a:pPr>
+              <a:lnSpc>
+                <a:spcPct val="135000"/>
+              </a:lnSpc>
+              <a:spcBef>
+                <a:spcPts val="0"/>
+              </a:spcBef>
+              <a:spcAft>
+                <a:spcPts val="0"/>
+              </a:spcAft>
+            </a:pPr>
+            <a:r>
+              <a:rPr sz="1400" b="0" i="0">
+                <a:solidFill>
+                  <a:srgbClr val="9AA4B0"/>
+                </a:solidFill>
+                <a:latin typeface="Calibri"/>
+              </a:rPr>
+              <a:t>Everything the three acts rest on but do not carry. In submission these become supplementary material.</a:t>
             </a:r>
           </a:p>
         </p:txBody>

</xml_diff>

<commit_message>
Reframe narrative motivation and Act IV prescriptively
- Add three-part question framing to Hook: What matters? Why don't frameworks capture it? How should they change?
- Reframe Act II title to emphasize answering 'what actually matters for lived experience'
- Convert Act IV from speculative questions to prescriptive recommendations grounded in evidence:
  * Implication 1: Fix wrong constructs (education access, health variables by development level)
  * Implication 2: Add missing coverage (build interpersonal trust into frameworks)
  * Conclusion: From evidence-based findings to concrete redesign suggestions
- Maintain exploratory tone while being actionable (research suggests, could mean, evidence points to)
- Shift from 'whether frameworks should change' to 'here's what change would look like based on what matters'

Co-Authored-By: Claude Haiku 4.5 <noreply@anthropic.com>
Claude-Session: https://claude.ai/code/session_01EScqJU3C944N93U7Je3P1X
</commit_message>
<xml_diff>
--- a/deck/Measured_Where_It_Varies.pptx
+++ b/deck/Measured_Where_It_Varies.pptx
@@ -6400,7 +6400,7 @@
                 </a:solidFill>
                 <a:latin typeface="Consolas"/>
               </a:rPr>
-              <a:t>THE SETUP</a:t>
+              <a:t>THREE QUESTIONS ABOUT MEASUREMENT</a:t>
             </a:r>
           </a:p>
         </p:txBody>
@@ -6445,7 +6445,7 @@
                 </a:solidFill>
                 <a:latin typeface="Georgia"/>
               </a:rPr>
-              <a:t>Development rose almost everywhere. Wellbeing did not follow it.</a:t>
+              <a:t>What actually matters for individual lived experience, and are development frameworks measuring it?</a:t>
             </a:r>
           </a:p>
         </p:txBody>
@@ -6484,13 +6484,13 @@
               </a:spcAft>
             </a:pPr>
             <a:r>
-              <a:rPr sz="1075" b="0" i="0">
+              <a:rPr sz="1050" b="0" i="0">
                 <a:solidFill>
                   <a:srgbClr val="5A6068"/>
                 </a:solidFill>
                 <a:latin typeface="Calibri"/>
               </a:rPr>
-              <a:t>The SDG paper now under review makes a narrow, awkward claim: the association between development indicators and happiness is strong when countries are compared with one another, and close to absent when each is compared with its own past. Thirty of 42 countries are significant in levels. Two are in year-to-year changes.</a:t>
+              <a:t>Development measurement has a wellbeing problem. Frameworks like the SDG and HDI were built to track progress on development goals, not to understand what predicts how people experience their lives. But if development is meant to improve wellbeing, we should ask: Do the frameworks capture what actually matters? What does matter at the individual level? And if they don't align, how should development measurement change?</a:t>
             </a:r>
           </a:p>
           <a:p>
@@ -6506,13 +6506,13 @@
               </a:spcAft>
             </a:pPr>
             <a:r>
-              <a:rPr sz="1075" b="0" i="0">
+              <a:rPr sz="1050" b="0" i="0">
                 <a:solidFill>
                   <a:srgbClr val="5A6068"/>
                 </a:solidFill>
                 <a:latin typeface="Calibri"/>
               </a:rPr>
-              <a:t>There is an obvious way to dismiss that. The SDG framework is a sprawling, negotiated instrument with uneven coverage; a null inside it says as much about the framework as about the world. This commentary closes that escape route by asking: which parts of development track lived experience at all? And why do some frameworks capture them while others systematically miss them?</a:t>
+              <a:t>The SDG paper under review provides the opening: the association between development indicators and happiness is strong between countries but nearly absent within them year-to-year. Thirty of 42 countries are significant in levels. Two are in differences. The obvious dismissal: the SDG framework is sprawling and unevenly covered; a null says as much about the framework as the world.</a:t>
             </a:r>
           </a:p>
           <a:p>
@@ -6528,13 +6528,13 @@
               </a:spcAft>
             </a:pPr>
             <a:r>
-              <a:rPr sz="1075" b="0" i="0">
+              <a:rPr sz="1050" b="0" i="0">
                 <a:solidFill>
                   <a:srgbClr val="5A6068"/>
                 </a:solidFill>
                 <a:latin typeface="Calibri"/>
               </a:rPr>
-              <a:t>The answer turns out to be about the frameworks' construction choices, not about development itself. Education, health, and social trust all matter — but which one you find depends on which framework you measure with, which construct you count, and whether you collected the data in the first place.</a:t>
+              <a:t>This commentary answers the three questions by testing them across frameworks. We replicate the collapse on the HDI, test it against individual-level wellbeing data (the ESS), and ask what domains actually predict life satisfaction when measured at the right level and resolution. The answer: education, health, and social trust all matter. But which framework sees them depends entirely on construction choices—which construct you count, which variable you measure, which domains you collect. Based on that evidence, we suggest how development measurement could evolve.</a:t>
             </a:r>
           </a:p>
         </p:txBody>
@@ -6854,7 +6854,7 @@
                 </a:solidFill>
                 <a:latin typeface="Calibri"/>
               </a:rPr>
-              <a:t>At the levels: three domains, three failure modes.</a:t>
+              <a:t>At the levels: what actually matters for lived experience?</a:t>
             </a:r>
           </a:p>
           <a:p>
@@ -6876,7 +6876,7 @@
                 </a:solidFill>
                 <a:latin typeface="Calibri"/>
               </a:rPr>
-              <a:t>Education, health, and social trust all matter. But frameworks see them differently because of construction choices, variable saturation, or missing coverage.</a:t>
+              <a:t>Three domains predict life satisfaction: education, health, and social trust. But frameworks see them differently because of construction choices, variable saturation, or missing coverage. This is what measurement shows matters.</a:t>
             </a:r>
           </a:p>
         </p:txBody>
@@ -7004,7 +7004,7 @@
                 </a:solidFill>
                 <a:latin typeface="Calibri"/>
               </a:rPr>
-              <a:t>Within-country evidence: why measurement type matters.</a:t>
+              <a:t>Why measurement type matters: within-country evidence.</a:t>
             </a:r>
           </a:p>
           <a:p>
@@ -7026,7 +7026,7 @@
                 </a:solidFill>
                 <a:latin typeface="Calibri"/>
               </a:rPr>
-              <a:t>Individual-level, self-reported data shows ESS captures year-to-year change. Development frameworks measure at the wrong temporal and individual resolution.</a:t>
+              <a:t>Individual-level, self-reported data captures year-to-year change that administrative frameworks miss. Development frameworks measure at the wrong temporal and individual resolution to see lived experience.</a:t>
             </a:r>
           </a:p>
         </p:txBody>
@@ -7154,7 +7154,7 @@
                 </a:solidFill>
                 <a:latin typeface="Calibri"/>
               </a:rPr>
-              <a:t>What this means for how we measure development.</a:t>
+              <a:t>How development frameworks could evolve.</a:t>
             </a:r>
           </a:p>
           <a:p>
@@ -7176,7 +7176,7 @@
                 </a:solidFill>
                 <a:latin typeface="Calibri"/>
               </a:rPr>
-              <a:t>A structural disconnect between how development is measured and what predicts lived experience, with implications for each domain and method.</a:t>
+              <a:t>Based on what matters for individual wellbeing, specific recommendations for education, health, and social trust. A roadmap for aligning development measurement with what research shows actually predicts lived experience.</a:t>
             </a:r>
           </a:p>
         </p:txBody>
@@ -7244,7 +7244,7 @@
                 </a:solidFill>
                 <a:latin typeface="Consolas"/>
               </a:rPr>
-              <a:t>THE DISCONNECT</a:t>
+              <a:t>THE STRUCTURAL DISCONNECT</a:t>
             </a:r>
           </a:p>
         </p:txBody>
@@ -7289,7 +7289,7 @@
                 </a:solidFill>
                 <a:latin typeface="Georgia"/>
               </a:rPr>
-              <a:t>These frameworks work for development. They do not work for wellbeing.</a:t>
+              <a:t>These frameworks were built to measure development, not to capture what predicts wellbeing</a:t>
             </a:r>
           </a:p>
         </p:txBody>
@@ -7334,7 +7334,7 @@
                 </a:solidFill>
                 <a:latin typeface="Calibri"/>
               </a:rPr>
-              <a:t>The HDI and SDG frameworks do not answer the question 'what makes people's lives better?' any more than a global income statistics database answers 'what makes a person happy?' They were designed to track development, measured at the aggregate level, with indicators chosen before the question of individual wellbeing was systematically tested. That is not a design failure; it is the intended scope.</a:t>
+              <a:t>The HDI and SDG frameworks do not answer the question 'what makes people's lives better?' They were designed to track development at the aggregate level, with indicators chosen before the question of individual wellbeing was systematically tested. That is not a design failure; it is the intended scope. But it creates a structural gap: frameworks measuring aggregate, infrequent administrative data cannot see individual experience that responds to change.</a:t>
             </a:r>
           </a:p>
           <a:p>
@@ -7356,7 +7356,7 @@
                 </a:solidFill>
                 <a:latin typeface="Calibri"/>
               </a:rPr>
-              <a:t>But it means the gap is structural. Education's access indicators work; pooling them with constructs that do not does not fix wellbeing prediction — it just builds a worse measure. Choosing a variable for health that is closer to saturated than the outcome it predicts is a measurement choice, not an incurable problem. And when a domain is never collected, no amount of better construction on the others will reach it.</a:t>
+              <a:t>The gap is not incurable. It is built on three concrete, fixable problems: wrong constructs for some domains, saturated variables for others, and missing coverage for those not measured at all. This commentary suggests how to fix each.</a:t>
             </a:r>
           </a:p>
         </p:txBody>
@@ -7466,7 +7466,7 @@
                 </a:solidFill>
                 <a:latin typeface="Consolas"/>
               </a:rPr>
-              <a:t>IMPLICATION 1 · MEASUREMENT CHOICES CONSTRAIN WHAT FRAMEWORKS CAN SEE</a:t>
+              <a:t>IMPLICATION 1 · FIX WRONG CONSTRUCTS</a:t>
             </a:r>
           </a:p>
         </p:txBody>
@@ -7511,7 +7511,7 @@
                 </a:solidFill>
                 <a:latin typeface="Georgia"/>
               </a:rPr>
-              <a:t>Education and health: the case for measurement specificity</a:t>
+              <a:t>Education and health: measurement specificity based on what predicts wellbeing</a:t>
             </a:r>
           </a:p>
         </p:txBody>
@@ -7556,7 +7556,7 @@
                 </a:solidFill>
                 <a:latin typeface="Calibri"/>
               </a:rPr>
-              <a:t>Education is significant everywhere it is measured as attainment, but nearly invisible in SDG4 because most indicators measure something else. Health is nearly invisible in the HDI because life expectancy has saturated. Neither domain has changed; the frameworks' construction choices have.</a:t>
+              <a:t>Education is significant everywhere it is measured as attainment (92% in ESS, 34% in HDI, 12.7% in SDG4 access alone). But SDG4 averages it with parity ratios and learning outcomes, which do not predict wellbeing, collapsing the pooled rate to 3.3%. The fix: development frameworks should make construction choices with explicit reference to what research shows matters for lived experience. For education in wellbeing contexts, this means weighting access and completion more heavily than equity ratios.</a:t>
             </a:r>
           </a:p>
           <a:p>
@@ -7578,7 +7578,7 @@
                 </a:solidFill>
                 <a:latin typeface="Calibri"/>
               </a:rPr>
-              <a:t>For education, this suggests development measurement should weigh access and completion more heavily than parity ratios in wellbeing contexts — not universally, but with explicit construction choices that account for what is known to matter. For health, it suggests that wellbeing-motivated measurement may need different variables at different development levels: life expectancy in lower-income settings, self-reported health or specific conditions in saturated ones.</a:t>
+              <a:t>Health is nearly invisible in the HDI (20% significant) because life expectancy is saturated in developed countries — the top 100 range from 81–85 years. Yet self-rated health is significant in 100% of ESS countries. The fix: use different variables at different income levels. Life expectancy for lower-income settings where it still varies; self-reported health, or condition-specific mortality (maternal, neonatal, under-five), in saturated ones.</a:t>
             </a:r>
           </a:p>
         </p:txBody>
@@ -7688,7 +7688,7 @@
                 </a:solidFill>
                 <a:latin typeface="Consolas"/>
               </a:rPr>
-              <a:t>IMPLICATION 2 · COVERAGE GAPS ARE MORE FUNDAMENTAL THAN CONSTRUCT CHOICE</a:t>
+              <a:t>IMPLICATION 2 · ADD MISSING COVERAGE</a:t>
             </a:r>
           </a:p>
         </p:txBody>
@@ -7733,7 +7733,7 @@
                 </a:solidFill>
                 <a:latin typeface="Georgia"/>
               </a:rPr>
-              <a:t>Social trust: why you cannot fix a measurement by measuring better</a:t>
+              <a:t>Social trust: why coverage gaps cannot be fixed by better measurement of wrong things</a:t>
             </a:r>
           </a:p>
         </p:txBody>
@@ -7778,7 +7778,7 @@
                 </a:solidFill>
                 <a:latin typeface="Calibri"/>
               </a:rPr>
-              <a:t>Social trust is the most tentative finding here. The ESS is Europe-only, across 36 countries, and relies on a single item. That bounds the claim: the pattern holds in Europe, with a wellbeing survey, on a self-report basis. It does not claim universality.</a:t>
+              <a:t>Social trust is significant in 94% of ESS countries and is the third-strongest predictor after health and income. Neither the HDI nor the SDG framework measures it. The SDG database has 13 series under Goal 16, but they measure institutional confidence—satisfaction with government, healthcare, education—not interpersonal trust. Moreover, 147 of 163 country-series have fewer than four years of data, making time-series designs impossible.</a:t>
             </a:r>
           </a:p>
           <a:p>
@@ -7800,29 +7800,7 @@
                 </a:solidFill>
                 <a:latin typeface="Calibri"/>
               </a:rPr>
-              <a:t>But the reason it is tentative points to the deepest problem: trust is not collected at global scale in either framework. The SDG database has 13 series adjacent to trust, but they measure institutional confidence, not interpersonal trust, and they are intermittent (147 of 163 country-series have fewer than four years of data). This is not a construct-choice problem that better measurement can solve. It is a coverage gap that requires deciding to collect the data in the first place.</a:t>
-            </a:r>
-          </a:p>
-          <a:p>
-            <a:pPr>
-              <a:lnSpc>
-                <a:spcPct val="132000"/>
-              </a:lnSpc>
-              <a:spcBef>
-                <a:spcPts val="0"/>
-              </a:spcBef>
-              <a:spcAft>
-                <a:spcPts val="1100"/>
-              </a:spcAft>
-            </a:pPr>
-            <a:r>
-              <a:rPr sz="1400" b="0" i="0">
-                <a:solidFill>
-                  <a:srgbClr val="5A6068"/>
-                </a:solidFill>
-                <a:latin typeface="Calibri"/>
-              </a:rPr>
-              <a:t>For wellbeing-conscious development monitoring, this suggests either building interpersonal-trust measurement into the core frameworks, or acknowledging that other surveys (the ESS, Gallup World Poll, World Values Survey) may be more suitable for understanding what shapes lived experience.</a:t>
+              <a:t>The fix: development frameworks cannot discover what matters by measuring something else and hoping it correlates. If wellbeing is part of development measurement's purpose, interpersonal trust must be collected at scale. This could mean building social trust into core frameworks, or integrating data from surveys designed to measure individual experience (ESS, Gallup World Poll, World Values Survey). The scope of trust findings—36 European countries, individual-level—is tentative. But tentative is better than absent.</a:t>
             </a:r>
           </a:p>
         </p:txBody>
@@ -7977,7 +7955,7 @@
                 </a:solidFill>
                 <a:latin typeface="Georgia"/>
               </a:rPr>
-              <a:t>A question rather than a prescription</a:t>
+              <a:t>From evidence to redesign</a:t>
             </a:r>
           </a:p>
         </p:txBody>
@@ -8022,7 +8000,7 @@
                 </a:solidFill>
                 <a:latin typeface="Calibri"/>
               </a:rPr>
-              <a:t>The evidence shows a consistent pattern: which domain looks most consequential for wellbeing depends on which framework measures it and what variable they chose. This is not about the domains; it is about the tools.</a:t>
+              <a:t>The evidence is clear: which domain predicts life satisfaction depends on which framework measures it and what variable they chose. This is not about the domains; it is about the tools. Development frameworks work well for their stated purpose — tracking aggregate progress toward development goals. But if that purpose is understood to include supporting lived experience, the measurement needs to change.</a:t>
             </a:r>
           </a:p>
           <a:p>
@@ -8044,7 +8022,7 @@
                 </a:solidFill>
                 <a:latin typeface="Calibri"/>
               </a:rPr>
-              <a:t>Whether development frameworks should be redesigned around wellbeing is outside the scope here. But if they were, this finding suggests the question to ask: should measurement choices be made with explicit reference to which variables still move and still matter for lived experience? Should coverage be built in for domains the frameworks discovered only by studying something else?</a:t>
+              <a:t>The three implications suggest where to start: make construction choices based on what research shows matters (education's access, health's variation, not saturation); choose variables that still move at the development levels being measured; and collect data for domains that matter but are currently missing. This is not a complete redesign. It is targeted adjustment rooted in evidence about what predicts individual wellbeing.</a:t>
             </a:r>
           </a:p>
           <a:p>
@@ -8066,7 +8044,7 @@
                 </a:solidFill>
                 <a:latin typeface="Calibri"/>
               </a:rPr>
-              <a:t>The frameworks work well for their stated purpose. The question is whether wellbeing should become part of that purpose — and if it does, whether the measurement that comes from that intent should be different from the aggregate, development-first measurement in place today.</a:t>
+              <a:t>The underlying question remains: Should development measurement be redesigned with lived experience in mind? If yes, should it measure at the individual level, with shorter intervals, using variables chosen for their responsiveness to change and their evidence of predicting wellbeing? The frameworks in place today are built for a different answer. These findings suggest what a different answer might measure.</a:t>
             </a:r>
           </a:p>
         </p:txBody>

</xml_diff>